<commit_message>
Architecture deck: the person in the courtroom is the human judge (L2 support)
</commit_message>
<xml_diff>
--- a/submission/architecture.pptx
+++ b/submission/architecture.pptx
@@ -114,30 +114,30 @@
   <p:extLst>
     <p:ext uri="{521415D9-36F7-43E2-AB2F-B90AF26B5E84}">
       <p14:sectionLst xmlns:p14="http://schemas.microsoft.com/office/powerpoint/2010/main">
-        <p14:section name="Overview" id="{bcea11ee-9254-139c-8481-ade01b6f9be2}">
+        <p14:section name="Overview" id="{ab7df54c-2a20-afcc-f6ac-5b99c1a29e93}">
           <p14:sldIdLst>
             <p14:sldId id="256"/>
           </p14:sldIdLst>
         </p14:section>
-        <p14:section name="The hearing" id="{ef61a018-daf8-1af8-9bc8-845887c77730}">
+        <p14:section name="The hearing" id="{76e6bf26-aa7f-1b35-f3bc-9483ad6cd6e9}">
           <p14:sldIdLst>
             <p14:sldId id="257"/>
             <p14:sldId id="258"/>
             <p14:sldId id="259"/>
           </p14:sldIdLst>
         </p14:section>
-        <p14:section name="Safeguards" id="{094c965a-0e33-2266-0e63-01c3bc5af80a}">
+        <p14:section name="Safeguards" id="{7b910bfa-7a97-eb8a-e15b-d64559be9111}">
           <p14:sldIdLst>
             <p14:sldId id="260"/>
             <p14:sldId id="261"/>
           </p14:sldIdLst>
         </p14:section>
-        <p14:section name="Platform" id="{b67d5c25-4a88-3180-2324-be9d2cb05894}">
+        <p14:section name="Platform" id="{96e40416-286e-6396-aa60-7a693d0b4186}">
           <p14:sldIdLst>
             <p14:sldId id="262"/>
           </p14:sldIdLst>
         </p14:section>
-        <p14:section name="Results" id="{2eee092c-cd98-0036-ba46-d07c359836ab}">
+        <p14:section name="Results" id="{26de2db8-43ac-7bf2-7ae3-b741a7b511bb}">
           <p14:sldIdLst>
             <p14:sldId id="263"/>
           </p14:sldIdLst>
@@ -634,7 +634,7 @@
           <a:p>
             <a:r>
               <a:rPr lang="en-US" dirty="0"/>
-              <a:t>The whole system in one picture. Each side gets its own AI advocate, and both argue from the identical case file, citing evidence by ID: here the rider's advocate cites the route comparison and the driver's advocate the driver's own chat message. The AI judge rules from the case file and both arguments, never from the original complaint. The example is a real case: the driven route was 41% longer than the fastest one, no road closure was on record, and the claim was upheld with a $3.68 refund. A support person steps in for safety reports and for any ruling the plain-code checks flag.</a:t>
+              <a:t>The whole system in one picture. Each side gets its own AI advocate, and both argue from the identical case file, citing evidence by ID: here the rider's advocate cites the route comparison and the driver's advocate the driver's own chat message. The AI judge rules from the case file and both arguments, never from the original complaint. The example is a real case: the driven route was 41% longer than the fastest one, no road closure was on record, and the claim was upheld with a $3.68 refund. A human judge, the L2 support team, steps in for safety reports and for any ruling the plain-code checks flag.</a:t>
             </a:r>
             <a:endParaRPr lang="en-US" dirty="0"/>
           </a:p>
@@ -2745,7 +2745,7 @@
                   <a:schemeClr val="accent4"/>
                 </a:solidFill>
               </a:rPr>
-              <a:t>A person</a:t>
+              <a:t>Human judge</a:t>
             </a:r>
             <a:endParaRPr lang="en-US" sz="1200" dirty="0"/>
           </a:p>
@@ -2754,12 +2754,12 @@
               <a:buNone/>
             </a:pPr>
             <a:r>
-              <a:rPr lang="en-US" sz="950" dirty="0">
+              <a:rPr lang="en-US" sz="1100" dirty="0">
                 <a:solidFill>
                   <a:schemeClr val="tx2"/>
                 </a:solidFill>
               </a:rPr>
-              <a:t>steps in when it's unsafe or unsure</a:t>
+              <a:t>L2 support</a:t>
             </a:r>
             <a:endParaRPr lang="en-US" sz="1200" dirty="0"/>
           </a:p>

</xml_diff>

<commit_message>
Architecture deck: system architecture slide with hosting zones and protocols
</commit_message>
<xml_diff>
--- a/submission/architecture.pptx
+++ b/submission/architecture.pptx
@@ -114,30 +114,30 @@
   <p:extLst>
     <p:ext uri="{521415D9-36F7-43E2-AB2F-B90AF26B5E84}">
       <p14:sectionLst xmlns:p14="http://schemas.microsoft.com/office/powerpoint/2010/main">
-        <p14:section name="Overview" id="{ab7df54c-2a20-afcc-f6ac-5b99c1a29e93}">
+        <p14:section name="Overview" id="{772baba1-792b-e3f6-0e12-73f26f51a42e}">
           <p14:sldIdLst>
             <p14:sldId id="256"/>
           </p14:sldIdLst>
         </p14:section>
-        <p14:section name="The hearing" id="{76e6bf26-aa7f-1b35-f3bc-9483ad6cd6e9}">
+        <p14:section name="The hearing" id="{3ee4cf82-3a82-c69f-1fdc-8f28eebd577e}">
           <p14:sldIdLst>
             <p14:sldId id="257"/>
             <p14:sldId id="258"/>
             <p14:sldId id="259"/>
           </p14:sldIdLst>
         </p14:section>
-        <p14:section name="Safeguards" id="{7b910bfa-7a97-eb8a-e15b-d64559be9111}">
+        <p14:section name="Safeguards" id="{23d4aab4-13b8-4ac4-95a2-62c20699e6d2}">
           <p14:sldIdLst>
             <p14:sldId id="260"/>
             <p14:sldId id="261"/>
           </p14:sldIdLst>
         </p14:section>
-        <p14:section name="Platform" id="{96e40416-286e-6396-aa60-7a693d0b4186}">
+        <p14:section name="Platform" id="{a17e6afb-8084-98ac-b684-233ac56a1a2a}">
           <p14:sldIdLst>
             <p14:sldId id="262"/>
           </p14:sldIdLst>
         </p14:section>
-        <p14:section name="Results" id="{26de2db8-43ac-7bf2-7ae3-b741a7b511bb}">
+        <p14:section name="Results" id="{dfb8ecd1-19a5-d9a0-24fe-54b9b2c3abf9}">
           <p14:sldIdLst>
             <p14:sldId id="263"/>
           </p14:sldIdLst>
@@ -1074,7 +1074,7 @@
           <a:p>
             <a:r>
               <a:rPr lang="en-US" dirty="0"/>
-              <a:t>Four layers. The frontend is a static React app on Vercel: the rider and driver apps, the support console and the AI trace; it sends actions over REST and receives every live update over server-sent events. The backend is one FastAPI service on Render: the orchestrator wires every step, five pydantic-ai agents with typed outputs and citation validators, rules with no AI, and narrow tools. Neon holds Postgres with pgvector and the evidence photos. DeepInfra serves the models, Logfire traces every agent run, and OneMap provides real Singapore road routes.</a:t>
+              <a:t>Riders and drivers, the L2 support team, and judges or operators all use one static React app on Vercel. It sends actions to the FastAPI backend on Render over REST and JSON, and receives every live update over server-sent events, which resume from the last event id after a dropped connection. Inside the backend, the orchestrator is a plain-code state machine: it runs intake, the hearing and the final checks, calls the five pydantic-ai agents and the rules that use no AI, and writes every step to the trace table, whose Postgres NOTIFY wakes the stream. Neon holds Postgres with pgvector and the evidence photos in S3-compatible object storage; only the Evidence Collection agent reads raw records. The models run on DeepInfra, Qwen3-235B for the agents and Gemma 4 for photos, with Gemini as the photo fallback. Logfire traces every agent run, and OneMap provides real Singapore road routes.</a:t>
             </a:r>
             <a:endParaRPr lang="en-US" dirty="0"/>
           </a:p>
@@ -8715,7 +8715,7 @@
                   <a:schemeClr val="tx1"/>
                 </a:solidFill>
               </a:rPr>
-              <a:t>Technical architecture</a:t>
+              <a:t>System architecture</a:t>
             </a:r>
             <a:endParaRPr lang="en-US" sz="3200" dirty="0"/>
           </a:p>
@@ -8753,7 +8753,7 @@
                   <a:schemeClr val="tx2"/>
                 </a:solidFill>
               </a:rPr>
-              <a:t>A React app, one FastAPI service and Neon. Every step streams live to the screen.</a:t>
+              <a:t>One FastAPI service on three managed platforms. Actions go over REST; every live update streams back over server-sent events.</a:t>
             </a:r>
             <a:endParaRPr lang="en-US" sz="1500" dirty="0"/>
           </a:p>
@@ -8761,27 +8761,27 @@
       </p:sp>
       <p:sp>
         <p:nvSpPr>
-          <p:cNvPr id="4" name="layer-0"/>
+          <p:cNvPr id="4" name="zone-users"/>
           <p:cNvSpPr/>
           <p:nvPr/>
         </p:nvSpPr>
         <p:spPr>
           <a:xfrm>
             <a:off x="548640" y="1691640"/>
-            <a:ext cx="11094415" cy="914400"/>
+            <a:ext cx="1097280" cy="4480560"/>
           </a:xfrm>
           <a:prstGeom prst="roundRect">
             <a:avLst>
-              <a:gd name="adj" fmla="val 10000"/>
+              <a:gd name="adj" fmla="val 8333"/>
             </a:avLst>
           </a:prstGeom>
           <a:solidFill>
             <a:schemeClr val="bg1"/>
           </a:solidFill>
-          <a:ln w="6350">
+          <a:ln w="9525">
             <a:solidFill>
               <a:schemeClr val="tx2">
-                <a:alpha val="30000"/>
+                <a:alpha val="45000"/>
               </a:schemeClr>
             </a:solidFill>
             <a:prstDash val="solid"/>
@@ -8790,14 +8790,14 @@
       </p:sp>
       <p:sp>
         <p:nvSpPr>
-          <p:cNvPr id="5" name="layer-0-label"/>
-          <p:cNvSpPr txBox="1"/>
-          <p:nvPr/>
-        </p:nvSpPr>
-        <p:spPr>
-          <a:xfrm>
-            <a:off x="731520" y="1783080"/>
-            <a:ext cx="1554480" cy="731520"/>
+          <p:cNvPr id="5" name="zone-users-head"/>
+          <p:cNvSpPr txBox="1"/>
+          <p:nvPr/>
+        </p:nvSpPr>
+        <p:spPr>
+          <a:xfrm>
+            <a:off x="685800" y="1764792"/>
+            <a:ext cx="822960" cy="457200"/>
           </a:xfrm>
           <a:prstGeom prst="rect">
             <a:avLst/>
@@ -8813,45 +8813,45 @@
               <a:buNone/>
             </a:pPr>
             <a:r>
-              <a:rPr lang="en-US" sz="1400" b="1" dirty="0">
+              <a:rPr lang="en-US" sz="1300" b="1" dirty="0">
                 <a:solidFill>
                   <a:schemeClr val="tx1"/>
                 </a:solidFill>
               </a:rPr>
-              <a:t>Frontend</a:t>
-            </a:r>
-            <a:endParaRPr lang="en-US" sz="1400" dirty="0"/>
-          </a:p>
-          <a:p>
-            <a:pPr indent="0" marL="0">
-              <a:buNone/>
-            </a:pPr>
-            <a:r>
-              <a:rPr lang="en-US" sz="1100" dirty="0">
+              <a:t>People</a:t>
+            </a:r>
+            <a:endParaRPr lang="en-US" sz="1300" dirty="0"/>
+          </a:p>
+          <a:p>
+            <a:pPr indent="0" marL="0">
+              <a:buNone/>
+            </a:pPr>
+            <a:r>
+              <a:rPr lang="en-US" sz="950" dirty="0">
                 <a:solidFill>
                   <a:schemeClr val="tx2"/>
                 </a:solidFill>
               </a:rPr>
-              <a:t>Vercel</a:t>
-            </a:r>
-            <a:endParaRPr lang="en-US" sz="1400" dirty="0"/>
-          </a:p>
-        </p:txBody>
-      </p:sp>
-      <p:sp>
-        <p:nvSpPr>
-          <p:cNvPr id="6" name="comp-95"/>
-          <p:cNvSpPr/>
-          <p:nvPr/>
-        </p:nvSpPr>
-        <p:spPr>
-          <a:xfrm>
-            <a:off x="2423160" y="1792224"/>
-            <a:ext cx="2181530" cy="713232"/>
+              <a:t>in a browser</a:t>
+            </a:r>
+            <a:endParaRPr lang="en-US" sz="1300" dirty="0"/>
+          </a:p>
+        </p:txBody>
+      </p:sp>
+      <p:sp>
+        <p:nvSpPr>
+          <p:cNvPr id="6" name="user-0"/>
+          <p:cNvSpPr/>
+          <p:nvPr/>
+        </p:nvSpPr>
+        <p:spPr>
+          <a:xfrm>
+            <a:off x="640080" y="2560320"/>
+            <a:ext cx="914400" cy="914400"/>
           </a:xfrm>
           <a:prstGeom prst="roundRect">
             <a:avLst>
-              <a:gd name="adj" fmla="val 8974"/>
+              <a:gd name="adj" fmla="val 7000"/>
             </a:avLst>
           </a:prstGeom>
           <a:solidFill>
@@ -8860,70 +8860,80 @@
           <a:ln/>
         </p:spPr>
       </p:sp>
-      <p:sp>
-        <p:nvSpPr>
-          <p:cNvPr id="7" name="comp-text-96"/>
-          <p:cNvSpPr txBox="1"/>
-          <p:nvPr/>
-        </p:nvSpPr>
-        <p:spPr>
-          <a:xfrm>
-            <a:off x="2551176" y="1847088"/>
-            <a:ext cx="1925498" cy="603504"/>
-          </a:xfrm>
-          <a:prstGeom prst="rect">
-            <a:avLst/>
-          </a:prstGeom>
-          <a:noFill/>
-          <a:ln/>
-        </p:spPr>
-        <p:txBody>
-          <a:bodyPr wrap="square" lIns="0" tIns="0" rIns="0" bIns="0" rtlCol="0" anchor="ctr"/>
-          <a:lstStyle/>
-          <a:p>
-            <a:pPr indent="0" marL="0">
-              <a:buNone/>
-            </a:pPr>
-            <a:r>
-              <a:rPr lang="en-US" sz="1300" b="1" dirty="0">
+      <p:pic>
+        <p:nvPicPr>
+          <p:cNvPr id="7" name="user-0-icon" descr="preencoded.png">    </p:cNvPr>
+          <p:cNvPicPr>
+            <a:picLocks noChangeAspect="1"/>
+          </p:cNvPicPr>
+          <p:nvPr/>
+        </p:nvPicPr>
+        <p:blipFill>
+          <a:blip r:embed="rId1"/>
+          <a:stretch>
+            <a:fillRect/>
+          </a:stretch>
+        </p:blipFill>
+        <p:spPr>
+          <a:xfrm>
+            <a:off x="960120" y="2670048"/>
+            <a:ext cx="274320" cy="274320"/>
+          </a:xfrm>
+          <a:prstGeom prst="rect">
+            <a:avLst/>
+          </a:prstGeom>
+        </p:spPr>
+      </p:pic>
+      <p:sp>
+        <p:nvSpPr>
+          <p:cNvPr id="8" name="user-0-text"/>
+          <p:cNvSpPr txBox="1"/>
+          <p:nvPr/>
+        </p:nvSpPr>
+        <p:spPr>
+          <a:xfrm>
+            <a:off x="658368" y="2980944"/>
+            <a:ext cx="877824" cy="438912"/>
+          </a:xfrm>
+          <a:prstGeom prst="rect">
+            <a:avLst/>
+          </a:prstGeom>
+          <a:noFill/>
+          <a:ln/>
+        </p:spPr>
+        <p:txBody>
+          <a:bodyPr wrap="square" lIns="0" tIns="0" rIns="0" bIns="0" rtlCol="0" anchor="t"/>
+          <a:lstStyle/>
+          <a:p>
+            <a:pPr algn="ctr" indent="0" marL="0">
+              <a:buNone/>
+            </a:pPr>
+            <a:r>
+              <a:rPr lang="en-US" sz="1050" b="1" dirty="0">
                 <a:solidFill>
                   <a:schemeClr val="tx1"/>
                 </a:solidFill>
               </a:rPr>
-              <a:t>Rider and driver apps</a:t>
-            </a:r>
-            <a:endParaRPr lang="en-US" sz="1300" dirty="0"/>
-          </a:p>
-          <a:p>
-            <a:pPr indent="0" marL="0">
-              <a:buNone/>
-            </a:pPr>
-            <a:r>
-              <a:rPr lang="en-US" sz="1100" dirty="0">
-                <a:solidFill>
-                  <a:schemeClr val="tx2"/>
-                </a:solidFill>
-              </a:rPr>
-              <a:t>report, reply, outcome</a:t>
-            </a:r>
-            <a:endParaRPr lang="en-US" sz="1300" dirty="0"/>
-          </a:p>
-        </p:txBody>
-      </p:sp>
-      <p:sp>
-        <p:nvSpPr>
-          <p:cNvPr id="8" name="comp-97"/>
-          <p:cNvSpPr/>
-          <p:nvPr/>
-        </p:nvSpPr>
-        <p:spPr>
-          <a:xfrm>
-            <a:off x="4732706" y="1792224"/>
-            <a:ext cx="2181530" cy="713232"/>
+              <a:t>Riders, drivers</a:t>
+            </a:r>
+            <a:endParaRPr lang="en-US" sz="1050" dirty="0"/>
+          </a:p>
+        </p:txBody>
+      </p:sp>
+      <p:sp>
+        <p:nvSpPr>
+          <p:cNvPr id="9" name="user-1"/>
+          <p:cNvSpPr/>
+          <p:nvPr/>
+        </p:nvSpPr>
+        <p:spPr>
+          <a:xfrm>
+            <a:off x="640080" y="3703320"/>
+            <a:ext cx="914400" cy="914400"/>
           </a:xfrm>
           <a:prstGeom prst="roundRect">
             <a:avLst>
-              <a:gd name="adj" fmla="val 8974"/>
+              <a:gd name="adj" fmla="val 7000"/>
             </a:avLst>
           </a:prstGeom>
           <a:solidFill>
@@ -8932,70 +8942,80 @@
           <a:ln/>
         </p:spPr>
       </p:sp>
-      <p:sp>
-        <p:nvSpPr>
-          <p:cNvPr id="9" name="comp-text-98"/>
-          <p:cNvSpPr txBox="1"/>
-          <p:nvPr/>
-        </p:nvSpPr>
-        <p:spPr>
-          <a:xfrm>
-            <a:off x="4860722" y="1847088"/>
-            <a:ext cx="1925498" cy="603504"/>
-          </a:xfrm>
-          <a:prstGeom prst="rect">
-            <a:avLst/>
-          </a:prstGeom>
-          <a:noFill/>
-          <a:ln/>
-        </p:spPr>
-        <p:txBody>
-          <a:bodyPr wrap="square" lIns="0" tIns="0" rIns="0" bIns="0" rtlCol="0" anchor="ctr"/>
-          <a:lstStyle/>
-          <a:p>
-            <a:pPr indent="0" marL="0">
-              <a:buNone/>
-            </a:pPr>
-            <a:r>
-              <a:rPr lang="en-US" sz="1300" b="1" dirty="0">
+      <p:pic>
+        <p:nvPicPr>
+          <p:cNvPr id="10" name="user-1-icon" descr="preencoded.png">    </p:cNvPr>
+          <p:cNvPicPr>
+            <a:picLocks noChangeAspect="1"/>
+          </p:cNvPicPr>
+          <p:nvPr/>
+        </p:nvPicPr>
+        <p:blipFill>
+          <a:blip r:embed="rId2"/>
+          <a:stretch>
+            <a:fillRect/>
+          </a:stretch>
+        </p:blipFill>
+        <p:spPr>
+          <a:xfrm>
+            <a:off x="960120" y="3813048"/>
+            <a:ext cx="274320" cy="274320"/>
+          </a:xfrm>
+          <a:prstGeom prst="rect">
+            <a:avLst/>
+          </a:prstGeom>
+        </p:spPr>
+      </p:pic>
+      <p:sp>
+        <p:nvSpPr>
+          <p:cNvPr id="11" name="user-1-text"/>
+          <p:cNvSpPr txBox="1"/>
+          <p:nvPr/>
+        </p:nvSpPr>
+        <p:spPr>
+          <a:xfrm>
+            <a:off x="658368" y="4123944"/>
+            <a:ext cx="877824" cy="438912"/>
+          </a:xfrm>
+          <a:prstGeom prst="rect">
+            <a:avLst/>
+          </a:prstGeom>
+          <a:noFill/>
+          <a:ln/>
+        </p:spPr>
+        <p:txBody>
+          <a:bodyPr wrap="square" lIns="0" tIns="0" rIns="0" bIns="0" rtlCol="0" anchor="t"/>
+          <a:lstStyle/>
+          <a:p>
+            <a:pPr algn="ctr" indent="0" marL="0">
+              <a:buNone/>
+            </a:pPr>
+            <a:r>
+              <a:rPr lang="en-US" sz="1050" b="1" dirty="0">
                 <a:solidFill>
                   <a:schemeClr val="tx1"/>
                 </a:solidFill>
               </a:rPr>
-              <a:t>Support console</a:t>
-            </a:r>
-            <a:endParaRPr lang="en-US" sz="1300" dirty="0"/>
-          </a:p>
-          <a:p>
-            <a:pPr indent="0" marL="0">
-              <a:buNone/>
-            </a:pPr>
-            <a:r>
-              <a:rPr lang="en-US" sz="1100" dirty="0">
-                <a:solidFill>
-                  <a:schemeClr val="tx2"/>
-                </a:solidFill>
-              </a:rPr>
-              <a:t>the person's queue</a:t>
-            </a:r>
-            <a:endParaRPr lang="en-US" sz="1300" dirty="0"/>
-          </a:p>
-        </p:txBody>
-      </p:sp>
-      <p:sp>
-        <p:nvSpPr>
-          <p:cNvPr id="10" name="comp-99"/>
-          <p:cNvSpPr/>
-          <p:nvPr/>
-        </p:nvSpPr>
-        <p:spPr>
-          <a:xfrm>
-            <a:off x="7042252" y="1792224"/>
-            <a:ext cx="2181530" cy="713232"/>
+              <a:t>Support (L2)</a:t>
+            </a:r>
+            <a:endParaRPr lang="en-US" sz="1050" dirty="0"/>
+          </a:p>
+        </p:txBody>
+      </p:sp>
+      <p:sp>
+        <p:nvSpPr>
+          <p:cNvPr id="12" name="user-2"/>
+          <p:cNvSpPr/>
+          <p:nvPr/>
+        </p:nvSpPr>
+        <p:spPr>
+          <a:xfrm>
+            <a:off x="640080" y="4846320"/>
+            <a:ext cx="914400" cy="914400"/>
           </a:xfrm>
           <a:prstGeom prst="roundRect">
             <a:avLst>
-              <a:gd name="adj" fmla="val 8974"/>
+              <a:gd name="adj" fmla="val 7000"/>
             </a:avLst>
           </a:prstGeom>
           <a:solidFill>
@@ -9004,70 +9024,159 @@
           <a:ln/>
         </p:spPr>
       </p:sp>
-      <p:sp>
-        <p:nvSpPr>
-          <p:cNvPr id="11" name="comp-text-100"/>
-          <p:cNvSpPr txBox="1"/>
-          <p:nvPr/>
-        </p:nvSpPr>
-        <p:spPr>
-          <a:xfrm>
-            <a:off x="7170268" y="1847088"/>
-            <a:ext cx="1925498" cy="603504"/>
-          </a:xfrm>
-          <a:prstGeom prst="rect">
-            <a:avLst/>
-          </a:prstGeom>
-          <a:noFill/>
-          <a:ln/>
-        </p:spPr>
-        <p:txBody>
-          <a:bodyPr wrap="square" lIns="0" tIns="0" rIns="0" bIns="0" rtlCol="0" anchor="ctr"/>
-          <a:lstStyle/>
-          <a:p>
-            <a:pPr indent="0" marL="0">
-              <a:buNone/>
-            </a:pPr>
-            <a:r>
-              <a:rPr lang="en-US" sz="1300" b="1" dirty="0">
+      <p:pic>
+        <p:nvPicPr>
+          <p:cNvPr id="13" name="user-2-icon" descr="preencoded.png">    </p:cNvPr>
+          <p:cNvPicPr>
+            <a:picLocks noChangeAspect="1"/>
+          </p:cNvPicPr>
+          <p:nvPr/>
+        </p:nvPicPr>
+        <p:blipFill>
+          <a:blip r:embed="rId3"/>
+          <a:stretch>
+            <a:fillRect/>
+          </a:stretch>
+        </p:blipFill>
+        <p:spPr>
+          <a:xfrm>
+            <a:off x="960120" y="4956048"/>
+            <a:ext cx="274320" cy="274320"/>
+          </a:xfrm>
+          <a:prstGeom prst="rect">
+            <a:avLst/>
+          </a:prstGeom>
+        </p:spPr>
+      </p:pic>
+      <p:sp>
+        <p:nvSpPr>
+          <p:cNvPr id="14" name="user-2-text"/>
+          <p:cNvSpPr txBox="1"/>
+          <p:nvPr/>
+        </p:nvSpPr>
+        <p:spPr>
+          <a:xfrm>
+            <a:off x="658368" y="5266944"/>
+            <a:ext cx="877824" cy="438912"/>
+          </a:xfrm>
+          <a:prstGeom prst="rect">
+            <a:avLst/>
+          </a:prstGeom>
+          <a:noFill/>
+          <a:ln/>
+        </p:spPr>
+        <p:txBody>
+          <a:bodyPr wrap="square" lIns="0" tIns="0" rIns="0" bIns="0" rtlCol="0" anchor="t"/>
+          <a:lstStyle/>
+          <a:p>
+            <a:pPr algn="ctr" indent="0" marL="0">
+              <a:buNone/>
+            </a:pPr>
+            <a:r>
+              <a:rPr lang="en-US" sz="1050" b="1" dirty="0">
                 <a:solidFill>
                   <a:schemeClr val="tx1"/>
                 </a:solidFill>
               </a:rPr>
-              <a:t>AI trace</a:t>
-            </a:r>
-            <a:endParaRPr lang="en-US" sz="1300" dirty="0"/>
-          </a:p>
-          <a:p>
-            <a:pPr indent="0" marL="0">
-              <a:buNone/>
-            </a:pPr>
-            <a:r>
-              <a:rPr lang="en-US" sz="1100" dirty="0">
-                <a:solidFill>
-                  <a:schemeClr val="tx2"/>
-                </a:solidFill>
-              </a:rPr>
-              <a:t>every case as a hearing</a:t>
-            </a:r>
-            <a:endParaRPr lang="en-US" sz="1300" dirty="0"/>
-          </a:p>
-        </p:txBody>
-      </p:sp>
-      <p:sp>
-        <p:nvSpPr>
-          <p:cNvPr id="12" name="comp-101"/>
-          <p:cNvSpPr/>
-          <p:nvPr/>
-        </p:nvSpPr>
-        <p:spPr>
-          <a:xfrm>
-            <a:off x="9351797" y="1792224"/>
-            <a:ext cx="2181530" cy="713232"/>
+              <a:t>Operators</a:t>
+            </a:r>
+            <a:endParaRPr lang="en-US" sz="1050" dirty="0"/>
+          </a:p>
+        </p:txBody>
+      </p:sp>
+      <p:sp>
+        <p:nvSpPr>
+          <p:cNvPr id="15" name="zone-frontend"/>
+          <p:cNvSpPr/>
+          <p:nvPr/>
+        </p:nvSpPr>
+        <p:spPr>
+          <a:xfrm>
+            <a:off x="2057400" y="1691640"/>
+            <a:ext cx="2011680" cy="4480560"/>
           </a:xfrm>
           <a:prstGeom prst="roundRect">
             <a:avLst>
-              <a:gd name="adj" fmla="val 8974"/>
+              <a:gd name="adj" fmla="val 4545"/>
+            </a:avLst>
+          </a:prstGeom>
+          <a:solidFill>
+            <a:schemeClr val="bg1"/>
+          </a:solidFill>
+          <a:ln w="9525">
+            <a:solidFill>
+              <a:schemeClr val="tx2">
+                <a:alpha val="45000"/>
+              </a:schemeClr>
+            </a:solidFill>
+            <a:prstDash val="solid"/>
+          </a:ln>
+        </p:spPr>
+      </p:sp>
+      <p:sp>
+        <p:nvSpPr>
+          <p:cNvPr id="16" name="zone-frontend-head"/>
+          <p:cNvSpPr txBox="1"/>
+          <p:nvPr/>
+        </p:nvSpPr>
+        <p:spPr>
+          <a:xfrm>
+            <a:off x="2194560" y="1764792"/>
+            <a:ext cx="1737360" cy="457200"/>
+          </a:xfrm>
+          <a:prstGeom prst="rect">
+            <a:avLst/>
+          </a:prstGeom>
+          <a:noFill/>
+          <a:ln/>
+        </p:spPr>
+        <p:txBody>
+          <a:bodyPr wrap="square" lIns="0" tIns="0" rIns="0" bIns="0" rtlCol="0" anchor="ctr"/>
+          <a:lstStyle/>
+          <a:p>
+            <a:pPr indent="0" marL="0">
+              <a:buNone/>
+            </a:pPr>
+            <a:r>
+              <a:rPr lang="en-US" sz="1300" b="1" dirty="0">
+                <a:solidFill>
+                  <a:schemeClr val="tx1"/>
+                </a:solidFill>
+              </a:rPr>
+              <a:t>Frontend</a:t>
+            </a:r>
+            <a:endParaRPr lang="en-US" sz="1300" dirty="0"/>
+          </a:p>
+          <a:p>
+            <a:pPr indent="0" marL="0">
+              <a:buNone/>
+            </a:pPr>
+            <a:r>
+              <a:rPr lang="en-US" sz="950" dirty="0">
+                <a:solidFill>
+                  <a:schemeClr val="tx2"/>
+                </a:solidFill>
+              </a:rPr>
+              <a:t>Vercel · static SPA</a:t>
+            </a:r>
+            <a:endParaRPr lang="en-US" sz="1300" dirty="0"/>
+          </a:p>
+        </p:txBody>
+      </p:sp>
+      <p:sp>
+        <p:nvSpPr>
+          <p:cNvPr id="17" name="box-95"/>
+          <p:cNvSpPr/>
+          <p:nvPr/>
+        </p:nvSpPr>
+        <p:spPr>
+          <a:xfrm>
+            <a:off x="2167128" y="2313432"/>
+            <a:ext cx="1792224" cy="822960"/>
+          </a:xfrm>
+          <a:prstGeom prst="roundRect">
+            <a:avLst>
+              <a:gd name="adj" fmla="val 7778"/>
             </a:avLst>
           </a:prstGeom>
           <a:solidFill>
@@ -9076,16 +9185,40 @@
           <a:ln/>
         </p:spPr>
       </p:sp>
-      <p:sp>
-        <p:nvSpPr>
-          <p:cNvPr id="13" name="comp-text-102"/>
-          <p:cNvSpPr txBox="1"/>
-          <p:nvPr/>
-        </p:nvSpPr>
-        <p:spPr>
-          <a:xfrm>
-            <a:off x="9479813" y="1847088"/>
-            <a:ext cx="1925498" cy="603504"/>
+      <p:pic>
+        <p:nvPicPr>
+          <p:cNvPr id="18" name="box-icon-96" descr="preencoded.png">    </p:cNvPr>
+          <p:cNvPicPr>
+            <a:picLocks noChangeAspect="1"/>
+          </p:cNvPicPr>
+          <p:nvPr/>
+        </p:nvPicPr>
+        <p:blipFill>
+          <a:blip r:embed="rId4"/>
+          <a:stretch>
+            <a:fillRect/>
+          </a:stretch>
+        </p:blipFill>
+        <p:spPr>
+          <a:xfrm>
+            <a:off x="2258568" y="2404872"/>
+            <a:ext cx="219456" cy="219456"/>
+          </a:xfrm>
+          <a:prstGeom prst="rect">
+            <a:avLst/>
+          </a:prstGeom>
+        </p:spPr>
+      </p:pic>
+      <p:sp>
+        <p:nvSpPr>
+          <p:cNvPr id="19" name="box-title-97"/>
+          <p:cNvSpPr txBox="1"/>
+          <p:nvPr/>
+        </p:nvSpPr>
+        <p:spPr>
+          <a:xfrm>
+            <a:off x="2532888" y="2377440"/>
+            <a:ext cx="1353312" cy="274320"/>
           </a:xfrm>
           <a:prstGeom prst="rect">
             <a:avLst/>
@@ -9101,41 +9234,453 @@
               <a:buNone/>
             </a:pPr>
             <a:r>
-              <a:rPr lang="en-US" sz="1300" b="1" dirty="0">
+              <a:rPr lang="en-US" sz="1150" b="1" dirty="0">
                 <a:solidFill>
                   <a:schemeClr val="tx1"/>
                 </a:solidFill>
               </a:rPr>
-              <a:t>Live updates</a:t>
-            </a:r>
-            <a:endParaRPr lang="en-US" sz="1300" dirty="0"/>
-          </a:p>
-          <a:p>
-            <a:pPr indent="0" marL="0">
-              <a:buNone/>
-            </a:pPr>
-            <a:r>
-              <a:rPr lang="en-US" sz="1100" dirty="0">
+              <a:t>Party apps</a:t>
+            </a:r>
+            <a:endParaRPr lang="en-US" sz="1150" dirty="0"/>
+          </a:p>
+        </p:txBody>
+      </p:sp>
+      <p:sp>
+        <p:nvSpPr>
+          <p:cNvPr id="20" name="box-sub-98"/>
+          <p:cNvSpPr txBox="1"/>
+          <p:nvPr/>
+        </p:nvSpPr>
+        <p:spPr>
+          <a:xfrm>
+            <a:off x="2258568" y="2679192"/>
+            <a:ext cx="1609344" cy="402336"/>
+          </a:xfrm>
+          <a:prstGeom prst="rect">
+            <a:avLst/>
+          </a:prstGeom>
+          <a:noFill/>
+          <a:ln/>
+        </p:spPr>
+        <p:txBody>
+          <a:bodyPr wrap="square" lIns="0" tIns="0" rIns="0" bIns="0" rtlCol="0" anchor="t"/>
+          <a:lstStyle/>
+          <a:p>
+            <a:pPr indent="0" marL="0">
+              <a:buNone/>
+            </a:pPr>
+            <a:r>
+              <a:rPr lang="en-US" sz="950" dirty="0">
                 <a:solidFill>
                   <a:schemeClr val="tx2"/>
                 </a:solidFill>
               </a:rPr>
-              <a:t>server-sent events</a:t>
-            </a:r>
-            <a:endParaRPr lang="en-US" sz="1300" dirty="0"/>
-          </a:p>
-        </p:txBody>
-      </p:sp>
-      <p:sp>
-        <p:nvSpPr>
-          <p:cNvPr id="14" name="arrow-103"/>
-          <p:cNvSpPr/>
-          <p:nvPr/>
-        </p:nvSpPr>
-        <p:spPr>
-          <a:xfrm>
-            <a:off x="6978244" y="2606040"/>
-            <a:ext cx="0" cy="182880"/>
+              <a:t>rider and driver: report, reply, outcome</a:t>
+            </a:r>
+            <a:endParaRPr lang="en-US" sz="950" dirty="0"/>
+          </a:p>
+        </p:txBody>
+      </p:sp>
+      <p:sp>
+        <p:nvSpPr>
+          <p:cNvPr id="21" name="box-99"/>
+          <p:cNvSpPr/>
+          <p:nvPr/>
+        </p:nvSpPr>
+        <p:spPr>
+          <a:xfrm>
+            <a:off x="2167128" y="3255264"/>
+            <a:ext cx="1792224" cy="822960"/>
+          </a:xfrm>
+          <a:prstGeom prst="roundRect">
+            <a:avLst>
+              <a:gd name="adj" fmla="val 7778"/>
+            </a:avLst>
+          </a:prstGeom>
+          <a:solidFill>
+            <a:schemeClr val="bg2"/>
+          </a:solidFill>
+          <a:ln/>
+        </p:spPr>
+      </p:sp>
+      <p:pic>
+        <p:nvPicPr>
+          <p:cNvPr id="22" name="box-icon-100" descr="preencoded.png">    </p:cNvPr>
+          <p:cNvPicPr>
+            <a:picLocks noChangeAspect="1"/>
+          </p:cNvPicPr>
+          <p:nvPr/>
+        </p:nvPicPr>
+        <p:blipFill>
+          <a:blip r:embed="rId5"/>
+          <a:stretch>
+            <a:fillRect/>
+          </a:stretch>
+        </p:blipFill>
+        <p:spPr>
+          <a:xfrm>
+            <a:off x="2258568" y="3346704"/>
+            <a:ext cx="219456" cy="219456"/>
+          </a:xfrm>
+          <a:prstGeom prst="rect">
+            <a:avLst/>
+          </a:prstGeom>
+        </p:spPr>
+      </p:pic>
+      <p:sp>
+        <p:nvSpPr>
+          <p:cNvPr id="23" name="box-title-101"/>
+          <p:cNvSpPr txBox="1"/>
+          <p:nvPr/>
+        </p:nvSpPr>
+        <p:spPr>
+          <a:xfrm>
+            <a:off x="2532888" y="3319272"/>
+            <a:ext cx="1353312" cy="274320"/>
+          </a:xfrm>
+          <a:prstGeom prst="rect">
+            <a:avLst/>
+          </a:prstGeom>
+          <a:noFill/>
+          <a:ln/>
+        </p:spPr>
+        <p:txBody>
+          <a:bodyPr wrap="square" lIns="0" tIns="0" rIns="0" bIns="0" rtlCol="0" anchor="ctr"/>
+          <a:lstStyle/>
+          <a:p>
+            <a:pPr indent="0" marL="0">
+              <a:buNone/>
+            </a:pPr>
+            <a:r>
+              <a:rPr lang="en-US" sz="1150" b="1" dirty="0">
+                <a:solidFill>
+                  <a:schemeClr val="tx1"/>
+                </a:solidFill>
+              </a:rPr>
+              <a:t>Support console</a:t>
+            </a:r>
+            <a:endParaRPr lang="en-US" sz="1150" dirty="0"/>
+          </a:p>
+        </p:txBody>
+      </p:sp>
+      <p:sp>
+        <p:nvSpPr>
+          <p:cNvPr id="24" name="box-sub-102"/>
+          <p:cNvSpPr txBox="1"/>
+          <p:nvPr/>
+        </p:nvSpPr>
+        <p:spPr>
+          <a:xfrm>
+            <a:off x="2258568" y="3621024"/>
+            <a:ext cx="1609344" cy="402336"/>
+          </a:xfrm>
+          <a:prstGeom prst="rect">
+            <a:avLst/>
+          </a:prstGeom>
+          <a:noFill/>
+          <a:ln/>
+        </p:spPr>
+        <p:txBody>
+          <a:bodyPr wrap="square" lIns="0" tIns="0" rIns="0" bIns="0" rtlCol="0" anchor="t"/>
+          <a:lstStyle/>
+          <a:p>
+            <a:pPr indent="0" marL="0">
+              <a:buNone/>
+            </a:pPr>
+            <a:r>
+              <a:rPr lang="en-US" sz="950" dirty="0">
+                <a:solidFill>
+                  <a:schemeClr val="tx2"/>
+                </a:solidFill>
+              </a:rPr>
+              <a:t>the human judge's queue</a:t>
+            </a:r>
+            <a:endParaRPr lang="en-US" sz="950" dirty="0"/>
+          </a:p>
+        </p:txBody>
+      </p:sp>
+      <p:sp>
+        <p:nvSpPr>
+          <p:cNvPr id="25" name="box-103"/>
+          <p:cNvSpPr/>
+          <p:nvPr/>
+        </p:nvSpPr>
+        <p:spPr>
+          <a:xfrm>
+            <a:off x="2167128" y="4197096"/>
+            <a:ext cx="1792224" cy="822960"/>
+          </a:xfrm>
+          <a:prstGeom prst="roundRect">
+            <a:avLst>
+              <a:gd name="adj" fmla="val 7778"/>
+            </a:avLst>
+          </a:prstGeom>
+          <a:solidFill>
+            <a:schemeClr val="bg2"/>
+          </a:solidFill>
+          <a:ln/>
+        </p:spPr>
+      </p:sp>
+      <p:pic>
+        <p:nvPicPr>
+          <p:cNvPr id="26" name="box-icon-104" descr="preencoded.png">    </p:cNvPr>
+          <p:cNvPicPr>
+            <a:picLocks noChangeAspect="1"/>
+          </p:cNvPicPr>
+          <p:nvPr/>
+        </p:nvPicPr>
+        <p:blipFill>
+          <a:blip r:embed="rId6"/>
+          <a:stretch>
+            <a:fillRect/>
+          </a:stretch>
+        </p:blipFill>
+        <p:spPr>
+          <a:xfrm>
+            <a:off x="2258568" y="4288536"/>
+            <a:ext cx="219456" cy="219456"/>
+          </a:xfrm>
+          <a:prstGeom prst="rect">
+            <a:avLst/>
+          </a:prstGeom>
+        </p:spPr>
+      </p:pic>
+      <p:sp>
+        <p:nvSpPr>
+          <p:cNvPr id="27" name="box-title-105"/>
+          <p:cNvSpPr txBox="1"/>
+          <p:nvPr/>
+        </p:nvSpPr>
+        <p:spPr>
+          <a:xfrm>
+            <a:off x="2532888" y="4261104"/>
+            <a:ext cx="1353312" cy="274320"/>
+          </a:xfrm>
+          <a:prstGeom prst="rect">
+            <a:avLst/>
+          </a:prstGeom>
+          <a:noFill/>
+          <a:ln/>
+        </p:spPr>
+        <p:txBody>
+          <a:bodyPr wrap="square" lIns="0" tIns="0" rIns="0" bIns="0" rtlCol="0" anchor="ctr"/>
+          <a:lstStyle/>
+          <a:p>
+            <a:pPr indent="0" marL="0">
+              <a:buNone/>
+            </a:pPr>
+            <a:r>
+              <a:rPr lang="en-US" sz="1150" b="1" dirty="0">
+                <a:solidFill>
+                  <a:schemeClr val="tx1"/>
+                </a:solidFill>
+              </a:rPr>
+              <a:t>AI trace</a:t>
+            </a:r>
+            <a:endParaRPr lang="en-US" sz="1150" dirty="0"/>
+          </a:p>
+        </p:txBody>
+      </p:sp>
+      <p:sp>
+        <p:nvSpPr>
+          <p:cNvPr id="28" name="box-sub-106"/>
+          <p:cNvSpPr txBox="1"/>
+          <p:nvPr/>
+        </p:nvSpPr>
+        <p:spPr>
+          <a:xfrm>
+            <a:off x="2258568" y="4562856"/>
+            <a:ext cx="1609344" cy="402336"/>
+          </a:xfrm>
+          <a:prstGeom prst="rect">
+            <a:avLst/>
+          </a:prstGeom>
+          <a:noFill/>
+          <a:ln/>
+        </p:spPr>
+        <p:txBody>
+          <a:bodyPr wrap="square" lIns="0" tIns="0" rIns="0" bIns="0" rtlCol="0" anchor="t"/>
+          <a:lstStyle/>
+          <a:p>
+            <a:pPr indent="0" marL="0">
+              <a:buNone/>
+            </a:pPr>
+            <a:r>
+              <a:rPr lang="en-US" sz="950" dirty="0">
+                <a:solidFill>
+                  <a:schemeClr val="tx2"/>
+                </a:solidFill>
+              </a:rPr>
+              <a:t>each case as a hearing; accuracy</a:t>
+            </a:r>
+            <a:endParaRPr lang="en-US" sz="950" dirty="0"/>
+          </a:p>
+        </p:txBody>
+      </p:sp>
+      <p:sp>
+        <p:nvSpPr>
+          <p:cNvPr id="29" name="box-107"/>
+          <p:cNvSpPr/>
+          <p:nvPr/>
+        </p:nvSpPr>
+        <p:spPr>
+          <a:xfrm>
+            <a:off x="2167128" y="5138928"/>
+            <a:ext cx="1792224" cy="822960"/>
+          </a:xfrm>
+          <a:prstGeom prst="roundRect">
+            <a:avLst>
+              <a:gd name="adj" fmla="val 7778"/>
+            </a:avLst>
+          </a:prstGeom>
+          <a:solidFill>
+            <a:schemeClr val="bg2"/>
+          </a:solidFill>
+          <a:ln/>
+        </p:spPr>
+      </p:sp>
+      <p:pic>
+        <p:nvPicPr>
+          <p:cNvPr id="30" name="box-icon-108" descr="preencoded.png">    </p:cNvPr>
+          <p:cNvPicPr>
+            <a:picLocks noChangeAspect="1"/>
+          </p:cNvPicPr>
+          <p:nvPr/>
+        </p:nvPicPr>
+        <p:blipFill>
+          <a:blip r:embed="rId7"/>
+          <a:stretch>
+            <a:fillRect/>
+          </a:stretch>
+        </p:blipFill>
+        <p:spPr>
+          <a:xfrm>
+            <a:off x="2258568" y="5230368"/>
+            <a:ext cx="219456" cy="219456"/>
+          </a:xfrm>
+          <a:prstGeom prst="rect">
+            <a:avLst/>
+          </a:prstGeom>
+        </p:spPr>
+      </p:pic>
+      <p:sp>
+        <p:nvSpPr>
+          <p:cNvPr id="31" name="box-title-109"/>
+          <p:cNvSpPr txBox="1"/>
+          <p:nvPr/>
+        </p:nvSpPr>
+        <p:spPr>
+          <a:xfrm>
+            <a:off x="2532888" y="5202936"/>
+            <a:ext cx="1353312" cy="274320"/>
+          </a:xfrm>
+          <a:prstGeom prst="rect">
+            <a:avLst/>
+          </a:prstGeom>
+          <a:noFill/>
+          <a:ln/>
+        </p:spPr>
+        <p:txBody>
+          <a:bodyPr wrap="square" lIns="0" tIns="0" rIns="0" bIns="0" rtlCol="0" anchor="ctr"/>
+          <a:lstStyle/>
+          <a:p>
+            <a:pPr indent="0" marL="0">
+              <a:buNone/>
+            </a:pPr>
+            <a:r>
+              <a:rPr lang="en-US" sz="1150" b="1" dirty="0">
+                <a:solidFill>
+                  <a:schemeClr val="tx1"/>
+                </a:solidFill>
+              </a:rPr>
+              <a:t>Maps</a:t>
+            </a:r>
+            <a:endParaRPr lang="en-US" sz="1150" dirty="0"/>
+          </a:p>
+        </p:txBody>
+      </p:sp>
+      <p:sp>
+        <p:nvSpPr>
+          <p:cNvPr id="32" name="box-sub-110"/>
+          <p:cNvSpPr txBox="1"/>
+          <p:nvPr/>
+        </p:nvSpPr>
+        <p:spPr>
+          <a:xfrm>
+            <a:off x="2258568" y="5504688"/>
+            <a:ext cx="1609344" cy="402336"/>
+          </a:xfrm>
+          <a:prstGeom prst="rect">
+            <a:avLst/>
+          </a:prstGeom>
+          <a:noFill/>
+          <a:ln/>
+        </p:spPr>
+        <p:txBody>
+          <a:bodyPr wrap="square" lIns="0" tIns="0" rIns="0" bIns="0" rtlCol="0" anchor="t"/>
+          <a:lstStyle/>
+          <a:p>
+            <a:pPr indent="0" marL="0">
+              <a:buNone/>
+            </a:pPr>
+            <a:r>
+              <a:rPr lang="en-US" sz="950" dirty="0">
+                <a:solidFill>
+                  <a:schemeClr val="tx2"/>
+                </a:solidFill>
+              </a:rPr>
+              <a:t>Leaflet on OneMap tiles</a:t>
+            </a:r>
+            <a:endParaRPr lang="en-US" sz="950" dirty="0"/>
+          </a:p>
+        </p:txBody>
+      </p:sp>
+      <p:sp>
+        <p:nvSpPr>
+          <p:cNvPr id="33" name="wire-label-111"/>
+          <p:cNvSpPr txBox="1"/>
+          <p:nvPr/>
+        </p:nvSpPr>
+        <p:spPr>
+          <a:xfrm>
+            <a:off x="2167128" y="5879592"/>
+            <a:ext cx="1792224" cy="201168"/>
+          </a:xfrm>
+          <a:prstGeom prst="rect">
+            <a:avLst/>
+          </a:prstGeom>
+          <a:noFill/>
+          <a:ln/>
+        </p:spPr>
+        <p:txBody>
+          <a:bodyPr wrap="square" lIns="0" tIns="0" rIns="0" bIns="0" rtlCol="0" anchor="ctr"/>
+          <a:lstStyle/>
+          <a:p>
+            <a:pPr algn="ctr" indent="0" marL="0">
+              <a:buNone/>
+            </a:pPr>
+            <a:r>
+              <a:rPr lang="en-US" sz="900" i="1" dirty="0">
+                <a:solidFill>
+                  <a:schemeClr val="tx2"/>
+                </a:solidFill>
+              </a:rPr>
+              <a:t>React 19 · Vite · TypeScript</a:t>
+            </a:r>
+            <a:endParaRPr lang="en-US" sz="900" dirty="0"/>
+          </a:p>
+        </p:txBody>
+      </p:sp>
+      <p:sp>
+        <p:nvSpPr>
+          <p:cNvPr id="34" name="arrow-112"/>
+          <p:cNvSpPr/>
+          <p:nvPr/>
+        </p:nvSpPr>
+        <p:spPr>
+          <a:xfrm>
+            <a:off x="1645920" y="4206240"/>
+            <a:ext cx="411480" cy="0"/>
           </a:xfrm>
           <a:prstGeom prst="line">
             <a:avLst/>
@@ -9152,27 +9697,63 @@
       </p:sp>
       <p:sp>
         <p:nvSpPr>
-          <p:cNvPr id="15" name="layer-1"/>
-          <p:cNvSpPr/>
-          <p:nvPr/>
-        </p:nvSpPr>
-        <p:spPr>
-          <a:xfrm>
-            <a:off x="548640" y="2788920"/>
-            <a:ext cx="11094415" cy="914400"/>
+          <p:cNvPr id="35" name="wire-label-113"/>
+          <p:cNvSpPr txBox="1"/>
+          <p:nvPr/>
+        </p:nvSpPr>
+        <p:spPr>
+          <a:xfrm>
+            <a:off x="1600200" y="3931920"/>
+            <a:ext cx="502920" cy="201168"/>
+          </a:xfrm>
+          <a:prstGeom prst="rect">
+            <a:avLst/>
+          </a:prstGeom>
+          <a:noFill/>
+          <a:ln/>
+        </p:spPr>
+        <p:txBody>
+          <a:bodyPr wrap="square" lIns="0" tIns="0" rIns="0" bIns="0" rtlCol="0" anchor="ctr"/>
+          <a:lstStyle/>
+          <a:p>
+            <a:pPr algn="ctr" indent="0" marL="0">
+              <a:buNone/>
+            </a:pPr>
+            <a:r>
+              <a:rPr lang="en-US" sz="900" i="1" dirty="0">
+                <a:solidFill>
+                  <a:schemeClr val="tx2"/>
+                </a:solidFill>
+              </a:rPr>
+              <a:t>HTTPS</a:t>
+            </a:r>
+            <a:endParaRPr lang="en-US" sz="900" dirty="0"/>
+          </a:p>
+        </p:txBody>
+      </p:sp>
+      <p:sp>
+        <p:nvSpPr>
+          <p:cNvPr id="36" name="zone-backend"/>
+          <p:cNvSpPr/>
+          <p:nvPr/>
+        </p:nvSpPr>
+        <p:spPr>
+          <a:xfrm>
+            <a:off x="4572000" y="1691640"/>
+            <a:ext cx="4647895" cy="4480560"/>
           </a:xfrm>
           <a:prstGeom prst="roundRect">
             <a:avLst>
-              <a:gd name="adj" fmla="val 10000"/>
+              <a:gd name="adj" fmla="val 2041"/>
             </a:avLst>
           </a:prstGeom>
           <a:solidFill>
             <a:schemeClr val="bg1"/>
           </a:solidFill>
-          <a:ln w="6350">
+          <a:ln w="9525">
             <a:solidFill>
               <a:schemeClr val="tx2">
-                <a:alpha val="30000"/>
+                <a:alpha val="45000"/>
               </a:schemeClr>
             </a:solidFill>
             <a:prstDash val="solid"/>
@@ -9181,14 +9762,14 @@
       </p:sp>
       <p:sp>
         <p:nvSpPr>
-          <p:cNvPr id="16" name="layer-1-label"/>
-          <p:cNvSpPr txBox="1"/>
-          <p:nvPr/>
-        </p:nvSpPr>
-        <p:spPr>
-          <a:xfrm>
-            <a:off x="731520" y="2880360"/>
-            <a:ext cx="1554480" cy="731520"/>
+          <p:cNvPr id="37" name="zone-backend-head"/>
+          <p:cNvSpPr txBox="1"/>
+          <p:nvPr/>
+        </p:nvSpPr>
+        <p:spPr>
+          <a:xfrm>
+            <a:off x="4709160" y="1764792"/>
+            <a:ext cx="4373575" cy="457200"/>
           </a:xfrm>
           <a:prstGeom prst="rect">
             <a:avLst/>
@@ -9204,45 +9785,281 @@
               <a:buNone/>
             </a:pPr>
             <a:r>
-              <a:rPr lang="en-US" sz="1400" b="1" dirty="0">
+              <a:rPr lang="en-US" sz="1300" b="1" dirty="0">
                 <a:solidFill>
                   <a:schemeClr val="tx1"/>
                 </a:solidFill>
               </a:rPr>
               <a:t>Backend</a:t>
             </a:r>
-            <a:endParaRPr lang="en-US" sz="1400" dirty="0"/>
-          </a:p>
-          <a:p>
-            <a:pPr indent="0" marL="0">
-              <a:buNone/>
-            </a:pPr>
-            <a:r>
-              <a:rPr lang="en-US" sz="1100" dirty="0">
+            <a:endParaRPr lang="en-US" sz="1300" dirty="0"/>
+          </a:p>
+          <a:p>
+            <a:pPr indent="0" marL="0">
+              <a:buNone/>
+            </a:pPr>
+            <a:r>
+              <a:rPr lang="en-US" sz="950" dirty="0">
                 <a:solidFill>
                   <a:schemeClr val="tx2"/>
                 </a:solidFill>
               </a:rPr>
-              <a:t>FastAPI on Render</a:t>
-            </a:r>
-            <a:endParaRPr lang="en-US" sz="1400" dirty="0"/>
-          </a:p>
-        </p:txBody>
-      </p:sp>
-      <p:sp>
-        <p:nvSpPr>
-          <p:cNvPr id="17" name="comp-104"/>
-          <p:cNvSpPr/>
-          <p:nvPr/>
-        </p:nvSpPr>
-        <p:spPr>
-          <a:xfrm>
-            <a:off x="2423160" y="2889504"/>
-            <a:ext cx="2181530" cy="713232"/>
+              <a:t>Render · Docker · FastAPI · Python 3.11, async</a:t>
+            </a:r>
+            <a:endParaRPr lang="en-US" sz="1300" dirty="0"/>
+          </a:p>
+        </p:txBody>
+      </p:sp>
+      <p:sp>
+        <p:nvSpPr>
+          <p:cNvPr id="38" name="box-114"/>
+          <p:cNvSpPr/>
+          <p:nvPr/>
+        </p:nvSpPr>
+        <p:spPr>
+          <a:xfrm>
+            <a:off x="4709160" y="2331720"/>
+            <a:ext cx="1371600" cy="1325880"/>
           </a:xfrm>
           <a:prstGeom prst="roundRect">
             <a:avLst>
-              <a:gd name="adj" fmla="val 8974"/>
+              <a:gd name="adj" fmla="val 4828"/>
+            </a:avLst>
+          </a:prstGeom>
+          <a:solidFill>
+            <a:schemeClr val="bg2"/>
+          </a:solidFill>
+          <a:ln/>
+        </p:spPr>
+      </p:sp>
+      <p:pic>
+        <p:nvPicPr>
+          <p:cNvPr id="39" name="box-icon-115" descr="preencoded.png">    </p:cNvPr>
+          <p:cNvPicPr>
+            <a:picLocks noChangeAspect="1"/>
+          </p:cNvPicPr>
+          <p:nvPr/>
+        </p:nvPicPr>
+        <p:blipFill>
+          <a:blip r:embed="rId8"/>
+          <a:stretch>
+            <a:fillRect/>
+          </a:stretch>
+        </p:blipFill>
+        <p:spPr>
+          <a:xfrm>
+            <a:off x="4800600" y="2423160"/>
+            <a:ext cx="219456" cy="219456"/>
+          </a:xfrm>
+          <a:prstGeom prst="rect">
+            <a:avLst/>
+          </a:prstGeom>
+        </p:spPr>
+      </p:pic>
+      <p:sp>
+        <p:nvSpPr>
+          <p:cNvPr id="40" name="box-title-116"/>
+          <p:cNvSpPr txBox="1"/>
+          <p:nvPr/>
+        </p:nvSpPr>
+        <p:spPr>
+          <a:xfrm>
+            <a:off x="5074920" y="2395728"/>
+            <a:ext cx="932688" cy="274320"/>
+          </a:xfrm>
+          <a:prstGeom prst="rect">
+            <a:avLst/>
+          </a:prstGeom>
+          <a:noFill/>
+          <a:ln/>
+        </p:spPr>
+        <p:txBody>
+          <a:bodyPr wrap="square" lIns="0" tIns="0" rIns="0" bIns="0" rtlCol="0" anchor="ctr"/>
+          <a:lstStyle/>
+          <a:p>
+            <a:pPr indent="0" marL="0">
+              <a:buNone/>
+            </a:pPr>
+            <a:r>
+              <a:rPr lang="en-US" sz="1150" b="1" dirty="0">
+                <a:solidFill>
+                  <a:schemeClr val="tx1"/>
+                </a:solidFill>
+              </a:rPr>
+              <a:t>REST API</a:t>
+            </a:r>
+            <a:endParaRPr lang="en-US" sz="1150" dirty="0"/>
+          </a:p>
+        </p:txBody>
+      </p:sp>
+      <p:sp>
+        <p:nvSpPr>
+          <p:cNvPr id="41" name="box-sub-117"/>
+          <p:cNvSpPr txBox="1"/>
+          <p:nvPr/>
+        </p:nvSpPr>
+        <p:spPr>
+          <a:xfrm>
+            <a:off x="4800600" y="2697480"/>
+            <a:ext cx="1188720" cy="905256"/>
+          </a:xfrm>
+          <a:prstGeom prst="rect">
+            <a:avLst/>
+          </a:prstGeom>
+          <a:noFill/>
+          <a:ln/>
+        </p:spPr>
+        <p:txBody>
+          <a:bodyPr wrap="square" lIns="0" tIns="0" rIns="0" bIns="0" rtlCol="0" anchor="t"/>
+          <a:lstStyle/>
+          <a:p>
+            <a:pPr indent="0" marL="0">
+              <a:buNone/>
+            </a:pPr>
+            <a:r>
+              <a:rPr lang="en-US" sz="950" dirty="0">
+                <a:solidFill>
+                  <a:schemeClr val="tx2"/>
+                </a:solidFill>
+              </a:rPr>
+              <a:t>cases, responses, decisions, l2, golden run</a:t>
+            </a:r>
+            <a:endParaRPr lang="en-US" sz="950" dirty="0"/>
+          </a:p>
+        </p:txBody>
+      </p:sp>
+      <p:sp>
+        <p:nvSpPr>
+          <p:cNvPr id="42" name="box-118"/>
+          <p:cNvSpPr/>
+          <p:nvPr/>
+        </p:nvSpPr>
+        <p:spPr>
+          <a:xfrm>
+            <a:off x="4709160" y="4160520"/>
+            <a:ext cx="1371600" cy="1463040"/>
+          </a:xfrm>
+          <a:prstGeom prst="roundRect">
+            <a:avLst>
+              <a:gd name="adj" fmla="val 4667"/>
+            </a:avLst>
+          </a:prstGeom>
+          <a:solidFill>
+            <a:schemeClr val="bg2"/>
+          </a:solidFill>
+          <a:ln/>
+        </p:spPr>
+      </p:sp>
+      <p:pic>
+        <p:nvPicPr>
+          <p:cNvPr id="43" name="box-icon-119" descr="preencoded.png">    </p:cNvPr>
+          <p:cNvPicPr>
+            <a:picLocks noChangeAspect="1"/>
+          </p:cNvPicPr>
+          <p:nvPr/>
+        </p:nvPicPr>
+        <p:blipFill>
+          <a:blip r:embed="rId9"/>
+          <a:stretch>
+            <a:fillRect/>
+          </a:stretch>
+        </p:blipFill>
+        <p:spPr>
+          <a:xfrm>
+            <a:off x="4800600" y="4251960"/>
+            <a:ext cx="219456" cy="219456"/>
+          </a:xfrm>
+          <a:prstGeom prst="rect">
+            <a:avLst/>
+          </a:prstGeom>
+        </p:spPr>
+      </p:pic>
+      <p:sp>
+        <p:nvSpPr>
+          <p:cNvPr id="44" name="box-title-120"/>
+          <p:cNvSpPr txBox="1"/>
+          <p:nvPr/>
+        </p:nvSpPr>
+        <p:spPr>
+          <a:xfrm>
+            <a:off x="5074920" y="4224528"/>
+            <a:ext cx="932688" cy="274320"/>
+          </a:xfrm>
+          <a:prstGeom prst="rect">
+            <a:avLst/>
+          </a:prstGeom>
+          <a:noFill/>
+          <a:ln/>
+        </p:spPr>
+        <p:txBody>
+          <a:bodyPr wrap="square" lIns="0" tIns="0" rIns="0" bIns="0" rtlCol="0" anchor="ctr"/>
+          <a:lstStyle/>
+          <a:p>
+            <a:pPr indent="0" marL="0">
+              <a:buNone/>
+            </a:pPr>
+            <a:r>
+              <a:rPr lang="en-US" sz="1150" b="1" dirty="0">
+                <a:solidFill>
+                  <a:schemeClr val="tx1"/>
+                </a:solidFill>
+              </a:rPr>
+              <a:t>SSE stream</a:t>
+            </a:r>
+            <a:endParaRPr lang="en-US" sz="1150" dirty="0"/>
+          </a:p>
+        </p:txBody>
+      </p:sp>
+      <p:sp>
+        <p:nvSpPr>
+          <p:cNvPr id="45" name="box-sub-121"/>
+          <p:cNvSpPr txBox="1"/>
+          <p:nvPr/>
+        </p:nvSpPr>
+        <p:spPr>
+          <a:xfrm>
+            <a:off x="4800600" y="4526280"/>
+            <a:ext cx="1188720" cy="1042416"/>
+          </a:xfrm>
+          <a:prstGeom prst="rect">
+            <a:avLst/>
+          </a:prstGeom>
+          <a:noFill/>
+          <a:ln/>
+        </p:spPr>
+        <p:txBody>
+          <a:bodyPr wrap="square" lIns="0" tIns="0" rIns="0" bIns="0" rtlCol="0" anchor="t"/>
+          <a:lstStyle/>
+          <a:p>
+            <a:pPr indent="0" marL="0">
+              <a:buNone/>
+            </a:pPr>
+            <a:r>
+              <a:rPr lang="en-US" sz="950" dirty="0">
+                <a:solidFill>
+                  <a:schemeClr val="tx2"/>
+                </a:solidFill>
+              </a:rPr>
+              <a:t>per case and the L2 queue. Woken by Postgres LISTEN/NOTIFY; resumes from Last-Event-ID</a:t>
+            </a:r>
+            <a:endParaRPr lang="en-US" sz="950" dirty="0"/>
+          </a:p>
+        </p:txBody>
+      </p:sp>
+      <p:sp>
+        <p:nvSpPr>
+          <p:cNvPr id="46" name="box-122"/>
+          <p:cNvSpPr/>
+          <p:nvPr/>
+        </p:nvSpPr>
+        <p:spPr>
+          <a:xfrm>
+            <a:off x="6281928" y="2331720"/>
+            <a:ext cx="1188720" cy="3703320"/>
+          </a:xfrm>
+          <a:prstGeom prst="roundRect">
+            <a:avLst>
+              <a:gd name="adj" fmla="val 5385"/>
             </a:avLst>
           </a:prstGeom>
           <a:solidFill>
@@ -9258,14 +10075,14 @@
       </p:sp>
       <p:sp>
         <p:nvSpPr>
-          <p:cNvPr id="18" name="comp-text-105"/>
-          <p:cNvSpPr txBox="1"/>
-          <p:nvPr/>
-        </p:nvSpPr>
-        <p:spPr>
-          <a:xfrm>
-            <a:off x="2551176" y="2944368"/>
-            <a:ext cx="1925498" cy="603504"/>
+          <p:cNvPr id="47" name="box-title-123"/>
+          <p:cNvSpPr txBox="1"/>
+          <p:nvPr/>
+        </p:nvSpPr>
+        <p:spPr>
+          <a:xfrm>
+            <a:off x="6373368" y="2395728"/>
+            <a:ext cx="1024128" cy="274320"/>
           </a:xfrm>
           <a:prstGeom prst="rect">
             <a:avLst/>
@@ -9281,45 +10098,67 @@
               <a:buNone/>
             </a:pPr>
             <a:r>
-              <a:rPr lang="en-US" sz="1300" b="1" dirty="0">
+              <a:rPr lang="en-US" sz="1150" b="1" dirty="0">
                 <a:solidFill>
                   <a:schemeClr val="tx1"/>
                 </a:solidFill>
               </a:rPr>
               <a:t>Orchestrator</a:t>
             </a:r>
-            <a:endParaRPr lang="en-US" sz="1300" dirty="0"/>
-          </a:p>
-          <a:p>
-            <a:pPr indent="0" marL="0">
-              <a:buNone/>
-            </a:pPr>
-            <a:r>
-              <a:rPr lang="en-US" sz="1100" dirty="0">
+            <a:endParaRPr lang="en-US" sz="1150" dirty="0"/>
+          </a:p>
+        </p:txBody>
+      </p:sp>
+      <p:sp>
+        <p:nvSpPr>
+          <p:cNvPr id="48" name="box-sub-124"/>
+          <p:cNvSpPr txBox="1"/>
+          <p:nvPr/>
+        </p:nvSpPr>
+        <p:spPr>
+          <a:xfrm>
+            <a:off x="6373368" y="2697480"/>
+            <a:ext cx="1005840" cy="3282696"/>
+          </a:xfrm>
+          <a:prstGeom prst="rect">
+            <a:avLst/>
+          </a:prstGeom>
+          <a:noFill/>
+          <a:ln/>
+        </p:spPr>
+        <p:txBody>
+          <a:bodyPr wrap="square" lIns="0" tIns="0" rIns="0" bIns="0" rtlCol="0" anchor="t"/>
+          <a:lstStyle/>
+          <a:p>
+            <a:pPr indent="0" marL="0">
+              <a:buNone/>
+            </a:pPr>
+            <a:r>
+              <a:rPr lang="en-US" sz="950" dirty="0">
                 <a:solidFill>
                   <a:schemeClr val="tx2"/>
                 </a:solidFill>
               </a:rPr>
-              <a:t>wires every step</a:t>
-            </a:r>
-            <a:endParaRPr lang="en-US" sz="1300" dirty="0"/>
-          </a:p>
-        </p:txBody>
-      </p:sp>
-      <p:sp>
-        <p:nvSpPr>
-          <p:cNvPr id="19" name="comp-106"/>
-          <p:cNvSpPr/>
-          <p:nvPr/>
-        </p:nvSpPr>
-        <p:spPr>
-          <a:xfrm>
-            <a:off x="4732706" y="2889504"/>
-            <a:ext cx="2181530" cy="713232"/>
+              <a:t>Case state machine: intake, hearing, final checks, outcome. Writes every step to the trace.</a:t>
+            </a:r>
+            <a:endParaRPr lang="en-US" sz="950" dirty="0"/>
+          </a:p>
+        </p:txBody>
+      </p:sp>
+      <p:sp>
+        <p:nvSpPr>
+          <p:cNvPr id="49" name="box-125"/>
+          <p:cNvSpPr/>
+          <p:nvPr/>
+        </p:nvSpPr>
+        <p:spPr>
+          <a:xfrm>
+            <a:off x="7671816" y="2331720"/>
+            <a:ext cx="1410919" cy="2148840"/>
           </a:xfrm>
           <a:prstGeom prst="roundRect">
             <a:avLst>
-              <a:gd name="adj" fmla="val 8974"/>
+              <a:gd name="adj" fmla="val 4537"/>
             </a:avLst>
           </a:prstGeom>
           <a:solidFill>
@@ -9328,16 +10167,40 @@
           <a:ln/>
         </p:spPr>
       </p:sp>
-      <p:sp>
-        <p:nvSpPr>
-          <p:cNvPr id="20" name="comp-text-107"/>
-          <p:cNvSpPr txBox="1"/>
-          <p:nvPr/>
-        </p:nvSpPr>
-        <p:spPr>
-          <a:xfrm>
-            <a:off x="4860722" y="2944368"/>
-            <a:ext cx="1925498" cy="603504"/>
+      <p:pic>
+        <p:nvPicPr>
+          <p:cNvPr id="50" name="box-icon-126" descr="preencoded.png">    </p:cNvPr>
+          <p:cNvPicPr>
+            <a:picLocks noChangeAspect="1"/>
+          </p:cNvPicPr>
+          <p:nvPr/>
+        </p:nvPicPr>
+        <p:blipFill>
+          <a:blip r:embed="rId10"/>
+          <a:stretch>
+            <a:fillRect/>
+          </a:stretch>
+        </p:blipFill>
+        <p:spPr>
+          <a:xfrm>
+            <a:off x="7763256" y="2423160"/>
+            <a:ext cx="219456" cy="219456"/>
+          </a:xfrm>
+          <a:prstGeom prst="rect">
+            <a:avLst/>
+          </a:prstGeom>
+        </p:spPr>
+      </p:pic>
+      <p:sp>
+        <p:nvSpPr>
+          <p:cNvPr id="51" name="box-title-127"/>
+          <p:cNvSpPr txBox="1"/>
+          <p:nvPr/>
+        </p:nvSpPr>
+        <p:spPr>
+          <a:xfrm>
+            <a:off x="8037576" y="2395728"/>
+            <a:ext cx="972007" cy="274320"/>
           </a:xfrm>
           <a:prstGeom prst="rect">
             <a:avLst/>
@@ -9353,45 +10216,67 @@
               <a:buNone/>
             </a:pPr>
             <a:r>
-              <a:rPr lang="en-US" sz="1300" b="1" dirty="0">
+              <a:rPr lang="en-US" sz="1150" b="1" dirty="0">
                 <a:solidFill>
                   <a:schemeClr val="bg1"/>
                 </a:solidFill>
               </a:rPr>
-              <a:t>5 AI agents</a:t>
-            </a:r>
-            <a:endParaRPr lang="en-US" sz="1300" dirty="0"/>
-          </a:p>
-          <a:p>
-            <a:pPr indent="0" marL="0">
-              <a:buNone/>
-            </a:pPr>
-            <a:r>
-              <a:rPr lang="en-US" sz="1100" dirty="0">
+              <a:t>AI agents</a:t>
+            </a:r>
+            <a:endParaRPr lang="en-US" sz="1150" dirty="0"/>
+          </a:p>
+        </p:txBody>
+      </p:sp>
+      <p:sp>
+        <p:nvSpPr>
+          <p:cNvPr id="52" name="box-sub-128"/>
+          <p:cNvSpPr txBox="1"/>
+          <p:nvPr/>
+        </p:nvSpPr>
+        <p:spPr>
+          <a:xfrm>
+            <a:off x="7763256" y="2697480"/>
+            <a:ext cx="1228039" cy="1728216"/>
+          </a:xfrm>
+          <a:prstGeom prst="rect">
+            <a:avLst/>
+          </a:prstGeom>
+          <a:noFill/>
+          <a:ln/>
+        </p:spPr>
+        <p:txBody>
+          <a:bodyPr wrap="square" lIns="0" tIns="0" rIns="0" bIns="0" rtlCol="0" anchor="t"/>
+          <a:lstStyle/>
+          <a:p>
+            <a:pPr indent="0" marL="0">
+              <a:buNone/>
+            </a:pPr>
+            <a:r>
+              <a:rPr lang="en-US" sz="950" dirty="0">
                 <a:solidFill>
                   <a:schemeClr val="bg2"/>
                 </a:solidFill>
               </a:rPr>
-              <a:t>pydantic-ai, typed output</a:t>
-            </a:r>
-            <a:endParaRPr lang="en-US" sz="1300" dirty="0"/>
-          </a:p>
-        </p:txBody>
-      </p:sp>
-      <p:sp>
-        <p:nvSpPr>
-          <p:cNvPr id="21" name="comp-108"/>
-          <p:cNvSpPr/>
-          <p:nvPr/>
-        </p:nvSpPr>
-        <p:spPr>
-          <a:xfrm>
-            <a:off x="7042252" y="2889504"/>
-            <a:ext cx="2181530" cy="713232"/>
+              <a:t>pydantic-ai: Triage, Evidence Collection, Rider and Driver advocates, Judge, plus Image Analysis. Typed output; citations checked in code.</a:t>
+            </a:r>
+            <a:endParaRPr lang="en-US" sz="950" dirty="0"/>
+          </a:p>
+        </p:txBody>
+      </p:sp>
+      <p:sp>
+        <p:nvSpPr>
+          <p:cNvPr id="53" name="box-129"/>
+          <p:cNvSpPr/>
+          <p:nvPr/>
+        </p:nvSpPr>
+        <p:spPr>
+          <a:xfrm>
+            <a:off x="7671816" y="4663440"/>
+            <a:ext cx="1410919" cy="1371600"/>
           </a:xfrm>
           <a:prstGeom prst="roundRect">
             <a:avLst>
-              <a:gd name="adj" fmla="val 8974"/>
+              <a:gd name="adj" fmla="val 4667"/>
             </a:avLst>
           </a:prstGeom>
           <a:solidFill>
@@ -9405,16 +10290,40 @@
           </a:ln>
         </p:spPr>
       </p:sp>
-      <p:sp>
-        <p:nvSpPr>
-          <p:cNvPr id="22" name="comp-text-109"/>
-          <p:cNvSpPr txBox="1"/>
-          <p:nvPr/>
-        </p:nvSpPr>
-        <p:spPr>
-          <a:xfrm>
-            <a:off x="7170268" y="2944368"/>
-            <a:ext cx="1925498" cy="603504"/>
+      <p:pic>
+        <p:nvPicPr>
+          <p:cNvPr id="54" name="box-icon-130" descr="preencoded.png">    </p:cNvPr>
+          <p:cNvPicPr>
+            <a:picLocks noChangeAspect="1"/>
+          </p:cNvPicPr>
+          <p:nvPr/>
+        </p:nvPicPr>
+        <p:blipFill>
+          <a:blip r:embed="rId11"/>
+          <a:stretch>
+            <a:fillRect/>
+          </a:stretch>
+        </p:blipFill>
+        <p:spPr>
+          <a:xfrm>
+            <a:off x="7763256" y="4754880"/>
+            <a:ext cx="219456" cy="219456"/>
+          </a:xfrm>
+          <a:prstGeom prst="rect">
+            <a:avLst/>
+          </a:prstGeom>
+        </p:spPr>
+      </p:pic>
+      <p:sp>
+        <p:nvSpPr>
+          <p:cNvPr id="55" name="box-title-131"/>
+          <p:cNvSpPr txBox="1"/>
+          <p:nvPr/>
+        </p:nvSpPr>
+        <p:spPr>
+          <a:xfrm>
+            <a:off x="8037576" y="4727448"/>
+            <a:ext cx="972007" cy="274320"/>
           </a:xfrm>
           <a:prstGeom prst="rect">
             <a:avLst/>
@@ -9430,113 +10339,63 @@
               <a:buNone/>
             </a:pPr>
             <a:r>
-              <a:rPr lang="en-US" sz="1300" b="1" dirty="0">
+              <a:rPr lang="en-US" sz="1150" b="1" dirty="0">
                 <a:solidFill>
                   <a:schemeClr val="tx1"/>
                 </a:solidFill>
               </a:rPr>
-              <a:t>Rules</a:t>
-            </a:r>
-            <a:endParaRPr lang="en-US" sz="1300" dirty="0"/>
-          </a:p>
-          <a:p>
-            <a:pPr indent="0" marL="0">
-              <a:buNone/>
-            </a:pPr>
-            <a:r>
-              <a:rPr lang="en-US" sz="1100" dirty="0">
+              <a:t>Rules · no AI</a:t>
+            </a:r>
+            <a:endParaRPr lang="en-US" sz="1150" dirty="0"/>
+          </a:p>
+        </p:txBody>
+      </p:sp>
+      <p:sp>
+        <p:nvSpPr>
+          <p:cNvPr id="56" name="box-sub-132"/>
+          <p:cNvSpPr txBox="1"/>
+          <p:nvPr/>
+        </p:nvSpPr>
+        <p:spPr>
+          <a:xfrm>
+            <a:off x="7763256" y="5029200"/>
+            <a:ext cx="1228039" cy="950976"/>
+          </a:xfrm>
+          <a:prstGeom prst="rect">
+            <a:avLst/>
+          </a:prstGeom>
+          <a:noFill/>
+          <a:ln/>
+        </p:spPr>
+        <p:txBody>
+          <a:bodyPr wrap="square" lIns="0" tIns="0" rIns="0" bIns="0" rtlCol="0" anchor="t"/>
+          <a:lstStyle/>
+          <a:p>
+            <a:pPr indent="0" marL="0">
+              <a:buNone/>
+            </a:pPr>
+            <a:r>
+              <a:rPr lang="en-US" sz="950" dirty="0">
                 <a:solidFill>
                   <a:schemeClr val="tx2"/>
                 </a:solidFill>
               </a:rPr>
-              <a:t>checks with no AI</a:t>
-            </a:r>
-            <a:endParaRPr lang="en-US" sz="1300" dirty="0"/>
-          </a:p>
-        </p:txBody>
-      </p:sp>
-      <p:sp>
-        <p:nvSpPr>
-          <p:cNvPr id="23" name="comp-110"/>
-          <p:cNvSpPr/>
-          <p:nvPr/>
-        </p:nvSpPr>
-        <p:spPr>
-          <a:xfrm>
-            <a:off x="9351797" y="2889504"/>
-            <a:ext cx="2181530" cy="713232"/>
-          </a:xfrm>
-          <a:prstGeom prst="roundRect">
-            <a:avLst>
-              <a:gd name="adj" fmla="val 8974"/>
-            </a:avLst>
-          </a:prstGeom>
-          <a:solidFill>
-            <a:schemeClr val="bg2"/>
-          </a:solidFill>
-          <a:ln/>
-        </p:spPr>
-      </p:sp>
-      <p:sp>
-        <p:nvSpPr>
-          <p:cNvPr id="24" name="comp-text-111"/>
-          <p:cNvSpPr txBox="1"/>
-          <p:nvPr/>
-        </p:nvSpPr>
-        <p:spPr>
-          <a:xfrm>
-            <a:off x="9479813" y="2944368"/>
-            <a:ext cx="1925498" cy="603504"/>
-          </a:xfrm>
-          <a:prstGeom prst="rect">
-            <a:avLst/>
-          </a:prstGeom>
-          <a:noFill/>
-          <a:ln/>
-        </p:spPr>
-        <p:txBody>
-          <a:bodyPr wrap="square" lIns="0" tIns="0" rIns="0" bIns="0" rtlCol="0" anchor="ctr"/>
-          <a:lstStyle/>
-          <a:p>
-            <a:pPr indent="0" marL="0">
-              <a:buNone/>
-            </a:pPr>
-            <a:r>
-              <a:rPr lang="en-US" sz="1300" b="1" dirty="0">
-                <a:solidFill>
-                  <a:schemeClr val="tx1"/>
-                </a:solidFill>
-              </a:rPr>
-              <a:t>Tools</a:t>
-            </a:r>
-            <a:endParaRPr lang="en-US" sz="1300" dirty="0"/>
-          </a:p>
-          <a:p>
-            <a:pPr indent="0" marL="0">
-              <a:buNone/>
-            </a:pPr>
-            <a:r>
-              <a:rPr lang="en-US" sz="1100" dirty="0">
-                <a:solidFill>
-                  <a:schemeClr val="tx2"/>
-                </a:solidFill>
-              </a:rPr>
-              <a:t>evidence, policy, photos</a:t>
-            </a:r>
-            <a:endParaRPr lang="en-US" sz="1300" dirty="0"/>
-          </a:p>
-        </p:txBody>
-      </p:sp>
-      <p:sp>
-        <p:nvSpPr>
-          <p:cNvPr id="25" name="arrow-112"/>
-          <p:cNvSpPr/>
-          <p:nvPr/>
-        </p:nvSpPr>
-        <p:spPr>
-          <a:xfrm>
-            <a:off x="6978244" y="3703320"/>
-            <a:ext cx="0" cy="182880"/>
+              <a:t>prevention, escalation gate, compliance, policy maths</a:t>
+            </a:r>
+            <a:endParaRPr lang="en-US" sz="950" dirty="0"/>
+          </a:p>
+        </p:txBody>
+      </p:sp>
+      <p:sp>
+        <p:nvSpPr>
+          <p:cNvPr id="57" name="arrow-133"/>
+          <p:cNvSpPr/>
+          <p:nvPr/>
+        </p:nvSpPr>
+        <p:spPr>
+          <a:xfrm>
+            <a:off x="4069080" y="2834640"/>
+            <a:ext cx="640080" cy="0"/>
           </a:xfrm>
           <a:prstGeom prst="line">
             <a:avLst/>
@@ -9553,43 +10412,14 @@
       </p:sp>
       <p:sp>
         <p:nvSpPr>
-          <p:cNvPr id="26" name="layer-2"/>
-          <p:cNvSpPr/>
-          <p:nvPr/>
-        </p:nvSpPr>
-        <p:spPr>
-          <a:xfrm>
-            <a:off x="548640" y="3886200"/>
-            <a:ext cx="11094415" cy="914400"/>
-          </a:xfrm>
-          <a:prstGeom prst="roundRect">
-            <a:avLst>
-              <a:gd name="adj" fmla="val 10000"/>
-            </a:avLst>
-          </a:prstGeom>
-          <a:solidFill>
-            <a:schemeClr val="bg1"/>
-          </a:solidFill>
-          <a:ln w="6350">
-            <a:solidFill>
-              <a:schemeClr val="tx2">
-                <a:alpha val="30000"/>
-              </a:schemeClr>
-            </a:solidFill>
-            <a:prstDash val="solid"/>
-          </a:ln>
-        </p:spPr>
-      </p:sp>
-      <p:sp>
-        <p:nvSpPr>
-          <p:cNvPr id="27" name="layer-2-label"/>
-          <p:cNvSpPr txBox="1"/>
-          <p:nvPr/>
-        </p:nvSpPr>
-        <p:spPr>
-          <a:xfrm>
-            <a:off x="731520" y="3977640"/>
-            <a:ext cx="1554480" cy="731520"/>
+          <p:cNvPr id="58" name="wire-label-134"/>
+          <p:cNvSpPr txBox="1"/>
+          <p:nvPr/>
+        </p:nvSpPr>
+        <p:spPr>
+          <a:xfrm>
+            <a:off x="3977640" y="2560320"/>
+            <a:ext cx="685800" cy="201168"/>
           </a:xfrm>
           <a:prstGeom prst="rect">
             <a:avLst/>
@@ -9601,189 +10431,31 @@
           <a:bodyPr wrap="square" lIns="0" tIns="0" rIns="0" bIns="0" rtlCol="0" anchor="ctr"/>
           <a:lstStyle/>
           <a:p>
-            <a:pPr indent="0" marL="0">
-              <a:buNone/>
-            </a:pPr>
-            <a:r>
-              <a:rPr lang="en-US" sz="1400" b="1" dirty="0">
-                <a:solidFill>
-                  <a:schemeClr val="tx1"/>
-                </a:solidFill>
-              </a:rPr>
-              <a:t>Data</a:t>
-            </a:r>
-            <a:endParaRPr lang="en-US" sz="1400" dirty="0"/>
-          </a:p>
-          <a:p>
-            <a:pPr indent="0" marL="0">
-              <a:buNone/>
-            </a:pPr>
-            <a:r>
-              <a:rPr lang="en-US" sz="1100" dirty="0">
+            <a:pPr algn="ctr" indent="0" marL="0">
+              <a:buNone/>
+            </a:pPr>
+            <a:r>
+              <a:rPr lang="en-US" sz="900" i="1" dirty="0">
                 <a:solidFill>
                   <a:schemeClr val="tx2"/>
                 </a:solidFill>
               </a:rPr>
-              <a:t>Neon</a:t>
-            </a:r>
-            <a:endParaRPr lang="en-US" sz="1400" dirty="0"/>
-          </a:p>
-        </p:txBody>
-      </p:sp>
-      <p:sp>
-        <p:nvSpPr>
-          <p:cNvPr id="28" name="comp-113"/>
-          <p:cNvSpPr/>
-          <p:nvPr/>
-        </p:nvSpPr>
-        <p:spPr>
-          <a:xfrm>
-            <a:off x="2423160" y="3986784"/>
-            <a:ext cx="4491076" cy="713232"/>
-          </a:xfrm>
-          <a:prstGeom prst="roundRect">
-            <a:avLst>
-              <a:gd name="adj" fmla="val 8974"/>
-            </a:avLst>
-          </a:prstGeom>
-          <a:solidFill>
-            <a:schemeClr val="bg2"/>
-          </a:solidFill>
-          <a:ln/>
-        </p:spPr>
-      </p:sp>
-      <p:sp>
-        <p:nvSpPr>
-          <p:cNvPr id="29" name="comp-text-114"/>
-          <p:cNvSpPr txBox="1"/>
-          <p:nvPr/>
-        </p:nvSpPr>
-        <p:spPr>
-          <a:xfrm>
-            <a:off x="2551176" y="4041648"/>
-            <a:ext cx="4235044" cy="603504"/>
-          </a:xfrm>
-          <a:prstGeom prst="rect">
-            <a:avLst/>
-          </a:prstGeom>
-          <a:noFill/>
-          <a:ln/>
-        </p:spPr>
-        <p:txBody>
-          <a:bodyPr wrap="square" lIns="0" tIns="0" rIns="0" bIns="0" rtlCol="0" anchor="ctr"/>
-          <a:lstStyle/>
-          <a:p>
-            <a:pPr indent="0" marL="0">
-              <a:buNone/>
-            </a:pPr>
-            <a:r>
-              <a:rPr lang="en-US" sz="1300" b="1" dirty="0">
-                <a:solidFill>
-                  <a:schemeClr val="tx1"/>
-                </a:solidFill>
-              </a:rPr>
-              <a:t>Postgres + pgvector</a:t>
-            </a:r>
-            <a:endParaRPr lang="en-US" sz="1300" dirty="0"/>
-          </a:p>
-          <a:p>
-            <a:pPr indent="0" marL="0">
-              <a:buNone/>
-            </a:pPr>
-            <a:r>
-              <a:rPr lang="en-US" sz="1100" dirty="0">
-                <a:solidFill>
-                  <a:schemeClr val="tx2"/>
-                </a:solidFill>
-              </a:rPr>
-              <a:t>cases, evidence, trace</a:t>
-            </a:r>
-            <a:endParaRPr lang="en-US" sz="1300" dirty="0"/>
-          </a:p>
-        </p:txBody>
-      </p:sp>
-      <p:sp>
-        <p:nvSpPr>
-          <p:cNvPr id="30" name="comp-115"/>
-          <p:cNvSpPr/>
-          <p:nvPr/>
-        </p:nvSpPr>
-        <p:spPr>
-          <a:xfrm>
-            <a:off x="7042252" y="3986784"/>
-            <a:ext cx="4491076" cy="713232"/>
-          </a:xfrm>
-          <a:prstGeom prst="roundRect">
-            <a:avLst>
-              <a:gd name="adj" fmla="val 8974"/>
-            </a:avLst>
-          </a:prstGeom>
-          <a:solidFill>
-            <a:schemeClr val="bg2"/>
-          </a:solidFill>
-          <a:ln/>
-        </p:spPr>
-      </p:sp>
-      <p:sp>
-        <p:nvSpPr>
-          <p:cNvPr id="31" name="comp-text-116"/>
-          <p:cNvSpPr txBox="1"/>
-          <p:nvPr/>
-        </p:nvSpPr>
-        <p:spPr>
-          <a:xfrm>
-            <a:off x="7170268" y="4041648"/>
-            <a:ext cx="4235044" cy="603504"/>
-          </a:xfrm>
-          <a:prstGeom prst="rect">
-            <a:avLst/>
-          </a:prstGeom>
-          <a:noFill/>
-          <a:ln/>
-        </p:spPr>
-        <p:txBody>
-          <a:bodyPr wrap="square" lIns="0" tIns="0" rIns="0" bIns="0" rtlCol="0" anchor="ctr"/>
-          <a:lstStyle/>
-          <a:p>
-            <a:pPr indent="0" marL="0">
-              <a:buNone/>
-            </a:pPr>
-            <a:r>
-              <a:rPr lang="en-US" sz="1300" b="1" dirty="0">
-                <a:solidFill>
-                  <a:schemeClr val="tx1"/>
-                </a:solidFill>
-              </a:rPr>
-              <a:t>Object storage</a:t>
-            </a:r>
-            <a:endParaRPr lang="en-US" sz="1300" dirty="0"/>
-          </a:p>
-          <a:p>
-            <a:pPr indent="0" marL="0">
-              <a:buNone/>
-            </a:pPr>
-            <a:r>
-              <a:rPr lang="en-US" sz="1100" dirty="0">
-                <a:solidFill>
-                  <a:schemeClr val="tx2"/>
-                </a:solidFill>
-              </a:rPr>
-              <a:t>evidence photos</a:t>
-            </a:r>
-            <a:endParaRPr lang="en-US" sz="1300" dirty="0"/>
-          </a:p>
-        </p:txBody>
-      </p:sp>
-      <p:sp>
-        <p:nvSpPr>
-          <p:cNvPr id="32" name="arrow-117"/>
-          <p:cNvSpPr/>
-          <p:nvPr/>
-        </p:nvSpPr>
-        <p:spPr>
-          <a:xfrm>
-            <a:off x="6978244" y="4800600"/>
-            <a:ext cx="0" cy="182880"/>
+              <a:t>REST/JSON</a:t>
+            </a:r>
+            <a:endParaRPr lang="en-US" sz="900" dirty="0"/>
+          </a:p>
+        </p:txBody>
+      </p:sp>
+      <p:sp>
+        <p:nvSpPr>
+          <p:cNvPr id="59" name="arrow-135"/>
+          <p:cNvSpPr/>
+          <p:nvPr/>
+        </p:nvSpPr>
+        <p:spPr>
+          <a:xfrm flipH="1">
+            <a:off x="4069080" y="4709160"/>
+            <a:ext cx="640080" cy="0"/>
           </a:xfrm>
           <a:prstGeom prst="line">
             <a:avLst/>
@@ -9800,27 +10472,159 @@
       </p:sp>
       <p:sp>
         <p:nvSpPr>
-          <p:cNvPr id="33" name="layer-3"/>
-          <p:cNvSpPr/>
-          <p:nvPr/>
-        </p:nvSpPr>
-        <p:spPr>
-          <a:xfrm>
-            <a:off x="548640" y="4983480"/>
-            <a:ext cx="11094415" cy="914400"/>
+          <p:cNvPr id="60" name="wire-label-136"/>
+          <p:cNvSpPr txBox="1"/>
+          <p:nvPr/>
+        </p:nvSpPr>
+        <p:spPr>
+          <a:xfrm>
+            <a:off x="3977640" y="4434840"/>
+            <a:ext cx="685800" cy="201168"/>
+          </a:xfrm>
+          <a:prstGeom prst="rect">
+            <a:avLst/>
+          </a:prstGeom>
+          <a:noFill/>
+          <a:ln/>
+        </p:spPr>
+        <p:txBody>
+          <a:bodyPr wrap="square" lIns="0" tIns="0" rIns="0" bIns="0" rtlCol="0" anchor="ctr"/>
+          <a:lstStyle/>
+          <a:p>
+            <a:pPr algn="ctr" indent="0" marL="0">
+              <a:buNone/>
+            </a:pPr>
+            <a:r>
+              <a:rPr lang="en-US" sz="900" i="1" dirty="0">
+                <a:solidFill>
+                  <a:schemeClr val="tx2"/>
+                </a:solidFill>
+              </a:rPr>
+              <a:t>SSE</a:t>
+            </a:r>
+            <a:endParaRPr lang="en-US" sz="900" dirty="0"/>
+          </a:p>
+        </p:txBody>
+      </p:sp>
+      <p:sp>
+        <p:nvSpPr>
+          <p:cNvPr id="61" name="arrow-137"/>
+          <p:cNvSpPr/>
+          <p:nvPr/>
+        </p:nvSpPr>
+        <p:spPr>
+          <a:xfrm>
+            <a:off x="6080760" y="2834640"/>
+            <a:ext cx="201168" cy="0"/>
+          </a:xfrm>
+          <a:prstGeom prst="line">
+            <a:avLst/>
+          </a:prstGeom>
+          <a:noFill/>
+          <a:ln w="19050">
+            <a:solidFill>
+              <a:schemeClr val="tx2"/>
+            </a:solidFill>
+            <a:prstDash val="solid"/>
+            <a:tailEnd type="triangle"/>
+          </a:ln>
+        </p:spPr>
+      </p:sp>
+      <p:sp>
+        <p:nvSpPr>
+          <p:cNvPr id="62" name="arrow-138"/>
+          <p:cNvSpPr/>
+          <p:nvPr/>
+        </p:nvSpPr>
+        <p:spPr>
+          <a:xfrm>
+            <a:off x="7470648" y="3246120"/>
+            <a:ext cx="201168" cy="0"/>
+          </a:xfrm>
+          <a:prstGeom prst="line">
+            <a:avLst/>
+          </a:prstGeom>
+          <a:noFill/>
+          <a:ln w="19050">
+            <a:solidFill>
+              <a:schemeClr val="tx2"/>
+            </a:solidFill>
+            <a:prstDash val="solid"/>
+            <a:tailEnd type="triangle"/>
+          </a:ln>
+        </p:spPr>
+      </p:sp>
+      <p:sp>
+        <p:nvSpPr>
+          <p:cNvPr id="63" name="arrow-139"/>
+          <p:cNvSpPr/>
+          <p:nvPr/>
+        </p:nvSpPr>
+        <p:spPr>
+          <a:xfrm>
+            <a:off x="7470648" y="5349240"/>
+            <a:ext cx="201168" cy="0"/>
+          </a:xfrm>
+          <a:prstGeom prst="line">
+            <a:avLst/>
+          </a:prstGeom>
+          <a:noFill/>
+          <a:ln w="19050">
+            <a:solidFill>
+              <a:schemeClr val="tx2"/>
+            </a:solidFill>
+            <a:prstDash val="solid"/>
+            <a:tailEnd type="triangle"/>
+          </a:ln>
+        </p:spPr>
+      </p:sp>
+      <p:sp>
+        <p:nvSpPr>
+          <p:cNvPr id="64" name="arrow-140"/>
+          <p:cNvSpPr/>
+          <p:nvPr/>
+        </p:nvSpPr>
+        <p:spPr>
+          <a:xfrm flipH="1">
+            <a:off x="6080760" y="4709160"/>
+            <a:ext cx="201168" cy="0"/>
+          </a:xfrm>
+          <a:prstGeom prst="line">
+            <a:avLst/>
+          </a:prstGeom>
+          <a:noFill/>
+          <a:ln w="19050">
+            <a:solidFill>
+              <a:schemeClr val="tx2"/>
+            </a:solidFill>
+            <a:prstDash val="solid"/>
+            <a:tailEnd type="triangle"/>
+          </a:ln>
+        </p:spPr>
+      </p:sp>
+      <p:sp>
+        <p:nvSpPr>
+          <p:cNvPr id="65" name="zone-data"/>
+          <p:cNvSpPr/>
+          <p:nvPr/>
+        </p:nvSpPr>
+        <p:spPr>
+          <a:xfrm>
+            <a:off x="9677095" y="1691640"/>
+            <a:ext cx="1965960" cy="2103120"/>
           </a:xfrm>
           <a:prstGeom prst="roundRect">
             <a:avLst>
-              <a:gd name="adj" fmla="val 10000"/>
+              <a:gd name="adj" fmla="val 4651"/>
             </a:avLst>
           </a:prstGeom>
           <a:solidFill>
             <a:schemeClr val="bg1"/>
           </a:solidFill>
-          <a:ln w="6350">
+          <a:ln w="9525">
             <a:solidFill>
               <a:schemeClr val="tx2">
-                <a:alpha val="30000"/>
+                <a:alpha val="45000"/>
               </a:schemeClr>
             </a:solidFill>
             <a:prstDash val="solid"/>
@@ -9829,14 +10633,14 @@
       </p:sp>
       <p:sp>
         <p:nvSpPr>
-          <p:cNvPr id="34" name="layer-3-label"/>
-          <p:cNvSpPr txBox="1"/>
-          <p:nvPr/>
-        </p:nvSpPr>
-        <p:spPr>
-          <a:xfrm>
-            <a:off x="731520" y="5074920"/>
-            <a:ext cx="1554480" cy="731520"/>
+          <p:cNvPr id="66" name="zone-data-head"/>
+          <p:cNvSpPr txBox="1"/>
+          <p:nvPr/>
+        </p:nvSpPr>
+        <p:spPr>
+          <a:xfrm>
+            <a:off x="9814255" y="1764792"/>
+            <a:ext cx="1691640" cy="457200"/>
           </a:xfrm>
           <a:prstGeom prst="rect">
             <a:avLst/>
@@ -9852,45 +10656,45 @@
               <a:buNone/>
             </a:pPr>
             <a:r>
-              <a:rPr lang="en-US" sz="1400" b="1" dirty="0">
+              <a:rPr lang="en-US" sz="1300" b="1" dirty="0">
                 <a:solidFill>
                   <a:schemeClr val="tx1"/>
                 </a:solidFill>
               </a:rPr>
-              <a:t>Services</a:t>
-            </a:r>
-            <a:endParaRPr lang="en-US" sz="1400" dirty="0"/>
-          </a:p>
-          <a:p>
-            <a:pPr indent="0" marL="0">
-              <a:buNone/>
-            </a:pPr>
-            <a:r>
-              <a:rPr lang="en-US" sz="1100" dirty="0">
+              <a:t>Data</a:t>
+            </a:r>
+            <a:endParaRPr lang="en-US" sz="1300" dirty="0"/>
+          </a:p>
+          <a:p>
+            <a:pPr indent="0" marL="0">
+              <a:buNone/>
+            </a:pPr>
+            <a:r>
+              <a:rPr lang="en-US" sz="950" dirty="0">
                 <a:solidFill>
                   <a:schemeClr val="tx2"/>
                 </a:solidFill>
               </a:rPr>
-              <a:t>external</a:t>
-            </a:r>
-            <a:endParaRPr lang="en-US" sz="1400" dirty="0"/>
-          </a:p>
-        </p:txBody>
-      </p:sp>
-      <p:sp>
-        <p:nvSpPr>
-          <p:cNvPr id="35" name="comp-118"/>
-          <p:cNvSpPr/>
-          <p:nvPr/>
-        </p:nvSpPr>
-        <p:spPr>
-          <a:xfrm>
-            <a:off x="2423160" y="5084064"/>
-            <a:ext cx="2951378" cy="713232"/>
+              <a:t>Neon · one project</a:t>
+            </a:r>
+            <a:endParaRPr lang="en-US" sz="1300" dirty="0"/>
+          </a:p>
+        </p:txBody>
+      </p:sp>
+      <p:sp>
+        <p:nvSpPr>
+          <p:cNvPr id="67" name="box-141"/>
+          <p:cNvSpPr/>
+          <p:nvPr/>
+        </p:nvSpPr>
+        <p:spPr>
+          <a:xfrm>
+            <a:off x="9786823" y="2258568"/>
+            <a:ext cx="1746504" cy="749808"/>
           </a:xfrm>
           <a:prstGeom prst="roundRect">
             <a:avLst>
-              <a:gd name="adj" fmla="val 8974"/>
+              <a:gd name="adj" fmla="val 8537"/>
             </a:avLst>
           </a:prstGeom>
           <a:solidFill>
@@ -9899,16 +10703,40 @@
           <a:ln/>
         </p:spPr>
       </p:sp>
-      <p:sp>
-        <p:nvSpPr>
-          <p:cNvPr id="36" name="comp-text-119"/>
-          <p:cNvSpPr txBox="1"/>
-          <p:nvPr/>
-        </p:nvSpPr>
-        <p:spPr>
-          <a:xfrm>
-            <a:off x="2551176" y="5138928"/>
-            <a:ext cx="2695346" cy="603504"/>
+      <p:pic>
+        <p:nvPicPr>
+          <p:cNvPr id="68" name="box-icon-142" descr="preencoded.png">    </p:cNvPr>
+          <p:cNvPicPr>
+            <a:picLocks noChangeAspect="1"/>
+          </p:cNvPicPr>
+          <p:nvPr/>
+        </p:nvPicPr>
+        <p:blipFill>
+          <a:blip r:embed="rId12"/>
+          <a:stretch>
+            <a:fillRect/>
+          </a:stretch>
+        </p:blipFill>
+        <p:spPr>
+          <a:xfrm>
+            <a:off x="9878263" y="2350008"/>
+            <a:ext cx="219456" cy="219456"/>
+          </a:xfrm>
+          <a:prstGeom prst="rect">
+            <a:avLst/>
+          </a:prstGeom>
+        </p:spPr>
+      </p:pic>
+      <p:sp>
+        <p:nvSpPr>
+          <p:cNvPr id="69" name="box-title-143"/>
+          <p:cNvSpPr txBox="1"/>
+          <p:nvPr/>
+        </p:nvSpPr>
+        <p:spPr>
+          <a:xfrm>
+            <a:off x="10152583" y="2322576"/>
+            <a:ext cx="1307592" cy="274320"/>
           </a:xfrm>
           <a:prstGeom prst="rect">
             <a:avLst/>
@@ -9924,45 +10752,67 @@
               <a:buNone/>
             </a:pPr>
             <a:r>
-              <a:rPr lang="en-US" sz="1300" b="1" dirty="0">
+              <a:rPr lang="en-US" sz="1150" b="1" dirty="0">
                 <a:solidFill>
                   <a:schemeClr val="tx1"/>
                 </a:solidFill>
               </a:rPr>
-              <a:t>DeepInfra</a:t>
-            </a:r>
-            <a:endParaRPr lang="en-US" sz="1300" dirty="0"/>
-          </a:p>
-          <a:p>
-            <a:pPr indent="0" marL="0">
-              <a:buNone/>
-            </a:pPr>
-            <a:r>
-              <a:rPr lang="en-US" sz="1100" dirty="0">
+              <a:t>Postgres</a:t>
+            </a:r>
+            <a:endParaRPr lang="en-US" sz="1150" dirty="0"/>
+          </a:p>
+        </p:txBody>
+      </p:sp>
+      <p:sp>
+        <p:nvSpPr>
+          <p:cNvPr id="70" name="box-sub-144"/>
+          <p:cNvSpPr txBox="1"/>
+          <p:nvPr/>
+        </p:nvSpPr>
+        <p:spPr>
+          <a:xfrm>
+            <a:off x="9878263" y="2624328"/>
+            <a:ext cx="1563624" cy="329184"/>
+          </a:xfrm>
+          <a:prstGeom prst="rect">
+            <a:avLst/>
+          </a:prstGeom>
+          <a:noFill/>
+          <a:ln/>
+        </p:spPr>
+        <p:txBody>
+          <a:bodyPr wrap="square" lIns="0" tIns="0" rIns="0" bIns="0" rtlCol="0" anchor="t"/>
+          <a:lstStyle/>
+          <a:p>
+            <a:pPr indent="0" marL="0">
+              <a:buNone/>
+            </a:pPr>
+            <a:r>
+              <a:rPr lang="en-US" sz="950" dirty="0">
                 <a:solidFill>
                   <a:schemeClr val="tx2"/>
                 </a:solidFill>
               </a:rPr>
-              <a:t>Qwen3-235B, Gemma 4</a:t>
-            </a:r>
-            <a:endParaRPr lang="en-US" sz="1300" dirty="0"/>
-          </a:p>
-        </p:txBody>
-      </p:sp>
-      <p:sp>
-        <p:nvSpPr>
-          <p:cNvPr id="37" name="comp-120"/>
-          <p:cNvSpPr/>
-          <p:nvPr/>
-        </p:nvSpPr>
-        <p:spPr>
-          <a:xfrm>
-            <a:off x="5502554" y="5084064"/>
-            <a:ext cx="2951378" cy="713232"/>
+              <a:t>pgvector. Cases, evidence, trace, decisions, usage</a:t>
+            </a:r>
+            <a:endParaRPr lang="en-US" sz="950" dirty="0"/>
+          </a:p>
+        </p:txBody>
+      </p:sp>
+      <p:sp>
+        <p:nvSpPr>
+          <p:cNvPr id="71" name="box-145"/>
+          <p:cNvSpPr/>
+          <p:nvPr/>
+        </p:nvSpPr>
+        <p:spPr>
+          <a:xfrm>
+            <a:off x="9786823" y="3063240"/>
+            <a:ext cx="1746504" cy="621792"/>
           </a:xfrm>
           <a:prstGeom prst="roundRect">
             <a:avLst>
-              <a:gd name="adj" fmla="val 8974"/>
+              <a:gd name="adj" fmla="val 10294"/>
             </a:avLst>
           </a:prstGeom>
           <a:solidFill>
@@ -9971,16 +10821,40 @@
           <a:ln/>
         </p:spPr>
       </p:sp>
-      <p:sp>
-        <p:nvSpPr>
-          <p:cNvPr id="38" name="comp-text-121"/>
-          <p:cNvSpPr txBox="1"/>
-          <p:nvPr/>
-        </p:nvSpPr>
-        <p:spPr>
-          <a:xfrm>
-            <a:off x="5630570" y="5138928"/>
-            <a:ext cx="2695346" cy="603504"/>
+      <p:pic>
+        <p:nvPicPr>
+          <p:cNvPr id="72" name="box-icon-146" descr="preencoded.png">    </p:cNvPr>
+          <p:cNvPicPr>
+            <a:picLocks noChangeAspect="1"/>
+          </p:cNvPicPr>
+          <p:nvPr/>
+        </p:nvPicPr>
+        <p:blipFill>
+          <a:blip r:embed="rId13"/>
+          <a:stretch>
+            <a:fillRect/>
+          </a:stretch>
+        </p:blipFill>
+        <p:spPr>
+          <a:xfrm>
+            <a:off x="9878263" y="3154680"/>
+            <a:ext cx="219456" cy="219456"/>
+          </a:xfrm>
+          <a:prstGeom prst="rect">
+            <a:avLst/>
+          </a:prstGeom>
+        </p:spPr>
+      </p:pic>
+      <p:sp>
+        <p:nvSpPr>
+          <p:cNvPr id="73" name="box-title-147"/>
+          <p:cNvSpPr txBox="1"/>
+          <p:nvPr/>
+        </p:nvSpPr>
+        <p:spPr>
+          <a:xfrm>
+            <a:off x="10152583" y="3127248"/>
+            <a:ext cx="1307592" cy="274320"/>
           </a:xfrm>
           <a:prstGeom prst="rect">
             <a:avLst/>
@@ -9996,45 +10870,146 @@
               <a:buNone/>
             </a:pPr>
             <a:r>
-              <a:rPr lang="en-US" sz="1300" b="1" dirty="0">
+              <a:rPr lang="en-US" sz="1150" b="1" dirty="0">
                 <a:solidFill>
                   <a:schemeClr val="tx1"/>
                 </a:solidFill>
               </a:rPr>
-              <a:t>Logfire</a:t>
-            </a:r>
-            <a:endParaRPr lang="en-US" sz="1300" dirty="0"/>
-          </a:p>
-          <a:p>
-            <a:pPr indent="0" marL="0">
-              <a:buNone/>
-            </a:pPr>
-            <a:r>
-              <a:rPr lang="en-US" sz="1100" dirty="0">
+              <a:t>Object storage</a:t>
+            </a:r>
+            <a:endParaRPr lang="en-US" sz="1150" dirty="0"/>
+          </a:p>
+        </p:txBody>
+      </p:sp>
+      <p:sp>
+        <p:nvSpPr>
+          <p:cNvPr id="74" name="box-sub-148"/>
+          <p:cNvSpPr txBox="1"/>
+          <p:nvPr/>
+        </p:nvSpPr>
+        <p:spPr>
+          <a:xfrm>
+            <a:off x="9878263" y="3429000"/>
+            <a:ext cx="1563624" cy="201168"/>
+          </a:xfrm>
+          <a:prstGeom prst="rect">
+            <a:avLst/>
+          </a:prstGeom>
+          <a:noFill/>
+          <a:ln/>
+        </p:spPr>
+        <p:txBody>
+          <a:bodyPr wrap="square" lIns="0" tIns="0" rIns="0" bIns="0" rtlCol="0" anchor="t"/>
+          <a:lstStyle/>
+          <a:p>
+            <a:pPr indent="0" marL="0">
+              <a:buNone/>
+            </a:pPr>
+            <a:r>
+              <a:rPr lang="en-US" sz="950" dirty="0">
                 <a:solidFill>
                   <a:schemeClr val="tx2"/>
                 </a:solidFill>
               </a:rPr>
-              <a:t>traces every agent run</a:t>
-            </a:r>
-            <a:endParaRPr lang="en-US" sz="1300" dirty="0"/>
-          </a:p>
-        </p:txBody>
-      </p:sp>
-      <p:sp>
-        <p:nvSpPr>
-          <p:cNvPr id="39" name="comp-122"/>
-          <p:cNvSpPr/>
-          <p:nvPr/>
-        </p:nvSpPr>
-        <p:spPr>
-          <a:xfrm>
-            <a:off x="8581949" y="5084064"/>
-            <a:ext cx="2951378" cy="713232"/>
+              <a:t>evidence photos</a:t>
+            </a:r>
+            <a:endParaRPr lang="en-US" sz="950" dirty="0"/>
+          </a:p>
+        </p:txBody>
+      </p:sp>
+      <p:sp>
+        <p:nvSpPr>
+          <p:cNvPr id="75" name="zone-external"/>
+          <p:cNvSpPr/>
+          <p:nvPr/>
+        </p:nvSpPr>
+        <p:spPr>
+          <a:xfrm>
+            <a:off x="9677095" y="3977640"/>
+            <a:ext cx="1965960" cy="2194560"/>
           </a:xfrm>
           <a:prstGeom prst="roundRect">
             <a:avLst>
-              <a:gd name="adj" fmla="val 8974"/>
+              <a:gd name="adj" fmla="val 4651"/>
+            </a:avLst>
+          </a:prstGeom>
+          <a:solidFill>
+            <a:schemeClr val="bg1"/>
+          </a:solidFill>
+          <a:ln w="9525">
+            <a:solidFill>
+              <a:schemeClr val="tx2">
+                <a:alpha val="45000"/>
+              </a:schemeClr>
+            </a:solidFill>
+            <a:prstDash val="solid"/>
+          </a:ln>
+        </p:spPr>
+      </p:sp>
+      <p:sp>
+        <p:nvSpPr>
+          <p:cNvPr id="76" name="zone-external-head"/>
+          <p:cNvSpPr txBox="1"/>
+          <p:nvPr/>
+        </p:nvSpPr>
+        <p:spPr>
+          <a:xfrm>
+            <a:off x="9814255" y="4050792"/>
+            <a:ext cx="1691640" cy="457200"/>
+          </a:xfrm>
+          <a:prstGeom prst="rect">
+            <a:avLst/>
+          </a:prstGeom>
+          <a:noFill/>
+          <a:ln/>
+        </p:spPr>
+        <p:txBody>
+          <a:bodyPr wrap="square" lIns="0" tIns="0" rIns="0" bIns="0" rtlCol="0" anchor="ctr"/>
+          <a:lstStyle/>
+          <a:p>
+            <a:pPr indent="0" marL="0">
+              <a:buNone/>
+            </a:pPr>
+            <a:r>
+              <a:rPr lang="en-US" sz="1300" b="1" dirty="0">
+                <a:solidFill>
+                  <a:schemeClr val="tx1"/>
+                </a:solidFill>
+              </a:rPr>
+              <a:t>External services</a:t>
+            </a:r>
+            <a:endParaRPr lang="en-US" sz="1300" dirty="0"/>
+          </a:p>
+          <a:p>
+            <a:pPr indent="0" marL="0">
+              <a:buNone/>
+            </a:pPr>
+            <a:r>
+              <a:rPr lang="en-US" sz="950" dirty="0">
+                <a:solidFill>
+                  <a:schemeClr val="tx2"/>
+                </a:solidFill>
+              </a:rPr>
+              <a:t>managed APIs</a:t>
+            </a:r>
+            <a:endParaRPr lang="en-US" sz="1300" dirty="0"/>
+          </a:p>
+        </p:txBody>
+      </p:sp>
+      <p:sp>
+        <p:nvSpPr>
+          <p:cNvPr id="77" name="box-149"/>
+          <p:cNvSpPr/>
+          <p:nvPr/>
+        </p:nvSpPr>
+        <p:spPr>
+          <a:xfrm>
+            <a:off x="9786823" y="4526280"/>
+            <a:ext cx="1746504" cy="768096"/>
+          </a:xfrm>
+          <a:prstGeom prst="roundRect">
+            <a:avLst>
+              <a:gd name="adj" fmla="val 8333"/>
             </a:avLst>
           </a:prstGeom>
           <a:solidFill>
@@ -10043,16 +11018,40 @@
           <a:ln/>
         </p:spPr>
       </p:sp>
-      <p:sp>
-        <p:nvSpPr>
-          <p:cNvPr id="40" name="comp-text-123"/>
-          <p:cNvSpPr txBox="1"/>
-          <p:nvPr/>
-        </p:nvSpPr>
-        <p:spPr>
-          <a:xfrm>
-            <a:off x="8709965" y="5138928"/>
-            <a:ext cx="2695346" cy="603504"/>
+      <p:pic>
+        <p:nvPicPr>
+          <p:cNvPr id="78" name="box-icon-150" descr="preencoded.png">    </p:cNvPr>
+          <p:cNvPicPr>
+            <a:picLocks noChangeAspect="1"/>
+          </p:cNvPicPr>
+          <p:nvPr/>
+        </p:nvPicPr>
+        <p:blipFill>
+          <a:blip r:embed="rId14"/>
+          <a:stretch>
+            <a:fillRect/>
+          </a:stretch>
+        </p:blipFill>
+        <p:spPr>
+          <a:xfrm>
+            <a:off x="9878263" y="4617720"/>
+            <a:ext cx="219456" cy="219456"/>
+          </a:xfrm>
+          <a:prstGeom prst="rect">
+            <a:avLst/>
+          </a:prstGeom>
+        </p:spPr>
+      </p:pic>
+      <p:sp>
+        <p:nvSpPr>
+          <p:cNvPr id="79" name="box-title-151"/>
+          <p:cNvSpPr txBox="1"/>
+          <p:nvPr/>
+        </p:nvSpPr>
+        <p:spPr>
+          <a:xfrm>
+            <a:off x="10152583" y="4590288"/>
+            <a:ext cx="1307592" cy="274320"/>
           </a:xfrm>
           <a:prstGeom prst="rect">
             <a:avLst/>
@@ -10068,28 +11067,394 @@
               <a:buNone/>
             </a:pPr>
             <a:r>
-              <a:rPr lang="en-US" sz="1300" b="1" dirty="0">
+              <a:rPr lang="en-US" sz="1150" b="1" dirty="0">
                 <a:solidFill>
                   <a:schemeClr val="tx1"/>
                 </a:solidFill>
               </a:rPr>
-              <a:t>OneMap</a:t>
-            </a:r>
-            <a:endParaRPr lang="en-US" sz="1300" dirty="0"/>
-          </a:p>
-          <a:p>
-            <a:pPr indent="0" marL="0">
-              <a:buNone/>
-            </a:pPr>
-            <a:r>
-              <a:rPr lang="en-US" sz="1100" dirty="0">
+              <a:t>Models</a:t>
+            </a:r>
+            <a:endParaRPr lang="en-US" sz="1150" dirty="0"/>
+          </a:p>
+        </p:txBody>
+      </p:sp>
+      <p:sp>
+        <p:nvSpPr>
+          <p:cNvPr id="80" name="box-sub-152"/>
+          <p:cNvSpPr txBox="1"/>
+          <p:nvPr/>
+        </p:nvSpPr>
+        <p:spPr>
+          <a:xfrm>
+            <a:off x="9878263" y="4892040"/>
+            <a:ext cx="1563624" cy="347472"/>
+          </a:xfrm>
+          <a:prstGeom prst="rect">
+            <a:avLst/>
+          </a:prstGeom>
+          <a:noFill/>
+          <a:ln/>
+        </p:spPr>
+        <p:txBody>
+          <a:bodyPr wrap="square" lIns="0" tIns="0" rIns="0" bIns="0" rtlCol="0" anchor="t"/>
+          <a:lstStyle/>
+          <a:p>
+            <a:pPr indent="0" marL="0">
+              <a:buNone/>
+            </a:pPr>
+            <a:r>
+              <a:rPr lang="en-US" sz="950" dirty="0">
                 <a:solidFill>
                   <a:schemeClr val="tx2"/>
                 </a:solidFill>
               </a:rPr>
-              <a:t>real Singapore routes</a:t>
-            </a:r>
-            <a:endParaRPr lang="en-US" sz="1300" dirty="0"/>
+              <a:t>DeepInfra: Qwen3-235B, Gemma 4. Gemini fallback</a:t>
+            </a:r>
+            <a:endParaRPr lang="en-US" sz="950" dirty="0"/>
+          </a:p>
+        </p:txBody>
+      </p:sp>
+      <p:sp>
+        <p:nvSpPr>
+          <p:cNvPr id="81" name="box-153"/>
+          <p:cNvSpPr/>
+          <p:nvPr/>
+        </p:nvSpPr>
+        <p:spPr>
+          <a:xfrm>
+            <a:off x="9786823" y="5349240"/>
+            <a:ext cx="1746504" cy="347472"/>
+          </a:xfrm>
+          <a:prstGeom prst="roundRect">
+            <a:avLst>
+              <a:gd name="adj" fmla="val 18421"/>
+            </a:avLst>
+          </a:prstGeom>
+          <a:solidFill>
+            <a:schemeClr val="bg2"/>
+          </a:solidFill>
+          <a:ln/>
+        </p:spPr>
+      </p:sp>
+      <p:pic>
+        <p:nvPicPr>
+          <p:cNvPr id="82" name="box-icon-154" descr="preencoded.png">    </p:cNvPr>
+          <p:cNvPicPr>
+            <a:picLocks noChangeAspect="1"/>
+          </p:cNvPicPr>
+          <p:nvPr/>
+        </p:nvPicPr>
+        <p:blipFill>
+          <a:blip r:embed="rId15"/>
+          <a:stretch>
+            <a:fillRect/>
+          </a:stretch>
+        </p:blipFill>
+        <p:spPr>
+          <a:xfrm>
+            <a:off x="9878263" y="5440680"/>
+            <a:ext cx="219456" cy="219456"/>
+          </a:xfrm>
+          <a:prstGeom prst="rect">
+            <a:avLst/>
+          </a:prstGeom>
+        </p:spPr>
+      </p:pic>
+      <p:sp>
+        <p:nvSpPr>
+          <p:cNvPr id="83" name="box-title-155"/>
+          <p:cNvSpPr txBox="1"/>
+          <p:nvPr/>
+        </p:nvSpPr>
+        <p:spPr>
+          <a:xfrm>
+            <a:off x="10152583" y="5413248"/>
+            <a:ext cx="1307592" cy="274320"/>
+          </a:xfrm>
+          <a:prstGeom prst="rect">
+            <a:avLst/>
+          </a:prstGeom>
+          <a:noFill/>
+          <a:ln/>
+        </p:spPr>
+        <p:txBody>
+          <a:bodyPr wrap="square" lIns="0" tIns="0" rIns="0" bIns="0" rtlCol="0" anchor="ctr"/>
+          <a:lstStyle/>
+          <a:p>
+            <a:pPr indent="0" marL="0">
+              <a:buNone/>
+            </a:pPr>
+            <a:r>
+              <a:rPr lang="en-US" sz="1150" b="1" dirty="0">
+                <a:solidFill>
+                  <a:schemeClr val="tx1"/>
+                </a:solidFill>
+              </a:rPr>
+              <a:t>Logfire</a:t>
+            </a:r>
+            <a:endParaRPr lang="en-US" sz="1150" dirty="0"/>
+          </a:p>
+        </p:txBody>
+      </p:sp>
+      <p:sp>
+        <p:nvSpPr>
+          <p:cNvPr id="84" name="box-156"/>
+          <p:cNvSpPr/>
+          <p:nvPr/>
+        </p:nvSpPr>
+        <p:spPr>
+          <a:xfrm>
+            <a:off x="9786823" y="5751576"/>
+            <a:ext cx="1746504" cy="347472"/>
+          </a:xfrm>
+          <a:prstGeom prst="roundRect">
+            <a:avLst>
+              <a:gd name="adj" fmla="val 18421"/>
+            </a:avLst>
+          </a:prstGeom>
+          <a:solidFill>
+            <a:schemeClr val="bg2"/>
+          </a:solidFill>
+          <a:ln/>
+        </p:spPr>
+      </p:sp>
+      <p:pic>
+        <p:nvPicPr>
+          <p:cNvPr id="85" name="box-icon-157" descr="preencoded.png">    </p:cNvPr>
+          <p:cNvPicPr>
+            <a:picLocks noChangeAspect="1"/>
+          </p:cNvPicPr>
+          <p:nvPr/>
+        </p:nvPicPr>
+        <p:blipFill>
+          <a:blip r:embed="rId16"/>
+          <a:stretch>
+            <a:fillRect/>
+          </a:stretch>
+        </p:blipFill>
+        <p:spPr>
+          <a:xfrm>
+            <a:off x="9878263" y="5843016"/>
+            <a:ext cx="219456" cy="219456"/>
+          </a:xfrm>
+          <a:prstGeom prst="rect">
+            <a:avLst/>
+          </a:prstGeom>
+        </p:spPr>
+      </p:pic>
+      <p:sp>
+        <p:nvSpPr>
+          <p:cNvPr id="86" name="box-title-158"/>
+          <p:cNvSpPr txBox="1"/>
+          <p:nvPr/>
+        </p:nvSpPr>
+        <p:spPr>
+          <a:xfrm>
+            <a:off x="10152583" y="5815584"/>
+            <a:ext cx="1307592" cy="274320"/>
+          </a:xfrm>
+          <a:prstGeom prst="rect">
+            <a:avLst/>
+          </a:prstGeom>
+          <a:noFill/>
+          <a:ln/>
+        </p:spPr>
+        <p:txBody>
+          <a:bodyPr wrap="square" lIns="0" tIns="0" rIns="0" bIns="0" rtlCol="0" anchor="ctr"/>
+          <a:lstStyle/>
+          <a:p>
+            <a:pPr indent="0" marL="0">
+              <a:buNone/>
+            </a:pPr>
+            <a:r>
+              <a:rPr lang="en-US" sz="1150" b="1" dirty="0">
+                <a:solidFill>
+                  <a:schemeClr val="tx1"/>
+                </a:solidFill>
+              </a:rPr>
+              <a:t>OneMap routing</a:t>
+            </a:r>
+            <a:endParaRPr lang="en-US" sz="1150" dirty="0"/>
+          </a:p>
+        </p:txBody>
+      </p:sp>
+      <p:sp>
+        <p:nvSpPr>
+          <p:cNvPr id="87" name="arrow-159"/>
+          <p:cNvSpPr/>
+          <p:nvPr/>
+        </p:nvSpPr>
+        <p:spPr>
+          <a:xfrm>
+            <a:off x="9082735" y="2642616"/>
+            <a:ext cx="704088" cy="0"/>
+          </a:xfrm>
+          <a:prstGeom prst="line">
+            <a:avLst/>
+          </a:prstGeom>
+          <a:noFill/>
+          <a:ln w="19050">
+            <a:solidFill>
+              <a:schemeClr val="tx2"/>
+            </a:solidFill>
+            <a:prstDash val="solid"/>
+            <a:tailEnd type="triangle"/>
+          </a:ln>
+        </p:spPr>
+      </p:sp>
+      <p:sp>
+        <p:nvSpPr>
+          <p:cNvPr id="88" name="wire-label-160"/>
+          <p:cNvSpPr txBox="1"/>
+          <p:nvPr/>
+        </p:nvSpPr>
+        <p:spPr>
+          <a:xfrm>
+            <a:off x="9064447" y="2368296"/>
+            <a:ext cx="502920" cy="201168"/>
+          </a:xfrm>
+          <a:prstGeom prst="rect">
+            <a:avLst/>
+          </a:prstGeom>
+          <a:noFill/>
+          <a:ln/>
+        </p:spPr>
+        <p:txBody>
+          <a:bodyPr wrap="square" lIns="0" tIns="0" rIns="0" bIns="0" rtlCol="0" anchor="ctr"/>
+          <a:lstStyle/>
+          <a:p>
+            <a:pPr algn="ctr" indent="0" marL="0">
+              <a:buNone/>
+            </a:pPr>
+            <a:r>
+              <a:rPr lang="en-US" sz="900" i="1" dirty="0">
+                <a:solidFill>
+                  <a:schemeClr val="tx2"/>
+                </a:solidFill>
+              </a:rPr>
+              <a:t>SQL</a:t>
+            </a:r>
+            <a:endParaRPr lang="en-US" sz="900" dirty="0"/>
+          </a:p>
+        </p:txBody>
+      </p:sp>
+      <p:sp>
+        <p:nvSpPr>
+          <p:cNvPr id="89" name="arrow-161"/>
+          <p:cNvSpPr/>
+          <p:nvPr/>
+        </p:nvSpPr>
+        <p:spPr>
+          <a:xfrm>
+            <a:off x="9082735" y="3374136"/>
+            <a:ext cx="704088" cy="0"/>
+          </a:xfrm>
+          <a:prstGeom prst="line">
+            <a:avLst/>
+          </a:prstGeom>
+          <a:noFill/>
+          <a:ln w="19050">
+            <a:solidFill>
+              <a:schemeClr val="tx2"/>
+            </a:solidFill>
+            <a:prstDash val="solid"/>
+            <a:tailEnd type="triangle"/>
+          </a:ln>
+        </p:spPr>
+      </p:sp>
+      <p:sp>
+        <p:nvSpPr>
+          <p:cNvPr id="90" name="wire-label-162"/>
+          <p:cNvSpPr txBox="1"/>
+          <p:nvPr/>
+        </p:nvSpPr>
+        <p:spPr>
+          <a:xfrm>
+            <a:off x="9064447" y="3099816"/>
+            <a:ext cx="502920" cy="201168"/>
+          </a:xfrm>
+          <a:prstGeom prst="rect">
+            <a:avLst/>
+          </a:prstGeom>
+          <a:noFill/>
+          <a:ln/>
+        </p:spPr>
+        <p:txBody>
+          <a:bodyPr wrap="square" lIns="0" tIns="0" rIns="0" bIns="0" rtlCol="0" anchor="ctr"/>
+          <a:lstStyle/>
+          <a:p>
+            <a:pPr algn="ctr" indent="0" marL="0">
+              <a:buNone/>
+            </a:pPr>
+            <a:r>
+              <a:rPr lang="en-US" sz="900" i="1" dirty="0">
+                <a:solidFill>
+                  <a:schemeClr val="tx2"/>
+                </a:solidFill>
+              </a:rPr>
+              <a:t>S3 API</a:t>
+            </a:r>
+            <a:endParaRPr lang="en-US" sz="900" dirty="0"/>
+          </a:p>
+        </p:txBody>
+      </p:sp>
+      <p:sp>
+        <p:nvSpPr>
+          <p:cNvPr id="91" name="arrow-163"/>
+          <p:cNvSpPr/>
+          <p:nvPr/>
+        </p:nvSpPr>
+        <p:spPr>
+          <a:xfrm>
+            <a:off x="9082735" y="4892040"/>
+            <a:ext cx="704088" cy="0"/>
+          </a:xfrm>
+          <a:prstGeom prst="line">
+            <a:avLst/>
+          </a:prstGeom>
+          <a:noFill/>
+          <a:ln w="19050">
+            <a:solidFill>
+              <a:schemeClr val="tx2"/>
+            </a:solidFill>
+            <a:prstDash val="solid"/>
+            <a:tailEnd type="triangle"/>
+          </a:ln>
+        </p:spPr>
+      </p:sp>
+      <p:sp>
+        <p:nvSpPr>
+          <p:cNvPr id="92" name="wire-label-164"/>
+          <p:cNvSpPr txBox="1"/>
+          <p:nvPr/>
+        </p:nvSpPr>
+        <p:spPr>
+          <a:xfrm>
+            <a:off x="9064447" y="4617720"/>
+            <a:ext cx="502920" cy="201168"/>
+          </a:xfrm>
+          <a:prstGeom prst="rect">
+            <a:avLst/>
+          </a:prstGeom>
+          <a:noFill/>
+          <a:ln/>
+        </p:spPr>
+        <p:txBody>
+          <a:bodyPr wrap="square" lIns="0" tIns="0" rIns="0" bIns="0" rtlCol="0" anchor="ctr"/>
+          <a:lstStyle/>
+          <a:p>
+            <a:pPr algn="ctr" indent="0" marL="0">
+              <a:buNone/>
+            </a:pPr>
+            <a:r>
+              <a:rPr lang="en-US" sz="900" i="1" dirty="0">
+                <a:solidFill>
+                  <a:schemeClr val="tx2"/>
+                </a:solidFill>
+              </a:rPr>
+              <a:t>HTTPS</a:t>
+            </a:r>
+            <a:endParaRPr lang="en-US" sz="900" dirty="0"/>
           </a:p>
         </p:txBody>
       </p:sp>

</xml_diff>

<commit_message>
Cover built around the courtroom illustration; agentic architecture slide
</commit_message>
<xml_diff>
--- a/submission/architecture.pptx
+++ b/submission/architecture.pptx
@@ -13,9 +13,10 @@
     <p:sldId id="261" r:id="rId7"/>
     <p:sldId id="262" r:id="rId8"/>
     <p:sldId id="263" r:id="rId9"/>
+    <p:sldId id="264" r:id="rId10"/>
   </p:sldIdLst>
   <p:notesMasterIdLst>
-    <p:notesMasterId r:id="rId10"/>
+    <p:notesMasterId r:id="rId11"/>
   </p:notesMasterIdLst>
   <p:sldSz cx="12192000" cy="6858000"/>
   <p:notesSz cx="6858000" cy="12192000"/>
@@ -114,32 +115,33 @@
   <p:extLst>
     <p:ext uri="{521415D9-36F7-43E2-AB2F-B90AF26B5E84}">
       <p14:sectionLst xmlns:p14="http://schemas.microsoft.com/office/powerpoint/2010/main">
-        <p14:section name="Overview" id="{772baba1-792b-e3f6-0e12-73f26f51a42e}">
+        <p14:section name="Overview" id="{2f2d2624-4026-ff4f-a6bf-0c33c608a9be}">
           <p14:sldIdLst>
             <p14:sldId id="256"/>
           </p14:sldIdLst>
         </p14:section>
-        <p14:section name="The hearing" id="{3ee4cf82-3a82-c69f-1fdc-8f28eebd577e}">
+        <p14:section name="The hearing" id="{217fdc10-10d1-971f-07ce-6d535297a380}">
           <p14:sldIdLst>
             <p14:sldId id="257"/>
             <p14:sldId id="258"/>
             <p14:sldId id="259"/>
           </p14:sldIdLst>
         </p14:section>
-        <p14:section name="Safeguards" id="{23d4aab4-13b8-4ac4-95a2-62c20699e6d2}">
+        <p14:section name="Safeguards" id="{30008fee-20dd-5c34-e1f2-bfa6954d9d94}">
           <p14:sldIdLst>
             <p14:sldId id="260"/>
             <p14:sldId id="261"/>
           </p14:sldIdLst>
         </p14:section>
-        <p14:section name="Platform" id="{a17e6afb-8084-98ac-b684-233ac56a1a2a}">
+        <p14:section name="Platform" id="{5ec2374d-b1c0-f032-094d-780f80217a36}">
           <p14:sldIdLst>
             <p14:sldId id="262"/>
+            <p14:sldId id="263"/>
           </p14:sldIdLst>
         </p14:section>
-        <p14:section name="Results" id="{dfb8ecd1-19a5-d9a0-24fe-54b9b2c3abf9}">
+        <p14:section name="Results" id="{f2ae5677-ded4-621e-44c0-f0b9992dec80}">
           <p14:sldIdLst>
-            <p14:sldId id="263"/>
+            <p14:sldId id="264"/>
           </p14:sldIdLst>
         </p14:section>
       </p14:sectionLst>
@@ -1162,7 +1164,7 @@
           <a:p>
             <a:r>
               <a:rPr lang="en-US" dirty="0"/>
-              <a:t>From the latest golden run with Qwen3-235B on DeepInfra: all 22 labelled cases matched their labels down to the exact amount; the fallback model, Qwen3.6-27B, also scored 22 of 22. Thirteen cases were decided with no person, and the other nine went to a person because the checks required it: safety reports, fees of $120 or more, and repeat filers. Model cost was about 1.2 US cents per fully argued case, and the median time from report to outcome was 202 seconds. The project also has 216 automated tests.</a:t>
+              <a:t>Agents are pydantic-ai agents, and the orchestrator, a plain-code state machine, calls them one at a time; no agent can call another. Triage has no tools and returns a TriageResult; a safety flag stops the case. Evidence Collection is the only agent with database access, through db_query, and code assembles its CaseFile so every item carries a citable ID. The two advocates run in parallel on the same case file, can look up only items in it, ask for an image analysis, and search the policy; each returns an Argument whose citations are checked in code. The Judge can search policy, look up the risk bucket and ask for a person, and returns a JudgeVerdict; code checks its citations and fills in every fixed amount. Every agent shares a model chain on DeepInfra with a fallback model, retries on rate limits, a Logfire trace span and per-call token logging.</a:t>
             </a:r>
             <a:endParaRPr lang="en-US" dirty="0"/>
           </a:p>
@@ -1186,6 +1188,94 @@
             <a:fld id="{F7021451-1387-4CA6-816F-3879F97B5CBC}" type="slidenum">
               <a:rPr lang="en-US"/>
               <a:t>8</a:t>
+            </a:fld>
+            <a:endParaRPr lang="en-US"/>
+          </a:p>
+        </p:txBody>
+      </p:sp>
+    </p:spTree>
+    <p:extLst>
+      <p:ext uri="{BB962C8B-B14F-4D97-AF65-F5344CB8AC3E}">
+        <p14:creationId xmlns:p14="http://schemas.microsoft.com/office/powerpoint/2010/main" val="1024086991"/>
+      </p:ext>
+    </p:extLst>
+  </p:cSld>
+  <p:clrMapOvr>
+    <a:masterClrMapping/>
+  </p:clrMapOvr>
+</p:notes>
+</file>
+
+<file path=ppt/notesSlides/notesSlide9.xml><?xml version="1.0" encoding="utf-8"?>
+<p:notes xmlns:a="http://schemas.openxmlformats.org/drawingml/2006/main" xmlns:r="http://schemas.openxmlformats.org/officeDocument/2006/relationships" xmlns:p="http://schemas.openxmlformats.org/presentationml/2006/main">
+  <p:cSld>
+    <p:spTree>
+      <p:nvGrpSpPr>
+        <p:cNvPr id="1" name=""/>
+        <p:cNvGrpSpPr/>
+        <p:nvPr/>
+      </p:nvGrpSpPr>
+      <p:grpSpPr>
+        <a:xfrm>
+          <a:off x="0" y="0"/>
+          <a:ext cx="0" cy="0"/>
+          <a:chOff x="0" y="0"/>
+          <a:chExt cx="0" cy="0"/>
+        </a:xfrm>
+      </p:grpSpPr>
+      <p:sp>
+        <p:nvSpPr>
+          <p:cNvPr id="2" name="Slide Image Placeholder 1"/>
+          <p:cNvSpPr>
+            <a:spLocks noGrp="1" noRot="1" noChangeAspect="1"/>
+          </p:cNvSpPr>
+          <p:nvPr>
+            <p:ph type="sldImg"/>
+          </p:nvPr>
+        </p:nvSpPr>
+        <p:spPr/>
+      </p:sp>
+      <p:sp>
+        <p:nvSpPr>
+          <p:cNvPr id="3" name="Notes Placeholder 2"/>
+          <p:cNvSpPr>
+            <a:spLocks noGrp="1"/>
+          </p:cNvSpPr>
+          <p:nvPr>
+            <p:ph type="body" idx="1"/>
+          </p:nvPr>
+        </p:nvSpPr>
+        <p:spPr/>
+        <p:txBody>
+          <a:bodyPr/>
+          <a:lstStyle/>
+          <a:p>
+            <a:r>
+              <a:rPr lang="en-US" dirty="0"/>
+              <a:t>From the latest golden run with Qwen3-235B on DeepInfra: all 22 labelled cases matched their labels down to the exact amount; the fallback model, Qwen3.6-27B, also scored 22 of 22. Thirteen cases were decided with no person, and the other nine went to a person because the checks required it: safety reports, fees of $120 or more, and repeat filers. Model cost was about 1.2 US cents per fully argued case, and the median time from report to outcome was 202 seconds. The project also has 216 automated tests.</a:t>
+            </a:r>
+            <a:endParaRPr lang="en-US" dirty="0"/>
+          </a:p>
+        </p:txBody>
+      </p:sp>
+      <p:sp>
+        <p:nvSpPr>
+          <p:cNvPr id="4" name="Slide Number Placeholder 3"/>
+          <p:cNvSpPr>
+            <a:spLocks noGrp="1"/>
+          </p:cNvSpPr>
+          <p:nvPr>
+            <p:ph type="sldNum" sz="quarter" idx="10"/>
+          </p:nvPr>
+        </p:nvSpPr>
+        <p:spPr/>
+        <p:txBody>
+          <a:bodyPr/>
+          <a:lstStyle/>
+          <a:p>
+            <a:fld id="{F7021451-1387-4CA6-816F-3879F97B5CBC}" type="slidenum">
+              <a:rPr lang="en-US"/>
+              <a:t>9</a:t>
             </a:fld>
             <a:endParaRPr lang="en-US"/>
           </a:p>
@@ -11560,7 +11650,7 @@
                   <a:schemeClr val="tx1"/>
                 </a:solidFill>
               </a:rPr>
-              <a:t>Results</a:t>
+              <a:t>Agentic architecture</a:t>
             </a:r>
             <a:endParaRPr lang="en-US" sz="3200" dirty="0"/>
           </a:p>
@@ -11598,7 +11688,7 @@
                   <a:schemeClr val="tx2"/>
                 </a:solidFill>
               </a:rPr>
-              <a:t>22 labelled test cases, each run through the full pipeline with real model calls.</a:t>
+              <a:t>Code calls each agent in turn. Each gets narrow tools and returns a typed object that code checks.</a:t>
             </a:r>
             <a:endParaRPr lang="en-US" sz="1500" dirty="0"/>
           </a:p>
@@ -11606,18 +11696,323 @@
       </p:sp>
       <p:sp>
         <p:nvSpPr>
-          <p:cNvPr id="4" name="hero-card"/>
-          <p:cNvSpPr/>
-          <p:nvPr/>
-        </p:nvSpPr>
-        <p:spPr>
-          <a:xfrm>
-            <a:off x="548640" y="1783080"/>
-            <a:ext cx="4206240" cy="4069080"/>
+          <p:cNvPr id="4" name="col-head-165"/>
+          <p:cNvSpPr txBox="1"/>
+          <p:nvPr/>
+        </p:nvSpPr>
+        <p:spPr>
+          <a:xfrm>
+            <a:off x="548640" y="1572768"/>
+            <a:ext cx="1280160" cy="256032"/>
+          </a:xfrm>
+          <a:prstGeom prst="rect">
+            <a:avLst/>
+          </a:prstGeom>
+          <a:noFill/>
+          <a:ln/>
+        </p:spPr>
+        <p:txBody>
+          <a:bodyPr wrap="square" lIns="0" tIns="0" rIns="0" bIns="0" rtlCol="0" anchor="ctr"/>
+          <a:lstStyle/>
+          <a:p>
+            <a:pPr indent="0" marL="0">
+              <a:buNone/>
+            </a:pPr>
+            <a:r>
+              <a:rPr lang="en-US" sz="1050" b="1" dirty="0">
+                <a:solidFill>
+                  <a:schemeClr val="tx2"/>
+                </a:solidFill>
+              </a:rPr>
+              <a:t>ORCHESTRATOR</a:t>
+            </a:r>
+            <a:endParaRPr lang="en-US" sz="1050" dirty="0"/>
+          </a:p>
+        </p:txBody>
+      </p:sp>
+      <p:sp>
+        <p:nvSpPr>
+          <p:cNvPr id="5" name="col-head-166"/>
+          <p:cNvSpPr txBox="1"/>
+          <p:nvPr/>
+        </p:nvSpPr>
+        <p:spPr>
+          <a:xfrm>
+            <a:off x="2148840" y="1572768"/>
+            <a:ext cx="2148840" cy="256032"/>
+          </a:xfrm>
+          <a:prstGeom prst="rect">
+            <a:avLst/>
+          </a:prstGeom>
+          <a:noFill/>
+          <a:ln/>
+        </p:spPr>
+        <p:txBody>
+          <a:bodyPr wrap="square" lIns="0" tIns="0" rIns="0" bIns="0" rtlCol="0" anchor="ctr"/>
+          <a:lstStyle/>
+          <a:p>
+            <a:pPr indent="0" marL="0">
+              <a:buNone/>
+            </a:pPr>
+            <a:r>
+              <a:rPr lang="en-US" sz="1050" b="1" dirty="0">
+                <a:solidFill>
+                  <a:schemeClr val="tx2"/>
+                </a:solidFill>
+              </a:rPr>
+              <a:t>AGENT</a:t>
+            </a:r>
+            <a:endParaRPr lang="en-US" sz="1050" dirty="0"/>
+          </a:p>
+        </p:txBody>
+      </p:sp>
+      <p:sp>
+        <p:nvSpPr>
+          <p:cNvPr id="6" name="col-head-167"/>
+          <p:cNvSpPr txBox="1"/>
+          <p:nvPr/>
+        </p:nvSpPr>
+        <p:spPr>
+          <a:xfrm>
+            <a:off x="4572000" y="1572768"/>
+            <a:ext cx="3246120" cy="256032"/>
+          </a:xfrm>
+          <a:prstGeom prst="rect">
+            <a:avLst/>
+          </a:prstGeom>
+          <a:noFill/>
+          <a:ln/>
+        </p:spPr>
+        <p:txBody>
+          <a:bodyPr wrap="square" lIns="0" tIns="0" rIns="0" bIns="0" rtlCol="0" anchor="ctr"/>
+          <a:lstStyle/>
+          <a:p>
+            <a:pPr indent="0" marL="0">
+              <a:buNone/>
+            </a:pPr>
+            <a:r>
+              <a:rPr lang="en-US" sz="1050" b="1" dirty="0">
+                <a:solidFill>
+                  <a:schemeClr val="tx2"/>
+                </a:solidFill>
+              </a:rPr>
+              <a:t>TOOLS IT CAN CALL</a:t>
+            </a:r>
+            <a:endParaRPr lang="en-US" sz="1050" dirty="0"/>
+          </a:p>
+        </p:txBody>
+      </p:sp>
+      <p:sp>
+        <p:nvSpPr>
+          <p:cNvPr id="7" name="col-head-168"/>
+          <p:cNvSpPr txBox="1"/>
+          <p:nvPr/>
+        </p:nvSpPr>
+        <p:spPr>
+          <a:xfrm>
+            <a:off x="8001000" y="1572768"/>
+            <a:ext cx="1600200" cy="256032"/>
+          </a:xfrm>
+          <a:prstGeom prst="rect">
+            <a:avLst/>
+          </a:prstGeom>
+          <a:noFill/>
+          <a:ln/>
+        </p:spPr>
+        <p:txBody>
+          <a:bodyPr wrap="square" lIns="0" tIns="0" rIns="0" bIns="0" rtlCol="0" anchor="ctr"/>
+          <a:lstStyle/>
+          <a:p>
+            <a:pPr indent="0" marL="0">
+              <a:buNone/>
+            </a:pPr>
+            <a:r>
+              <a:rPr lang="en-US" sz="1050" b="1" dirty="0">
+                <a:solidFill>
+                  <a:schemeClr val="tx2"/>
+                </a:solidFill>
+              </a:rPr>
+              <a:t>RETURNS (TYPED)</a:t>
+            </a:r>
+            <a:endParaRPr lang="en-US" sz="1050" dirty="0"/>
+          </a:p>
+        </p:txBody>
+      </p:sp>
+      <p:sp>
+        <p:nvSpPr>
+          <p:cNvPr id="8" name="col-head-169"/>
+          <p:cNvSpPr txBox="1"/>
+          <p:nvPr/>
+        </p:nvSpPr>
+        <p:spPr>
+          <a:xfrm>
+            <a:off x="9829800" y="1572768"/>
+            <a:ext cx="1813255" cy="256032"/>
+          </a:xfrm>
+          <a:prstGeom prst="rect">
+            <a:avLst/>
+          </a:prstGeom>
+          <a:noFill/>
+          <a:ln/>
+        </p:spPr>
+        <p:txBody>
+          <a:bodyPr wrap="square" lIns="0" tIns="0" rIns="0" bIns="0" rtlCol="0" anchor="ctr"/>
+          <a:lstStyle/>
+          <a:p>
+            <a:pPr indent="0" marL="0">
+              <a:buNone/>
+            </a:pPr>
+            <a:r>
+              <a:rPr lang="en-US" sz="1050" b="1" dirty="0">
+                <a:solidFill>
+                  <a:schemeClr val="tx2"/>
+                </a:solidFill>
+              </a:rPr>
+              <a:t>CHECKED IN CODE</a:t>
+            </a:r>
+            <a:endParaRPr lang="en-US" sz="1050" dirty="0"/>
+          </a:p>
+        </p:txBody>
+      </p:sp>
+      <p:sp>
+        <p:nvSpPr>
+          <p:cNvPr id="9" name="orchestrator"/>
+          <p:cNvSpPr/>
+          <p:nvPr/>
+        </p:nvSpPr>
+        <p:spPr>
+          <a:xfrm>
+            <a:off x="548640" y="1901952"/>
+            <a:ext cx="1280160" cy="3291840"/>
           </a:xfrm>
           <a:prstGeom prst="roundRect">
             <a:avLst>
-              <a:gd name="adj" fmla="val 3146"/>
+              <a:gd name="adj" fmla="val 7143"/>
+            </a:avLst>
+          </a:prstGeom>
+          <a:solidFill>
+            <a:schemeClr val="bg1"/>
+          </a:solidFill>
+          <a:ln w="15875">
+            <a:solidFill>
+              <a:schemeClr val="tx2"/>
+            </a:solidFill>
+            <a:prstDash val="dash"/>
+          </a:ln>
+        </p:spPr>
+      </p:sp>
+      <p:pic>
+        <p:nvPicPr>
+          <p:cNvPr id="10" name="orchestrator-icon" descr="preencoded.png">    </p:cNvPr>
+          <p:cNvPicPr>
+            <a:picLocks noChangeAspect="1"/>
+          </p:cNvPicPr>
+          <p:nvPr/>
+        </p:nvPicPr>
+        <p:blipFill>
+          <a:blip r:embed="rId1"/>
+          <a:stretch>
+            <a:fillRect/>
+          </a:stretch>
+        </p:blipFill>
+        <p:spPr>
+          <a:xfrm>
+            <a:off x="1005840" y="2862072"/>
+            <a:ext cx="365760" cy="365760"/>
+          </a:xfrm>
+          <a:prstGeom prst="rect">
+            <a:avLst/>
+          </a:prstGeom>
+        </p:spPr>
+      </p:pic>
+      <p:sp>
+        <p:nvSpPr>
+          <p:cNvPr id="11" name="orchestrator-text"/>
+          <p:cNvSpPr txBox="1"/>
+          <p:nvPr/>
+        </p:nvSpPr>
+        <p:spPr>
+          <a:xfrm>
+            <a:off x="621792" y="3319272"/>
+            <a:ext cx="1133856" cy="731520"/>
+          </a:xfrm>
+          <a:prstGeom prst="rect">
+            <a:avLst/>
+          </a:prstGeom>
+          <a:noFill/>
+          <a:ln/>
+        </p:spPr>
+        <p:txBody>
+          <a:bodyPr wrap="square" lIns="0" tIns="0" rIns="0" bIns="0" rtlCol="0" anchor="t"/>
+          <a:lstStyle/>
+          <a:p>
+            <a:pPr algn="ctr" indent="0" marL="0">
+              <a:buNone/>
+            </a:pPr>
+            <a:r>
+              <a:rPr lang="en-US" sz="1300" b="1" dirty="0">
+                <a:solidFill>
+                  <a:schemeClr val="tx1"/>
+                </a:solidFill>
+              </a:rPr>
+              <a:t>Orchestrator</a:t>
+            </a:r>
+            <a:endParaRPr lang="en-US" sz="1300" dirty="0"/>
+          </a:p>
+          <a:p>
+            <a:pPr algn="ctr" indent="0" marL="0">
+              <a:buNone/>
+            </a:pPr>
+            <a:r>
+              <a:rPr lang="en-US" sz="1000" dirty="0">
+                <a:solidFill>
+                  <a:schemeClr val="tx2"/>
+                </a:solidFill>
+              </a:rPr>
+              <a:t>plain code, a state machine</a:t>
+            </a:r>
+            <a:endParaRPr lang="en-US" sz="1300" dirty="0"/>
+          </a:p>
+        </p:txBody>
+      </p:sp>
+      <p:sp>
+        <p:nvSpPr>
+          <p:cNvPr id="12" name="arrow-170"/>
+          <p:cNvSpPr/>
+          <p:nvPr/>
+        </p:nvSpPr>
+        <p:spPr>
+          <a:xfrm>
+            <a:off x="1828800" y="2258568"/>
+            <a:ext cx="320040" cy="0"/>
+          </a:xfrm>
+          <a:prstGeom prst="line">
+            <a:avLst/>
+          </a:prstGeom>
+          <a:noFill/>
+          <a:ln w="19050">
+            <a:solidFill>
+              <a:schemeClr val="tx2"/>
+            </a:solidFill>
+            <a:prstDash val="solid"/>
+            <a:tailEnd type="triangle"/>
+          </a:ln>
+        </p:spPr>
+      </p:sp>
+      <p:sp>
+        <p:nvSpPr>
+          <p:cNvPr id="13" name="node-171"/>
+          <p:cNvSpPr/>
+          <p:nvPr/>
+        </p:nvSpPr>
+        <p:spPr>
+          <a:xfrm>
+            <a:off x="2148840" y="1901952"/>
+            <a:ext cx="2148840" cy="713232"/>
+          </a:xfrm>
+          <a:prstGeom prst="roundRect">
+            <a:avLst>
+              <a:gd name="adj" fmla="val 12821"/>
             </a:avLst>
           </a:prstGeom>
           <a:solidFill>
@@ -11626,16 +12021,40 @@
           <a:ln/>
         </p:spPr>
       </p:sp>
-      <p:sp>
-        <p:nvSpPr>
-          <p:cNvPr id="5" name="hero-value"/>
-          <p:cNvSpPr txBox="1"/>
-          <p:nvPr/>
-        </p:nvSpPr>
-        <p:spPr>
-          <a:xfrm>
-            <a:off x="914400" y="2240280"/>
-            <a:ext cx="3474720" cy="1554480"/>
+      <p:pic>
+        <p:nvPicPr>
+          <p:cNvPr id="14" name="icon-172" descr="preencoded.png">    </p:cNvPr>
+          <p:cNvPicPr>
+            <a:picLocks noChangeAspect="1"/>
+          </p:cNvPicPr>
+          <p:nvPr/>
+        </p:nvPicPr>
+        <p:blipFill>
+          <a:blip r:embed="rId2"/>
+          <a:stretch>
+            <a:fillRect/>
+          </a:stretch>
+        </p:blipFill>
+        <p:spPr>
+          <a:xfrm>
+            <a:off x="2276856" y="2029968"/>
+            <a:ext cx="292608" cy="292608"/>
+          </a:xfrm>
+          <a:prstGeom prst="rect">
+            <a:avLst/>
+          </a:prstGeom>
+        </p:spPr>
+      </p:pic>
+      <p:sp>
+        <p:nvSpPr>
+          <p:cNvPr id="15" name="node-title-173"/>
+          <p:cNvSpPr txBox="1"/>
+          <p:nvPr/>
+        </p:nvSpPr>
+        <p:spPr>
+          <a:xfrm>
+            <a:off x="2660904" y="2002536"/>
+            <a:ext cx="1508760" cy="347472"/>
           </a:xfrm>
           <a:prstGeom prst="rect">
             <a:avLst/>
@@ -11651,27 +12070,27 @@
               <a:buNone/>
             </a:pPr>
             <a:r>
-              <a:rPr lang="en-US" sz="9600" b="1" dirty="0">
+              <a:rPr lang="en-US" sz="1400" b="1" dirty="0">
                 <a:solidFill>
                   <a:schemeClr val="bg1"/>
                 </a:solidFill>
               </a:rPr>
-              <a:t>22/22</a:t>
-            </a:r>
-            <a:endParaRPr lang="en-US" sz="9600" dirty="0"/>
-          </a:p>
-        </p:txBody>
-      </p:sp>
-      <p:sp>
-        <p:nvSpPr>
-          <p:cNvPr id="6" name="hero-label"/>
-          <p:cNvSpPr txBox="1"/>
-          <p:nvPr/>
-        </p:nvSpPr>
-        <p:spPr>
-          <a:xfrm>
-            <a:off x="914400" y="3977640"/>
-            <a:ext cx="3474720" cy="1463040"/>
+              <a:t>Triage</a:t>
+            </a:r>
+            <a:endParaRPr lang="en-US" sz="1400" dirty="0"/>
+          </a:p>
+        </p:txBody>
+      </p:sp>
+      <p:sp>
+        <p:nvSpPr>
+          <p:cNvPr id="16" name="node-sub-174"/>
+          <p:cNvSpPr txBox="1"/>
+          <p:nvPr/>
+        </p:nvSpPr>
+        <p:spPr>
+          <a:xfrm>
+            <a:off x="2276856" y="2395728"/>
+            <a:ext cx="1892808" cy="182880"/>
           </a:xfrm>
           <a:prstGeom prst="rect">
             <a:avLst/>
@@ -11687,45 +12106,1443 @@
               <a:buNone/>
             </a:pPr>
             <a:r>
-              <a:rPr lang="en-US" sz="2200" b="1" dirty="0">
-                <a:solidFill>
-                  <a:schemeClr val="bg1"/>
-                </a:solidFill>
-              </a:rPr>
-              <a:t>verdicts correct</a:t>
-            </a:r>
-            <a:endParaRPr lang="en-US" sz="2200" dirty="0"/>
-          </a:p>
-          <a:p>
-            <a:pPr indent="0" marL="0">
-              <a:buNone/>
-            </a:pPr>
-            <a:r>
-              <a:rPr lang="en-US" sz="1400" dirty="0">
+              <a:rPr lang="en-US" sz="1050" dirty="0">
                 <a:solidFill>
                   <a:schemeClr val="bg2"/>
                 </a:solidFill>
               </a:rPr>
-              <a:t>Outcome, remedy and exact amount all match the label, across every category.</a:t>
-            </a:r>
-            <a:endParaRPr lang="en-US" sz="2200" dirty="0"/>
-          </a:p>
-        </p:txBody>
-      </p:sp>
-      <p:sp>
-        <p:nvSpPr>
-          <p:cNvPr id="7" name="stat-0"/>
-          <p:cNvSpPr/>
-          <p:nvPr/>
-        </p:nvSpPr>
-        <p:spPr>
-          <a:xfrm>
-            <a:off x="5074920" y="1783080"/>
-            <a:ext cx="3124048" cy="1874520"/>
+              <a:t>reads the report</a:t>
+            </a:r>
+            <a:endParaRPr lang="en-US" sz="1050" dirty="0"/>
+          </a:p>
+        </p:txBody>
+      </p:sp>
+      <p:sp>
+        <p:nvSpPr>
+          <p:cNvPr id="17" name="no-tools-175"/>
+          <p:cNvSpPr txBox="1"/>
+          <p:nvPr/>
+        </p:nvSpPr>
+        <p:spPr>
+          <a:xfrm>
+            <a:off x="4572000" y="2121408"/>
+            <a:ext cx="3246120" cy="274320"/>
+          </a:xfrm>
+          <a:prstGeom prst="rect">
+            <a:avLst/>
+          </a:prstGeom>
+          <a:noFill/>
+          <a:ln/>
+        </p:spPr>
+        <p:txBody>
+          <a:bodyPr wrap="square" lIns="0" tIns="0" rIns="0" bIns="0" rtlCol="0" anchor="ctr"/>
+          <a:lstStyle/>
+          <a:p>
+            <a:pPr indent="0" marL="0">
+              <a:buNone/>
+            </a:pPr>
+            <a:r>
+              <a:rPr lang="en-US" sz="1100" i="1" dirty="0">
+                <a:solidFill>
+                  <a:schemeClr val="tx2"/>
+                </a:solidFill>
+              </a:rPr>
+              <a:t>no tools</a:t>
+            </a:r>
+            <a:endParaRPr lang="en-US" sz="1100" dirty="0"/>
+          </a:p>
+        </p:txBody>
+      </p:sp>
+      <p:sp>
+        <p:nvSpPr>
+          <p:cNvPr id="18" name="chip-176"/>
+          <p:cNvSpPr/>
+          <p:nvPr/>
+        </p:nvSpPr>
+        <p:spPr>
+          <a:xfrm>
+            <a:off x="8001000" y="2121408"/>
+            <a:ext cx="1100938" cy="274320"/>
           </a:xfrm>
           <a:prstGeom prst="roundRect">
             <a:avLst>
-              <a:gd name="adj" fmla="val 5854"/>
+              <a:gd name="adj" fmla="val 20000"/>
+            </a:avLst>
+          </a:prstGeom>
+          <a:solidFill>
+            <a:schemeClr val="tx1"/>
+          </a:solidFill>
+          <a:ln/>
+        </p:spPr>
+      </p:sp>
+      <p:sp>
+        <p:nvSpPr>
+          <p:cNvPr id="19" name="chip-text-177"/>
+          <p:cNvSpPr txBox="1"/>
+          <p:nvPr/>
+        </p:nvSpPr>
+        <p:spPr>
+          <a:xfrm>
+            <a:off x="8001000" y="2121408"/>
+            <a:ext cx="1100938" cy="274320"/>
+          </a:xfrm>
+          <a:prstGeom prst="rect">
+            <a:avLst/>
+          </a:prstGeom>
+          <a:noFill/>
+          <a:ln/>
+        </p:spPr>
+        <p:txBody>
+          <a:bodyPr wrap="square" lIns="0" tIns="0" rIns="0" bIns="0" rtlCol="0" anchor="ctr"/>
+          <a:lstStyle/>
+          <a:p>
+            <a:pPr algn="ctr" indent="0" marL="0">
+              <a:buNone/>
+            </a:pPr>
+            <a:r>
+              <a:rPr lang="en-US" sz="1000" b="1" dirty="0">
+                <a:solidFill>
+                  <a:schemeClr val="bg1"/>
+                </a:solidFill>
+                <a:latin typeface="Courier New" pitchFamily="34" charset="0"/>
+                <a:ea typeface="Courier New" pitchFamily="34" charset="-122"/>
+                <a:cs typeface="Courier New" pitchFamily="34" charset="-120"/>
+              </a:rPr>
+              <a:t>TriageResult</a:t>
+            </a:r>
+            <a:endParaRPr lang="en-US" sz="1000" dirty="0"/>
+          </a:p>
+        </p:txBody>
+      </p:sp>
+      <p:sp>
+        <p:nvSpPr>
+          <p:cNvPr id="20" name="check-178"/>
+          <p:cNvSpPr txBox="1"/>
+          <p:nvPr/>
+        </p:nvSpPr>
+        <p:spPr>
+          <a:xfrm>
+            <a:off x="9829800" y="1956816"/>
+            <a:ext cx="1813255" cy="603504"/>
+          </a:xfrm>
+          <a:prstGeom prst="rect">
+            <a:avLst/>
+          </a:prstGeom>
+          <a:noFill/>
+          <a:ln/>
+        </p:spPr>
+        <p:txBody>
+          <a:bodyPr wrap="square" lIns="0" tIns="0" rIns="0" bIns="0" rtlCol="0" anchor="ctr"/>
+          <a:lstStyle/>
+          <a:p>
+            <a:pPr indent="0" marL="0">
+              <a:buNone/>
+            </a:pPr>
+            <a:r>
+              <a:rPr lang="en-US" sz="1100" dirty="0">
+                <a:solidFill>
+                  <a:schemeClr val="tx1"/>
+                </a:solidFill>
+              </a:rPr>
+              <a:t>A safety flag stops the case before any other agent</a:t>
+            </a:r>
+            <a:endParaRPr lang="en-US" sz="1100" dirty="0"/>
+          </a:p>
+        </p:txBody>
+      </p:sp>
+      <p:sp>
+        <p:nvSpPr>
+          <p:cNvPr id="21" name="arrow-179"/>
+          <p:cNvSpPr/>
+          <p:nvPr/>
+        </p:nvSpPr>
+        <p:spPr>
+          <a:xfrm>
+            <a:off x="1828800" y="3118104"/>
+            <a:ext cx="320040" cy="0"/>
+          </a:xfrm>
+          <a:prstGeom prst="line">
+            <a:avLst/>
+          </a:prstGeom>
+          <a:noFill/>
+          <a:ln w="19050">
+            <a:solidFill>
+              <a:schemeClr val="tx2"/>
+            </a:solidFill>
+            <a:prstDash val="solid"/>
+            <a:tailEnd type="triangle"/>
+          </a:ln>
+        </p:spPr>
+      </p:sp>
+      <p:sp>
+        <p:nvSpPr>
+          <p:cNvPr id="22" name="node-180"/>
+          <p:cNvSpPr/>
+          <p:nvPr/>
+        </p:nvSpPr>
+        <p:spPr>
+          <a:xfrm>
+            <a:off x="2148840" y="2761488"/>
+            <a:ext cx="2148840" cy="713232"/>
+          </a:xfrm>
+          <a:prstGeom prst="roundRect">
+            <a:avLst>
+              <a:gd name="adj" fmla="val 12821"/>
+            </a:avLst>
+          </a:prstGeom>
+          <a:solidFill>
+            <a:schemeClr val="tx1"/>
+          </a:solidFill>
+          <a:ln/>
+        </p:spPr>
+      </p:sp>
+      <p:pic>
+        <p:nvPicPr>
+          <p:cNvPr id="23" name="icon-181" descr="preencoded.png">    </p:cNvPr>
+          <p:cNvPicPr>
+            <a:picLocks noChangeAspect="1"/>
+          </p:cNvPicPr>
+          <p:nvPr/>
+        </p:nvPicPr>
+        <p:blipFill>
+          <a:blip r:embed="rId3"/>
+          <a:stretch>
+            <a:fillRect/>
+          </a:stretch>
+        </p:blipFill>
+        <p:spPr>
+          <a:xfrm>
+            <a:off x="2276856" y="2889504"/>
+            <a:ext cx="292608" cy="292608"/>
+          </a:xfrm>
+          <a:prstGeom prst="rect">
+            <a:avLst/>
+          </a:prstGeom>
+        </p:spPr>
+      </p:pic>
+      <p:sp>
+        <p:nvSpPr>
+          <p:cNvPr id="24" name="node-title-182"/>
+          <p:cNvSpPr txBox="1"/>
+          <p:nvPr/>
+        </p:nvSpPr>
+        <p:spPr>
+          <a:xfrm>
+            <a:off x="2660904" y="2862072"/>
+            <a:ext cx="1508760" cy="347472"/>
+          </a:xfrm>
+          <a:prstGeom prst="rect">
+            <a:avLst/>
+          </a:prstGeom>
+          <a:noFill/>
+          <a:ln/>
+        </p:spPr>
+        <p:txBody>
+          <a:bodyPr wrap="square" lIns="0" tIns="0" rIns="0" bIns="0" rtlCol="0" anchor="ctr"/>
+          <a:lstStyle/>
+          <a:p>
+            <a:pPr indent="0" marL="0">
+              <a:buNone/>
+            </a:pPr>
+            <a:r>
+              <a:rPr lang="en-US" sz="1400" b="1" dirty="0">
+                <a:solidFill>
+                  <a:schemeClr val="bg1"/>
+                </a:solidFill>
+              </a:rPr>
+              <a:t>Evidence Collection</a:t>
+            </a:r>
+            <a:endParaRPr lang="en-US" sz="1400" dirty="0"/>
+          </a:p>
+        </p:txBody>
+      </p:sp>
+      <p:sp>
+        <p:nvSpPr>
+          <p:cNvPr id="25" name="node-sub-183"/>
+          <p:cNvSpPr txBox="1"/>
+          <p:nvPr/>
+        </p:nvSpPr>
+        <p:spPr>
+          <a:xfrm>
+            <a:off x="2276856" y="3255264"/>
+            <a:ext cx="1892808" cy="182880"/>
+          </a:xfrm>
+          <a:prstGeom prst="rect">
+            <a:avLst/>
+          </a:prstGeom>
+          <a:noFill/>
+          <a:ln/>
+        </p:spPr>
+        <p:txBody>
+          <a:bodyPr wrap="square" lIns="0" tIns="0" rIns="0" bIns="0" rtlCol="0" anchor="t"/>
+          <a:lstStyle/>
+          <a:p>
+            <a:pPr indent="0" marL="0">
+              <a:buNone/>
+            </a:pPr>
+            <a:r>
+              <a:rPr lang="en-US" sz="1050" dirty="0">
+                <a:solidFill>
+                  <a:schemeClr val="bg2"/>
+                </a:solidFill>
+              </a:rPr>
+              <a:t>the only agent with data access</a:t>
+            </a:r>
+            <a:endParaRPr lang="en-US" sz="1050" dirty="0"/>
+          </a:p>
+        </p:txBody>
+      </p:sp>
+      <p:sp>
+        <p:nvSpPr>
+          <p:cNvPr id="26" name="chip-184"/>
+          <p:cNvSpPr/>
+          <p:nvPr/>
+        </p:nvSpPr>
+        <p:spPr>
+          <a:xfrm>
+            <a:off x="4572000" y="2980944"/>
+            <a:ext cx="801014" cy="274320"/>
+          </a:xfrm>
+          <a:prstGeom prst="roundRect">
+            <a:avLst>
+              <a:gd name="adj" fmla="val 20000"/>
+            </a:avLst>
+          </a:prstGeom>
+          <a:solidFill>
+            <a:schemeClr val="bg1"/>
+          </a:solidFill>
+          <a:ln w="9525">
+            <a:solidFill>
+              <a:schemeClr val="tx2"/>
+            </a:solidFill>
+            <a:prstDash val="solid"/>
+          </a:ln>
+        </p:spPr>
+      </p:sp>
+      <p:sp>
+        <p:nvSpPr>
+          <p:cNvPr id="27" name="chip-text-185"/>
+          <p:cNvSpPr txBox="1"/>
+          <p:nvPr/>
+        </p:nvSpPr>
+        <p:spPr>
+          <a:xfrm>
+            <a:off x="4572000" y="2980944"/>
+            <a:ext cx="801014" cy="274320"/>
+          </a:xfrm>
+          <a:prstGeom prst="rect">
+            <a:avLst/>
+          </a:prstGeom>
+          <a:noFill/>
+          <a:ln/>
+        </p:spPr>
+        <p:txBody>
+          <a:bodyPr wrap="square" lIns="0" tIns="0" rIns="0" bIns="0" rtlCol="0" anchor="ctr"/>
+          <a:lstStyle/>
+          <a:p>
+            <a:pPr algn="ctr" indent="0" marL="0">
+              <a:buNone/>
+            </a:pPr>
+            <a:r>
+              <a:rPr lang="en-US" sz="1000" b="1" dirty="0">
+                <a:solidFill>
+                  <a:schemeClr val="tx1"/>
+                </a:solidFill>
+                <a:latin typeface="Courier New" pitchFamily="34" charset="0"/>
+                <a:ea typeface="Courier New" pitchFamily="34" charset="-122"/>
+                <a:cs typeface="Courier New" pitchFamily="34" charset="-120"/>
+              </a:rPr>
+              <a:t>db_query</a:t>
+            </a:r>
+            <a:endParaRPr lang="en-US" sz="1000" dirty="0"/>
+          </a:p>
+        </p:txBody>
+      </p:sp>
+      <p:sp>
+        <p:nvSpPr>
+          <p:cNvPr id="28" name="chip-186"/>
+          <p:cNvSpPr/>
+          <p:nvPr/>
+        </p:nvSpPr>
+        <p:spPr>
+          <a:xfrm>
+            <a:off x="5464454" y="2980944"/>
+            <a:ext cx="950976" cy="274320"/>
+          </a:xfrm>
+          <a:prstGeom prst="roundRect">
+            <a:avLst>
+              <a:gd name="adj" fmla="val 20000"/>
+            </a:avLst>
+          </a:prstGeom>
+          <a:solidFill>
+            <a:schemeClr val="bg1"/>
+          </a:solidFill>
+          <a:ln w="9525">
+            <a:solidFill>
+              <a:schemeClr val="tx2"/>
+            </a:solidFill>
+            <a:prstDash val="solid"/>
+          </a:ln>
+        </p:spPr>
+      </p:sp>
+      <p:sp>
+        <p:nvSpPr>
+          <p:cNvPr id="29" name="chip-text-187"/>
+          <p:cNvSpPr txBox="1"/>
+          <p:nvPr/>
+        </p:nvSpPr>
+        <p:spPr>
+          <a:xfrm>
+            <a:off x="5464454" y="2980944"/>
+            <a:ext cx="950976" cy="274320"/>
+          </a:xfrm>
+          <a:prstGeom prst="rect">
+            <a:avLst/>
+          </a:prstGeom>
+          <a:noFill/>
+          <a:ln/>
+        </p:spPr>
+        <p:txBody>
+          <a:bodyPr wrap="square" lIns="0" tIns="0" rIns="0" bIns="0" rtlCol="0" anchor="ctr"/>
+          <a:lstStyle/>
+          <a:p>
+            <a:pPr algn="ctr" indent="0" marL="0">
+              <a:buNone/>
+            </a:pPr>
+            <a:r>
+              <a:rPr lang="en-US" sz="1000" b="1" dirty="0">
+                <a:solidFill>
+                  <a:schemeClr val="tx1"/>
+                </a:solidFill>
+                <a:latin typeface="Courier New" pitchFamily="34" charset="0"/>
+                <a:ea typeface="Courier New" pitchFamily="34" charset="-122"/>
+                <a:cs typeface="Courier New" pitchFamily="34" charset="-120"/>
+              </a:rPr>
+              <a:t>policy_rag</a:t>
+            </a:r>
+            <a:endParaRPr lang="en-US" sz="1000" dirty="0"/>
+          </a:p>
+        </p:txBody>
+      </p:sp>
+      <p:sp>
+        <p:nvSpPr>
+          <p:cNvPr id="30" name="chip-188"/>
+          <p:cNvSpPr/>
+          <p:nvPr/>
+        </p:nvSpPr>
+        <p:spPr>
+          <a:xfrm>
+            <a:off x="8001000" y="2980944"/>
+            <a:ext cx="801014" cy="274320"/>
+          </a:xfrm>
+          <a:prstGeom prst="roundRect">
+            <a:avLst>
+              <a:gd name="adj" fmla="val 20000"/>
+            </a:avLst>
+          </a:prstGeom>
+          <a:solidFill>
+            <a:schemeClr val="tx1"/>
+          </a:solidFill>
+          <a:ln/>
+        </p:spPr>
+      </p:sp>
+      <p:sp>
+        <p:nvSpPr>
+          <p:cNvPr id="31" name="chip-text-189"/>
+          <p:cNvSpPr txBox="1"/>
+          <p:nvPr/>
+        </p:nvSpPr>
+        <p:spPr>
+          <a:xfrm>
+            <a:off x="8001000" y="2980944"/>
+            <a:ext cx="801014" cy="274320"/>
+          </a:xfrm>
+          <a:prstGeom prst="rect">
+            <a:avLst/>
+          </a:prstGeom>
+          <a:noFill/>
+          <a:ln/>
+        </p:spPr>
+        <p:txBody>
+          <a:bodyPr wrap="square" lIns="0" tIns="0" rIns="0" bIns="0" rtlCol="0" anchor="ctr"/>
+          <a:lstStyle/>
+          <a:p>
+            <a:pPr algn="ctr" indent="0" marL="0">
+              <a:buNone/>
+            </a:pPr>
+            <a:r>
+              <a:rPr lang="en-US" sz="1000" b="1" dirty="0">
+                <a:solidFill>
+                  <a:schemeClr val="bg1"/>
+                </a:solidFill>
+                <a:latin typeface="Courier New" pitchFamily="34" charset="0"/>
+                <a:ea typeface="Courier New" pitchFamily="34" charset="-122"/>
+                <a:cs typeface="Courier New" pitchFamily="34" charset="-120"/>
+              </a:rPr>
+              <a:t>CaseFile</a:t>
+            </a:r>
+            <a:endParaRPr lang="en-US" sz="1000" dirty="0"/>
+          </a:p>
+        </p:txBody>
+      </p:sp>
+      <p:sp>
+        <p:nvSpPr>
+          <p:cNvPr id="32" name="check-190"/>
+          <p:cNvSpPr txBox="1"/>
+          <p:nvPr/>
+        </p:nvSpPr>
+        <p:spPr>
+          <a:xfrm>
+            <a:off x="9829800" y="2816352"/>
+            <a:ext cx="1813255" cy="603504"/>
+          </a:xfrm>
+          <a:prstGeom prst="rect">
+            <a:avLst/>
+          </a:prstGeom>
+          <a:noFill/>
+          <a:ln/>
+        </p:spPr>
+        <p:txBody>
+          <a:bodyPr wrap="square" lIns="0" tIns="0" rIns="0" bIns="0" rtlCol="0" anchor="ctr"/>
+          <a:lstStyle/>
+          <a:p>
+            <a:pPr indent="0" marL="0">
+              <a:buNone/>
+            </a:pPr>
+            <a:r>
+              <a:rPr lang="en-US" sz="1100" dirty="0">
+                <a:solidFill>
+                  <a:schemeClr val="tx1"/>
+                </a:solidFill>
+              </a:rPr>
+              <a:t>Must call db_query; every item gets a citable ID</a:t>
+            </a:r>
+            <a:endParaRPr lang="en-US" sz="1100" dirty="0"/>
+          </a:p>
+        </p:txBody>
+      </p:sp>
+      <p:sp>
+        <p:nvSpPr>
+          <p:cNvPr id="33" name="arrow-191"/>
+          <p:cNvSpPr/>
+          <p:nvPr/>
+        </p:nvSpPr>
+        <p:spPr>
+          <a:xfrm>
+            <a:off x="1828800" y="3977640"/>
+            <a:ext cx="320040" cy="0"/>
+          </a:xfrm>
+          <a:prstGeom prst="line">
+            <a:avLst/>
+          </a:prstGeom>
+          <a:noFill/>
+          <a:ln w="19050">
+            <a:solidFill>
+              <a:schemeClr val="tx2"/>
+            </a:solidFill>
+            <a:prstDash val="solid"/>
+            <a:tailEnd type="triangle"/>
+          </a:ln>
+        </p:spPr>
+      </p:sp>
+      <p:sp>
+        <p:nvSpPr>
+          <p:cNvPr id="34" name="node-192"/>
+          <p:cNvSpPr/>
+          <p:nvPr/>
+        </p:nvSpPr>
+        <p:spPr>
+          <a:xfrm>
+            <a:off x="2148840" y="3621024"/>
+            <a:ext cx="1028700" cy="713232"/>
+          </a:xfrm>
+          <a:prstGeom prst="roundRect">
+            <a:avLst>
+              <a:gd name="adj" fmla="val 12821"/>
+            </a:avLst>
+          </a:prstGeom>
+          <a:solidFill>
+            <a:schemeClr val="accent1"/>
+          </a:solidFill>
+          <a:ln/>
+        </p:spPr>
+      </p:sp>
+      <p:sp>
+        <p:nvSpPr>
+          <p:cNvPr id="35" name="node-title-193"/>
+          <p:cNvSpPr txBox="1"/>
+          <p:nvPr/>
+        </p:nvSpPr>
+        <p:spPr>
+          <a:xfrm>
+            <a:off x="2276856" y="3675888"/>
+            <a:ext cx="772668" cy="603504"/>
+          </a:xfrm>
+          <a:prstGeom prst="rect">
+            <a:avLst/>
+          </a:prstGeom>
+          <a:noFill/>
+          <a:ln/>
+        </p:spPr>
+        <p:txBody>
+          <a:bodyPr wrap="square" lIns="0" tIns="0" rIns="0" bIns="0" rtlCol="0" anchor="ctr"/>
+          <a:lstStyle/>
+          <a:p>
+            <a:pPr indent="0" marL="0">
+              <a:buNone/>
+            </a:pPr>
+            <a:r>
+              <a:rPr lang="en-US" sz="1350" b="1" dirty="0">
+                <a:solidFill>
+                  <a:schemeClr val="bg1"/>
+                </a:solidFill>
+              </a:rPr>
+              <a:t>Rider’s advocate</a:t>
+            </a:r>
+            <a:endParaRPr lang="en-US" sz="1350" dirty="0"/>
+          </a:p>
+        </p:txBody>
+      </p:sp>
+      <p:sp>
+        <p:nvSpPr>
+          <p:cNvPr id="36" name="node-194"/>
+          <p:cNvSpPr/>
+          <p:nvPr/>
+        </p:nvSpPr>
+        <p:spPr>
+          <a:xfrm>
+            <a:off x="3268980" y="3621024"/>
+            <a:ext cx="1028700" cy="713232"/>
+          </a:xfrm>
+          <a:prstGeom prst="roundRect">
+            <a:avLst>
+              <a:gd name="adj" fmla="val 12821"/>
+            </a:avLst>
+          </a:prstGeom>
+          <a:solidFill>
+            <a:schemeClr val="accent2"/>
+          </a:solidFill>
+          <a:ln/>
+        </p:spPr>
+      </p:sp>
+      <p:sp>
+        <p:nvSpPr>
+          <p:cNvPr id="37" name="node-title-195"/>
+          <p:cNvSpPr txBox="1"/>
+          <p:nvPr/>
+        </p:nvSpPr>
+        <p:spPr>
+          <a:xfrm>
+            <a:off x="3396996" y="3675888"/>
+            <a:ext cx="772668" cy="603504"/>
+          </a:xfrm>
+          <a:prstGeom prst="rect">
+            <a:avLst/>
+          </a:prstGeom>
+          <a:noFill/>
+          <a:ln/>
+        </p:spPr>
+        <p:txBody>
+          <a:bodyPr wrap="square" lIns="0" tIns="0" rIns="0" bIns="0" rtlCol="0" anchor="ctr"/>
+          <a:lstStyle/>
+          <a:p>
+            <a:pPr indent="0" marL="0">
+              <a:buNone/>
+            </a:pPr>
+            <a:r>
+              <a:rPr lang="en-US" sz="1350" b="1" dirty="0">
+                <a:solidFill>
+                  <a:schemeClr val="bg1"/>
+                </a:solidFill>
+              </a:rPr>
+              <a:t>Driver’s advocate</a:t>
+            </a:r>
+            <a:endParaRPr lang="en-US" sz="1350" dirty="0"/>
+          </a:p>
+        </p:txBody>
+      </p:sp>
+      <p:sp>
+        <p:nvSpPr>
+          <p:cNvPr id="38" name="parallel-note"/>
+          <p:cNvSpPr txBox="1"/>
+          <p:nvPr/>
+        </p:nvSpPr>
+        <p:spPr>
+          <a:xfrm>
+            <a:off x="2148840" y="4338828"/>
+            <a:ext cx="2148840" cy="146304"/>
+          </a:xfrm>
+          <a:prstGeom prst="rect">
+            <a:avLst/>
+          </a:prstGeom>
+          <a:noFill/>
+          <a:ln/>
+        </p:spPr>
+        <p:txBody>
+          <a:bodyPr wrap="square" lIns="0" tIns="0" rIns="0" bIns="0" rtlCol="0" anchor="ctr"/>
+          <a:lstStyle/>
+          <a:p>
+            <a:pPr algn="ctr" indent="0" marL="0">
+              <a:buNone/>
+            </a:pPr>
+            <a:r>
+              <a:rPr lang="en-US" sz="850" i="1" dirty="0">
+                <a:solidFill>
+                  <a:schemeClr val="tx2"/>
+                </a:solidFill>
+              </a:rPr>
+              <a:t>in parallel, same case file</a:t>
+            </a:r>
+            <a:endParaRPr lang="en-US" sz="850" dirty="0"/>
+          </a:p>
+        </p:txBody>
+      </p:sp>
+      <p:sp>
+        <p:nvSpPr>
+          <p:cNvPr id="39" name="chip-196"/>
+          <p:cNvSpPr/>
+          <p:nvPr/>
+        </p:nvSpPr>
+        <p:spPr>
+          <a:xfrm>
+            <a:off x="4572000" y="3666744"/>
+            <a:ext cx="1325880" cy="274320"/>
+          </a:xfrm>
+          <a:prstGeom prst="roundRect">
+            <a:avLst>
+              <a:gd name="adj" fmla="val 20000"/>
+            </a:avLst>
+          </a:prstGeom>
+          <a:solidFill>
+            <a:schemeClr val="bg1"/>
+          </a:solidFill>
+          <a:ln w="9525">
+            <a:solidFill>
+              <a:schemeClr val="tx2"/>
+            </a:solidFill>
+            <a:prstDash val="solid"/>
+          </a:ln>
+        </p:spPr>
+      </p:sp>
+      <p:sp>
+        <p:nvSpPr>
+          <p:cNvPr id="40" name="chip-text-197"/>
+          <p:cNvSpPr txBox="1"/>
+          <p:nvPr/>
+        </p:nvSpPr>
+        <p:spPr>
+          <a:xfrm>
+            <a:off x="4572000" y="3666744"/>
+            <a:ext cx="1325880" cy="274320"/>
+          </a:xfrm>
+          <a:prstGeom prst="rect">
+            <a:avLst/>
+          </a:prstGeom>
+          <a:noFill/>
+          <a:ln/>
+        </p:spPr>
+        <p:txBody>
+          <a:bodyPr wrap="square" lIns="0" tIns="0" rIns="0" bIns="0" rtlCol="0" anchor="ctr"/>
+          <a:lstStyle/>
+          <a:p>
+            <a:pPr algn="ctr" indent="0" marL="0">
+              <a:buNone/>
+            </a:pPr>
+            <a:r>
+              <a:rPr lang="en-US" sz="1000" b="1" dirty="0">
+                <a:solidFill>
+                  <a:schemeClr val="tx1"/>
+                </a:solidFill>
+                <a:latin typeface="Courier New" pitchFamily="34" charset="0"/>
+                <a:ea typeface="Courier New" pitchFamily="34" charset="-122"/>
+                <a:cs typeface="Courier New" pitchFamily="34" charset="-120"/>
+              </a:rPr>
+              <a:t>evidence_lookup</a:t>
+            </a:r>
+            <a:endParaRPr lang="en-US" sz="1000" dirty="0"/>
+          </a:p>
+        </p:txBody>
+      </p:sp>
+      <p:sp>
+        <p:nvSpPr>
+          <p:cNvPr id="41" name="chip-198"/>
+          <p:cNvSpPr/>
+          <p:nvPr/>
+        </p:nvSpPr>
+        <p:spPr>
+          <a:xfrm>
+            <a:off x="5989320" y="3666744"/>
+            <a:ext cx="1250899" cy="274320"/>
+          </a:xfrm>
+          <a:prstGeom prst="roundRect">
+            <a:avLst>
+              <a:gd name="adj" fmla="val 20000"/>
+            </a:avLst>
+          </a:prstGeom>
+          <a:solidFill>
+            <a:schemeClr val="bg1"/>
+          </a:solidFill>
+          <a:ln w="9525">
+            <a:solidFill>
+              <a:schemeClr val="tx2"/>
+            </a:solidFill>
+            <a:prstDash val="solid"/>
+          </a:ln>
+        </p:spPr>
+      </p:sp>
+      <p:sp>
+        <p:nvSpPr>
+          <p:cNvPr id="42" name="chip-text-199"/>
+          <p:cNvSpPr txBox="1"/>
+          <p:nvPr/>
+        </p:nvSpPr>
+        <p:spPr>
+          <a:xfrm>
+            <a:off x="5989320" y="3666744"/>
+            <a:ext cx="1250899" cy="274320"/>
+          </a:xfrm>
+          <a:prstGeom prst="rect">
+            <a:avLst/>
+          </a:prstGeom>
+          <a:noFill/>
+          <a:ln/>
+        </p:spPr>
+        <p:txBody>
+          <a:bodyPr wrap="square" lIns="0" tIns="0" rIns="0" bIns="0" rtlCol="0" anchor="ctr"/>
+          <a:lstStyle/>
+          <a:p>
+            <a:pPr algn="ctr" indent="0" marL="0">
+              <a:buNone/>
+            </a:pPr>
+            <a:r>
+              <a:rPr lang="en-US" sz="1000" b="1" dirty="0">
+                <a:solidFill>
+                  <a:schemeClr val="tx1"/>
+                </a:solidFill>
+                <a:latin typeface="Courier New" pitchFamily="34" charset="0"/>
+                <a:ea typeface="Courier New" pitchFamily="34" charset="-122"/>
+                <a:cs typeface="Courier New" pitchFamily="34" charset="-120"/>
+              </a:rPr>
+              <a:t>image_analysis</a:t>
+            </a:r>
+            <a:endParaRPr lang="en-US" sz="1000" dirty="0"/>
+          </a:p>
+        </p:txBody>
+      </p:sp>
+      <p:sp>
+        <p:nvSpPr>
+          <p:cNvPr id="43" name="chip-200"/>
+          <p:cNvSpPr/>
+          <p:nvPr/>
+        </p:nvSpPr>
+        <p:spPr>
+          <a:xfrm>
+            <a:off x="4572000" y="4014216"/>
+            <a:ext cx="950976" cy="274320"/>
+          </a:xfrm>
+          <a:prstGeom prst="roundRect">
+            <a:avLst>
+              <a:gd name="adj" fmla="val 20000"/>
+            </a:avLst>
+          </a:prstGeom>
+          <a:solidFill>
+            <a:schemeClr val="bg1"/>
+          </a:solidFill>
+          <a:ln w="9525">
+            <a:solidFill>
+              <a:schemeClr val="tx2"/>
+            </a:solidFill>
+            <a:prstDash val="solid"/>
+          </a:ln>
+        </p:spPr>
+      </p:sp>
+      <p:sp>
+        <p:nvSpPr>
+          <p:cNvPr id="44" name="chip-text-201"/>
+          <p:cNvSpPr txBox="1"/>
+          <p:nvPr/>
+        </p:nvSpPr>
+        <p:spPr>
+          <a:xfrm>
+            <a:off x="4572000" y="4014216"/>
+            <a:ext cx="950976" cy="274320"/>
+          </a:xfrm>
+          <a:prstGeom prst="rect">
+            <a:avLst/>
+          </a:prstGeom>
+          <a:noFill/>
+          <a:ln/>
+        </p:spPr>
+        <p:txBody>
+          <a:bodyPr wrap="square" lIns="0" tIns="0" rIns="0" bIns="0" rtlCol="0" anchor="ctr"/>
+          <a:lstStyle/>
+          <a:p>
+            <a:pPr algn="ctr" indent="0" marL="0">
+              <a:buNone/>
+            </a:pPr>
+            <a:r>
+              <a:rPr lang="en-US" sz="1000" b="1" dirty="0">
+                <a:solidFill>
+                  <a:schemeClr val="tx1"/>
+                </a:solidFill>
+                <a:latin typeface="Courier New" pitchFamily="34" charset="0"/>
+                <a:ea typeface="Courier New" pitchFamily="34" charset="-122"/>
+                <a:cs typeface="Courier New" pitchFamily="34" charset="-120"/>
+              </a:rPr>
+              <a:t>policy_rag</a:t>
+            </a:r>
+            <a:endParaRPr lang="en-US" sz="1000" dirty="0"/>
+          </a:p>
+        </p:txBody>
+      </p:sp>
+      <p:sp>
+        <p:nvSpPr>
+          <p:cNvPr id="45" name="chip-202"/>
+          <p:cNvSpPr/>
+          <p:nvPr/>
+        </p:nvSpPr>
+        <p:spPr>
+          <a:xfrm>
+            <a:off x="8001000" y="3840480"/>
+            <a:ext cx="801014" cy="274320"/>
+          </a:xfrm>
+          <a:prstGeom prst="roundRect">
+            <a:avLst>
+              <a:gd name="adj" fmla="val 20000"/>
+            </a:avLst>
+          </a:prstGeom>
+          <a:solidFill>
+            <a:schemeClr val="tx1"/>
+          </a:solidFill>
+          <a:ln/>
+        </p:spPr>
+      </p:sp>
+      <p:sp>
+        <p:nvSpPr>
+          <p:cNvPr id="46" name="chip-text-203"/>
+          <p:cNvSpPr txBox="1"/>
+          <p:nvPr/>
+        </p:nvSpPr>
+        <p:spPr>
+          <a:xfrm>
+            <a:off x="8001000" y="3840480"/>
+            <a:ext cx="801014" cy="274320"/>
+          </a:xfrm>
+          <a:prstGeom prst="rect">
+            <a:avLst/>
+          </a:prstGeom>
+          <a:noFill/>
+          <a:ln/>
+        </p:spPr>
+        <p:txBody>
+          <a:bodyPr wrap="square" lIns="0" tIns="0" rIns="0" bIns="0" rtlCol="0" anchor="ctr"/>
+          <a:lstStyle/>
+          <a:p>
+            <a:pPr algn="ctr" indent="0" marL="0">
+              <a:buNone/>
+            </a:pPr>
+            <a:r>
+              <a:rPr lang="en-US" sz="1000" b="1" dirty="0">
+                <a:solidFill>
+                  <a:schemeClr val="bg1"/>
+                </a:solidFill>
+                <a:latin typeface="Courier New" pitchFamily="34" charset="0"/>
+                <a:ea typeface="Courier New" pitchFamily="34" charset="-122"/>
+                <a:cs typeface="Courier New" pitchFamily="34" charset="-120"/>
+              </a:rPr>
+              <a:t>Argument</a:t>
+            </a:r>
+            <a:endParaRPr lang="en-US" sz="1000" dirty="0"/>
+          </a:p>
+        </p:txBody>
+      </p:sp>
+      <p:sp>
+        <p:nvSpPr>
+          <p:cNvPr id="47" name="check-204"/>
+          <p:cNvSpPr txBox="1"/>
+          <p:nvPr/>
+        </p:nvSpPr>
+        <p:spPr>
+          <a:xfrm>
+            <a:off x="9829800" y="3675888"/>
+            <a:ext cx="1813255" cy="603504"/>
+          </a:xfrm>
+          <a:prstGeom prst="rect">
+            <a:avLst/>
+          </a:prstGeom>
+          <a:noFill/>
+          <a:ln/>
+        </p:spPr>
+        <p:txBody>
+          <a:bodyPr wrap="square" lIns="0" tIns="0" rIns="0" bIns="0" rtlCol="0" anchor="ctr"/>
+          <a:lstStyle/>
+          <a:p>
+            <a:pPr indent="0" marL="0">
+              <a:buNone/>
+            </a:pPr>
+            <a:r>
+              <a:rPr lang="en-US" sz="1100" dirty="0">
+                <a:solidFill>
+                  <a:schemeClr val="tx1"/>
+                </a:solidFill>
+              </a:rPr>
+              <a:t>Every cited ID must exist, or the claim is struck</a:t>
+            </a:r>
+            <a:endParaRPr lang="en-US" sz="1100" dirty="0"/>
+          </a:p>
+        </p:txBody>
+      </p:sp>
+      <p:sp>
+        <p:nvSpPr>
+          <p:cNvPr id="48" name="arrow-205"/>
+          <p:cNvSpPr/>
+          <p:nvPr/>
+        </p:nvSpPr>
+        <p:spPr>
+          <a:xfrm>
+            <a:off x="1828800" y="4837176"/>
+            <a:ext cx="320040" cy="0"/>
+          </a:xfrm>
+          <a:prstGeom prst="line">
+            <a:avLst/>
+          </a:prstGeom>
+          <a:noFill/>
+          <a:ln w="19050">
+            <a:solidFill>
+              <a:schemeClr val="tx2"/>
+            </a:solidFill>
+            <a:prstDash val="solid"/>
+            <a:tailEnd type="triangle"/>
+          </a:ln>
+        </p:spPr>
+      </p:sp>
+      <p:sp>
+        <p:nvSpPr>
+          <p:cNvPr id="49" name="node-206"/>
+          <p:cNvSpPr/>
+          <p:nvPr/>
+        </p:nvSpPr>
+        <p:spPr>
+          <a:xfrm>
+            <a:off x="2148840" y="4480560"/>
+            <a:ext cx="2148840" cy="713232"/>
+          </a:xfrm>
+          <a:prstGeom prst="roundRect">
+            <a:avLst>
+              <a:gd name="adj" fmla="val 12821"/>
+            </a:avLst>
+          </a:prstGeom>
+          <a:solidFill>
+            <a:schemeClr val="tx1"/>
+          </a:solidFill>
+          <a:ln/>
+        </p:spPr>
+      </p:sp>
+      <p:pic>
+        <p:nvPicPr>
+          <p:cNvPr id="50" name="icon-207" descr="preencoded.png">    </p:cNvPr>
+          <p:cNvPicPr>
+            <a:picLocks noChangeAspect="1"/>
+          </p:cNvPicPr>
+          <p:nvPr/>
+        </p:nvPicPr>
+        <p:blipFill>
+          <a:blip r:embed="rId4"/>
+          <a:stretch>
+            <a:fillRect/>
+          </a:stretch>
+        </p:blipFill>
+        <p:spPr>
+          <a:xfrm>
+            <a:off x="2276856" y="4608576"/>
+            <a:ext cx="292608" cy="292608"/>
+          </a:xfrm>
+          <a:prstGeom prst="rect">
+            <a:avLst/>
+          </a:prstGeom>
+        </p:spPr>
+      </p:pic>
+      <p:sp>
+        <p:nvSpPr>
+          <p:cNvPr id="51" name="node-title-208"/>
+          <p:cNvSpPr txBox="1"/>
+          <p:nvPr/>
+        </p:nvSpPr>
+        <p:spPr>
+          <a:xfrm>
+            <a:off x="2660904" y="4581144"/>
+            <a:ext cx="1508760" cy="347472"/>
+          </a:xfrm>
+          <a:prstGeom prst="rect">
+            <a:avLst/>
+          </a:prstGeom>
+          <a:noFill/>
+          <a:ln/>
+        </p:spPr>
+        <p:txBody>
+          <a:bodyPr wrap="square" lIns="0" tIns="0" rIns="0" bIns="0" rtlCol="0" anchor="ctr"/>
+          <a:lstStyle/>
+          <a:p>
+            <a:pPr indent="0" marL="0">
+              <a:buNone/>
+            </a:pPr>
+            <a:r>
+              <a:rPr lang="en-US" sz="1400" b="1" dirty="0">
+                <a:solidFill>
+                  <a:schemeClr val="bg1"/>
+                </a:solidFill>
+              </a:rPr>
+              <a:t>Judge</a:t>
+            </a:r>
+            <a:endParaRPr lang="en-US" sz="1400" dirty="0"/>
+          </a:p>
+        </p:txBody>
+      </p:sp>
+      <p:sp>
+        <p:nvSpPr>
+          <p:cNvPr id="52" name="node-sub-209"/>
+          <p:cNvSpPr txBox="1"/>
+          <p:nvPr/>
+        </p:nvSpPr>
+        <p:spPr>
+          <a:xfrm>
+            <a:off x="2276856" y="4974336"/>
+            <a:ext cx="1892808" cy="182880"/>
+          </a:xfrm>
+          <a:prstGeom prst="rect">
+            <a:avLst/>
+          </a:prstGeom>
+          <a:noFill/>
+          <a:ln/>
+        </p:spPr>
+        <p:txBody>
+          <a:bodyPr wrap="square" lIns="0" tIns="0" rIns="0" bIns="0" rtlCol="0" anchor="t"/>
+          <a:lstStyle/>
+          <a:p>
+            <a:pPr indent="0" marL="0">
+              <a:buNone/>
+            </a:pPr>
+            <a:r>
+              <a:rPr lang="en-US" sz="1050" dirty="0">
+                <a:solidFill>
+                  <a:schemeClr val="bg2"/>
+                </a:solidFill>
+              </a:rPr>
+              <a:t>never sees the complaint</a:t>
+            </a:r>
+            <a:endParaRPr lang="en-US" sz="1050" dirty="0"/>
+          </a:p>
+        </p:txBody>
+      </p:sp>
+      <p:sp>
+        <p:nvSpPr>
+          <p:cNvPr id="53" name="chip-210"/>
+          <p:cNvSpPr/>
+          <p:nvPr/>
+        </p:nvSpPr>
+        <p:spPr>
+          <a:xfrm>
+            <a:off x="4572000" y="4526280"/>
+            <a:ext cx="950976" cy="274320"/>
+          </a:xfrm>
+          <a:prstGeom prst="roundRect">
+            <a:avLst>
+              <a:gd name="adj" fmla="val 20000"/>
+            </a:avLst>
+          </a:prstGeom>
+          <a:solidFill>
+            <a:schemeClr val="bg1"/>
+          </a:solidFill>
+          <a:ln w="9525">
+            <a:solidFill>
+              <a:schemeClr val="tx2"/>
+            </a:solidFill>
+            <a:prstDash val="solid"/>
+          </a:ln>
+        </p:spPr>
+      </p:sp>
+      <p:sp>
+        <p:nvSpPr>
+          <p:cNvPr id="54" name="chip-text-211"/>
+          <p:cNvSpPr txBox="1"/>
+          <p:nvPr/>
+        </p:nvSpPr>
+        <p:spPr>
+          <a:xfrm>
+            <a:off x="4572000" y="4526280"/>
+            <a:ext cx="950976" cy="274320"/>
+          </a:xfrm>
+          <a:prstGeom prst="rect">
+            <a:avLst/>
+          </a:prstGeom>
+          <a:noFill/>
+          <a:ln/>
+        </p:spPr>
+        <p:txBody>
+          <a:bodyPr wrap="square" lIns="0" tIns="0" rIns="0" bIns="0" rtlCol="0" anchor="ctr"/>
+          <a:lstStyle/>
+          <a:p>
+            <a:pPr algn="ctr" indent="0" marL="0">
+              <a:buNone/>
+            </a:pPr>
+            <a:r>
+              <a:rPr lang="en-US" sz="1000" b="1" dirty="0">
+                <a:solidFill>
+                  <a:schemeClr val="tx1"/>
+                </a:solidFill>
+                <a:latin typeface="Courier New" pitchFamily="34" charset="0"/>
+                <a:ea typeface="Courier New" pitchFamily="34" charset="-122"/>
+                <a:cs typeface="Courier New" pitchFamily="34" charset="-120"/>
+              </a:rPr>
+              <a:t>policy_rag</a:t>
+            </a:r>
+            <a:endParaRPr lang="en-US" sz="1000" dirty="0"/>
+          </a:p>
+        </p:txBody>
+      </p:sp>
+      <p:sp>
+        <p:nvSpPr>
+          <p:cNvPr id="55" name="chip-212"/>
+          <p:cNvSpPr/>
+          <p:nvPr/>
+        </p:nvSpPr>
+        <p:spPr>
+          <a:xfrm>
+            <a:off x="5614416" y="4526280"/>
+            <a:ext cx="2000707" cy="274320"/>
+          </a:xfrm>
+          <a:prstGeom prst="roundRect">
+            <a:avLst>
+              <a:gd name="adj" fmla="val 20000"/>
+            </a:avLst>
+          </a:prstGeom>
+          <a:solidFill>
+            <a:schemeClr val="bg1"/>
+          </a:solidFill>
+          <a:ln w="9525">
+            <a:solidFill>
+              <a:schemeClr val="tx2"/>
+            </a:solidFill>
+            <a:prstDash val="solid"/>
+          </a:ln>
+        </p:spPr>
+      </p:sp>
+      <p:sp>
+        <p:nvSpPr>
+          <p:cNvPr id="56" name="chip-text-213"/>
+          <p:cNvSpPr txBox="1"/>
+          <p:nvPr/>
+        </p:nvSpPr>
+        <p:spPr>
+          <a:xfrm>
+            <a:off x="5614416" y="4526280"/>
+            <a:ext cx="2000707" cy="274320"/>
+          </a:xfrm>
+          <a:prstGeom prst="rect">
+            <a:avLst/>
+          </a:prstGeom>
+          <a:noFill/>
+          <a:ln/>
+        </p:spPr>
+        <p:txBody>
+          <a:bodyPr wrap="square" lIns="0" tIns="0" rIns="0" bIns="0" rtlCol="0" anchor="ctr"/>
+          <a:lstStyle/>
+          <a:p>
+            <a:pPr algn="ctr" indent="0" marL="0">
+              <a:buNone/>
+            </a:pPr>
+            <a:r>
+              <a:rPr lang="en-US" sz="1000" b="1" dirty="0">
+                <a:solidFill>
+                  <a:schemeClr val="tx1"/>
+                </a:solidFill>
+                <a:latin typeface="Courier New" pitchFamily="34" charset="0"/>
+                <a:ea typeface="Courier New" pitchFamily="34" charset="-122"/>
+                <a:cs typeface="Courier New" pitchFamily="34" charset="-120"/>
+              </a:rPr>
+              <a:t>escalation_bucket_lookup</a:t>
+            </a:r>
+            <a:endParaRPr lang="en-US" sz="1000" dirty="0"/>
+          </a:p>
+        </p:txBody>
+      </p:sp>
+      <p:sp>
+        <p:nvSpPr>
+          <p:cNvPr id="57" name="chip-214"/>
+          <p:cNvSpPr/>
+          <p:nvPr/>
+        </p:nvSpPr>
+        <p:spPr>
+          <a:xfrm>
+            <a:off x="4572000" y="4873752"/>
+            <a:ext cx="1250899" cy="274320"/>
+          </a:xfrm>
+          <a:prstGeom prst="roundRect">
+            <a:avLst>
+              <a:gd name="adj" fmla="val 20000"/>
+            </a:avLst>
+          </a:prstGeom>
+          <a:solidFill>
+            <a:schemeClr val="bg1"/>
+          </a:solidFill>
+          <a:ln w="9525">
+            <a:solidFill>
+              <a:schemeClr val="tx2"/>
+            </a:solidFill>
+            <a:prstDash val="solid"/>
+          </a:ln>
+        </p:spPr>
+      </p:sp>
+      <p:sp>
+        <p:nvSpPr>
+          <p:cNvPr id="58" name="chip-text-215"/>
+          <p:cNvSpPr txBox="1"/>
+          <p:nvPr/>
+        </p:nvSpPr>
+        <p:spPr>
+          <a:xfrm>
+            <a:off x="4572000" y="4873752"/>
+            <a:ext cx="1250899" cy="274320"/>
+          </a:xfrm>
+          <a:prstGeom prst="rect">
+            <a:avLst/>
+          </a:prstGeom>
+          <a:noFill/>
+          <a:ln/>
+        </p:spPr>
+        <p:txBody>
+          <a:bodyPr wrap="square" lIns="0" tIns="0" rIns="0" bIns="0" rtlCol="0" anchor="ctr"/>
+          <a:lstStyle/>
+          <a:p>
+            <a:pPr algn="ctr" indent="0" marL="0">
+              <a:buNone/>
+            </a:pPr>
+            <a:r>
+              <a:rPr lang="en-US" sz="1000" b="1" dirty="0">
+                <a:solidFill>
+                  <a:schemeClr val="tx1"/>
+                </a:solidFill>
+                <a:latin typeface="Courier New" pitchFamily="34" charset="0"/>
+                <a:ea typeface="Courier New" pitchFamily="34" charset="-122"/>
+                <a:cs typeface="Courier New" pitchFamily="34" charset="-120"/>
+              </a:rPr>
+              <a:t>escalate_to_l2</a:t>
+            </a:r>
+            <a:endParaRPr lang="en-US" sz="1000" dirty="0"/>
+          </a:p>
+        </p:txBody>
+      </p:sp>
+      <p:sp>
+        <p:nvSpPr>
+          <p:cNvPr id="59" name="chip-216"/>
+          <p:cNvSpPr/>
+          <p:nvPr/>
+        </p:nvSpPr>
+        <p:spPr>
+          <a:xfrm>
+            <a:off x="8001000" y="4700016"/>
+            <a:ext cx="1100938" cy="274320"/>
+          </a:xfrm>
+          <a:prstGeom prst="roundRect">
+            <a:avLst>
+              <a:gd name="adj" fmla="val 20000"/>
+            </a:avLst>
+          </a:prstGeom>
+          <a:solidFill>
+            <a:schemeClr val="tx1"/>
+          </a:solidFill>
+          <a:ln/>
+        </p:spPr>
+      </p:sp>
+      <p:sp>
+        <p:nvSpPr>
+          <p:cNvPr id="60" name="chip-text-217"/>
+          <p:cNvSpPr txBox="1"/>
+          <p:nvPr/>
+        </p:nvSpPr>
+        <p:spPr>
+          <a:xfrm>
+            <a:off x="8001000" y="4700016"/>
+            <a:ext cx="1100938" cy="274320"/>
+          </a:xfrm>
+          <a:prstGeom prst="rect">
+            <a:avLst/>
+          </a:prstGeom>
+          <a:noFill/>
+          <a:ln/>
+        </p:spPr>
+        <p:txBody>
+          <a:bodyPr wrap="square" lIns="0" tIns="0" rIns="0" bIns="0" rtlCol="0" anchor="ctr"/>
+          <a:lstStyle/>
+          <a:p>
+            <a:pPr algn="ctr" indent="0" marL="0">
+              <a:buNone/>
+            </a:pPr>
+            <a:r>
+              <a:rPr lang="en-US" sz="1000" b="1" dirty="0">
+                <a:solidFill>
+                  <a:schemeClr val="bg1"/>
+                </a:solidFill>
+                <a:latin typeface="Courier New" pitchFamily="34" charset="0"/>
+                <a:ea typeface="Courier New" pitchFamily="34" charset="-122"/>
+                <a:cs typeface="Courier New" pitchFamily="34" charset="-120"/>
+              </a:rPr>
+              <a:t>JudgeVerdict</a:t>
+            </a:r>
+            <a:endParaRPr lang="en-US" sz="1000" dirty="0"/>
+          </a:p>
+        </p:txBody>
+      </p:sp>
+      <p:sp>
+        <p:nvSpPr>
+          <p:cNvPr id="61" name="check-218"/>
+          <p:cNvSpPr txBox="1"/>
+          <p:nvPr/>
+        </p:nvSpPr>
+        <p:spPr>
+          <a:xfrm>
+            <a:off x="9829800" y="4535424"/>
+            <a:ext cx="1813255" cy="603504"/>
+          </a:xfrm>
+          <a:prstGeom prst="rect">
+            <a:avLst/>
+          </a:prstGeom>
+          <a:noFill/>
+          <a:ln/>
+        </p:spPr>
+        <p:txBody>
+          <a:bodyPr wrap="square" lIns="0" tIns="0" rIns="0" bIns="0" rtlCol="0" anchor="ctr"/>
+          <a:lstStyle/>
+          <a:p>
+            <a:pPr indent="0" marL="0">
+              <a:buNone/>
+            </a:pPr>
+            <a:r>
+              <a:rPr lang="en-US" sz="1100" dirty="0">
+                <a:solidFill>
+                  <a:schemeClr val="tx1"/>
+                </a:solidFill>
+              </a:rPr>
+              <a:t>Citations exist; fixed amounts are filled in by code</a:t>
+            </a:r>
+            <a:endParaRPr lang="en-US" sz="1100" dirty="0"/>
+          </a:p>
+        </p:txBody>
+      </p:sp>
+      <p:sp>
+        <p:nvSpPr>
+          <p:cNvPr id="62" name="shared-card"/>
+          <p:cNvSpPr/>
+          <p:nvPr/>
+        </p:nvSpPr>
+        <p:spPr>
+          <a:xfrm>
+            <a:off x="548640" y="5468112"/>
+            <a:ext cx="11094415" cy="566928"/>
+          </a:xfrm>
+          <a:prstGeom prst="roundRect">
+            <a:avLst>
+              <a:gd name="adj" fmla="val 19355"/>
             </a:avLst>
           </a:prstGeom>
           <a:solidFill>
@@ -11743,14 +13560,14 @@
       </p:sp>
       <p:sp>
         <p:nvSpPr>
-          <p:cNvPr id="8" name="stat-0-value"/>
-          <p:cNvSpPr txBox="1"/>
-          <p:nvPr/>
-        </p:nvSpPr>
-        <p:spPr>
-          <a:xfrm>
-            <a:off x="5394960" y="2057400"/>
-            <a:ext cx="2483968" cy="777240"/>
+          <p:cNvPr id="63" name="shared-text"/>
+          <p:cNvSpPr txBox="1"/>
+          <p:nvPr/>
+        </p:nvSpPr>
+        <p:spPr>
+          <a:xfrm>
+            <a:off x="822960" y="5468112"/>
+            <a:ext cx="10545775" cy="566928"/>
           </a:xfrm>
           <a:prstGeom prst="rect">
             <a:avLst/>
@@ -11766,27 +13583,110 @@
               <a:buNone/>
             </a:pPr>
             <a:r>
-              <a:rPr lang="en-US" sz="4000" b="1" dirty="0">
+              <a:rPr lang="en-US" sz="1250" b="1" dirty="0">
                 <a:solidFill>
                   <a:schemeClr val="tx1"/>
                 </a:solidFill>
               </a:rPr>
-              <a:t>13 of 22</a:t>
-            </a:r>
-            <a:endParaRPr lang="en-US" sz="4000" dirty="0"/>
-          </a:p>
-        </p:txBody>
-      </p:sp>
-      <p:sp>
-        <p:nvSpPr>
-          <p:cNvPr id="9" name="stat-0-label"/>
-          <p:cNvSpPr txBox="1"/>
-          <p:nvPr/>
-        </p:nvSpPr>
-        <p:spPr>
-          <a:xfrm>
-            <a:off x="5394960" y="2880360"/>
-            <a:ext cx="2483968" cy="640080"/>
+              <a:t>Every agent:  </a:t>
+            </a:r>
+            <a:pPr indent="0" marL="0">
+              <a:buNone/>
+            </a:pPr>
+            <a:r>
+              <a:rPr lang="en-US" sz="1250" dirty="0">
+                <a:solidFill>
+                  <a:schemeClr val="tx2"/>
+                </a:solidFill>
+              </a:rPr>
+              <a:t>pydantic-ai  ·  Qwen3-235B, Qwen3.6-27B as fallback  ·  retries on rate limits  ·  a Logfire span per run  ·  tokens logged</a:t>
+            </a:r>
+            <a:endParaRPr lang="en-US" sz="1250" dirty="0"/>
+          </a:p>
+        </p:txBody>
+      </p:sp>
+      <p:sp>
+        <p:nvSpPr>
+          <p:cNvPr id="25" name="Slide Number Placeholder 0"/>
+          <p:cNvSpPr>
+            <a:spLocks noGrp="1"/>
+          </p:cNvSpPr>
+          <p:nvPr>
+            <p:ph type="sldNum" sz="quarter" idx="4294967295"/>
+          </p:nvPr>
+        </p:nvSpPr>
+        <p:spPr>
+          <a:xfrm>
+            <a:off x="11094415" y="6400800"/>
+            <a:ext cx="548640" cy="274320"/>
+          </a:xfrm>
+          <a:prstGeom prst="rect">
+            <a:avLst/>
+          </a:prstGeom>
+          <a:extLst>
+            <a:ext uri="{C572A759-6A51-4108-AA02-DFA0A04FC94B}">
+              <ma14:wrappingTextBoxFlag xmlns:ma14="http://schemas.microsoft.com/office/mac/drawingml/2011/main" val="0"/>
+            </a:ext>
+          </a:extLst>
+        </p:spPr>
+        <p:txBody>
+          <a:bodyPr/>
+          <a:lstStyle>
+            <a:lvl1pPr>
+              <a:defRPr sz="1000">
+                <a:solidFill>
+                  <a:schemeClr val="tx2"/>
+                </a:solidFill>
+              </a:defRPr>
+            </a:lvl1pPr>
+          </a:lstStyle>
+          <a:p>
+            <a:pPr algn="r"/>
+            <a:fld id="{F7021451-1387-4CA6-816F-3879F97B5CBC}" type="slidenum">
+              <a:rPr b="0" lang="en-US"/>
+              <a:t>8</a:t>
+            </a:fld>
+            <a:endParaRPr lang="en-US"/>
+          </a:p>
+        </p:txBody>
+      </p:sp>
+    </p:spTree>
+  </p:cSld>
+  <p:clrMapOvr>
+    <a:masterClrMapping/>
+  </p:clrMapOvr>
+</p:sld>
+</file>
+
+<file path=ppt/slides/slide9.xml><?xml version="1.0" encoding="utf-8"?>
+<p:sld xmlns:a="http://schemas.openxmlformats.org/drawingml/2006/main" xmlns:r="http://schemas.openxmlformats.org/officeDocument/2006/relationships" xmlns:p="http://schemas.openxmlformats.org/presentationml/2006/main">
+  <p:cSld name="Slide 9">
+    <p:spTree>
+      <p:nvGrpSpPr>
+        <p:cNvPr id="1" name=""/>
+        <p:cNvGrpSpPr/>
+        <p:nvPr/>
+      </p:nvGrpSpPr>
+      <p:grpSpPr>
+        <a:xfrm>
+          <a:off x="0" y="0"/>
+          <a:ext cx="0" cy="0"/>
+          <a:chOff x="0" y="0"/>
+          <a:chExt cx="0" cy="0"/>
+        </a:xfrm>
+      </p:grpSpPr>
+      <p:sp>
+        <p:nvSpPr>
+          <p:cNvPr id="2" name="Text 1"/>
+          <p:cNvSpPr/>
+          <p:nvPr>
+            <p:ph idx="101" type="title" hasCustomPrompt="1"/>
+          </p:nvPr>
+        </p:nvSpPr>
+        <p:spPr>
+          <a:xfrm>
+            <a:off x="548640" y="384048"/>
+            <a:ext cx="11094415" cy="640080"/>
           </a:xfrm>
           <a:prstGeom prst="rect">
             <a:avLst/>
@@ -11798,44 +13698,176 @@
           <a:bodyPr wrap="square" lIns="0" tIns="0" rIns="0" bIns="0" rtlCol="0" anchor="t"/>
           <a:lstStyle/>
           <a:p>
-            <a:pPr indent="0" marL="0">
-              <a:buNone/>
-            </a:pPr>
-            <a:r>
-              <a:rPr lang="en-US" sz="1500" b="1" dirty="0">
+            <a:pPr algn="l" indent="0" marL="0">
+              <a:buNone/>
+            </a:pPr>
+            <a:r>
+              <a:rPr lang="en-US" sz="3200" b="1" dirty="0">
                 <a:solidFill>
                   <a:schemeClr val="tx1"/>
                 </a:solidFill>
               </a:rPr>
-              <a:t>decided with no person</a:t>
+              <a:t>Results</a:t>
+            </a:r>
+            <a:endParaRPr lang="en-US" sz="3200" dirty="0"/>
+          </a:p>
+        </p:txBody>
+      </p:sp>
+      <p:sp>
+        <p:nvSpPr>
+          <p:cNvPr id="3" name="Text 1"/>
+          <p:cNvSpPr/>
+          <p:nvPr>
+            <p:ph idx="102" type="body" hasCustomPrompt="1"/>
+          </p:nvPr>
+        </p:nvSpPr>
+        <p:spPr>
+          <a:xfrm>
+            <a:off x="548640" y="1024128"/>
+            <a:ext cx="11094415" cy="411480"/>
+          </a:xfrm>
+          <a:prstGeom prst="rect">
+            <a:avLst/>
+          </a:prstGeom>
+          <a:noFill/>
+          <a:ln/>
+        </p:spPr>
+        <p:txBody>
+          <a:bodyPr wrap="square" lIns="0" tIns="0" rIns="0" bIns="0" rtlCol="0" anchor="t"/>
+          <a:lstStyle/>
+          <a:p>
+            <a:pPr indent="0" marL="0">
+              <a:buNone/>
+            </a:pPr>
+            <a:r>
+              <a:rPr lang="en-US" sz="1500" dirty="0">
+                <a:solidFill>
+                  <a:schemeClr val="tx2"/>
+                </a:solidFill>
+              </a:rPr>
+              <a:t>22 labelled test cases, each run through the full pipeline with real model calls.</a:t>
             </a:r>
             <a:endParaRPr lang="en-US" sz="1500" dirty="0"/>
           </a:p>
-          <a:p>
-            <a:pPr indent="0" marL="0">
-              <a:buNone/>
-            </a:pPr>
-            <a:r>
-              <a:rPr lang="en-US" sz="1250" dirty="0">
-                <a:solidFill>
-                  <a:schemeClr val="tx2"/>
-                </a:solidFill>
-              </a:rPr>
-              <a:t>the other 9 went to a person, as the rules require</a:t>
-            </a:r>
-            <a:endParaRPr lang="en-US" sz="1500" dirty="0"/>
-          </a:p>
-        </p:txBody>
-      </p:sp>
-      <p:sp>
-        <p:nvSpPr>
-          <p:cNvPr id="10" name="stat-1"/>
-          <p:cNvSpPr/>
-          <p:nvPr/>
-        </p:nvSpPr>
-        <p:spPr>
-          <a:xfrm>
-            <a:off x="8519008" y="1783080"/>
+        </p:txBody>
+      </p:sp>
+      <p:sp>
+        <p:nvSpPr>
+          <p:cNvPr id="4" name="hero-card"/>
+          <p:cNvSpPr/>
+          <p:nvPr/>
+        </p:nvSpPr>
+        <p:spPr>
+          <a:xfrm>
+            <a:off x="548640" y="1783080"/>
+            <a:ext cx="4206240" cy="4069080"/>
+          </a:xfrm>
+          <a:prstGeom prst="roundRect">
+            <a:avLst>
+              <a:gd name="adj" fmla="val 3146"/>
+            </a:avLst>
+          </a:prstGeom>
+          <a:solidFill>
+            <a:schemeClr val="tx1"/>
+          </a:solidFill>
+          <a:ln/>
+        </p:spPr>
+      </p:sp>
+      <p:sp>
+        <p:nvSpPr>
+          <p:cNvPr id="5" name="hero-value"/>
+          <p:cNvSpPr txBox="1"/>
+          <p:nvPr/>
+        </p:nvSpPr>
+        <p:spPr>
+          <a:xfrm>
+            <a:off x="914400" y="2240280"/>
+            <a:ext cx="3474720" cy="1554480"/>
+          </a:xfrm>
+          <a:prstGeom prst="rect">
+            <a:avLst/>
+          </a:prstGeom>
+          <a:noFill/>
+          <a:ln/>
+        </p:spPr>
+        <p:txBody>
+          <a:bodyPr wrap="square" lIns="0" tIns="0" rIns="0" bIns="0" rtlCol="0" anchor="ctr"/>
+          <a:lstStyle/>
+          <a:p>
+            <a:pPr indent="0" marL="0">
+              <a:buNone/>
+            </a:pPr>
+            <a:r>
+              <a:rPr lang="en-US" sz="9600" b="1" dirty="0">
+                <a:solidFill>
+                  <a:schemeClr val="bg1"/>
+                </a:solidFill>
+              </a:rPr>
+              <a:t>22/22</a:t>
+            </a:r>
+            <a:endParaRPr lang="en-US" sz="9600" dirty="0"/>
+          </a:p>
+        </p:txBody>
+      </p:sp>
+      <p:sp>
+        <p:nvSpPr>
+          <p:cNvPr id="6" name="hero-label"/>
+          <p:cNvSpPr txBox="1"/>
+          <p:nvPr/>
+        </p:nvSpPr>
+        <p:spPr>
+          <a:xfrm>
+            <a:off x="914400" y="3977640"/>
+            <a:ext cx="3474720" cy="1463040"/>
+          </a:xfrm>
+          <a:prstGeom prst="rect">
+            <a:avLst/>
+          </a:prstGeom>
+          <a:noFill/>
+          <a:ln/>
+        </p:spPr>
+        <p:txBody>
+          <a:bodyPr wrap="square" lIns="0" tIns="0" rIns="0" bIns="0" rtlCol="0" anchor="t"/>
+          <a:lstStyle/>
+          <a:p>
+            <a:pPr indent="0" marL="0">
+              <a:buNone/>
+            </a:pPr>
+            <a:r>
+              <a:rPr lang="en-US" sz="2200" b="1" dirty="0">
+                <a:solidFill>
+                  <a:schemeClr val="bg1"/>
+                </a:solidFill>
+              </a:rPr>
+              <a:t>verdicts correct</a:t>
+            </a:r>
+            <a:endParaRPr lang="en-US" sz="2200" dirty="0"/>
+          </a:p>
+          <a:p>
+            <a:pPr indent="0" marL="0">
+              <a:buNone/>
+            </a:pPr>
+            <a:r>
+              <a:rPr lang="en-US" sz="1400" dirty="0">
+                <a:solidFill>
+                  <a:schemeClr val="bg2"/>
+                </a:solidFill>
+              </a:rPr>
+              <a:t>Outcome, remedy and exact amount all match the label, across every category.</a:t>
+            </a:r>
+            <a:endParaRPr lang="en-US" sz="2200" dirty="0"/>
+          </a:p>
+        </p:txBody>
+      </p:sp>
+      <p:sp>
+        <p:nvSpPr>
+          <p:cNvPr id="7" name="stat-0"/>
+          <p:cNvSpPr/>
+          <p:nvPr/>
+        </p:nvSpPr>
+        <p:spPr>
+          <a:xfrm>
+            <a:off x="5074920" y="1783080"/>
             <a:ext cx="3124048" cy="1874520"/>
           </a:xfrm>
           <a:prstGeom prst="roundRect">
@@ -11858,13 +13890,13 @@
       </p:sp>
       <p:sp>
         <p:nvSpPr>
-          <p:cNvPr id="11" name="stat-1-value"/>
-          <p:cNvSpPr txBox="1"/>
-          <p:nvPr/>
-        </p:nvSpPr>
-        <p:spPr>
-          <a:xfrm>
-            <a:off x="8839048" y="2057400"/>
+          <p:cNvPr id="8" name="stat-0-value"/>
+          <p:cNvSpPr txBox="1"/>
+          <p:nvPr/>
+        </p:nvSpPr>
+        <p:spPr>
+          <a:xfrm>
+            <a:off x="5394960" y="2057400"/>
             <a:ext cx="2483968" cy="777240"/>
           </a:xfrm>
           <a:prstGeom prst="rect">
@@ -11886,7 +13918,7 @@
                   <a:schemeClr val="tx1"/>
                 </a:solidFill>
               </a:rPr>
-              <a:t>100%</a:t>
+              <a:t>13 of 22</a:t>
             </a:r>
             <a:endParaRPr lang="en-US" sz="4000" dirty="0"/>
           </a:p>
@@ -11894,13 +13926,13 @@
       </p:sp>
       <p:sp>
         <p:nvSpPr>
-          <p:cNvPr id="12" name="stat-1-label"/>
-          <p:cNvSpPr txBox="1"/>
-          <p:nvPr/>
-        </p:nvSpPr>
-        <p:spPr>
-          <a:xfrm>
-            <a:off x="8839048" y="2880360"/>
+          <p:cNvPr id="9" name="stat-0-label"/>
+          <p:cNvSpPr txBox="1"/>
+          <p:nvPr/>
+        </p:nvSpPr>
+        <p:spPr>
+          <a:xfrm>
+            <a:off x="5394960" y="2880360"/>
             <a:ext cx="2483968" cy="640080"/>
           </a:xfrm>
           <a:prstGeom prst="rect">
@@ -11922,7 +13954,7 @@
                   <a:schemeClr val="tx1"/>
                 </a:solidFill>
               </a:rPr>
-              <a:t>safety reports to a person</a:t>
+              <a:t>decided with no person</a:t>
             </a:r>
             <a:endParaRPr lang="en-US" sz="1500" dirty="0"/>
           </a:p>
@@ -11936,7 +13968,7 @@
                   <a:schemeClr val="tx2"/>
                 </a:solidFill>
               </a:rPr>
-              <a:t>no AI ever decides one</a:t>
+              <a:t>the other 9 went to a person, as the rules require</a:t>
             </a:r>
             <a:endParaRPr lang="en-US" sz="1500" dirty="0"/>
           </a:p>
@@ -11944,13 +13976,13 @@
       </p:sp>
       <p:sp>
         <p:nvSpPr>
-          <p:cNvPr id="13" name="stat-2"/>
-          <p:cNvSpPr/>
-          <p:nvPr/>
-        </p:nvSpPr>
-        <p:spPr>
-          <a:xfrm>
-            <a:off x="5074920" y="3977640"/>
+          <p:cNvPr id="10" name="stat-1"/>
+          <p:cNvSpPr/>
+          <p:nvPr/>
+        </p:nvSpPr>
+        <p:spPr>
+          <a:xfrm>
+            <a:off x="8519008" y="1783080"/>
             <a:ext cx="3124048" cy="1874520"/>
           </a:xfrm>
           <a:prstGeom prst="roundRect">
@@ -11973,13 +14005,13 @@
       </p:sp>
       <p:sp>
         <p:nvSpPr>
-          <p:cNvPr id="14" name="stat-2-value"/>
-          <p:cNvSpPr txBox="1"/>
-          <p:nvPr/>
-        </p:nvSpPr>
-        <p:spPr>
-          <a:xfrm>
-            <a:off x="5394960" y="4251960"/>
+          <p:cNvPr id="11" name="stat-1-value"/>
+          <p:cNvSpPr txBox="1"/>
+          <p:nvPr/>
+        </p:nvSpPr>
+        <p:spPr>
+          <a:xfrm>
+            <a:off x="8839048" y="2057400"/>
             <a:ext cx="2483968" cy="777240"/>
           </a:xfrm>
           <a:prstGeom prst="rect">
@@ -12001,7 +14033,7 @@
                   <a:schemeClr val="tx1"/>
                 </a:solidFill>
               </a:rPr>
-              <a:t>$0.012</a:t>
+              <a:t>100%</a:t>
             </a:r>
             <a:endParaRPr lang="en-US" sz="4000" dirty="0"/>
           </a:p>
@@ -12009,13 +14041,13 @@
       </p:sp>
       <p:sp>
         <p:nvSpPr>
-          <p:cNvPr id="15" name="stat-2-label"/>
-          <p:cNvSpPr txBox="1"/>
-          <p:nvPr/>
-        </p:nvSpPr>
-        <p:spPr>
-          <a:xfrm>
-            <a:off x="5394960" y="5074920"/>
+          <p:cNvPr id="12" name="stat-1-label"/>
+          <p:cNvSpPr txBox="1"/>
+          <p:nvPr/>
+        </p:nvSpPr>
+        <p:spPr>
+          <a:xfrm>
+            <a:off x="8839048" y="2880360"/>
             <a:ext cx="2483968" cy="640080"/>
           </a:xfrm>
           <a:prstGeom prst="rect">
@@ -12037,7 +14069,7 @@
                   <a:schemeClr val="tx1"/>
                 </a:solidFill>
               </a:rPr>
-              <a:t>model cost per case</a:t>
+              <a:t>safety reports to a person</a:t>
             </a:r>
             <a:endParaRPr lang="en-US" sz="1500" dirty="0"/>
           </a:p>
@@ -12051,7 +14083,7 @@
                   <a:schemeClr val="tx2"/>
                 </a:solidFill>
               </a:rPr>
-              <a:t>about 124K input and 2.3K output tokens</a:t>
+              <a:t>no AI ever decides one</a:t>
             </a:r>
             <a:endParaRPr lang="en-US" sz="1500" dirty="0"/>
           </a:p>
@@ -12059,13 +14091,13 @@
       </p:sp>
       <p:sp>
         <p:nvSpPr>
-          <p:cNvPr id="16" name="stat-3"/>
-          <p:cNvSpPr/>
-          <p:nvPr/>
-        </p:nvSpPr>
-        <p:spPr>
-          <a:xfrm>
-            <a:off x="8519008" y="3977640"/>
+          <p:cNvPr id="13" name="stat-2"/>
+          <p:cNvSpPr/>
+          <p:nvPr/>
+        </p:nvSpPr>
+        <p:spPr>
+          <a:xfrm>
+            <a:off x="5074920" y="3977640"/>
             <a:ext cx="3124048" cy="1874520"/>
           </a:xfrm>
           <a:prstGeom prst="roundRect">
@@ -12088,6 +14120,121 @@
       </p:sp>
       <p:sp>
         <p:nvSpPr>
+          <p:cNvPr id="14" name="stat-2-value"/>
+          <p:cNvSpPr txBox="1"/>
+          <p:nvPr/>
+        </p:nvSpPr>
+        <p:spPr>
+          <a:xfrm>
+            <a:off x="5394960" y="4251960"/>
+            <a:ext cx="2483968" cy="777240"/>
+          </a:xfrm>
+          <a:prstGeom prst="rect">
+            <a:avLst/>
+          </a:prstGeom>
+          <a:noFill/>
+          <a:ln/>
+        </p:spPr>
+        <p:txBody>
+          <a:bodyPr wrap="square" lIns="0" tIns="0" rIns="0" bIns="0" rtlCol="0" anchor="ctr"/>
+          <a:lstStyle/>
+          <a:p>
+            <a:pPr indent="0" marL="0">
+              <a:buNone/>
+            </a:pPr>
+            <a:r>
+              <a:rPr lang="en-US" sz="4000" b="1" dirty="0">
+                <a:solidFill>
+                  <a:schemeClr val="tx1"/>
+                </a:solidFill>
+              </a:rPr>
+              <a:t>$0.012</a:t>
+            </a:r>
+            <a:endParaRPr lang="en-US" sz="4000" dirty="0"/>
+          </a:p>
+        </p:txBody>
+      </p:sp>
+      <p:sp>
+        <p:nvSpPr>
+          <p:cNvPr id="15" name="stat-2-label"/>
+          <p:cNvSpPr txBox="1"/>
+          <p:nvPr/>
+        </p:nvSpPr>
+        <p:spPr>
+          <a:xfrm>
+            <a:off x="5394960" y="5074920"/>
+            <a:ext cx="2483968" cy="640080"/>
+          </a:xfrm>
+          <a:prstGeom prst="rect">
+            <a:avLst/>
+          </a:prstGeom>
+          <a:noFill/>
+          <a:ln/>
+        </p:spPr>
+        <p:txBody>
+          <a:bodyPr wrap="square" lIns="0" tIns="0" rIns="0" bIns="0" rtlCol="0" anchor="t"/>
+          <a:lstStyle/>
+          <a:p>
+            <a:pPr indent="0" marL="0">
+              <a:buNone/>
+            </a:pPr>
+            <a:r>
+              <a:rPr lang="en-US" sz="1500" b="1" dirty="0">
+                <a:solidFill>
+                  <a:schemeClr val="tx1"/>
+                </a:solidFill>
+              </a:rPr>
+              <a:t>model cost per case</a:t>
+            </a:r>
+            <a:endParaRPr lang="en-US" sz="1500" dirty="0"/>
+          </a:p>
+          <a:p>
+            <a:pPr indent="0" marL="0">
+              <a:buNone/>
+            </a:pPr>
+            <a:r>
+              <a:rPr lang="en-US" sz="1250" dirty="0">
+                <a:solidFill>
+                  <a:schemeClr val="tx2"/>
+                </a:solidFill>
+              </a:rPr>
+              <a:t>about 124K input and 2.3K output tokens</a:t>
+            </a:r>
+            <a:endParaRPr lang="en-US" sz="1500" dirty="0"/>
+          </a:p>
+        </p:txBody>
+      </p:sp>
+      <p:sp>
+        <p:nvSpPr>
+          <p:cNvPr id="16" name="stat-3"/>
+          <p:cNvSpPr/>
+          <p:nvPr/>
+        </p:nvSpPr>
+        <p:spPr>
+          <a:xfrm>
+            <a:off x="8519008" y="3977640"/>
+            <a:ext cx="3124048" cy="1874520"/>
+          </a:xfrm>
+          <a:prstGeom prst="roundRect">
+            <a:avLst>
+              <a:gd name="adj" fmla="val 5854"/>
+            </a:avLst>
+          </a:prstGeom>
+          <a:solidFill>
+            <a:schemeClr val="bg1"/>
+          </a:solidFill>
+          <a:ln/>
+          <a:effectLst>
+            <a:outerShdw sx="100000" sy="100000" kx="0" ky="0" algn="bl" rotWithShape="0" blurRad="101600" dist="25400" dir="5400000">
+              <a:srgbClr val="000000">
+                <a:alpha val="8000"/>
+              </a:srgbClr>
+            </a:outerShdw>
+          </a:effectLst>
+        </p:spPr>
+      </p:sp>
+      <p:sp>
+        <p:nvSpPr>
           <p:cNvPr id="17" name="stat-3-value"/>
           <p:cNvSpPr txBox="1"/>
           <p:nvPr/>
@@ -12211,7 +14358,7 @@
             <a:pPr algn="r"/>
             <a:fld id="{F7021451-1387-4CA6-816F-3879F97B5CBC}" type="slidenum">
               <a:rPr b="0" lang="en-US"/>
-              <a:t>8</a:t>
+              <a:t>9</a:t>
             </a:fld>
             <a:endParaRPr lang="en-US"/>
           </a:p>

</xml_diff>

<commit_message>
Architecture deck: the README's pipeline diagram as the agentic-architecture flow
</commit_message>
<xml_diff>
--- a/submission/architecture.pptx
+++ b/submission/architecture.pptx
@@ -115,31 +115,31 @@
   <p:extLst>
     <p:ext uri="{521415D9-36F7-43E2-AB2F-B90AF26B5E84}">
       <p14:sectionLst xmlns:p14="http://schemas.microsoft.com/office/powerpoint/2010/main">
-        <p14:section name="Overview" id="{2f2d2624-4026-ff4f-a6bf-0c33c608a9be}">
+        <p14:section name="Overview" id="{099ad21f-4248-c82f-e652-a292d7e82195}">
           <p14:sldIdLst>
             <p14:sldId id="256"/>
           </p14:sldIdLst>
         </p14:section>
-        <p14:section name="The hearing" id="{217fdc10-10d1-971f-07ce-6d535297a380}">
+        <p14:section name="The hearing" id="{9d2ba6bd-8b7a-9cd7-838c-01c0f5604032}">
           <p14:sldIdLst>
             <p14:sldId id="257"/>
             <p14:sldId id="258"/>
             <p14:sldId id="259"/>
           </p14:sldIdLst>
         </p14:section>
-        <p14:section name="Safeguards" id="{30008fee-20dd-5c34-e1f2-bfa6954d9d94}">
+        <p14:section name="Safeguards" id="{25f7511d-80ca-7490-c417-f906deaa4022}">
           <p14:sldIdLst>
             <p14:sldId id="260"/>
             <p14:sldId id="261"/>
           </p14:sldIdLst>
         </p14:section>
-        <p14:section name="Platform" id="{5ec2374d-b1c0-f032-094d-780f80217a36}">
+        <p14:section name="Platform" id="{72f48d5e-ff60-5b17-cc55-c99b53b57bb3}">
           <p14:sldIdLst>
             <p14:sldId id="262"/>
             <p14:sldId id="263"/>
           </p14:sldIdLst>
         </p14:section>
-        <p14:section name="Results" id="{f2ae5677-ded4-621e-44c0-f0b9992dec80}">
+        <p14:section name="Results" id="{6874d5e2-8fcb-d44b-19c7-31acc47bb6d8}">
           <p14:sldIdLst>
             <p14:sldId id="264"/>
           </p14:sldIdLst>
@@ -724,7 +724,7 @@
           <a:p>
             <a:r>
               <a:rPr lang="en-US" dirty="0"/>
-              <a:t>Top row is intake. An agent triages the report, then six plain-code rules run: a safety flag hands the case to a person, and missing evidence declines it (the claimant can refile). Evidence Collection, the only agent allowed to read raw records, builds one case file; cleaning-fee photos get a vision check whose finding code maps to the fee tier. Bottom row is the hearing: two advocates argue in parallel from the identical case file, the Judge rules, and plain-code checks plus a compliance veto decide whether the ruling stands or goes to a person.</a:t>
+              <a:t>This is the agentic architecture as a flow, the same diagram as the README. Circles are AI agents; dashed hexagons are plain-code checks with no model; amber is a person. A claim is triaged by an agent; a safety flag sends it straight to a person. Six prevention rules can decline it, and the claimant can refile. Evidence Collection, the only agent with data access, builds one case file, with photos graded by Image Analysis and code setting the fee tier. After the other side responds, the rider's and driver's advocates argue from that same case file, and the Judge rules. The escalation gate and the compliance check run on every ruling: if both pass, the decision is final and cited; if either flags it, a human reviewer in the L2 console decides.</a:t>
             </a:r>
             <a:endParaRPr lang="en-US" dirty="0"/>
           </a:p>
@@ -3029,7 +3029,7 @@
                   <a:schemeClr val="tx1"/>
                 </a:solidFill>
               </a:rPr>
-              <a:t>One dispute, end to end</a:t>
+              <a:t>Agentic architecture</a:t>
             </a:r>
             <a:endParaRPr lang="en-US" sz="3200" dirty="0"/>
           </a:p>
@@ -3067,7 +3067,7 @@
                   <a:schemeClr val="tx2"/>
                 </a:solidFill>
               </a:rPr>
-              <a:t>Plain code connects the steps. Agents never call each other.</a:t>
+              <a:t>Code wires the agents together; they never call each other. Every case runs this path.</a:t>
             </a:r>
             <a:endParaRPr lang="en-US" sz="1500" dirty="0"/>
           </a:p>
@@ -3075,18 +3075,18 @@
       </p:sp>
       <p:sp>
         <p:nvSpPr>
-          <p:cNvPr id="4" name="node-1"/>
-          <p:cNvSpPr/>
-          <p:nvPr/>
-        </p:nvSpPr>
-        <p:spPr>
-          <a:xfrm>
-            <a:off x="548640" y="1783080"/>
-            <a:ext cx="1874520" cy="914400"/>
+          <p:cNvPr id="4" name="claim"/>
+          <p:cNvSpPr/>
+          <p:nvPr/>
+        </p:nvSpPr>
+        <p:spPr>
+          <a:xfrm>
+            <a:off x="548640" y="1920240"/>
+            <a:ext cx="1417320" cy="640080"/>
           </a:xfrm>
           <a:prstGeom prst="roundRect">
             <a:avLst>
-              <a:gd name="adj" fmla="val 10000"/>
+              <a:gd name="adj" fmla="val 50000"/>
             </a:avLst>
           </a:prstGeom>
           <a:solidFill>
@@ -3098,239 +3098,106 @@
             <a:solidFill>
               <a:schemeClr val="accent4"/>
             </a:solidFill>
-            <a:prstDash val="solid"/>
           </a:ln>
         </p:spPr>
-      </p:sp>
-      <p:pic>
-        <p:nvPicPr>
-          <p:cNvPr id="5" name="icon-2" descr="preencoded.png">    </p:cNvPr>
-          <p:cNvPicPr>
-            <a:picLocks noChangeAspect="1"/>
-          </p:cNvPicPr>
-          <p:nvPr/>
-        </p:nvPicPr>
-        <p:blipFill>
-          <a:blip r:embed="rId1"/>
-          <a:stretch>
-            <a:fillRect/>
-          </a:stretch>
-        </p:blipFill>
-        <p:spPr>
-          <a:xfrm>
-            <a:off x="676656" y="1911096"/>
-            <a:ext cx="292608" cy="292608"/>
-          </a:xfrm>
-          <a:prstGeom prst="rect">
-            <a:avLst/>
-          </a:prstGeom>
-        </p:spPr>
-      </p:pic>
-      <p:sp>
-        <p:nvSpPr>
-          <p:cNvPr id="6" name="node-title-3"/>
-          <p:cNvSpPr txBox="1"/>
-          <p:nvPr/>
-        </p:nvSpPr>
-        <p:spPr>
-          <a:xfrm>
-            <a:off x="1060704" y="1883664"/>
-            <a:ext cx="1234440" cy="347472"/>
-          </a:xfrm>
-          <a:prstGeom prst="rect">
-            <a:avLst/>
-          </a:prstGeom>
-          <a:noFill/>
-          <a:ln/>
-        </p:spPr>
-        <p:txBody>
-          <a:bodyPr wrap="square" lIns="0" tIns="0" rIns="0" bIns="0" rtlCol="0" anchor="ctr"/>
-          <a:lstStyle/>
-          <a:p>
-            <a:pPr indent="0" marL="0">
-              <a:buNone/>
-            </a:pPr>
-            <a:r>
-              <a:rPr lang="en-US" sz="1400" b="1" dirty="0">
+        <p:txBody>
+          <a:bodyPr wrap="square" lIns="508" tIns="508" rIns="508" bIns="508" rtlCol="0" anchor="ctr"/>
+          <a:lstStyle/>
+          <a:p>
+            <a:pPr algn="ctr" indent="0" marL="0">
+              <a:buNone/>
+            </a:pPr>
+            <a:r>
+              <a:rPr lang="en-US" sz="1200" b="1" dirty="0">
                 <a:solidFill>
                   <a:schemeClr val="tx1"/>
                 </a:solidFill>
               </a:rPr>
-              <a:t>Report filed</a:t>
-            </a:r>
-            <a:endParaRPr lang="en-US" sz="1400" dirty="0"/>
-          </a:p>
-        </p:txBody>
-      </p:sp>
-      <p:sp>
-        <p:nvSpPr>
-          <p:cNvPr id="7" name="node-sub-4"/>
-          <p:cNvSpPr txBox="1"/>
-          <p:nvPr/>
-        </p:nvSpPr>
-        <p:spPr>
-          <a:xfrm>
-            <a:off x="676656" y="2276856"/>
-            <a:ext cx="1618488" cy="384048"/>
-          </a:xfrm>
-          <a:prstGeom prst="rect">
-            <a:avLst/>
-          </a:prstGeom>
-          <a:noFill/>
-          <a:ln/>
-        </p:spPr>
-        <p:txBody>
-          <a:bodyPr wrap="square" lIns="0" tIns="0" rIns="0" bIns="0" rtlCol="0" anchor="t"/>
-          <a:lstStyle/>
-          <a:p>
-            <a:pPr indent="0" marL="0">
-              <a:buNone/>
-            </a:pPr>
-            <a:r>
-              <a:rPr lang="en-US" sz="1100" dirty="0">
-                <a:solidFill>
-                  <a:schemeClr val="tx2"/>
-                </a:solidFill>
-              </a:rPr>
-              <a:t>From the trip, in a chat</a:t>
-            </a:r>
-            <a:endParaRPr lang="en-US" sz="1100" dirty="0"/>
-          </a:p>
-        </p:txBody>
-      </p:sp>
-      <p:sp>
-        <p:nvSpPr>
-          <p:cNvPr id="8" name="node-5"/>
-          <p:cNvSpPr/>
-          <p:nvPr/>
-        </p:nvSpPr>
-        <p:spPr>
-          <a:xfrm>
-            <a:off x="2853614" y="1783080"/>
-            <a:ext cx="1874520" cy="914400"/>
-          </a:xfrm>
-          <a:prstGeom prst="roundRect">
-            <a:avLst>
-              <a:gd name="adj" fmla="val 10000"/>
-            </a:avLst>
+              <a:t>Claim filed</a:t>
+            </a:r>
+            <a:endParaRPr lang="en-US" sz="1200" dirty="0"/>
+          </a:p>
+          <a:p>
+            <a:pPr algn="ctr" indent="0" marL="0">
+              <a:buNone/>
+            </a:pPr>
+            <a:r>
+              <a:rPr lang="en-US" sz="950" dirty="0">
+                <a:solidFill>
+                  <a:schemeClr val="tx1"/>
+                </a:solidFill>
+              </a:rPr>
+              <a:t>rider or driver</a:t>
+            </a:r>
+            <a:endParaRPr lang="en-US" sz="1200" dirty="0"/>
+          </a:p>
+        </p:txBody>
+      </p:sp>
+      <p:sp>
+        <p:nvSpPr>
+          <p:cNvPr id="5" name="triage"/>
+          <p:cNvSpPr/>
+          <p:nvPr/>
+        </p:nvSpPr>
+        <p:spPr>
+          <a:xfrm>
+            <a:off x="2377440" y="1737360"/>
+            <a:ext cx="1005840" cy="1005840"/>
+          </a:xfrm>
+          <a:prstGeom prst="ellipse">
+            <a:avLst/>
           </a:prstGeom>
           <a:solidFill>
             <a:schemeClr val="tx1"/>
           </a:solidFill>
           <a:ln/>
         </p:spPr>
-      </p:sp>
-      <p:pic>
-        <p:nvPicPr>
-          <p:cNvPr id="9" name="icon-6" descr="preencoded.png">    </p:cNvPr>
-          <p:cNvPicPr>
-            <a:picLocks noChangeAspect="1"/>
-          </p:cNvPicPr>
-          <p:nvPr/>
-        </p:nvPicPr>
-        <p:blipFill>
-          <a:blip r:embed="rId2"/>
-          <a:stretch>
-            <a:fillRect/>
-          </a:stretch>
-        </p:blipFill>
-        <p:spPr>
-          <a:xfrm>
-            <a:off x="2981630" y="1911096"/>
-            <a:ext cx="292608" cy="292608"/>
-          </a:xfrm>
-          <a:prstGeom prst="rect">
-            <a:avLst/>
-          </a:prstGeom>
-        </p:spPr>
-      </p:pic>
-      <p:sp>
-        <p:nvSpPr>
-          <p:cNvPr id="10" name="node-title-7"/>
-          <p:cNvSpPr txBox="1"/>
-          <p:nvPr/>
-        </p:nvSpPr>
-        <p:spPr>
-          <a:xfrm>
-            <a:off x="3365678" y="1883664"/>
-            <a:ext cx="1234440" cy="347472"/>
-          </a:xfrm>
-          <a:prstGeom prst="rect">
-            <a:avLst/>
-          </a:prstGeom>
-          <a:noFill/>
-          <a:ln/>
-        </p:spPr>
-        <p:txBody>
-          <a:bodyPr wrap="square" lIns="0" tIns="0" rIns="0" bIns="0" rtlCol="0" anchor="ctr"/>
-          <a:lstStyle/>
-          <a:p>
-            <a:pPr indent="0" marL="0">
-              <a:buNone/>
-            </a:pPr>
-            <a:r>
-              <a:rPr lang="en-US" sz="1400" b="1" dirty="0">
+        <p:txBody>
+          <a:bodyPr wrap="square" lIns="508" tIns="508" rIns="508" bIns="508" rtlCol="0" anchor="ctr"/>
+          <a:lstStyle/>
+          <a:p>
+            <a:pPr algn="ctr" indent="0" marL="0">
+              <a:buNone/>
+            </a:pPr>
+            <a:r>
+              <a:rPr lang="en-US" sz="1200" b="1" dirty="0">
                 <a:solidFill>
                   <a:schemeClr val="bg1"/>
                 </a:solidFill>
               </a:rPr>
               <a:t>Triage</a:t>
             </a:r>
-            <a:endParaRPr lang="en-US" sz="1400" dirty="0"/>
-          </a:p>
-        </p:txBody>
-      </p:sp>
-      <p:sp>
-        <p:nvSpPr>
-          <p:cNvPr id="11" name="node-sub-8"/>
-          <p:cNvSpPr txBox="1"/>
-          <p:nvPr/>
-        </p:nvSpPr>
-        <p:spPr>
-          <a:xfrm>
-            <a:off x="2981630" y="2276856"/>
-            <a:ext cx="1618488" cy="384048"/>
-          </a:xfrm>
-          <a:prstGeom prst="rect">
-            <a:avLst/>
-          </a:prstGeom>
-          <a:noFill/>
-          <a:ln/>
-        </p:spPr>
-        <p:txBody>
-          <a:bodyPr wrap="square" lIns="0" tIns="0" rIns="0" bIns="0" rtlCol="0" anchor="t"/>
-          <a:lstStyle/>
-          <a:p>
-            <a:pPr indent="0" marL="0">
-              <a:buNone/>
-            </a:pPr>
-            <a:r>
-              <a:rPr lang="en-US" sz="1100" dirty="0">
-                <a:solidFill>
-                  <a:schemeClr val="bg2"/>
-                </a:solidFill>
-              </a:rPr>
-              <a:t>Kind of dispute, safety flag</a:t>
-            </a:r>
-            <a:endParaRPr lang="en-US" sz="1100" dirty="0"/>
-          </a:p>
-        </p:txBody>
-      </p:sp>
-      <p:sp>
-        <p:nvSpPr>
-          <p:cNvPr id="12" name="node-9"/>
-          <p:cNvSpPr/>
-          <p:nvPr/>
-        </p:nvSpPr>
-        <p:spPr>
-          <a:xfrm>
-            <a:off x="5158588" y="1783080"/>
-            <a:ext cx="1874520" cy="914400"/>
-          </a:xfrm>
-          <a:prstGeom prst="roundRect">
-            <a:avLst>
-              <a:gd name="adj" fmla="val 10000"/>
-            </a:avLst>
+            <a:endParaRPr lang="en-US" sz="1200" dirty="0"/>
+          </a:p>
+          <a:p>
+            <a:pPr algn="ctr" indent="0" marL="0">
+              <a:buNone/>
+            </a:pPr>
+            <a:r>
+              <a:rPr lang="en-US" sz="950" dirty="0">
+                <a:solidFill>
+                  <a:schemeClr val="bg1"/>
+                </a:solidFill>
+              </a:rPr>
+              <a:t>agent</a:t>
+            </a:r>
+            <a:endParaRPr lang="en-US" sz="1200" dirty="0"/>
+          </a:p>
+        </p:txBody>
+      </p:sp>
+      <p:sp>
+        <p:nvSpPr>
+          <p:cNvPr id="6" name="prevention"/>
+          <p:cNvSpPr/>
+          <p:nvPr/>
+        </p:nvSpPr>
+        <p:spPr>
+          <a:xfrm>
+            <a:off x="3794760" y="1801368"/>
+            <a:ext cx="1691640" cy="877824"/>
+          </a:xfrm>
+          <a:prstGeom prst="hexagon">
+            <a:avLst/>
           </a:prstGeom>
           <a:solidFill>
             <a:schemeClr val="bg1"/>
@@ -3342,113 +3209,101 @@
             <a:prstDash val="dash"/>
           </a:ln>
         </p:spPr>
-      </p:sp>
-      <p:pic>
-        <p:nvPicPr>
-          <p:cNvPr id="13" name="icon-10" descr="preencoded.png">    </p:cNvPr>
-          <p:cNvPicPr>
-            <a:picLocks noChangeAspect="1"/>
-          </p:cNvPicPr>
-          <p:nvPr/>
-        </p:nvPicPr>
-        <p:blipFill>
-          <a:blip r:embed="rId3"/>
-          <a:stretch>
-            <a:fillRect/>
-          </a:stretch>
-        </p:blipFill>
-        <p:spPr>
-          <a:xfrm>
-            <a:off x="5286604" y="1911096"/>
-            <a:ext cx="292608" cy="292608"/>
-          </a:xfrm>
-          <a:prstGeom prst="rect">
-            <a:avLst/>
-          </a:prstGeom>
-        </p:spPr>
-      </p:pic>
-      <p:sp>
-        <p:nvSpPr>
-          <p:cNvPr id="14" name="node-title-11"/>
-          <p:cNvSpPr txBox="1"/>
-          <p:nvPr/>
-        </p:nvSpPr>
-        <p:spPr>
-          <a:xfrm>
-            <a:off x="5670652" y="1883664"/>
-            <a:ext cx="1234440" cy="347472"/>
-          </a:xfrm>
-          <a:prstGeom prst="rect">
-            <a:avLst/>
-          </a:prstGeom>
-          <a:noFill/>
-          <a:ln/>
-        </p:spPr>
-        <p:txBody>
-          <a:bodyPr wrap="square" lIns="0" tIns="0" rIns="0" bIns="0" rtlCol="0" anchor="ctr"/>
-          <a:lstStyle/>
-          <a:p>
-            <a:pPr indent="0" marL="0">
-              <a:buNone/>
-            </a:pPr>
-            <a:r>
-              <a:rPr lang="en-US" sz="1400" b="1" dirty="0">
+        <p:txBody>
+          <a:bodyPr wrap="square" lIns="508" tIns="508" rIns="508" bIns="508" rtlCol="0" anchor="ctr"/>
+          <a:lstStyle/>
+          <a:p>
+            <a:pPr algn="ctr" indent="0" marL="0">
+              <a:buNone/>
+            </a:pPr>
+            <a:r>
+              <a:rPr lang="en-US" sz="1200" b="1" dirty="0">
                 <a:solidFill>
                   <a:schemeClr val="tx1"/>
                 </a:solidFill>
               </a:rPr>
-              <a:t>Eligibility</a:t>
-            </a:r>
-            <a:endParaRPr lang="en-US" sz="1400" dirty="0"/>
-          </a:p>
-        </p:txBody>
-      </p:sp>
-      <p:sp>
-        <p:nvSpPr>
-          <p:cNvPr id="15" name="node-sub-12"/>
-          <p:cNvSpPr txBox="1"/>
-          <p:nvPr/>
-        </p:nvSpPr>
-        <p:spPr>
-          <a:xfrm>
-            <a:off x="5286604" y="2276856"/>
-            <a:ext cx="1618488" cy="384048"/>
-          </a:xfrm>
-          <a:prstGeom prst="rect">
-            <a:avLst/>
-          </a:prstGeom>
-          <a:noFill/>
-          <a:ln/>
-        </p:spPr>
-        <p:txBody>
-          <a:bodyPr wrap="square" lIns="0" tIns="0" rIns="0" bIns="0" rtlCol="0" anchor="t"/>
-          <a:lstStyle/>
-          <a:p>
-            <a:pPr indent="0" marL="0">
-              <a:buNone/>
-            </a:pPr>
-            <a:r>
-              <a:rPr lang="en-US" sz="1100" dirty="0">
-                <a:solidFill>
-                  <a:schemeClr val="tx2"/>
-                </a:solidFill>
-              </a:rPr>
-              <a:t>Six rules, no AI</a:t>
-            </a:r>
-            <a:endParaRPr lang="en-US" sz="1100" dirty="0"/>
-          </a:p>
-        </p:txBody>
-      </p:sp>
-      <p:sp>
-        <p:nvSpPr>
-          <p:cNvPr id="16" name="node-13"/>
-          <p:cNvSpPr/>
-          <p:nvPr/>
-        </p:nvSpPr>
-        <p:spPr>
-          <a:xfrm>
-            <a:off x="7463561" y="1783080"/>
-            <a:ext cx="1874520" cy="914400"/>
+              <a:t>Prevention rules</a:t>
+            </a:r>
+            <a:endParaRPr lang="en-US" sz="1200" dirty="0"/>
+          </a:p>
+          <a:p>
+            <a:pPr algn="ctr" indent="0" marL="0">
+              <a:buNone/>
+            </a:pPr>
+            <a:r>
+              <a:rPr lang="en-US" sz="950" dirty="0">
+                <a:solidFill>
+                  <a:schemeClr val="tx1"/>
+                </a:solidFill>
+              </a:rPr>
+              <a:t>6 checks</a:t>
+            </a:r>
+            <a:endParaRPr lang="en-US" sz="1200" dirty="0"/>
+          </a:p>
+        </p:txBody>
+      </p:sp>
+      <p:sp>
+        <p:nvSpPr>
+          <p:cNvPr id="7" name="evidence"/>
+          <p:cNvSpPr/>
+          <p:nvPr/>
+        </p:nvSpPr>
+        <p:spPr>
+          <a:xfrm>
+            <a:off x="5852160" y="1691640"/>
+            <a:ext cx="1097280" cy="1097280"/>
+          </a:xfrm>
+          <a:prstGeom prst="ellipse">
+            <a:avLst/>
+          </a:prstGeom>
+          <a:solidFill>
+            <a:schemeClr val="tx1"/>
+          </a:solidFill>
+          <a:ln/>
+        </p:spPr>
+        <p:txBody>
+          <a:bodyPr wrap="square" lIns="508" tIns="508" rIns="508" bIns="508" rtlCol="0" anchor="ctr"/>
+          <a:lstStyle/>
+          <a:p>
+            <a:pPr algn="ctr" indent="0" marL="0">
+              <a:buNone/>
+            </a:pPr>
+            <a:r>
+              <a:rPr lang="en-US" sz="1200" b="1" dirty="0">
+                <a:solidFill>
+                  <a:schemeClr val="bg1"/>
+                </a:solidFill>
+              </a:rPr>
+              <a:t>Evidence</a:t>
+            </a:r>
+            <a:endParaRPr lang="en-US" sz="1200" dirty="0"/>
+          </a:p>
+          <a:p>
+            <a:pPr algn="ctr" indent="0" marL="0">
+              <a:buNone/>
+            </a:pPr>
+            <a:r>
+              <a:rPr lang="en-US" sz="950" dirty="0">
+                <a:solidFill>
+                  <a:schemeClr val="bg1"/>
+                </a:solidFill>
+              </a:rPr>
+              <a:t>Collection</a:t>
+            </a:r>
+            <a:endParaRPr lang="en-US" sz="1200" dirty="0"/>
+          </a:p>
+        </p:txBody>
+      </p:sp>
+      <p:sp>
+        <p:nvSpPr>
+          <p:cNvPr id="8" name="image"/>
+          <p:cNvSpPr/>
+          <p:nvPr/>
+        </p:nvSpPr>
+        <p:spPr>
+          <a:xfrm>
+            <a:off x="7360920" y="1874520"/>
+            <a:ext cx="1600200" cy="731520"/>
           </a:xfrm>
           <a:prstGeom prst="roundRect">
             <a:avLst>
@@ -3460,231 +3315,105 @@
           </a:solidFill>
           <a:ln/>
         </p:spPr>
-      </p:sp>
-      <p:pic>
-        <p:nvPicPr>
-          <p:cNvPr id="17" name="icon-14" descr="preencoded.png">    </p:cNvPr>
-          <p:cNvPicPr>
-            <a:picLocks noChangeAspect="1"/>
-          </p:cNvPicPr>
-          <p:nvPr/>
-        </p:nvPicPr>
-        <p:blipFill>
-          <a:blip r:embed="rId4"/>
-          <a:stretch>
-            <a:fillRect/>
-          </a:stretch>
-        </p:blipFill>
-        <p:spPr>
-          <a:xfrm>
-            <a:off x="7591577" y="1911096"/>
-            <a:ext cx="292608" cy="292608"/>
-          </a:xfrm>
-          <a:prstGeom prst="rect">
-            <a:avLst/>
-          </a:prstGeom>
-        </p:spPr>
-      </p:pic>
-      <p:sp>
-        <p:nvSpPr>
-          <p:cNvPr id="18" name="node-title-15"/>
-          <p:cNvSpPr txBox="1"/>
-          <p:nvPr/>
-        </p:nvSpPr>
-        <p:spPr>
-          <a:xfrm>
-            <a:off x="7975625" y="1883664"/>
-            <a:ext cx="1234440" cy="347472"/>
-          </a:xfrm>
-          <a:prstGeom prst="rect">
-            <a:avLst/>
-          </a:prstGeom>
-          <a:noFill/>
-          <a:ln/>
-        </p:spPr>
-        <p:txBody>
-          <a:bodyPr wrap="square" lIns="0" tIns="0" rIns="0" bIns="0" rtlCol="0" anchor="ctr"/>
-          <a:lstStyle/>
-          <a:p>
-            <a:pPr indent="0" marL="0">
-              <a:buNone/>
-            </a:pPr>
-            <a:r>
-              <a:rPr lang="en-US" sz="1400" b="1" dirty="0">
+        <p:txBody>
+          <a:bodyPr wrap="square" lIns="508" tIns="508" rIns="508" bIns="508" rtlCol="0" anchor="ctr"/>
+          <a:lstStyle/>
+          <a:p>
+            <a:pPr algn="ctr" indent="0" marL="0">
+              <a:buNone/>
+            </a:pPr>
+            <a:r>
+              <a:rPr lang="en-US" sz="1200" b="1" dirty="0">
                 <a:solidFill>
                   <a:schemeClr val="bg1"/>
                 </a:solidFill>
               </a:rPr>
-              <a:t>Evidence</a:t>
-            </a:r>
-            <a:endParaRPr lang="en-US" sz="1400" dirty="0"/>
-          </a:p>
-        </p:txBody>
-      </p:sp>
-      <p:sp>
-        <p:nvSpPr>
-          <p:cNvPr id="19" name="node-sub-16"/>
-          <p:cNvSpPr txBox="1"/>
-          <p:nvPr/>
-        </p:nvSpPr>
-        <p:spPr>
-          <a:xfrm>
-            <a:off x="7591577" y="2276856"/>
-            <a:ext cx="1618488" cy="384048"/>
-          </a:xfrm>
-          <a:prstGeom prst="rect">
-            <a:avLst/>
-          </a:prstGeom>
-          <a:noFill/>
-          <a:ln/>
-        </p:spPr>
-        <p:txBody>
-          <a:bodyPr wrap="square" lIns="0" tIns="0" rIns="0" bIns="0" rtlCol="0" anchor="t"/>
-          <a:lstStyle/>
-          <a:p>
-            <a:pPr indent="0" marL="0">
-              <a:buNone/>
-            </a:pPr>
-            <a:r>
-              <a:rPr lang="en-US" sz="1100" dirty="0">
-                <a:solidFill>
-                  <a:schemeClr val="bg2"/>
-                </a:solidFill>
-              </a:rPr>
-              <a:t>Builds one case file</a:t>
-            </a:r>
-            <a:endParaRPr lang="en-US" sz="1100" dirty="0"/>
-          </a:p>
-        </p:txBody>
-      </p:sp>
-      <p:sp>
-        <p:nvSpPr>
-          <p:cNvPr id="20" name="node-17"/>
-          <p:cNvSpPr/>
-          <p:nvPr/>
-        </p:nvSpPr>
-        <p:spPr>
-          <a:xfrm>
-            <a:off x="9768535" y="1783080"/>
-            <a:ext cx="1874520" cy="914400"/>
-          </a:xfrm>
-          <a:prstGeom prst="roundRect">
-            <a:avLst>
-              <a:gd name="adj" fmla="val 10000"/>
-            </a:avLst>
+              <a:t>Image Analysis</a:t>
+            </a:r>
+            <a:endParaRPr lang="en-US" sz="1200" dirty="0"/>
+          </a:p>
+          <a:p>
+            <a:pPr algn="ctr" indent="0" marL="0">
+              <a:buNone/>
+            </a:pPr>
+            <a:r>
+              <a:rPr lang="en-US" sz="950" dirty="0">
+                <a:solidFill>
+                  <a:schemeClr val="bg1"/>
+                </a:solidFill>
+              </a:rPr>
+              <a:t>vision → tier in code</a:t>
+            </a:r>
+            <a:endParaRPr lang="en-US" sz="1200" dirty="0"/>
+          </a:p>
+        </p:txBody>
+      </p:sp>
+      <p:sp>
+        <p:nvSpPr>
+          <p:cNvPr id="9" name="casefile"/>
+          <p:cNvSpPr/>
+          <p:nvPr/>
+        </p:nvSpPr>
+        <p:spPr>
+          <a:xfrm>
+            <a:off x="9418320" y="1737360"/>
+            <a:ext cx="1737360" cy="1005840"/>
+          </a:xfrm>
+          <a:prstGeom prst="can">
+            <a:avLst/>
           </a:prstGeom>
           <a:solidFill>
-            <a:schemeClr val="tx1"/>
+            <a:schemeClr val="bg1"/>
           </a:solidFill>
-          <a:ln/>
-        </p:spPr>
-      </p:sp>
-      <p:pic>
-        <p:nvPicPr>
-          <p:cNvPr id="21" name="icon-18" descr="preencoded.png">    </p:cNvPr>
-          <p:cNvPicPr>
-            <a:picLocks noChangeAspect="1"/>
-          </p:cNvPicPr>
-          <p:nvPr/>
-        </p:nvPicPr>
-        <p:blipFill>
-          <a:blip r:embed="rId5"/>
-          <a:stretch>
-            <a:fillRect/>
-          </a:stretch>
-        </p:blipFill>
-        <p:spPr>
-          <a:xfrm>
-            <a:off x="9896551" y="1911096"/>
-            <a:ext cx="292608" cy="292608"/>
-          </a:xfrm>
-          <a:prstGeom prst="rect">
-            <a:avLst/>
-          </a:prstGeom>
-        </p:spPr>
-      </p:pic>
-      <p:sp>
-        <p:nvSpPr>
-          <p:cNvPr id="22" name="node-title-19"/>
-          <p:cNvSpPr txBox="1"/>
-          <p:nvPr/>
-        </p:nvSpPr>
-        <p:spPr>
-          <a:xfrm>
-            <a:off x="10280599" y="1883664"/>
-            <a:ext cx="1234440" cy="347472"/>
-          </a:xfrm>
-          <a:prstGeom prst="rect">
-            <a:avLst/>
-          </a:prstGeom>
-          <a:noFill/>
-          <a:ln/>
-        </p:spPr>
-        <p:txBody>
-          <a:bodyPr wrap="square" lIns="0" tIns="0" rIns="0" bIns="0" rtlCol="0" anchor="ctr"/>
-          <a:lstStyle/>
-          <a:p>
-            <a:pPr indent="0" marL="0">
-              <a:buNone/>
-            </a:pPr>
-            <a:r>
-              <a:rPr lang="en-US" sz="1400" b="1" dirty="0">
-                <a:solidFill>
-                  <a:schemeClr val="bg1"/>
-                </a:solidFill>
-              </a:rPr>
-              <a:t>Photo check</a:t>
-            </a:r>
-            <a:endParaRPr lang="en-US" sz="1400" dirty="0"/>
-          </a:p>
-        </p:txBody>
-      </p:sp>
-      <p:sp>
-        <p:nvSpPr>
-          <p:cNvPr id="23" name="node-sub-20"/>
-          <p:cNvSpPr txBox="1"/>
-          <p:nvPr/>
-        </p:nvSpPr>
-        <p:spPr>
-          <a:xfrm>
-            <a:off x="9896551" y="2276856"/>
-            <a:ext cx="1618488" cy="384048"/>
-          </a:xfrm>
-          <a:prstGeom prst="rect">
-            <a:avLst/>
-          </a:prstGeom>
-          <a:noFill/>
-          <a:ln/>
-        </p:spPr>
-        <p:txBody>
-          <a:bodyPr wrap="square" lIns="0" tIns="0" rIns="0" bIns="0" rtlCol="0" anchor="t"/>
-          <a:lstStyle/>
-          <a:p>
-            <a:pPr indent="0" marL="0">
-              <a:buNone/>
-            </a:pPr>
-            <a:r>
-              <a:rPr lang="en-US" sz="1100" dirty="0">
-                <a:solidFill>
-                  <a:schemeClr val="bg2"/>
-                </a:solidFill>
-              </a:rPr>
-              <a:t>Code sets the fee tier</a:t>
-            </a:r>
-            <a:endParaRPr lang="en-US" sz="1100" dirty="0"/>
-          </a:p>
-        </p:txBody>
-      </p:sp>
-      <p:sp>
-        <p:nvSpPr>
-          <p:cNvPr id="24" name="arrow-21"/>
-          <p:cNvSpPr/>
-          <p:nvPr/>
-        </p:nvSpPr>
-        <p:spPr>
-          <a:xfrm>
-            <a:off x="2423160" y="2240280"/>
-            <a:ext cx="430454" cy="0"/>
+          <a:ln w="15875">
+            <a:solidFill>
+              <a:schemeClr val="tx1"/>
+            </a:solidFill>
+          </a:ln>
+        </p:spPr>
+        <p:txBody>
+          <a:bodyPr wrap="square" lIns="508" tIns="508" rIns="508" bIns="508" rtlCol="0" anchor="ctr"/>
+          <a:lstStyle/>
+          <a:p>
+            <a:pPr algn="ctr" indent="0" marL="0">
+              <a:buNone/>
+            </a:pPr>
+            <a:r>
+              <a:rPr lang="en-US" sz="1200" b="1" dirty="0">
+                <a:solidFill>
+                  <a:schemeClr val="tx1"/>
+                </a:solidFill>
+              </a:rPr>
+              <a:t>Case file</a:t>
+            </a:r>
+            <a:endParaRPr lang="en-US" sz="1200" dirty="0"/>
+          </a:p>
+          <a:p>
+            <a:pPr algn="ctr" indent="0" marL="0">
+              <a:buNone/>
+            </a:pPr>
+            <a:r>
+              <a:rPr lang="en-US" sz="950" dirty="0">
+                <a:solidFill>
+                  <a:schemeClr val="tx1"/>
+                </a:solidFill>
+              </a:rPr>
+              <a:t>every item citable</a:t>
+            </a:r>
+            <a:endParaRPr lang="en-US" sz="1200" dirty="0"/>
+          </a:p>
+        </p:txBody>
+      </p:sp>
+      <p:sp>
+        <p:nvSpPr>
+          <p:cNvPr id="10" name="arrow-1"/>
+          <p:cNvSpPr/>
+          <p:nvPr/>
+        </p:nvSpPr>
+        <p:spPr>
+          <a:xfrm>
+            <a:off x="1965960" y="2240280"/>
+            <a:ext cx="411480" cy="0"/>
           </a:xfrm>
           <a:prstGeom prst="line">
             <a:avLst/>
@@ -3701,14 +3430,14 @@
       </p:sp>
       <p:sp>
         <p:nvSpPr>
-          <p:cNvPr id="25" name="arrow-22"/>
-          <p:cNvSpPr/>
-          <p:nvPr/>
-        </p:nvSpPr>
-        <p:spPr>
-          <a:xfrm>
-            <a:off x="4728134" y="2240280"/>
-            <a:ext cx="430454" cy="0"/>
+          <p:cNvPr id="11" name="arrow-2"/>
+          <p:cNvSpPr/>
+          <p:nvPr/>
+        </p:nvSpPr>
+        <p:spPr>
+          <a:xfrm>
+            <a:off x="3383280" y="2240280"/>
+            <a:ext cx="411480" cy="0"/>
           </a:xfrm>
           <a:prstGeom prst="line">
             <a:avLst/>
@@ -3725,14 +3454,14 @@
       </p:sp>
       <p:sp>
         <p:nvSpPr>
-          <p:cNvPr id="26" name="arrow-23"/>
-          <p:cNvSpPr/>
-          <p:nvPr/>
-        </p:nvSpPr>
-        <p:spPr>
-          <a:xfrm>
-            <a:off x="7033108" y="2240280"/>
-            <a:ext cx="430454" cy="0"/>
+          <p:cNvPr id="12" name="arrow-3"/>
+          <p:cNvSpPr/>
+          <p:nvPr/>
+        </p:nvSpPr>
+        <p:spPr>
+          <a:xfrm>
+            <a:off x="5486400" y="2240280"/>
+            <a:ext cx="365760" cy="0"/>
           </a:xfrm>
           <a:prstGeom prst="line">
             <a:avLst/>
@@ -3749,14 +3478,14 @@
       </p:sp>
       <p:sp>
         <p:nvSpPr>
-          <p:cNvPr id="27" name="arrow-24"/>
-          <p:cNvSpPr/>
-          <p:nvPr/>
-        </p:nvSpPr>
-        <p:spPr>
-          <a:xfrm>
-            <a:off x="9338081" y="2240280"/>
-            <a:ext cx="430454" cy="0"/>
+          <p:cNvPr id="13" name="arrow-4"/>
+          <p:cNvSpPr/>
+          <p:nvPr/>
+        </p:nvSpPr>
+        <p:spPr>
+          <a:xfrm>
+            <a:off x="6949440" y="2240280"/>
+            <a:ext cx="411480" cy="0"/>
           </a:xfrm>
           <a:prstGeom prst="line">
             <a:avLst/>
@@ -3773,67 +3502,285 @@
       </p:sp>
       <p:sp>
         <p:nvSpPr>
-          <p:cNvPr id="28" name="node-25"/>
-          <p:cNvSpPr/>
-          <p:nvPr/>
-        </p:nvSpPr>
-        <p:spPr>
-          <a:xfrm>
-            <a:off x="4655668" y="2971800"/>
-            <a:ext cx="1325880" cy="457200"/>
+          <p:cNvPr id="14" name="arrow-5"/>
+          <p:cNvSpPr/>
+          <p:nvPr/>
+        </p:nvSpPr>
+        <p:spPr>
+          <a:xfrm>
+            <a:off x="8961120" y="2240280"/>
+            <a:ext cx="457200" cy="0"/>
+          </a:xfrm>
+          <a:prstGeom prst="line">
+            <a:avLst/>
+          </a:prstGeom>
+          <a:noFill/>
+          <a:ln w="19050">
+            <a:solidFill>
+              <a:schemeClr val="tx2"/>
+            </a:solidFill>
+            <a:prstDash val="solid"/>
+            <a:tailEnd type="triangle"/>
+          </a:ln>
+        </p:spPr>
+      </p:sp>
+      <p:sp>
+        <p:nvSpPr>
+          <p:cNvPr id="15" name="flow-tag-6"/>
+          <p:cNvSpPr txBox="1"/>
+          <p:nvPr/>
+        </p:nvSpPr>
+        <p:spPr>
+          <a:xfrm>
+            <a:off x="7360920" y="2642616"/>
+            <a:ext cx="1600200" cy="201168"/>
+          </a:xfrm>
+          <a:prstGeom prst="rect">
+            <a:avLst/>
+          </a:prstGeom>
+          <a:noFill/>
+          <a:ln/>
+        </p:spPr>
+        <p:txBody>
+          <a:bodyPr wrap="square" lIns="0" tIns="0" rIns="0" bIns="0" rtlCol="0" anchor="ctr"/>
+          <a:lstStyle/>
+          <a:p>
+            <a:pPr algn="ctr" indent="0" marL="0">
+              <a:buNone/>
+            </a:pPr>
+            <a:r>
+              <a:rPr lang="en-US" sz="950" i="1" dirty="0">
+                <a:solidFill>
+                  <a:schemeClr val="tx2"/>
+                </a:solidFill>
+              </a:rPr>
+              <a:t>photos only</a:t>
+            </a:r>
+            <a:endParaRPr lang="en-US" sz="950" dirty="0"/>
+          </a:p>
+        </p:txBody>
+      </p:sp>
+      <p:sp>
+        <p:nvSpPr>
+          <p:cNvPr id="16" name="exit-safety"/>
+          <p:cNvSpPr/>
+          <p:nvPr/>
+        </p:nvSpPr>
+        <p:spPr>
+          <a:xfrm>
+            <a:off x="2057400" y="3044952"/>
+            <a:ext cx="1645920" cy="384048"/>
           </a:xfrm>
           <a:prstGeom prst="roundRect">
             <a:avLst>
-              <a:gd name="adj" fmla="val 20000"/>
+              <a:gd name="adj" fmla="val 23810"/>
             </a:avLst>
           </a:prstGeom>
           <a:solidFill>
-            <a:schemeClr val="accent5">
-              <a:alpha val="12000"/>
+            <a:schemeClr val="accent4">
+              <a:alpha val="14000"/>
             </a:schemeClr>
           </a:solidFill>
-          <a:ln w="15875">
+          <a:ln w="19050">
+            <a:solidFill>
+              <a:schemeClr val="accent4"/>
+            </a:solidFill>
+          </a:ln>
+        </p:spPr>
+        <p:txBody>
+          <a:bodyPr wrap="square" lIns="508" tIns="508" rIns="508" bIns="508" rtlCol="0" anchor="ctr"/>
+          <a:lstStyle/>
+          <a:p>
+            <a:pPr algn="ctr" indent="0" marL="0">
+              <a:buNone/>
+            </a:pPr>
+            <a:r>
+              <a:rPr lang="en-US" sz="1100" b="1" dirty="0">
+                <a:solidFill>
+                  <a:schemeClr val="tx1"/>
+                </a:solidFill>
+              </a:rPr>
+              <a:t>Safety → a person</a:t>
+            </a:r>
+            <a:endParaRPr lang="en-US" sz="1100" dirty="0"/>
+          </a:p>
+        </p:txBody>
+      </p:sp>
+      <p:sp>
+        <p:nvSpPr>
+          <p:cNvPr id="17" name="exit-declined"/>
+          <p:cNvSpPr/>
+          <p:nvPr/>
+        </p:nvSpPr>
+        <p:spPr>
+          <a:xfrm>
+            <a:off x="3794760" y="3044952"/>
+            <a:ext cx="1691640" cy="384048"/>
+          </a:xfrm>
+          <a:prstGeom prst="roundRect">
+            <a:avLst>
+              <a:gd name="adj" fmla="val 50000"/>
+            </a:avLst>
+          </a:prstGeom>
+          <a:solidFill>
+            <a:schemeClr val="bg1"/>
+          </a:solidFill>
+          <a:ln w="12700">
+            <a:solidFill>
+              <a:schemeClr val="tx2"/>
+            </a:solidFill>
+            <a:prstDash val="dash"/>
+          </a:ln>
+        </p:spPr>
+        <p:txBody>
+          <a:bodyPr wrap="square" lIns="508" tIns="508" rIns="508" bIns="508" rtlCol="0" anchor="ctr"/>
+          <a:lstStyle/>
+          <a:p>
+            <a:pPr algn="ctr" indent="0" marL="0">
+              <a:buNone/>
+            </a:pPr>
+            <a:r>
+              <a:rPr lang="en-US" sz="1100" b="1" dirty="0">
+                <a:solidFill>
+                  <a:schemeClr val="tx1"/>
+                </a:solidFill>
+              </a:rPr>
+              <a:t>Declined · can refile</a:t>
+            </a:r>
+            <a:endParaRPr lang="en-US" sz="1100" dirty="0"/>
+          </a:p>
+        </p:txBody>
+      </p:sp>
+      <p:sp>
+        <p:nvSpPr>
+          <p:cNvPr id="18" name="arrow-7"/>
+          <p:cNvSpPr/>
+          <p:nvPr/>
+        </p:nvSpPr>
+        <p:spPr>
+          <a:xfrm>
+            <a:off x="2880360" y="2743200"/>
+            <a:ext cx="0" cy="301752"/>
+          </a:xfrm>
+          <a:prstGeom prst="line">
+            <a:avLst/>
+          </a:prstGeom>
+          <a:noFill/>
+          <a:ln w="19050">
             <a:solidFill>
               <a:schemeClr val="accent5"/>
             </a:solidFill>
             <a:prstDash val="solid"/>
+            <a:tailEnd type="triangle"/>
           </a:ln>
         </p:spPr>
       </p:sp>
-      <p:pic>
-        <p:nvPicPr>
-          <p:cNvPr id="29" name="icon-26" descr="preencoded.png">    </p:cNvPr>
-          <p:cNvPicPr>
-            <a:picLocks noChangeAspect="1"/>
-          </p:cNvPicPr>
-          <p:nvPr/>
-        </p:nvPicPr>
-        <p:blipFill>
-          <a:blip r:embed="rId6"/>
-          <a:stretch>
-            <a:fillRect/>
-          </a:stretch>
-        </p:blipFill>
-        <p:spPr>
-          <a:xfrm>
-            <a:off x="4783684" y="3099816"/>
-            <a:ext cx="292608" cy="292608"/>
-          </a:xfrm>
-          <a:prstGeom prst="rect">
-            <a:avLst/>
-          </a:prstGeom>
-        </p:spPr>
-      </p:pic>
-      <p:sp>
-        <p:nvSpPr>
-          <p:cNvPr id="30" name="node-title-27"/>
+      <p:sp>
+        <p:nvSpPr>
+          <p:cNvPr id="19" name="arrow-8"/>
+          <p:cNvSpPr/>
+          <p:nvPr/>
+        </p:nvSpPr>
+        <p:spPr>
+          <a:xfrm>
+            <a:off x="4640580" y="2679192"/>
+            <a:ext cx="0" cy="365760"/>
+          </a:xfrm>
+          <a:prstGeom prst="line">
+            <a:avLst/>
+          </a:prstGeom>
+          <a:noFill/>
+          <a:ln w="19050">
+            <a:solidFill>
+              <a:schemeClr val="tx2"/>
+            </a:solidFill>
+            <a:prstDash val="solid"/>
+            <a:tailEnd type="triangle"/>
+          </a:ln>
+        </p:spPr>
+      </p:sp>
+      <p:sp>
+        <p:nvSpPr>
+          <p:cNvPr id="20" name="arrow-9"/>
+          <p:cNvSpPr/>
+          <p:nvPr/>
+        </p:nvSpPr>
+        <p:spPr>
+          <a:xfrm>
+            <a:off x="10287000" y="2743200"/>
+            <a:ext cx="0" cy="777240"/>
+          </a:xfrm>
+          <a:prstGeom prst="line">
+            <a:avLst/>
+          </a:prstGeom>
+          <a:noFill/>
+          <a:ln w="19050">
+            <a:solidFill>
+              <a:schemeClr val="tx2"/>
+            </a:solidFill>
+            <a:prstDash val="solid"/>
+            <a:tailEnd type="none"/>
+          </a:ln>
+        </p:spPr>
+      </p:sp>
+      <p:sp>
+        <p:nvSpPr>
+          <p:cNvPr id="21" name="arrow-10"/>
+          <p:cNvSpPr/>
+          <p:nvPr/>
+        </p:nvSpPr>
+        <p:spPr>
+          <a:xfrm flipH="1">
+            <a:off x="1261872" y="3520440"/>
+            <a:ext cx="9025128" cy="0"/>
+          </a:xfrm>
+          <a:prstGeom prst="line">
+            <a:avLst/>
+          </a:prstGeom>
+          <a:noFill/>
+          <a:ln w="19050">
+            <a:solidFill>
+              <a:schemeClr val="tx2"/>
+            </a:solidFill>
+            <a:prstDash val="solid"/>
+            <a:tailEnd type="none"/>
+          </a:ln>
+        </p:spPr>
+      </p:sp>
+      <p:sp>
+        <p:nvSpPr>
+          <p:cNvPr id="22" name="arrow-11"/>
+          <p:cNvSpPr/>
+          <p:nvPr/>
+        </p:nvSpPr>
+        <p:spPr>
+          <a:xfrm>
+            <a:off x="1261872" y="3520440"/>
+            <a:ext cx="0" cy="566928"/>
+          </a:xfrm>
+          <a:prstGeom prst="line">
+            <a:avLst/>
+          </a:prstGeom>
+          <a:noFill/>
+          <a:ln w="19050">
+            <a:solidFill>
+              <a:schemeClr val="tx2"/>
+            </a:solidFill>
+            <a:prstDash val="solid"/>
+            <a:tailEnd type="triangle"/>
+          </a:ln>
+        </p:spPr>
+      </p:sp>
+      <p:sp>
+        <p:nvSpPr>
+          <p:cNvPr id="23" name="flow-tag-12"/>
           <p:cNvSpPr txBox="1"/>
           <p:nvPr/>
         </p:nvSpPr>
         <p:spPr>
           <a:xfrm>
-            <a:off x="5167732" y="3026664"/>
-            <a:ext cx="685800" cy="347472"/>
+            <a:off x="5943600" y="3273552"/>
+            <a:ext cx="4206240" cy="201168"/>
           </a:xfrm>
           <a:prstGeom prst="rect">
             <a:avLst/>
@@ -3845,36 +3792,232 @@
           <a:bodyPr wrap="square" lIns="0" tIns="0" rIns="0" bIns="0" rtlCol="0" anchor="ctr"/>
           <a:lstStyle/>
           <a:p>
-            <a:pPr indent="0" marL="0">
-              <a:buNone/>
-            </a:pPr>
-            <a:r>
-              <a:rPr lang="en-US" sz="1350" b="1" dirty="0">
+            <a:pPr algn="r" indent="0" marL="0">
+              <a:buNone/>
+            </a:pPr>
+            <a:r>
+              <a:rPr lang="en-US" sz="950" i="1" dirty="0">
+                <a:solidFill>
+                  <a:schemeClr val="tx2"/>
+                </a:solidFill>
+              </a:rPr>
+              <a:t>the same case file goes to both advocates and the Judge</a:t>
+            </a:r>
+            <a:endParaRPr lang="en-US" sz="950" dirty="0"/>
+          </a:p>
+        </p:txBody>
+      </p:sp>
+      <p:sp>
+        <p:nvSpPr>
+          <p:cNvPr id="24" name="response"/>
+          <p:cNvSpPr/>
+          <p:nvPr/>
+        </p:nvSpPr>
+        <p:spPr>
+          <a:xfrm>
+            <a:off x="548640" y="4087368"/>
+            <a:ext cx="1463040" cy="694944"/>
+          </a:xfrm>
+          <a:prstGeom prst="parallelogram">
+            <a:avLst/>
+          </a:prstGeom>
+          <a:solidFill>
+            <a:schemeClr val="bg1"/>
+          </a:solidFill>
+          <a:ln w="15875">
+            <a:solidFill>
+              <a:schemeClr val="tx1"/>
+            </a:solidFill>
+          </a:ln>
+        </p:spPr>
+        <p:txBody>
+          <a:bodyPr wrap="square" lIns="508" tIns="508" rIns="508" bIns="508" rtlCol="0" anchor="ctr"/>
+          <a:lstStyle/>
+          <a:p>
+            <a:pPr algn="ctr" indent="0" marL="0">
+              <a:buNone/>
+            </a:pPr>
+            <a:r>
+              <a:rPr lang="en-US" sz="1200" b="1" dirty="0">
                 <a:solidFill>
                   <a:schemeClr val="tx1"/>
                 </a:solidFill>
               </a:rPr>
-              <a:t>Safety</a:t>
-            </a:r>
-            <a:endParaRPr lang="en-US" sz="1350" dirty="0"/>
-          </a:p>
-        </p:txBody>
-      </p:sp>
-      <p:sp>
-        <p:nvSpPr>
-          <p:cNvPr id="31" name="node-28"/>
-          <p:cNvSpPr/>
-          <p:nvPr/>
-        </p:nvSpPr>
-        <p:spPr>
-          <a:xfrm>
-            <a:off x="6347308" y="2971800"/>
-            <a:ext cx="1600200" cy="457200"/>
-          </a:xfrm>
-          <a:prstGeom prst="roundRect">
-            <a:avLst>
-              <a:gd name="adj" fmla="val 20000"/>
-            </a:avLst>
+              <a:t>Other side</a:t>
+            </a:r>
+            <a:endParaRPr lang="en-US" sz="1200" dirty="0"/>
+          </a:p>
+          <a:p>
+            <a:pPr algn="ctr" indent="0" marL="0">
+              <a:buNone/>
+            </a:pPr>
+            <a:r>
+              <a:rPr lang="en-US" sz="950" dirty="0">
+                <a:solidFill>
+                  <a:schemeClr val="tx1"/>
+                </a:solidFill>
+              </a:rPr>
+              <a:t>responds</a:t>
+            </a:r>
+            <a:endParaRPr lang="en-US" sz="1200" dirty="0"/>
+          </a:p>
+        </p:txBody>
+      </p:sp>
+      <p:sp>
+        <p:nvSpPr>
+          <p:cNvPr id="25" name="rider"/>
+          <p:cNvSpPr/>
+          <p:nvPr/>
+        </p:nvSpPr>
+        <p:spPr>
+          <a:xfrm>
+            <a:off x="2468880" y="3520440"/>
+            <a:ext cx="868680" cy="868680"/>
+          </a:xfrm>
+          <a:prstGeom prst="ellipse">
+            <a:avLst/>
+          </a:prstGeom>
+          <a:solidFill>
+            <a:schemeClr val="accent1"/>
+          </a:solidFill>
+          <a:ln/>
+        </p:spPr>
+        <p:txBody>
+          <a:bodyPr wrap="square" lIns="508" tIns="508" rIns="508" bIns="508" rtlCol="0" anchor="ctr"/>
+          <a:lstStyle/>
+          <a:p>
+            <a:pPr algn="ctr" indent="0" marL="0">
+              <a:buNone/>
+            </a:pPr>
+            <a:r>
+              <a:rPr lang="en-US" sz="1200" b="1" dirty="0">
+                <a:solidFill>
+                  <a:schemeClr val="bg1"/>
+                </a:solidFill>
+              </a:rPr>
+              <a:t>Rider</a:t>
+            </a:r>
+            <a:endParaRPr lang="en-US" sz="1200" dirty="0"/>
+          </a:p>
+          <a:p>
+            <a:pPr algn="ctr" indent="0" marL="0">
+              <a:buNone/>
+            </a:pPr>
+            <a:r>
+              <a:rPr lang="en-US" sz="950" dirty="0">
+                <a:solidFill>
+                  <a:schemeClr val="bg1"/>
+                </a:solidFill>
+              </a:rPr>
+              <a:t>advocate</a:t>
+            </a:r>
+            <a:endParaRPr lang="en-US" sz="1200" dirty="0"/>
+          </a:p>
+        </p:txBody>
+      </p:sp>
+      <p:sp>
+        <p:nvSpPr>
+          <p:cNvPr id="26" name="driver"/>
+          <p:cNvSpPr/>
+          <p:nvPr/>
+        </p:nvSpPr>
+        <p:spPr>
+          <a:xfrm>
+            <a:off x="2468880" y="4480560"/>
+            <a:ext cx="868680" cy="868680"/>
+          </a:xfrm>
+          <a:prstGeom prst="ellipse">
+            <a:avLst/>
+          </a:prstGeom>
+          <a:solidFill>
+            <a:schemeClr val="accent2"/>
+          </a:solidFill>
+          <a:ln/>
+        </p:spPr>
+        <p:txBody>
+          <a:bodyPr wrap="square" lIns="508" tIns="508" rIns="508" bIns="508" rtlCol="0" anchor="ctr"/>
+          <a:lstStyle/>
+          <a:p>
+            <a:pPr algn="ctr" indent="0" marL="0">
+              <a:buNone/>
+            </a:pPr>
+            <a:r>
+              <a:rPr lang="en-US" sz="1200" b="1" dirty="0">
+                <a:solidFill>
+                  <a:schemeClr val="bg1"/>
+                </a:solidFill>
+              </a:rPr>
+              <a:t>Driver</a:t>
+            </a:r>
+            <a:endParaRPr lang="en-US" sz="1200" dirty="0"/>
+          </a:p>
+          <a:p>
+            <a:pPr algn="ctr" indent="0" marL="0">
+              <a:buNone/>
+            </a:pPr>
+            <a:r>
+              <a:rPr lang="en-US" sz="950" dirty="0">
+                <a:solidFill>
+                  <a:schemeClr val="bg1"/>
+                </a:solidFill>
+              </a:rPr>
+              <a:t>advocate</a:t>
+            </a:r>
+            <a:endParaRPr lang="en-US" sz="1200" dirty="0"/>
+          </a:p>
+        </p:txBody>
+      </p:sp>
+      <p:sp>
+        <p:nvSpPr>
+          <p:cNvPr id="27" name="judge"/>
+          <p:cNvSpPr/>
+          <p:nvPr/>
+        </p:nvSpPr>
+        <p:spPr>
+          <a:xfrm>
+            <a:off x="4206240" y="3886200"/>
+            <a:ext cx="1097280" cy="1097280"/>
+          </a:xfrm>
+          <a:prstGeom prst="ellipse">
+            <a:avLst/>
+          </a:prstGeom>
+          <a:solidFill>
+            <a:schemeClr val="tx1"/>
+          </a:solidFill>
+          <a:ln/>
+        </p:spPr>
+        <p:txBody>
+          <a:bodyPr wrap="square" lIns="508" tIns="508" rIns="508" bIns="508" rtlCol="0" anchor="ctr"/>
+          <a:lstStyle/>
+          <a:p>
+            <a:pPr algn="ctr" indent="0" marL="0">
+              <a:buNone/>
+            </a:pPr>
+            <a:r>
+              <a:rPr lang="en-US" sz="1200" b="1" dirty="0">
+                <a:solidFill>
+                  <a:schemeClr val="bg1"/>
+                </a:solidFill>
+              </a:rPr>
+              <a:t>Judge</a:t>
+            </a:r>
+            <a:endParaRPr lang="en-US" sz="1200" dirty="0"/>
+          </a:p>
+        </p:txBody>
+      </p:sp>
+      <p:sp>
+        <p:nvSpPr>
+          <p:cNvPr id="28" name="gate"/>
+          <p:cNvSpPr/>
+          <p:nvPr/>
+        </p:nvSpPr>
+        <p:spPr>
+          <a:xfrm>
+            <a:off x="5715000" y="3931920"/>
+            <a:ext cx="1965960" cy="1005840"/>
+          </a:xfrm>
+          <a:prstGeom prst="hexagon">
+            <a:avLst/>
           </a:prstGeom>
           <a:solidFill>
             <a:schemeClr val="bg1"/>
@@ -3886,592 +4029,52 @@
             <a:prstDash val="dash"/>
           </a:ln>
         </p:spPr>
-      </p:sp>
-      <p:pic>
-        <p:nvPicPr>
-          <p:cNvPr id="32" name="icon-29" descr="preencoded.png">    </p:cNvPr>
-          <p:cNvPicPr>
-            <a:picLocks noChangeAspect="1"/>
-          </p:cNvPicPr>
-          <p:nvPr/>
-        </p:nvPicPr>
-        <p:blipFill>
-          <a:blip r:embed="rId7"/>
-          <a:stretch>
-            <a:fillRect/>
-          </a:stretch>
-        </p:blipFill>
-        <p:spPr>
-          <a:xfrm>
-            <a:off x="6475324" y="3099816"/>
-            <a:ext cx="292608" cy="292608"/>
-          </a:xfrm>
-          <a:prstGeom prst="rect">
-            <a:avLst/>
-          </a:prstGeom>
-        </p:spPr>
-      </p:pic>
-      <p:sp>
-        <p:nvSpPr>
-          <p:cNvPr id="33" name="node-title-30"/>
-          <p:cNvSpPr txBox="1"/>
-          <p:nvPr/>
-        </p:nvSpPr>
-        <p:spPr>
-          <a:xfrm>
-            <a:off x="6859372" y="3026664"/>
-            <a:ext cx="960120" cy="347472"/>
-          </a:xfrm>
-          <a:prstGeom prst="rect">
-            <a:avLst/>
-          </a:prstGeom>
-          <a:noFill/>
-          <a:ln/>
-        </p:spPr>
-        <p:txBody>
-          <a:bodyPr wrap="square" lIns="0" tIns="0" rIns="0" bIns="0" rtlCol="0" anchor="ctr"/>
-          <a:lstStyle/>
-          <a:p>
-            <a:pPr indent="0" marL="0">
-              <a:buNone/>
-            </a:pPr>
-            <a:r>
-              <a:rPr lang="en-US" sz="1350" b="1" dirty="0">
+        <p:txBody>
+          <a:bodyPr wrap="square" lIns="508" tIns="508" rIns="508" bIns="508" rtlCol="0" anchor="ctr"/>
+          <a:lstStyle/>
+          <a:p>
+            <a:pPr algn="ctr" indent="0" marL="0">
+              <a:buNone/>
+            </a:pPr>
+            <a:r>
+              <a:rPr lang="en-US" sz="1200" b="1" dirty="0">
                 <a:solidFill>
                   <a:schemeClr val="tx1"/>
                 </a:solidFill>
               </a:rPr>
-              <a:t>Declined</a:t>
-            </a:r>
-            <a:endParaRPr lang="en-US" sz="1350" dirty="0"/>
-          </a:p>
-        </p:txBody>
-      </p:sp>
-      <p:sp>
-        <p:nvSpPr>
-          <p:cNvPr id="34" name="exit-safety-note"/>
-          <p:cNvSpPr txBox="1"/>
-          <p:nvPr/>
-        </p:nvSpPr>
-        <p:spPr>
-          <a:xfrm>
-            <a:off x="4655668" y="3465576"/>
-            <a:ext cx="1600200" cy="237744"/>
-          </a:xfrm>
-          <a:prstGeom prst="rect">
-            <a:avLst/>
-          </a:prstGeom>
-          <a:noFill/>
-          <a:ln/>
-        </p:spPr>
-        <p:txBody>
-          <a:bodyPr wrap="square" lIns="0" tIns="0" rIns="0" bIns="0" rtlCol="0" anchor="ctr"/>
-          <a:lstStyle/>
-          <a:p>
-            <a:pPr indent="0" marL="0">
-              <a:buNone/>
-            </a:pPr>
-            <a:r>
-              <a:rPr lang="en-US" sz="1050" i="1" dirty="0">
-                <a:solidFill>
-                  <a:schemeClr val="tx2"/>
-                </a:solidFill>
-              </a:rPr>
-              <a:t>to a person</a:t>
-            </a:r>
-            <a:endParaRPr lang="en-US" sz="1050" dirty="0"/>
-          </a:p>
-        </p:txBody>
-      </p:sp>
-      <p:sp>
-        <p:nvSpPr>
-          <p:cNvPr id="35" name="exit-declined-note"/>
-          <p:cNvSpPr txBox="1"/>
-          <p:nvPr/>
-        </p:nvSpPr>
-        <p:spPr>
-          <a:xfrm>
-            <a:off x="6347308" y="3465576"/>
-            <a:ext cx="1737360" cy="237744"/>
-          </a:xfrm>
-          <a:prstGeom prst="rect">
-            <a:avLst/>
-          </a:prstGeom>
-          <a:noFill/>
-          <a:ln/>
-        </p:spPr>
-        <p:txBody>
-          <a:bodyPr wrap="square" lIns="0" tIns="0" rIns="0" bIns="0" rtlCol="0" anchor="ctr"/>
-          <a:lstStyle/>
-          <a:p>
-            <a:pPr indent="0" marL="0">
-              <a:buNone/>
-            </a:pPr>
-            <a:r>
-              <a:rPr lang="en-US" sz="1050" i="1" dirty="0">
-                <a:solidFill>
-                  <a:schemeClr val="tx2"/>
-                </a:solidFill>
-              </a:rPr>
-              <a:t>can refile</a:t>
-            </a:r>
-            <a:endParaRPr lang="en-US" sz="1050" dirty="0"/>
-          </a:p>
-        </p:txBody>
-      </p:sp>
-      <p:sp>
-        <p:nvSpPr>
-          <p:cNvPr id="36" name="arrow-31"/>
-          <p:cNvSpPr/>
-          <p:nvPr/>
-        </p:nvSpPr>
-        <p:spPr>
-          <a:xfrm>
-            <a:off x="5341468" y="2697480"/>
-            <a:ext cx="0" cy="274320"/>
-          </a:xfrm>
-          <a:prstGeom prst="line">
-            <a:avLst/>
-          </a:prstGeom>
-          <a:noFill/>
-          <a:ln w="19050">
-            <a:solidFill>
-              <a:schemeClr val="accent5"/>
-            </a:solidFill>
-            <a:prstDash val="solid"/>
-            <a:tailEnd type="triangle"/>
-          </a:ln>
-        </p:spPr>
-      </p:sp>
-      <p:sp>
-        <p:nvSpPr>
-          <p:cNvPr id="37" name="arrow-32"/>
-          <p:cNvSpPr/>
-          <p:nvPr/>
-        </p:nvSpPr>
-        <p:spPr>
-          <a:xfrm>
-            <a:off x="6941668" y="2697480"/>
-            <a:ext cx="0" cy="274320"/>
-          </a:xfrm>
-          <a:prstGeom prst="line">
-            <a:avLst/>
-          </a:prstGeom>
-          <a:noFill/>
-          <a:ln w="19050">
-            <a:solidFill>
-              <a:schemeClr val="tx2"/>
-            </a:solidFill>
-            <a:prstDash val="solid"/>
-            <a:tailEnd type="triangle"/>
-          </a:ln>
-        </p:spPr>
-      </p:sp>
-      <p:sp>
-        <p:nvSpPr>
-          <p:cNvPr id="38" name="arrow-33"/>
-          <p:cNvSpPr/>
-          <p:nvPr/>
-        </p:nvSpPr>
-        <p:spPr>
-          <a:xfrm>
-            <a:off x="10705795" y="2697480"/>
-            <a:ext cx="0" cy="1097280"/>
-          </a:xfrm>
-          <a:prstGeom prst="line">
-            <a:avLst/>
-          </a:prstGeom>
-          <a:noFill/>
-          <a:ln w="19050">
-            <a:solidFill>
-              <a:schemeClr val="tx2"/>
-            </a:solidFill>
-            <a:prstDash val="solid"/>
-            <a:tailEnd type="none"/>
-          </a:ln>
-        </p:spPr>
-      </p:sp>
-      <p:sp>
-        <p:nvSpPr>
-          <p:cNvPr id="39" name="arrow-34"/>
-          <p:cNvSpPr/>
-          <p:nvPr/>
-        </p:nvSpPr>
-        <p:spPr>
-          <a:xfrm flipH="1">
-            <a:off x="1485900" y="3794760"/>
-            <a:ext cx="9219895" cy="0"/>
-          </a:xfrm>
-          <a:prstGeom prst="line">
-            <a:avLst/>
-          </a:prstGeom>
-          <a:noFill/>
-          <a:ln w="19050">
-            <a:solidFill>
-              <a:schemeClr val="tx2"/>
-            </a:solidFill>
-            <a:prstDash val="solid"/>
-            <a:tailEnd type="none"/>
-          </a:ln>
-        </p:spPr>
-      </p:sp>
-      <p:sp>
-        <p:nvSpPr>
-          <p:cNvPr id="40" name="return-label"/>
-          <p:cNvSpPr txBox="1"/>
-          <p:nvPr/>
-        </p:nvSpPr>
-        <p:spPr>
-          <a:xfrm>
-            <a:off x="8191195" y="3520440"/>
-            <a:ext cx="2377440" cy="237744"/>
-          </a:xfrm>
-          <a:prstGeom prst="rect">
-            <a:avLst/>
-          </a:prstGeom>
-          <a:noFill/>
-          <a:ln/>
-        </p:spPr>
-        <p:txBody>
-          <a:bodyPr wrap="square" lIns="0" tIns="0" rIns="0" bIns="0" rtlCol="0" anchor="ctr"/>
-          <a:lstStyle/>
-          <a:p>
-            <a:pPr algn="r" indent="0" marL="0">
-              <a:buNone/>
-            </a:pPr>
-            <a:r>
-              <a:rPr lang="en-US" sz="1050" i="1" dirty="0">
-                <a:solidFill>
-                  <a:schemeClr val="tx2"/>
-                </a:solidFill>
-              </a:rPr>
-              <a:t>the same case file to both sides</a:t>
-            </a:r>
-            <a:endParaRPr lang="en-US" sz="1050" dirty="0"/>
-          </a:p>
-        </p:txBody>
-      </p:sp>
-      <p:sp>
-        <p:nvSpPr>
-          <p:cNvPr id="41" name="arrow-35"/>
-          <p:cNvSpPr/>
-          <p:nvPr/>
-        </p:nvSpPr>
-        <p:spPr>
-          <a:xfrm>
-            <a:off x="1485900" y="3794760"/>
-            <a:ext cx="0" cy="274320"/>
-          </a:xfrm>
-          <a:prstGeom prst="line">
-            <a:avLst/>
-          </a:prstGeom>
-          <a:noFill/>
-          <a:ln w="19050">
-            <a:solidFill>
-              <a:schemeClr val="tx2"/>
-            </a:solidFill>
-            <a:prstDash val="solid"/>
-            <a:tailEnd type="triangle"/>
-          </a:ln>
-        </p:spPr>
-      </p:sp>
-      <p:sp>
-        <p:nvSpPr>
-          <p:cNvPr id="42" name="node-36"/>
-          <p:cNvSpPr/>
-          <p:nvPr/>
-        </p:nvSpPr>
-        <p:spPr>
-          <a:xfrm>
-            <a:off x="548640" y="4069080"/>
-            <a:ext cx="1874520" cy="713232"/>
-          </a:xfrm>
-          <a:prstGeom prst="roundRect">
-            <a:avLst>
-              <a:gd name="adj" fmla="val 12821"/>
-            </a:avLst>
-          </a:prstGeom>
-          <a:solidFill>
-            <a:schemeClr val="accent1"/>
-          </a:solidFill>
-          <a:ln/>
-        </p:spPr>
-      </p:sp>
-      <p:pic>
-        <p:nvPicPr>
-          <p:cNvPr id="43" name="icon-37" descr="preencoded.png">    </p:cNvPr>
-          <p:cNvPicPr>
-            <a:picLocks noChangeAspect="1"/>
-          </p:cNvPicPr>
-          <p:nvPr/>
-        </p:nvPicPr>
-        <p:blipFill>
-          <a:blip r:embed="rId8"/>
-          <a:stretch>
-            <a:fillRect/>
-          </a:stretch>
-        </p:blipFill>
-        <p:spPr>
-          <a:xfrm>
-            <a:off x="676656" y="4197096"/>
-            <a:ext cx="292608" cy="292608"/>
-          </a:xfrm>
-          <a:prstGeom prst="rect">
-            <a:avLst/>
-          </a:prstGeom>
-        </p:spPr>
-      </p:pic>
-      <p:sp>
-        <p:nvSpPr>
-          <p:cNvPr id="44" name="node-title-38"/>
-          <p:cNvSpPr txBox="1"/>
-          <p:nvPr/>
-        </p:nvSpPr>
-        <p:spPr>
-          <a:xfrm>
-            <a:off x="1060704" y="4123944"/>
-            <a:ext cx="1234440" cy="603504"/>
-          </a:xfrm>
-          <a:prstGeom prst="rect">
-            <a:avLst/>
-          </a:prstGeom>
-          <a:noFill/>
-          <a:ln/>
-        </p:spPr>
-        <p:txBody>
-          <a:bodyPr wrap="square" lIns="0" tIns="0" rIns="0" bIns="0" rtlCol="0" anchor="ctr"/>
-          <a:lstStyle/>
-          <a:p>
-            <a:pPr indent="0" marL="0">
-              <a:buNone/>
-            </a:pPr>
-            <a:r>
-              <a:rPr lang="en-US" sz="1350" b="1" dirty="0">
-                <a:solidFill>
-                  <a:schemeClr val="bg1"/>
-                </a:solidFill>
-              </a:rPr>
-              <a:t>Rider's advocate</a:t>
-            </a:r>
-            <a:endParaRPr lang="en-US" sz="1350" dirty="0"/>
-          </a:p>
-        </p:txBody>
-      </p:sp>
-      <p:sp>
-        <p:nvSpPr>
-          <p:cNvPr id="45" name="node-39"/>
-          <p:cNvSpPr/>
-          <p:nvPr/>
-        </p:nvSpPr>
-        <p:spPr>
-          <a:xfrm>
-            <a:off x="548640" y="4910328"/>
-            <a:ext cx="1874520" cy="713232"/>
-          </a:xfrm>
-          <a:prstGeom prst="roundRect">
-            <a:avLst>
-              <a:gd name="adj" fmla="val 12821"/>
-            </a:avLst>
-          </a:prstGeom>
-          <a:solidFill>
-            <a:schemeClr val="accent2"/>
-          </a:solidFill>
-          <a:ln/>
-        </p:spPr>
-      </p:sp>
-      <p:pic>
-        <p:nvPicPr>
-          <p:cNvPr id="46" name="icon-40" descr="preencoded.png">    </p:cNvPr>
-          <p:cNvPicPr>
-            <a:picLocks noChangeAspect="1"/>
-          </p:cNvPicPr>
-          <p:nvPr/>
-        </p:nvPicPr>
-        <p:blipFill>
-          <a:blip r:embed="rId9"/>
-          <a:stretch>
-            <a:fillRect/>
-          </a:stretch>
-        </p:blipFill>
-        <p:spPr>
-          <a:xfrm>
-            <a:off x="676656" y="5038344"/>
-            <a:ext cx="292608" cy="292608"/>
-          </a:xfrm>
-          <a:prstGeom prst="rect">
-            <a:avLst/>
-          </a:prstGeom>
-        </p:spPr>
-      </p:pic>
-      <p:sp>
-        <p:nvSpPr>
-          <p:cNvPr id="47" name="node-title-41"/>
-          <p:cNvSpPr txBox="1"/>
-          <p:nvPr/>
-        </p:nvSpPr>
-        <p:spPr>
-          <a:xfrm>
-            <a:off x="1060704" y="4965192"/>
-            <a:ext cx="1234440" cy="603504"/>
-          </a:xfrm>
-          <a:prstGeom prst="rect">
-            <a:avLst/>
-          </a:prstGeom>
-          <a:noFill/>
-          <a:ln/>
-        </p:spPr>
-        <p:txBody>
-          <a:bodyPr wrap="square" lIns="0" tIns="0" rIns="0" bIns="0" rtlCol="0" anchor="ctr"/>
-          <a:lstStyle/>
-          <a:p>
-            <a:pPr indent="0" marL="0">
-              <a:buNone/>
-            </a:pPr>
-            <a:r>
-              <a:rPr lang="en-US" sz="1350" b="1" dirty="0">
-                <a:solidFill>
-                  <a:schemeClr val="bg1"/>
-                </a:solidFill>
-              </a:rPr>
-              <a:t>Driver's advocate</a:t>
-            </a:r>
-            <a:endParaRPr lang="en-US" sz="1350" dirty="0"/>
-          </a:p>
-        </p:txBody>
-      </p:sp>
-      <p:sp>
-        <p:nvSpPr>
-          <p:cNvPr id="48" name="node-42"/>
-          <p:cNvSpPr/>
-          <p:nvPr/>
-        </p:nvSpPr>
-        <p:spPr>
-          <a:xfrm>
-            <a:off x="2853614" y="4069080"/>
-            <a:ext cx="1874520" cy="1554480"/>
-          </a:xfrm>
-          <a:prstGeom prst="roundRect">
-            <a:avLst>
-              <a:gd name="adj" fmla="val 5882"/>
-            </a:avLst>
-          </a:prstGeom>
-          <a:solidFill>
-            <a:schemeClr val="tx1"/>
-          </a:solidFill>
-          <a:ln/>
-        </p:spPr>
-      </p:sp>
-      <p:pic>
-        <p:nvPicPr>
-          <p:cNvPr id="49" name="icon-43" descr="preencoded.png">    </p:cNvPr>
-          <p:cNvPicPr>
-            <a:picLocks noChangeAspect="1"/>
-          </p:cNvPicPr>
-          <p:nvPr/>
-        </p:nvPicPr>
-        <p:blipFill>
-          <a:blip r:embed="rId10"/>
-          <a:stretch>
-            <a:fillRect/>
-          </a:stretch>
-        </p:blipFill>
-        <p:spPr>
-          <a:xfrm>
-            <a:off x="2981630" y="4197096"/>
-            <a:ext cx="292608" cy="292608"/>
-          </a:xfrm>
-          <a:prstGeom prst="rect">
-            <a:avLst/>
-          </a:prstGeom>
-        </p:spPr>
-      </p:pic>
-      <p:sp>
-        <p:nvSpPr>
-          <p:cNvPr id="50" name="node-title-44"/>
-          <p:cNvSpPr txBox="1"/>
-          <p:nvPr/>
-        </p:nvSpPr>
-        <p:spPr>
-          <a:xfrm>
-            <a:off x="3365678" y="4169664"/>
-            <a:ext cx="1234440" cy="347472"/>
-          </a:xfrm>
-          <a:prstGeom prst="rect">
-            <a:avLst/>
-          </a:prstGeom>
-          <a:noFill/>
-          <a:ln/>
-        </p:spPr>
-        <p:txBody>
-          <a:bodyPr wrap="square" lIns="0" tIns="0" rIns="0" bIns="0" rtlCol="0" anchor="ctr"/>
-          <a:lstStyle/>
-          <a:p>
-            <a:pPr indent="0" marL="0">
-              <a:buNone/>
-            </a:pPr>
-            <a:r>
-              <a:rPr lang="en-US" sz="1400" b="1" dirty="0">
-                <a:solidFill>
-                  <a:schemeClr val="bg1"/>
-                </a:solidFill>
-              </a:rPr>
-              <a:t>Judge</a:t>
-            </a:r>
-            <a:endParaRPr lang="en-US" sz="1400" dirty="0"/>
-          </a:p>
-        </p:txBody>
-      </p:sp>
-      <p:sp>
-        <p:nvSpPr>
-          <p:cNvPr id="51" name="node-sub-45"/>
-          <p:cNvSpPr txBox="1"/>
-          <p:nvPr/>
-        </p:nvSpPr>
-        <p:spPr>
-          <a:xfrm>
-            <a:off x="2981630" y="4562856"/>
-            <a:ext cx="1618488" cy="1024128"/>
-          </a:xfrm>
-          <a:prstGeom prst="rect">
-            <a:avLst/>
-          </a:prstGeom>
-          <a:noFill/>
-          <a:ln/>
-        </p:spPr>
-        <p:txBody>
-          <a:bodyPr wrap="square" lIns="0" tIns="0" rIns="0" bIns="0" rtlCol="0" anchor="t"/>
-          <a:lstStyle/>
-          <a:p>
-            <a:pPr indent="0" marL="0">
-              <a:buNone/>
-            </a:pPr>
-            <a:r>
-              <a:rPr lang="en-US" sz="1100" dirty="0">
-                <a:solidFill>
-                  <a:schemeClr val="bg2"/>
-                </a:solidFill>
-              </a:rPr>
-              <a:t>Rules from both arguments and the case file</a:t>
-            </a:r>
-            <a:endParaRPr lang="en-US" sz="1100" dirty="0"/>
-          </a:p>
-        </p:txBody>
-      </p:sp>
-      <p:sp>
-        <p:nvSpPr>
-          <p:cNvPr id="52" name="node-46"/>
-          <p:cNvSpPr/>
-          <p:nvPr/>
-        </p:nvSpPr>
-        <p:spPr>
-          <a:xfrm>
-            <a:off x="5158588" y="4069080"/>
-            <a:ext cx="1874520" cy="1554480"/>
-          </a:xfrm>
-          <a:prstGeom prst="roundRect">
-            <a:avLst>
-              <a:gd name="adj" fmla="val 5882"/>
-            </a:avLst>
+              <a:t>Escalation gate</a:t>
+            </a:r>
+            <a:endParaRPr lang="en-US" sz="1200" dirty="0"/>
+          </a:p>
+          <a:p>
+            <a:pPr algn="ctr" indent="0" marL="0">
+              <a:buNone/>
+            </a:pPr>
+            <a:r>
+              <a:rPr lang="en-US" sz="950" dirty="0">
+                <a:solidFill>
+                  <a:schemeClr val="tx1"/>
+                </a:solidFill>
+              </a:rPr>
+              <a:t>confidence ≥ 0.6, risk</a:t>
+            </a:r>
+            <a:endParaRPr lang="en-US" sz="1200" dirty="0"/>
+          </a:p>
+        </p:txBody>
+      </p:sp>
+      <p:sp>
+        <p:nvSpPr>
+          <p:cNvPr id="29" name="compliance"/>
+          <p:cNvSpPr/>
+          <p:nvPr/>
+        </p:nvSpPr>
+        <p:spPr>
+          <a:xfrm>
+            <a:off x="8046720" y="3977640"/>
+            <a:ext cx="1645920" cy="914400"/>
+          </a:xfrm>
+          <a:prstGeom prst="hexagon">
+            <a:avLst/>
           </a:prstGeom>
           <a:solidFill>
             <a:schemeClr val="bg1"/>
@@ -4483,414 +4086,151 @@
             <a:prstDash val="dash"/>
           </a:ln>
         </p:spPr>
-      </p:sp>
-      <p:pic>
-        <p:nvPicPr>
-          <p:cNvPr id="53" name="icon-47" descr="preencoded.png">    </p:cNvPr>
-          <p:cNvPicPr>
-            <a:picLocks noChangeAspect="1"/>
-          </p:cNvPicPr>
-          <p:nvPr/>
-        </p:nvPicPr>
-        <p:blipFill>
-          <a:blip r:embed="rId11"/>
-          <a:stretch>
-            <a:fillRect/>
-          </a:stretch>
-        </p:blipFill>
-        <p:spPr>
-          <a:xfrm>
-            <a:off x="5286604" y="4197096"/>
-            <a:ext cx="292608" cy="292608"/>
-          </a:xfrm>
-          <a:prstGeom prst="rect">
-            <a:avLst/>
-          </a:prstGeom>
-        </p:spPr>
-      </p:pic>
-      <p:sp>
-        <p:nvSpPr>
-          <p:cNvPr id="54" name="node-title-48"/>
-          <p:cNvSpPr txBox="1"/>
-          <p:nvPr/>
-        </p:nvSpPr>
-        <p:spPr>
-          <a:xfrm>
-            <a:off x="5670652" y="4169664"/>
-            <a:ext cx="1234440" cy="347472"/>
-          </a:xfrm>
-          <a:prstGeom prst="rect">
-            <a:avLst/>
-          </a:prstGeom>
-          <a:noFill/>
-          <a:ln/>
-        </p:spPr>
-        <p:txBody>
-          <a:bodyPr wrap="square" lIns="0" tIns="0" rIns="0" bIns="0" rtlCol="0" anchor="ctr"/>
-          <a:lstStyle/>
-          <a:p>
-            <a:pPr indent="0" marL="0">
-              <a:buNone/>
-            </a:pPr>
-            <a:r>
-              <a:rPr lang="en-US" sz="1400" b="1" dirty="0">
+        <p:txBody>
+          <a:bodyPr wrap="square" lIns="508" tIns="508" rIns="508" bIns="508" rtlCol="0" anchor="ctr"/>
+          <a:lstStyle/>
+          <a:p>
+            <a:pPr algn="ctr" indent="0" marL="0">
+              <a:buNone/>
+            </a:pPr>
+            <a:r>
+              <a:rPr lang="en-US" sz="1200" b="1" dirty="0">
                 <a:solidFill>
                   <a:schemeClr val="tx1"/>
                 </a:solidFill>
               </a:rPr>
-              <a:t>Final checks</a:t>
-            </a:r>
-            <a:endParaRPr lang="en-US" sz="1400" dirty="0"/>
-          </a:p>
-        </p:txBody>
-      </p:sp>
-      <p:sp>
-        <p:nvSpPr>
-          <p:cNvPr id="55" name="node-sub-49"/>
-          <p:cNvSpPr txBox="1"/>
-          <p:nvPr/>
-        </p:nvSpPr>
-        <p:spPr>
-          <a:xfrm>
-            <a:off x="5286604" y="4562856"/>
-            <a:ext cx="1618488" cy="1024128"/>
-          </a:xfrm>
-          <a:prstGeom prst="rect">
-            <a:avLst/>
-          </a:prstGeom>
-          <a:noFill/>
-          <a:ln/>
-        </p:spPr>
-        <p:txBody>
-          <a:bodyPr wrap="square" lIns="0" tIns="0" rIns="0" bIns="0" rtlCol="0" anchor="t"/>
-          <a:lstStyle/>
-          <a:p>
-            <a:pPr indent="0" marL="0">
-              <a:buNone/>
-            </a:pPr>
-            <a:r>
-              <a:rPr lang="en-US" sz="1100" dirty="0">
-                <a:solidFill>
-                  <a:schemeClr val="tx2"/>
-                </a:solidFill>
-              </a:rPr>
-              <a:t>Confidence and risk, no AI</a:t>
-            </a:r>
-            <a:endParaRPr lang="en-US" sz="1100" dirty="0"/>
-          </a:p>
-        </p:txBody>
-      </p:sp>
-      <p:sp>
-        <p:nvSpPr>
-          <p:cNvPr id="56" name="node-50"/>
-          <p:cNvSpPr/>
-          <p:nvPr/>
-        </p:nvSpPr>
-        <p:spPr>
-          <a:xfrm>
-            <a:off x="7463561" y="4069080"/>
-            <a:ext cx="1874520" cy="1554480"/>
+              <a:t>Compliance</a:t>
+            </a:r>
+            <a:endParaRPr lang="en-US" sz="1200" dirty="0"/>
+          </a:p>
+          <a:p>
+            <a:pPr algn="ctr" indent="0" marL="0">
+              <a:buNone/>
+            </a:pPr>
+            <a:r>
+              <a:rPr lang="en-US" sz="950" dirty="0">
+                <a:solidFill>
+                  <a:schemeClr val="tx1"/>
+                </a:solidFill>
+              </a:rPr>
+              <a:t>veto only</a:t>
+            </a:r>
+            <a:endParaRPr lang="en-US" sz="1200" dirty="0"/>
+          </a:p>
+        </p:txBody>
+      </p:sp>
+      <p:sp>
+        <p:nvSpPr>
+          <p:cNvPr id="30" name="decided"/>
+          <p:cNvSpPr/>
+          <p:nvPr/>
+        </p:nvSpPr>
+        <p:spPr>
+          <a:xfrm>
+            <a:off x="10241280" y="4069080"/>
+            <a:ext cx="1401775" cy="731520"/>
           </a:xfrm>
           <a:prstGeom prst="roundRect">
             <a:avLst>
-              <a:gd name="adj" fmla="val 5882"/>
+              <a:gd name="adj" fmla="val 43750"/>
             </a:avLst>
           </a:prstGeom>
           <a:solidFill>
-            <a:schemeClr val="bg1"/>
+            <a:schemeClr val="accent3"/>
           </a:solidFill>
-          <a:ln w="15875">
+          <a:ln/>
+        </p:spPr>
+        <p:txBody>
+          <a:bodyPr wrap="square" lIns="508" tIns="508" rIns="508" bIns="508" rtlCol="0" anchor="ctr"/>
+          <a:lstStyle/>
+          <a:p>
+            <a:pPr algn="ctr" indent="0" marL="0">
+              <a:buNone/>
+            </a:pPr>
+            <a:r>
+              <a:rPr lang="en-US" sz="1200" b="1" dirty="0">
+                <a:solidFill>
+                  <a:schemeClr val="bg1"/>
+                </a:solidFill>
+              </a:rPr>
+              <a:t>Decision</a:t>
+            </a:r>
+            <a:endParaRPr lang="en-US" sz="1200" dirty="0"/>
+          </a:p>
+          <a:p>
+            <a:pPr algn="ctr" indent="0" marL="0">
+              <a:buNone/>
+            </a:pPr>
+            <a:r>
+              <a:rPr lang="en-US" sz="950" dirty="0">
+                <a:solidFill>
+                  <a:schemeClr val="bg1"/>
+                </a:solidFill>
+              </a:rPr>
+              <a:t>final, cited</a:t>
+            </a:r>
+            <a:endParaRPr lang="en-US" sz="1200" dirty="0"/>
+          </a:p>
+        </p:txBody>
+      </p:sp>
+      <p:sp>
+        <p:nvSpPr>
+          <p:cNvPr id="31" name="arrow-13"/>
+          <p:cNvSpPr/>
+          <p:nvPr/>
+        </p:nvSpPr>
+        <p:spPr>
+          <a:xfrm>
+            <a:off x="2011680" y="4434840"/>
+            <a:ext cx="137160" cy="0"/>
+          </a:xfrm>
+          <a:prstGeom prst="line">
+            <a:avLst/>
+          </a:prstGeom>
+          <a:noFill/>
+          <a:ln w="19050">
             <a:solidFill>
               <a:schemeClr val="tx2"/>
             </a:solidFill>
-            <a:prstDash val="dash"/>
+            <a:prstDash val="solid"/>
+            <a:tailEnd type="none"/>
           </a:ln>
         </p:spPr>
       </p:sp>
-      <p:pic>
-        <p:nvPicPr>
-          <p:cNvPr id="57" name="icon-51" descr="preencoded.png">    </p:cNvPr>
-          <p:cNvPicPr>
-            <a:picLocks noChangeAspect="1"/>
-          </p:cNvPicPr>
-          <p:nvPr/>
-        </p:nvPicPr>
-        <p:blipFill>
-          <a:blip r:embed="rId12"/>
-          <a:stretch>
-            <a:fillRect/>
-          </a:stretch>
-        </p:blipFill>
-        <p:spPr>
-          <a:xfrm>
-            <a:off x="7591577" y="4197096"/>
-            <a:ext cx="292608" cy="292608"/>
-          </a:xfrm>
-          <a:prstGeom prst="rect">
-            <a:avLst/>
-          </a:prstGeom>
-        </p:spPr>
-      </p:pic>
-      <p:sp>
-        <p:nvSpPr>
-          <p:cNvPr id="58" name="node-title-52"/>
-          <p:cNvSpPr txBox="1"/>
-          <p:nvPr/>
-        </p:nvSpPr>
-        <p:spPr>
-          <a:xfrm>
-            <a:off x="7975625" y="4169664"/>
-            <a:ext cx="1234440" cy="347472"/>
-          </a:xfrm>
-          <a:prstGeom prst="rect">
-            <a:avLst/>
-          </a:prstGeom>
-          <a:noFill/>
-          <a:ln/>
-        </p:spPr>
-        <p:txBody>
-          <a:bodyPr wrap="square" lIns="0" tIns="0" rIns="0" bIns="0" rtlCol="0" anchor="ctr"/>
-          <a:lstStyle/>
-          <a:p>
-            <a:pPr indent="0" marL="0">
-              <a:buNone/>
-            </a:pPr>
-            <a:r>
-              <a:rPr lang="en-US" sz="1400" b="1" dirty="0">
-                <a:solidFill>
-                  <a:schemeClr val="tx1"/>
-                </a:solidFill>
-              </a:rPr>
-              <a:t>Compliance</a:t>
-            </a:r>
-            <a:endParaRPr lang="en-US" sz="1400" dirty="0"/>
-          </a:p>
-        </p:txBody>
-      </p:sp>
-      <p:sp>
-        <p:nvSpPr>
-          <p:cNvPr id="59" name="node-sub-53"/>
-          <p:cNvSpPr txBox="1"/>
-          <p:nvPr/>
-        </p:nvSpPr>
-        <p:spPr>
-          <a:xfrm>
-            <a:off x="7591577" y="4562856"/>
-            <a:ext cx="1618488" cy="1024128"/>
-          </a:xfrm>
-          <a:prstGeom prst="rect">
-            <a:avLst/>
-          </a:prstGeom>
-          <a:noFill/>
-          <a:ln/>
-        </p:spPr>
-        <p:txBody>
-          <a:bodyPr wrap="square" lIns="0" tIns="0" rIns="0" bIns="0" rtlCol="0" anchor="t"/>
-          <a:lstStyle/>
-          <a:p>
-            <a:pPr indent="0" marL="0">
-              <a:buNone/>
-            </a:pPr>
-            <a:r>
-              <a:rPr lang="en-US" sz="1100" dirty="0">
-                <a:solidFill>
-                  <a:schemeClr val="tx2"/>
-                </a:solidFill>
-              </a:rPr>
-              <a:t>Can veto a ruling, never writes one</a:t>
-            </a:r>
-            <a:endParaRPr lang="en-US" sz="1100" dirty="0"/>
-          </a:p>
-        </p:txBody>
-      </p:sp>
-      <p:sp>
-        <p:nvSpPr>
-          <p:cNvPr id="60" name="node-54"/>
-          <p:cNvSpPr/>
-          <p:nvPr/>
-        </p:nvSpPr>
-        <p:spPr>
-          <a:xfrm>
-            <a:off x="9768535" y="4069080"/>
-            <a:ext cx="1874520" cy="713232"/>
-          </a:xfrm>
-          <a:prstGeom prst="roundRect">
-            <a:avLst>
-              <a:gd name="adj" fmla="val 12821"/>
-            </a:avLst>
-          </a:prstGeom>
-          <a:solidFill>
-            <a:schemeClr val="accent3">
-              <a:alpha val="14000"/>
-            </a:schemeClr>
-          </a:solidFill>
-          <a:ln w="15875">
+      <p:sp>
+        <p:nvSpPr>
+          <p:cNvPr id="32" name="arrow-14"/>
+          <p:cNvSpPr/>
+          <p:nvPr/>
+        </p:nvSpPr>
+        <p:spPr>
+          <a:xfrm>
+            <a:off x="2148840" y="3954780"/>
+            <a:ext cx="0" cy="960120"/>
+          </a:xfrm>
+          <a:prstGeom prst="line">
+            <a:avLst/>
+          </a:prstGeom>
+          <a:noFill/>
+          <a:ln w="19050">
             <a:solidFill>
-              <a:schemeClr val="accent3"/>
+              <a:schemeClr val="tx2"/>
             </a:solidFill>
             <a:prstDash val="solid"/>
+            <a:tailEnd type="none"/>
           </a:ln>
         </p:spPr>
       </p:sp>
-      <p:pic>
-        <p:nvPicPr>
-          <p:cNvPr id="61" name="icon-55" descr="preencoded.png">    </p:cNvPr>
-          <p:cNvPicPr>
-            <a:picLocks noChangeAspect="1"/>
-          </p:cNvPicPr>
-          <p:nvPr/>
-        </p:nvPicPr>
-        <p:blipFill>
-          <a:blip r:embed="rId13"/>
-          <a:stretch>
-            <a:fillRect/>
-          </a:stretch>
-        </p:blipFill>
-        <p:spPr>
-          <a:xfrm>
-            <a:off x="9896551" y="4197096"/>
-            <a:ext cx="292608" cy="292608"/>
-          </a:xfrm>
-          <a:prstGeom prst="rect">
-            <a:avLst/>
-          </a:prstGeom>
-        </p:spPr>
-      </p:pic>
-      <p:sp>
-        <p:nvSpPr>
-          <p:cNvPr id="62" name="node-title-56"/>
-          <p:cNvSpPr txBox="1"/>
-          <p:nvPr/>
-        </p:nvSpPr>
-        <p:spPr>
-          <a:xfrm>
-            <a:off x="10280599" y="4123944"/>
-            <a:ext cx="1234440" cy="603504"/>
-          </a:xfrm>
-          <a:prstGeom prst="rect">
-            <a:avLst/>
-          </a:prstGeom>
-          <a:noFill/>
-          <a:ln/>
-        </p:spPr>
-        <p:txBody>
-          <a:bodyPr wrap="square" lIns="0" tIns="0" rIns="0" bIns="0" rtlCol="0" anchor="ctr"/>
-          <a:lstStyle/>
-          <a:p>
-            <a:pPr indent="0" marL="0">
-              <a:buNone/>
-            </a:pPr>
-            <a:r>
-              <a:rPr lang="en-US" sz="1350" b="1" dirty="0">
-                <a:solidFill>
-                  <a:schemeClr val="tx1"/>
-                </a:solidFill>
-              </a:rPr>
-              <a:t>Decided</a:t>
-            </a:r>
-            <a:endParaRPr lang="en-US" sz="1350" dirty="0"/>
-          </a:p>
-        </p:txBody>
-      </p:sp>
-      <p:sp>
-        <p:nvSpPr>
-          <p:cNvPr id="63" name="node-57"/>
-          <p:cNvSpPr/>
-          <p:nvPr/>
-        </p:nvSpPr>
-        <p:spPr>
-          <a:xfrm>
-            <a:off x="9768535" y="4910328"/>
-            <a:ext cx="1874520" cy="713232"/>
-          </a:xfrm>
-          <a:prstGeom prst="roundRect">
-            <a:avLst>
-              <a:gd name="adj" fmla="val 12821"/>
-            </a:avLst>
-          </a:prstGeom>
-          <a:solidFill>
-            <a:schemeClr val="accent4">
-              <a:alpha val="14000"/>
-            </a:schemeClr>
-          </a:solidFill>
-          <a:ln w="15875">
-            <a:solidFill>
-              <a:schemeClr val="accent4"/>
-            </a:solidFill>
-            <a:prstDash val="solid"/>
-          </a:ln>
-        </p:spPr>
-      </p:sp>
-      <p:pic>
-        <p:nvPicPr>
-          <p:cNvPr id="64" name="icon-58" descr="preencoded.png">    </p:cNvPr>
-          <p:cNvPicPr>
-            <a:picLocks noChangeAspect="1"/>
-          </p:cNvPicPr>
-          <p:nvPr/>
-        </p:nvPicPr>
-        <p:blipFill>
-          <a:blip r:embed="rId14"/>
-          <a:stretch>
-            <a:fillRect/>
-          </a:stretch>
-        </p:blipFill>
-        <p:spPr>
-          <a:xfrm>
-            <a:off x="9896551" y="5038344"/>
-            <a:ext cx="292608" cy="292608"/>
-          </a:xfrm>
-          <a:prstGeom prst="rect">
-            <a:avLst/>
-          </a:prstGeom>
-        </p:spPr>
-      </p:pic>
-      <p:sp>
-        <p:nvSpPr>
-          <p:cNvPr id="65" name="node-title-59"/>
-          <p:cNvSpPr txBox="1"/>
-          <p:nvPr/>
-        </p:nvSpPr>
-        <p:spPr>
-          <a:xfrm>
-            <a:off x="10280599" y="4965192"/>
-            <a:ext cx="1234440" cy="603504"/>
-          </a:xfrm>
-          <a:prstGeom prst="rect">
-            <a:avLst/>
-          </a:prstGeom>
-          <a:noFill/>
-          <a:ln/>
-        </p:spPr>
-        <p:txBody>
-          <a:bodyPr wrap="square" lIns="0" tIns="0" rIns="0" bIns="0" rtlCol="0" anchor="ctr"/>
-          <a:lstStyle/>
-          <a:p>
-            <a:pPr indent="0" marL="0">
-              <a:buNone/>
-            </a:pPr>
-            <a:r>
-              <a:rPr lang="en-US" sz="1350" b="1" dirty="0">
-                <a:solidFill>
-                  <a:schemeClr val="tx1"/>
-                </a:solidFill>
-              </a:rPr>
-              <a:t>A person</a:t>
-            </a:r>
-            <a:endParaRPr lang="en-US" sz="1350" dirty="0"/>
-          </a:p>
-        </p:txBody>
-      </p:sp>
-      <p:sp>
-        <p:nvSpPr>
-          <p:cNvPr id="66" name="arrow-60"/>
-          <p:cNvSpPr/>
-          <p:nvPr/>
-        </p:nvSpPr>
-        <p:spPr>
-          <a:xfrm>
-            <a:off x="2423160" y="4425696"/>
-            <a:ext cx="430454" cy="0"/>
+      <p:sp>
+        <p:nvSpPr>
+          <p:cNvPr id="33" name="arrow-15"/>
+          <p:cNvSpPr/>
+          <p:nvPr/>
+        </p:nvSpPr>
+        <p:spPr>
+          <a:xfrm>
+            <a:off x="2148840" y="3954780"/>
+            <a:ext cx="320040" cy="0"/>
           </a:xfrm>
           <a:prstGeom prst="line">
             <a:avLst/>
@@ -4907,14 +4247,14 @@
       </p:sp>
       <p:sp>
         <p:nvSpPr>
-          <p:cNvPr id="67" name="arrow-61"/>
-          <p:cNvSpPr/>
-          <p:nvPr/>
-        </p:nvSpPr>
-        <p:spPr>
-          <a:xfrm>
-            <a:off x="2423160" y="5266944"/>
-            <a:ext cx="430454" cy="0"/>
+          <p:cNvPr id="34" name="arrow-16"/>
+          <p:cNvSpPr/>
+          <p:nvPr/>
+        </p:nvSpPr>
+        <p:spPr>
+          <a:xfrm>
+            <a:off x="2148840" y="4914900"/>
+            <a:ext cx="320040" cy="0"/>
           </a:xfrm>
           <a:prstGeom prst="line">
             <a:avLst/>
@@ -4931,14 +4271,86 @@
       </p:sp>
       <p:sp>
         <p:nvSpPr>
-          <p:cNvPr id="68" name="arrow-62"/>
-          <p:cNvSpPr/>
-          <p:nvPr/>
-        </p:nvSpPr>
-        <p:spPr>
-          <a:xfrm>
-            <a:off x="4728134" y="4846320"/>
-            <a:ext cx="430454" cy="0"/>
+          <p:cNvPr id="35" name="arrow-17"/>
+          <p:cNvSpPr/>
+          <p:nvPr/>
+        </p:nvSpPr>
+        <p:spPr>
+          <a:xfrm>
+            <a:off x="3337560" y="3954780"/>
+            <a:ext cx="548640" cy="0"/>
+          </a:xfrm>
+          <a:prstGeom prst="line">
+            <a:avLst/>
+          </a:prstGeom>
+          <a:noFill/>
+          <a:ln w="19050">
+            <a:solidFill>
+              <a:schemeClr val="tx2"/>
+            </a:solidFill>
+            <a:prstDash val="solid"/>
+            <a:tailEnd type="none"/>
+          </a:ln>
+        </p:spPr>
+      </p:sp>
+      <p:sp>
+        <p:nvSpPr>
+          <p:cNvPr id="36" name="arrow-18"/>
+          <p:cNvSpPr/>
+          <p:nvPr/>
+        </p:nvSpPr>
+        <p:spPr>
+          <a:xfrm>
+            <a:off x="3337560" y="4914900"/>
+            <a:ext cx="548640" cy="0"/>
+          </a:xfrm>
+          <a:prstGeom prst="line">
+            <a:avLst/>
+          </a:prstGeom>
+          <a:noFill/>
+          <a:ln w="19050">
+            <a:solidFill>
+              <a:schemeClr val="tx2"/>
+            </a:solidFill>
+            <a:prstDash val="solid"/>
+            <a:tailEnd type="none"/>
+          </a:ln>
+        </p:spPr>
+      </p:sp>
+      <p:sp>
+        <p:nvSpPr>
+          <p:cNvPr id="37" name="arrow-19"/>
+          <p:cNvSpPr/>
+          <p:nvPr/>
+        </p:nvSpPr>
+        <p:spPr>
+          <a:xfrm>
+            <a:off x="3886200" y="3954780"/>
+            <a:ext cx="0" cy="960120"/>
+          </a:xfrm>
+          <a:prstGeom prst="line">
+            <a:avLst/>
+          </a:prstGeom>
+          <a:noFill/>
+          <a:ln w="19050">
+            <a:solidFill>
+              <a:schemeClr val="tx2"/>
+            </a:solidFill>
+            <a:prstDash val="solid"/>
+            <a:tailEnd type="none"/>
+          </a:ln>
+        </p:spPr>
+      </p:sp>
+      <p:sp>
+        <p:nvSpPr>
+          <p:cNvPr id="38" name="arrow-20"/>
+          <p:cNvSpPr/>
+          <p:nvPr/>
+        </p:nvSpPr>
+        <p:spPr>
+          <a:xfrm>
+            <a:off x="3886200" y="4434840"/>
+            <a:ext cx="320040" cy="0"/>
           </a:xfrm>
           <a:prstGeom prst="line">
             <a:avLst/>
@@ -4955,14 +4367,14 @@
       </p:sp>
       <p:sp>
         <p:nvSpPr>
-          <p:cNvPr id="69" name="arrow-63"/>
-          <p:cNvSpPr/>
-          <p:nvPr/>
-        </p:nvSpPr>
-        <p:spPr>
-          <a:xfrm>
-            <a:off x="7033108" y="4846320"/>
-            <a:ext cx="430454" cy="0"/>
+          <p:cNvPr id="39" name="arrow-21"/>
+          <p:cNvSpPr/>
+          <p:nvPr/>
+        </p:nvSpPr>
+        <p:spPr>
+          <a:xfrm>
+            <a:off x="5303520" y="4434840"/>
+            <a:ext cx="411480" cy="0"/>
           </a:xfrm>
           <a:prstGeom prst="line">
             <a:avLst/>
@@ -4979,14 +4391,38 @@
       </p:sp>
       <p:sp>
         <p:nvSpPr>
-          <p:cNvPr id="70" name="arrow-64"/>
-          <p:cNvSpPr/>
-          <p:nvPr/>
-        </p:nvSpPr>
-        <p:spPr>
-          <a:xfrm>
-            <a:off x="9338081" y="4425696"/>
-            <a:ext cx="430454" cy="0"/>
+          <p:cNvPr id="40" name="arrow-22"/>
+          <p:cNvSpPr/>
+          <p:nvPr/>
+        </p:nvSpPr>
+        <p:spPr>
+          <a:xfrm>
+            <a:off x="7680960" y="4434840"/>
+            <a:ext cx="365760" cy="0"/>
+          </a:xfrm>
+          <a:prstGeom prst="line">
+            <a:avLst/>
+          </a:prstGeom>
+          <a:noFill/>
+          <a:ln w="19050">
+            <a:solidFill>
+              <a:schemeClr val="tx2"/>
+            </a:solidFill>
+            <a:prstDash val="solid"/>
+            <a:tailEnd type="triangle"/>
+          </a:ln>
+        </p:spPr>
+      </p:sp>
+      <p:sp>
+        <p:nvSpPr>
+          <p:cNvPr id="41" name="arrow-23"/>
+          <p:cNvSpPr/>
+          <p:nvPr/>
+        </p:nvSpPr>
+        <p:spPr>
+          <a:xfrm>
+            <a:off x="9692640" y="4434840"/>
+            <a:ext cx="548640" cy="0"/>
           </a:xfrm>
           <a:prstGeom prst="line">
             <a:avLst/>
@@ -5003,14 +4439,110 @@
       </p:sp>
       <p:sp>
         <p:nvSpPr>
-          <p:cNvPr id="71" name="arrow-65"/>
-          <p:cNvSpPr/>
-          <p:nvPr/>
-        </p:nvSpPr>
-        <p:spPr>
-          <a:xfrm>
-            <a:off x="9338081" y="5266944"/>
-            <a:ext cx="430454" cy="0"/>
+          <p:cNvPr id="42" name="flow-tag-24"/>
+          <p:cNvSpPr txBox="1"/>
+          <p:nvPr/>
+        </p:nvSpPr>
+        <p:spPr>
+          <a:xfrm>
+            <a:off x="9710928" y="4178808"/>
+            <a:ext cx="530352" cy="201168"/>
+          </a:xfrm>
+          <a:prstGeom prst="rect">
+            <a:avLst/>
+          </a:prstGeom>
+          <a:noFill/>
+          <a:ln/>
+        </p:spPr>
+        <p:txBody>
+          <a:bodyPr wrap="square" lIns="0" tIns="0" rIns="0" bIns="0" rtlCol="0" anchor="ctr"/>
+          <a:lstStyle/>
+          <a:p>
+            <a:pPr algn="ctr" indent="0" marL="0">
+              <a:buNone/>
+            </a:pPr>
+            <a:r>
+              <a:rPr lang="en-US" sz="950" i="1" dirty="0">
+                <a:solidFill>
+                  <a:schemeClr val="accent3"/>
+                </a:solidFill>
+              </a:rPr>
+              <a:t>all pass</a:t>
+            </a:r>
+            <a:endParaRPr lang="en-US" sz="950" dirty="0"/>
+          </a:p>
+        </p:txBody>
+      </p:sp>
+      <p:sp>
+        <p:nvSpPr>
+          <p:cNvPr id="43" name="human"/>
+          <p:cNvSpPr/>
+          <p:nvPr/>
+        </p:nvSpPr>
+        <p:spPr>
+          <a:xfrm>
+            <a:off x="6035040" y="5532120"/>
+            <a:ext cx="2743200" cy="566928"/>
+          </a:xfrm>
+          <a:prstGeom prst="roundRect">
+            <a:avLst>
+              <a:gd name="adj" fmla="val 16129"/>
+            </a:avLst>
+          </a:prstGeom>
+          <a:solidFill>
+            <a:schemeClr val="accent4">
+              <a:alpha val="14000"/>
+            </a:schemeClr>
+          </a:solidFill>
+          <a:ln w="19050">
+            <a:solidFill>
+              <a:schemeClr val="accent4"/>
+            </a:solidFill>
+          </a:ln>
+        </p:spPr>
+        <p:txBody>
+          <a:bodyPr wrap="square" lIns="508" tIns="508" rIns="508" bIns="508" rtlCol="0" anchor="ctr"/>
+          <a:lstStyle/>
+          <a:p>
+            <a:pPr algn="ctr" indent="0" marL="0">
+              <a:buNone/>
+            </a:pPr>
+            <a:r>
+              <a:rPr lang="en-US" sz="1200" b="1" dirty="0">
+                <a:solidFill>
+                  <a:schemeClr val="tx1"/>
+                </a:solidFill>
+              </a:rPr>
+              <a:t>Human review</a:t>
+            </a:r>
+            <a:endParaRPr lang="en-US" sz="1200" dirty="0"/>
+          </a:p>
+          <a:p>
+            <a:pPr algn="ctr" indent="0" marL="0">
+              <a:buNone/>
+            </a:pPr>
+            <a:r>
+              <a:rPr lang="en-US" sz="950" dirty="0">
+                <a:solidFill>
+                  <a:schemeClr val="tx1"/>
+                </a:solidFill>
+              </a:rPr>
+              <a:t>L2 support console</a:t>
+            </a:r>
+            <a:endParaRPr lang="en-US" sz="1200" dirty="0"/>
+          </a:p>
+        </p:txBody>
+      </p:sp>
+      <p:sp>
+        <p:nvSpPr>
+          <p:cNvPr id="44" name="arrow-25"/>
+          <p:cNvSpPr/>
+          <p:nvPr/>
+        </p:nvSpPr>
+        <p:spPr>
+          <a:xfrm>
+            <a:off x="6400800" y="4937760"/>
+            <a:ext cx="0" cy="594360"/>
           </a:xfrm>
           <a:prstGeom prst="line">
             <a:avLst/>
@@ -5027,19 +4559,221 @@
       </p:sp>
       <p:sp>
         <p:nvSpPr>
-          <p:cNvPr id="72" name="legend-key-66"/>
-          <p:cNvSpPr/>
-          <p:nvPr/>
-        </p:nvSpPr>
-        <p:spPr>
-          <a:xfrm>
-            <a:off x="548640" y="5998464"/>
-            <a:ext cx="292608" cy="201168"/>
-          </a:xfrm>
-          <a:prstGeom prst="roundRect">
-            <a:avLst>
-              <a:gd name="adj" fmla="val 22727"/>
-            </a:avLst>
+          <p:cNvPr id="45" name="flow-tag-26"/>
+          <p:cNvSpPr txBox="1"/>
+          <p:nvPr/>
+        </p:nvSpPr>
+        <p:spPr>
+          <a:xfrm>
+            <a:off x="6473952" y="5056632"/>
+            <a:ext cx="731520" cy="201168"/>
+          </a:xfrm>
+          <a:prstGeom prst="rect">
+            <a:avLst/>
+          </a:prstGeom>
+          <a:noFill/>
+          <a:ln/>
+        </p:spPr>
+        <p:txBody>
+          <a:bodyPr wrap="square" lIns="0" tIns="0" rIns="0" bIns="0" rtlCol="0" anchor="ctr"/>
+          <a:lstStyle/>
+          <a:p>
+            <a:pPr algn="l" indent="0" marL="0">
+              <a:buNone/>
+            </a:pPr>
+            <a:r>
+              <a:rPr lang="en-US" sz="950" i="1" dirty="0">
+                <a:solidFill>
+                  <a:schemeClr val="accent4"/>
+                </a:solidFill>
+              </a:rPr>
+              <a:t>flagged</a:t>
+            </a:r>
+            <a:endParaRPr lang="en-US" sz="950" dirty="0"/>
+          </a:p>
+        </p:txBody>
+      </p:sp>
+      <p:sp>
+        <p:nvSpPr>
+          <p:cNvPr id="46" name="arrow-27"/>
+          <p:cNvSpPr/>
+          <p:nvPr/>
+        </p:nvSpPr>
+        <p:spPr>
+          <a:xfrm>
+            <a:off x="8869680" y="4892040"/>
+            <a:ext cx="0" cy="923544"/>
+          </a:xfrm>
+          <a:prstGeom prst="line">
+            <a:avLst/>
+          </a:prstGeom>
+          <a:noFill/>
+          <a:ln w="19050">
+            <a:solidFill>
+              <a:schemeClr val="accent4"/>
+            </a:solidFill>
+            <a:prstDash val="solid"/>
+            <a:tailEnd type="none"/>
+          </a:ln>
+        </p:spPr>
+      </p:sp>
+      <p:sp>
+        <p:nvSpPr>
+          <p:cNvPr id="47" name="arrow-28"/>
+          <p:cNvSpPr/>
+          <p:nvPr/>
+        </p:nvSpPr>
+        <p:spPr>
+          <a:xfrm flipH="1">
+            <a:off x="8778240" y="5815584"/>
+            <a:ext cx="91440" cy="0"/>
+          </a:xfrm>
+          <a:prstGeom prst="line">
+            <a:avLst/>
+          </a:prstGeom>
+          <a:noFill/>
+          <a:ln w="19050">
+            <a:solidFill>
+              <a:schemeClr val="accent4"/>
+            </a:solidFill>
+            <a:prstDash val="solid"/>
+            <a:tailEnd type="triangle"/>
+          </a:ln>
+        </p:spPr>
+      </p:sp>
+      <p:sp>
+        <p:nvSpPr>
+          <p:cNvPr id="48" name="flow-tag-29"/>
+          <p:cNvSpPr txBox="1"/>
+          <p:nvPr/>
+        </p:nvSpPr>
+        <p:spPr>
+          <a:xfrm>
+            <a:off x="8942832" y="5056632"/>
+            <a:ext cx="548640" cy="201168"/>
+          </a:xfrm>
+          <a:prstGeom prst="rect">
+            <a:avLst/>
+          </a:prstGeom>
+          <a:noFill/>
+          <a:ln/>
+        </p:spPr>
+        <p:txBody>
+          <a:bodyPr wrap="square" lIns="0" tIns="0" rIns="0" bIns="0" rtlCol="0" anchor="ctr"/>
+          <a:lstStyle/>
+          <a:p>
+            <a:pPr algn="l" indent="0" marL="0">
+              <a:buNone/>
+            </a:pPr>
+            <a:r>
+              <a:rPr lang="en-US" sz="950" i="1" dirty="0">
+                <a:solidFill>
+                  <a:schemeClr val="accent4"/>
+                </a:solidFill>
+              </a:rPr>
+              <a:t>veto</a:t>
+            </a:r>
+            <a:endParaRPr lang="en-US" sz="950" dirty="0"/>
+          </a:p>
+        </p:txBody>
+      </p:sp>
+      <p:sp>
+        <p:nvSpPr>
+          <p:cNvPr id="49" name="arrow-30"/>
+          <p:cNvSpPr/>
+          <p:nvPr/>
+        </p:nvSpPr>
+        <p:spPr>
+          <a:xfrm>
+            <a:off x="8869680" y="5815584"/>
+            <a:ext cx="2057400" cy="0"/>
+          </a:xfrm>
+          <a:prstGeom prst="line">
+            <a:avLst/>
+          </a:prstGeom>
+          <a:noFill/>
+          <a:ln w="19050">
+            <a:solidFill>
+              <a:schemeClr val="accent4"/>
+            </a:solidFill>
+            <a:prstDash val="solid"/>
+            <a:tailEnd type="none"/>
+          </a:ln>
+        </p:spPr>
+      </p:sp>
+      <p:sp>
+        <p:nvSpPr>
+          <p:cNvPr id="50" name="arrow-31"/>
+          <p:cNvSpPr/>
+          <p:nvPr/>
+        </p:nvSpPr>
+        <p:spPr>
+          <a:xfrm flipV="1">
+            <a:off x="10927080" y="4800600"/>
+            <a:ext cx="0" cy="1014984"/>
+          </a:xfrm>
+          <a:prstGeom prst="line">
+            <a:avLst/>
+          </a:prstGeom>
+          <a:noFill/>
+          <a:ln w="19050">
+            <a:solidFill>
+              <a:schemeClr val="accent4"/>
+            </a:solidFill>
+            <a:prstDash val="solid"/>
+            <a:tailEnd type="triangle"/>
+          </a:ln>
+        </p:spPr>
+      </p:sp>
+      <p:sp>
+        <p:nvSpPr>
+          <p:cNvPr id="51" name="flow-tag-32"/>
+          <p:cNvSpPr txBox="1"/>
+          <p:nvPr/>
+        </p:nvSpPr>
+        <p:spPr>
+          <a:xfrm>
+            <a:off x="9144000" y="5861304"/>
+            <a:ext cx="1691640" cy="201168"/>
+          </a:xfrm>
+          <a:prstGeom prst="rect">
+            <a:avLst/>
+          </a:prstGeom>
+          <a:noFill/>
+          <a:ln/>
+        </p:spPr>
+        <p:txBody>
+          <a:bodyPr wrap="square" lIns="0" tIns="0" rIns="0" bIns="0" rtlCol="0" anchor="ctr"/>
+          <a:lstStyle/>
+          <a:p>
+            <a:pPr algn="ctr" indent="0" marL="0">
+              <a:buNone/>
+            </a:pPr>
+            <a:r>
+              <a:rPr lang="en-US" sz="950" i="1" dirty="0">
+                <a:solidFill>
+                  <a:schemeClr val="accent4"/>
+                </a:solidFill>
+              </a:rPr>
+              <a:t>a person decides</a:t>
+            </a:r>
+            <a:endParaRPr lang="en-US" sz="950" dirty="0"/>
+          </a:p>
+        </p:txBody>
+      </p:sp>
+      <p:sp>
+        <p:nvSpPr>
+          <p:cNvPr id="52" name="legend-key-33"/>
+          <p:cNvSpPr/>
+          <p:nvPr/>
+        </p:nvSpPr>
+        <p:spPr>
+          <a:xfrm>
+            <a:off x="548640" y="5641848"/>
+            <a:ext cx="237744" cy="237744"/>
+          </a:xfrm>
+          <a:prstGeom prst="ellipse">
+            <a:avLst/>
           </a:prstGeom>
           <a:solidFill>
             <a:schemeClr val="tx1"/>
@@ -5049,14 +4783,14 @@
       </p:sp>
       <p:sp>
         <p:nvSpPr>
-          <p:cNvPr id="73" name="legend-text-67"/>
+          <p:cNvPr id="53" name="legend-text-34"/>
           <p:cNvSpPr txBox="1"/>
           <p:nvPr/>
         </p:nvSpPr>
         <p:spPr>
           <a:xfrm>
-            <a:off x="932688" y="5961888"/>
-            <a:ext cx="1828800" cy="274320"/>
+            <a:off x="960120" y="5596128"/>
+            <a:ext cx="1463040" cy="329184"/>
           </a:xfrm>
           <a:prstGeom prst="rect">
             <a:avLst/>
@@ -5072,37 +4806,35 @@
               <a:buNone/>
             </a:pPr>
             <a:r>
-              <a:rPr lang="en-US" sz="1100" dirty="0">
+              <a:rPr lang="en-US" sz="1050" dirty="0">
                 <a:solidFill>
                   <a:schemeClr val="tx2"/>
                 </a:solidFill>
               </a:rPr>
-              <a:t>AI step (model call)</a:t>
-            </a:r>
-            <a:endParaRPr lang="en-US" sz="1100" dirty="0"/>
-          </a:p>
-        </p:txBody>
-      </p:sp>
-      <p:sp>
-        <p:nvSpPr>
-          <p:cNvPr id="74" name="legend-key-68"/>
-          <p:cNvSpPr/>
-          <p:nvPr/>
-        </p:nvSpPr>
-        <p:spPr>
-          <a:xfrm>
-            <a:off x="2788920" y="5998464"/>
-            <a:ext cx="292608" cy="201168"/>
-          </a:xfrm>
-          <a:prstGeom prst="roundRect">
-            <a:avLst>
-              <a:gd name="adj" fmla="val 22727"/>
-            </a:avLst>
+              <a:t>AI agent</a:t>
+            </a:r>
+            <a:endParaRPr lang="en-US" sz="1050" dirty="0"/>
+          </a:p>
+        </p:txBody>
+      </p:sp>
+      <p:sp>
+        <p:nvSpPr>
+          <p:cNvPr id="54" name="legend-key-35"/>
+          <p:cNvSpPr/>
+          <p:nvPr/>
+        </p:nvSpPr>
+        <p:spPr>
+          <a:xfrm>
+            <a:off x="1965960" y="5641848"/>
+            <a:ext cx="329184" cy="237744"/>
+          </a:xfrm>
+          <a:prstGeom prst="hexagon">
+            <a:avLst/>
           </a:prstGeom>
           <a:solidFill>
             <a:schemeClr val="bg1"/>
           </a:solidFill>
-          <a:ln w="15875">
+          <a:ln w="12700">
             <a:solidFill>
               <a:schemeClr val="tx2"/>
             </a:solidFill>
@@ -5112,14 +4844,14 @@
       </p:sp>
       <p:sp>
         <p:nvSpPr>
-          <p:cNvPr id="75" name="legend-text-69"/>
+          <p:cNvPr id="55" name="legend-text-36"/>
           <p:cNvSpPr txBox="1"/>
           <p:nvPr/>
         </p:nvSpPr>
         <p:spPr>
           <a:xfrm>
-            <a:off x="3172968" y="5961888"/>
-            <a:ext cx="1828800" cy="274320"/>
+            <a:off x="2377440" y="5596128"/>
+            <a:ext cx="1463040" cy="329184"/>
           </a:xfrm>
           <a:prstGeom prst="rect">
             <a:avLst/>
@@ -5135,39 +4867,37 @@
               <a:buNone/>
             </a:pPr>
             <a:r>
-              <a:rPr lang="en-US" sz="1100" dirty="0">
+              <a:rPr lang="en-US" sz="1050" dirty="0">
                 <a:solidFill>
                   <a:schemeClr val="tx2"/>
                 </a:solidFill>
               </a:rPr>
-              <a:t>Plain code, no AI</a:t>
-            </a:r>
-            <a:endParaRPr lang="en-US" sz="1100" dirty="0"/>
-          </a:p>
-        </p:txBody>
-      </p:sp>
-      <p:sp>
-        <p:nvSpPr>
-          <p:cNvPr id="76" name="legend-key-70"/>
-          <p:cNvSpPr/>
-          <p:nvPr/>
-        </p:nvSpPr>
-        <p:spPr>
-          <a:xfrm>
-            <a:off x="5029200" y="5998464"/>
-            <a:ext cx="292608" cy="201168"/>
+              <a:t>plain code, no AI</a:t>
+            </a:r>
+            <a:endParaRPr lang="en-US" sz="1050" dirty="0"/>
+          </a:p>
+        </p:txBody>
+      </p:sp>
+      <p:sp>
+        <p:nvSpPr>
+          <p:cNvPr id="56" name="legend-key-37"/>
+          <p:cNvSpPr/>
+          <p:nvPr/>
+        </p:nvSpPr>
+        <p:spPr>
+          <a:xfrm>
+            <a:off x="3840480" y="5641848"/>
+            <a:ext cx="329184" cy="237744"/>
           </a:xfrm>
           <a:prstGeom prst="roundRect">
-            <a:avLst>
-              <a:gd name="adj" fmla="val 22727"/>
-            </a:avLst>
+            <a:avLst/>
           </a:prstGeom>
           <a:solidFill>
             <a:schemeClr val="accent4">
               <a:alpha val="14000"/>
             </a:schemeClr>
           </a:solidFill>
-          <a:ln w="15875">
+          <a:ln w="12700">
             <a:solidFill>
               <a:schemeClr val="accent4"/>
             </a:solidFill>
@@ -5177,14 +4907,14 @@
       </p:sp>
       <p:sp>
         <p:nvSpPr>
-          <p:cNvPr id="77" name="legend-text-71"/>
+          <p:cNvPr id="57" name="legend-text-38"/>
           <p:cNvSpPr txBox="1"/>
           <p:nvPr/>
         </p:nvSpPr>
         <p:spPr>
           <a:xfrm>
-            <a:off x="5413248" y="5961888"/>
-            <a:ext cx="1828800" cy="274320"/>
+            <a:off x="4251960" y="5596128"/>
+            <a:ext cx="1463040" cy="329184"/>
           </a:xfrm>
           <a:prstGeom prst="rect">
             <a:avLst/>
@@ -5200,130 +4930,14 @@
               <a:buNone/>
             </a:pPr>
             <a:r>
-              <a:rPr lang="en-US" sz="1100" dirty="0">
+              <a:rPr lang="en-US" sz="1050" dirty="0">
                 <a:solidFill>
                   <a:schemeClr val="tx2"/>
                 </a:solidFill>
               </a:rPr>
-              <a:t>A person decides</a:t>
-            </a:r>
-            <a:endParaRPr lang="en-US" sz="1100" dirty="0"/>
-          </a:p>
-        </p:txBody>
-      </p:sp>
-      <p:sp>
-        <p:nvSpPr>
-          <p:cNvPr id="78" name="legend-key-72"/>
-          <p:cNvSpPr/>
-          <p:nvPr/>
-        </p:nvSpPr>
-        <p:spPr>
-          <a:xfrm>
-            <a:off x="7269480" y="5998464"/>
-            <a:ext cx="292608" cy="201168"/>
-          </a:xfrm>
-          <a:prstGeom prst="roundRect">
-            <a:avLst>
-              <a:gd name="adj" fmla="val 22727"/>
-            </a:avLst>
-          </a:prstGeom>
-          <a:solidFill>
-            <a:schemeClr val="accent1"/>
-          </a:solidFill>
-          <a:ln/>
-        </p:spPr>
-      </p:sp>
-      <p:sp>
-        <p:nvSpPr>
-          <p:cNvPr id="79" name="legend-text-73"/>
-          <p:cNvSpPr txBox="1"/>
-          <p:nvPr/>
-        </p:nvSpPr>
-        <p:spPr>
-          <a:xfrm>
-            <a:off x="7653528" y="5961888"/>
-            <a:ext cx="1828800" cy="274320"/>
-          </a:xfrm>
-          <a:prstGeom prst="rect">
-            <a:avLst/>
-          </a:prstGeom>
-          <a:noFill/>
-          <a:ln/>
-        </p:spPr>
-        <p:txBody>
-          <a:bodyPr wrap="square" lIns="0" tIns="0" rIns="0" bIns="0" rtlCol="0" anchor="ctr"/>
-          <a:lstStyle/>
-          <a:p>
-            <a:pPr indent="0" marL="0">
-              <a:buNone/>
-            </a:pPr>
-            <a:r>
-              <a:rPr lang="en-US" sz="1100" dirty="0">
-                <a:solidFill>
-                  <a:schemeClr val="tx2"/>
-                </a:solidFill>
-              </a:rPr>
-              <a:t>Rider's side</a:t>
-            </a:r>
-            <a:endParaRPr lang="en-US" sz="1100" dirty="0"/>
-          </a:p>
-        </p:txBody>
-      </p:sp>
-      <p:sp>
-        <p:nvSpPr>
-          <p:cNvPr id="80" name="legend-key-74"/>
-          <p:cNvSpPr/>
-          <p:nvPr/>
-        </p:nvSpPr>
-        <p:spPr>
-          <a:xfrm>
-            <a:off x="9509760" y="5998464"/>
-            <a:ext cx="292608" cy="201168"/>
-          </a:xfrm>
-          <a:prstGeom prst="roundRect">
-            <a:avLst>
-              <a:gd name="adj" fmla="val 22727"/>
-            </a:avLst>
-          </a:prstGeom>
-          <a:solidFill>
-            <a:schemeClr val="accent2"/>
-          </a:solidFill>
-          <a:ln/>
-        </p:spPr>
-      </p:sp>
-      <p:sp>
-        <p:nvSpPr>
-          <p:cNvPr id="81" name="legend-text-75"/>
-          <p:cNvSpPr txBox="1"/>
-          <p:nvPr/>
-        </p:nvSpPr>
-        <p:spPr>
-          <a:xfrm>
-            <a:off x="9893808" y="5961888"/>
-            <a:ext cx="1828800" cy="274320"/>
-          </a:xfrm>
-          <a:prstGeom prst="rect">
-            <a:avLst/>
-          </a:prstGeom>
-          <a:noFill/>
-          <a:ln/>
-        </p:spPr>
-        <p:txBody>
-          <a:bodyPr wrap="square" lIns="0" tIns="0" rIns="0" bIns="0" rtlCol="0" anchor="ctr"/>
-          <a:lstStyle/>
-          <a:p>
-            <a:pPr indent="0" marL="0">
-              <a:buNone/>
-            </a:pPr>
-            <a:r>
-              <a:rPr lang="en-US" sz="1100" dirty="0">
-                <a:solidFill>
-                  <a:schemeClr val="tx2"/>
-                </a:solidFill>
-              </a:rPr>
-              <a:t>Driver's side</a:t>
-            </a:r>
-            <a:endParaRPr lang="en-US" sz="1100" dirty="0"/>
+              <a:t>a person</a:t>
+            </a:r>
+            <a:endParaRPr lang="en-US" sz="1050" dirty="0"/>
           </a:p>
         </p:txBody>
       </p:sp>
@@ -6862,7 +6476,7 @@
       </p:sp>
       <p:sp>
         <p:nvSpPr>
-          <p:cNvPr id="8" name="arrow-76"/>
+          <p:cNvPr id="8" name="arrow-39"/>
           <p:cNvSpPr/>
           <p:nvPr/>
         </p:nvSpPr>
@@ -7011,7 +6625,7 @@
       </p:sp>
       <p:sp>
         <p:nvSpPr>
-          <p:cNvPr id="13" name="arrow-77"/>
+          <p:cNvPr id="13" name="arrow-40"/>
           <p:cNvSpPr/>
           <p:nvPr/>
         </p:nvSpPr>
@@ -7035,7 +6649,7 @@
       </p:sp>
       <p:sp>
         <p:nvSpPr>
-          <p:cNvPr id="14" name="node-78"/>
+          <p:cNvPr id="14" name="node-41"/>
           <p:cNvSpPr/>
           <p:nvPr/>
         </p:nvSpPr>
@@ -7057,7 +6671,7 @@
       </p:sp>
       <p:pic>
         <p:nvPicPr>
-          <p:cNvPr id="15" name="icon-79" descr="preencoded.png">    </p:cNvPr>
+          <p:cNvPr id="15" name="icon-42" descr="preencoded.png">    </p:cNvPr>
           <p:cNvPicPr>
             <a:picLocks noChangeAspect="1"/>
           </p:cNvPicPr>
@@ -7081,7 +6695,7 @@
       </p:pic>
       <p:sp>
         <p:nvSpPr>
-          <p:cNvPr id="16" name="node-title-80"/>
+          <p:cNvPr id="16" name="node-title-43"/>
           <p:cNvSpPr txBox="1"/>
           <p:nvPr/>
         </p:nvSpPr>
@@ -7117,7 +6731,7 @@
       </p:sp>
       <p:sp>
         <p:nvSpPr>
-          <p:cNvPr id="17" name="node-sub-81"/>
+          <p:cNvPr id="17" name="node-sub-44"/>
           <p:cNvSpPr txBox="1"/>
           <p:nvPr/>
         </p:nvSpPr>
@@ -7153,7 +6767,7 @@
       </p:sp>
       <p:sp>
         <p:nvSpPr>
-          <p:cNvPr id="18" name="arrow-82"/>
+          <p:cNvPr id="18" name="arrow-45"/>
           <p:cNvSpPr/>
           <p:nvPr/>
         </p:nvSpPr>
@@ -7177,7 +6791,7 @@
       </p:sp>
       <p:sp>
         <p:nvSpPr>
-          <p:cNvPr id="19" name="node-83"/>
+          <p:cNvPr id="19" name="node-46"/>
           <p:cNvSpPr/>
           <p:nvPr/>
         </p:nvSpPr>
@@ -7204,7 +6818,7 @@
       </p:sp>
       <p:pic>
         <p:nvPicPr>
-          <p:cNvPr id="20" name="icon-84" descr="preencoded.png">    </p:cNvPr>
+          <p:cNvPr id="20" name="icon-47" descr="preencoded.png">    </p:cNvPr>
           <p:cNvPicPr>
             <a:picLocks noChangeAspect="1"/>
           </p:cNvPicPr>
@@ -7228,7 +6842,7 @@
       </p:pic>
       <p:sp>
         <p:nvSpPr>
-          <p:cNvPr id="21" name="node-title-85"/>
+          <p:cNvPr id="21" name="node-title-48"/>
           <p:cNvSpPr txBox="1"/>
           <p:nvPr/>
         </p:nvSpPr>
@@ -7264,7 +6878,7 @@
       </p:sp>
       <p:sp>
         <p:nvSpPr>
-          <p:cNvPr id="22" name="node-sub-86"/>
+          <p:cNvPr id="22" name="node-sub-49"/>
           <p:cNvSpPr txBox="1"/>
           <p:nvPr/>
         </p:nvSpPr>
@@ -7300,7 +6914,7 @@
       </p:sp>
       <p:sp>
         <p:nvSpPr>
-          <p:cNvPr id="23" name="arrow-87"/>
+          <p:cNvPr id="23" name="arrow-50"/>
           <p:cNvSpPr/>
           <p:nvPr/>
         </p:nvSpPr>
@@ -7801,7 +7415,7 @@
       </p:sp>
       <p:sp>
         <p:nvSpPr>
-          <p:cNvPr id="7" name="arrow-88"/>
+          <p:cNvPr id="7" name="arrow-51"/>
           <p:cNvSpPr/>
           <p:nvPr/>
         </p:nvSpPr>
@@ -7928,7 +7542,7 @@
       </p:sp>
       <p:sp>
         <p:nvSpPr>
-          <p:cNvPr id="11" name="arrow-89"/>
+          <p:cNvPr id="11" name="arrow-52"/>
           <p:cNvSpPr/>
           <p:nvPr/>
         </p:nvSpPr>
@@ -8055,7 +7669,7 @@
       </p:sp>
       <p:sp>
         <p:nvSpPr>
-          <p:cNvPr id="15" name="arrow-90"/>
+          <p:cNvPr id="15" name="arrow-53"/>
           <p:cNvSpPr/>
           <p:nvPr/>
         </p:nvSpPr>
@@ -8182,7 +7796,7 @@
       </p:sp>
       <p:sp>
         <p:nvSpPr>
-          <p:cNvPr id="19" name="arrow-91"/>
+          <p:cNvPr id="19" name="arrow-54"/>
           <p:cNvSpPr/>
           <p:nvPr/>
         </p:nvSpPr>
@@ -8309,7 +7923,7 @@
       </p:sp>
       <p:sp>
         <p:nvSpPr>
-          <p:cNvPr id="23" name="arrow-92"/>
+          <p:cNvPr id="23" name="arrow-55"/>
           <p:cNvSpPr/>
           <p:nvPr/>
         </p:nvSpPr>
@@ -8333,7 +7947,7 @@
       </p:sp>
       <p:sp>
         <p:nvSpPr>
-          <p:cNvPr id="24" name="arrow-93"/>
+          <p:cNvPr id="24" name="arrow-56"/>
           <p:cNvSpPr/>
           <p:nvPr/>
         </p:nvSpPr>
@@ -8413,7 +8027,7 @@
       </p:sp>
       <p:sp>
         <p:nvSpPr>
-          <p:cNvPr id="27" name="arrow-94"/>
+          <p:cNvPr id="27" name="arrow-57"/>
           <p:cNvSpPr/>
           <p:nvPr/>
         </p:nvSpPr>
@@ -9255,7 +8869,7 @@
       </p:sp>
       <p:sp>
         <p:nvSpPr>
-          <p:cNvPr id="17" name="box-95"/>
+          <p:cNvPr id="17" name="box-58"/>
           <p:cNvSpPr/>
           <p:nvPr/>
         </p:nvSpPr>
@@ -9277,7 +8891,7 @@
       </p:sp>
       <p:pic>
         <p:nvPicPr>
-          <p:cNvPr id="18" name="box-icon-96" descr="preencoded.png">    </p:cNvPr>
+          <p:cNvPr id="18" name="box-icon-59" descr="preencoded.png">    </p:cNvPr>
           <p:cNvPicPr>
             <a:picLocks noChangeAspect="1"/>
           </p:cNvPicPr>
@@ -9301,7 +8915,7 @@
       </p:pic>
       <p:sp>
         <p:nvSpPr>
-          <p:cNvPr id="19" name="box-title-97"/>
+          <p:cNvPr id="19" name="box-title-60"/>
           <p:cNvSpPr txBox="1"/>
           <p:nvPr/>
         </p:nvSpPr>
@@ -9337,7 +8951,7 @@
       </p:sp>
       <p:sp>
         <p:nvSpPr>
-          <p:cNvPr id="20" name="box-sub-98"/>
+          <p:cNvPr id="20" name="box-sub-61"/>
           <p:cNvSpPr txBox="1"/>
           <p:nvPr/>
         </p:nvSpPr>
@@ -9373,7 +8987,7 @@
       </p:sp>
       <p:sp>
         <p:nvSpPr>
-          <p:cNvPr id="21" name="box-99"/>
+          <p:cNvPr id="21" name="box-62"/>
           <p:cNvSpPr/>
           <p:nvPr/>
         </p:nvSpPr>
@@ -9395,7 +9009,7 @@
       </p:sp>
       <p:pic>
         <p:nvPicPr>
-          <p:cNvPr id="22" name="box-icon-100" descr="preencoded.png">    </p:cNvPr>
+          <p:cNvPr id="22" name="box-icon-63" descr="preencoded.png">    </p:cNvPr>
           <p:cNvPicPr>
             <a:picLocks noChangeAspect="1"/>
           </p:cNvPicPr>
@@ -9419,7 +9033,7 @@
       </p:pic>
       <p:sp>
         <p:nvSpPr>
-          <p:cNvPr id="23" name="box-title-101"/>
+          <p:cNvPr id="23" name="box-title-64"/>
           <p:cNvSpPr txBox="1"/>
           <p:nvPr/>
         </p:nvSpPr>
@@ -9455,7 +9069,7 @@
       </p:sp>
       <p:sp>
         <p:nvSpPr>
-          <p:cNvPr id="24" name="box-sub-102"/>
+          <p:cNvPr id="24" name="box-sub-65"/>
           <p:cNvSpPr txBox="1"/>
           <p:nvPr/>
         </p:nvSpPr>
@@ -9491,7 +9105,7 @@
       </p:sp>
       <p:sp>
         <p:nvSpPr>
-          <p:cNvPr id="25" name="box-103"/>
+          <p:cNvPr id="25" name="box-66"/>
           <p:cNvSpPr/>
           <p:nvPr/>
         </p:nvSpPr>
@@ -9513,7 +9127,7 @@
       </p:sp>
       <p:pic>
         <p:nvPicPr>
-          <p:cNvPr id="26" name="box-icon-104" descr="preencoded.png">    </p:cNvPr>
+          <p:cNvPr id="26" name="box-icon-67" descr="preencoded.png">    </p:cNvPr>
           <p:cNvPicPr>
             <a:picLocks noChangeAspect="1"/>
           </p:cNvPicPr>
@@ -9537,7 +9151,7 @@
       </p:pic>
       <p:sp>
         <p:nvSpPr>
-          <p:cNvPr id="27" name="box-title-105"/>
+          <p:cNvPr id="27" name="box-title-68"/>
           <p:cNvSpPr txBox="1"/>
           <p:nvPr/>
         </p:nvSpPr>
@@ -9573,7 +9187,7 @@
       </p:sp>
       <p:sp>
         <p:nvSpPr>
-          <p:cNvPr id="28" name="box-sub-106"/>
+          <p:cNvPr id="28" name="box-sub-69"/>
           <p:cNvSpPr txBox="1"/>
           <p:nvPr/>
         </p:nvSpPr>
@@ -9609,7 +9223,7 @@
       </p:sp>
       <p:sp>
         <p:nvSpPr>
-          <p:cNvPr id="29" name="box-107"/>
+          <p:cNvPr id="29" name="box-70"/>
           <p:cNvSpPr/>
           <p:nvPr/>
         </p:nvSpPr>
@@ -9631,7 +9245,7 @@
       </p:sp>
       <p:pic>
         <p:nvPicPr>
-          <p:cNvPr id="30" name="box-icon-108" descr="preencoded.png">    </p:cNvPr>
+          <p:cNvPr id="30" name="box-icon-71" descr="preencoded.png">    </p:cNvPr>
           <p:cNvPicPr>
             <a:picLocks noChangeAspect="1"/>
           </p:cNvPicPr>
@@ -9655,7 +9269,7 @@
       </p:pic>
       <p:sp>
         <p:nvSpPr>
-          <p:cNvPr id="31" name="box-title-109"/>
+          <p:cNvPr id="31" name="box-title-72"/>
           <p:cNvSpPr txBox="1"/>
           <p:nvPr/>
         </p:nvSpPr>
@@ -9691,7 +9305,7 @@
       </p:sp>
       <p:sp>
         <p:nvSpPr>
-          <p:cNvPr id="32" name="box-sub-110"/>
+          <p:cNvPr id="32" name="box-sub-73"/>
           <p:cNvSpPr txBox="1"/>
           <p:nvPr/>
         </p:nvSpPr>
@@ -9727,7 +9341,7 @@
       </p:sp>
       <p:sp>
         <p:nvSpPr>
-          <p:cNvPr id="33" name="wire-label-111"/>
+          <p:cNvPr id="33" name="wire-label-74"/>
           <p:cNvSpPr txBox="1"/>
           <p:nvPr/>
         </p:nvSpPr>
@@ -9763,7 +9377,7 @@
       </p:sp>
       <p:sp>
         <p:nvSpPr>
-          <p:cNvPr id="34" name="arrow-112"/>
+          <p:cNvPr id="34" name="arrow-75"/>
           <p:cNvSpPr/>
           <p:nvPr/>
         </p:nvSpPr>
@@ -9787,7 +9401,7 @@
       </p:sp>
       <p:sp>
         <p:nvSpPr>
-          <p:cNvPr id="35" name="wire-label-113"/>
+          <p:cNvPr id="35" name="wire-label-76"/>
           <p:cNvSpPr txBox="1"/>
           <p:nvPr/>
         </p:nvSpPr>
@@ -9902,7 +9516,7 @@
       </p:sp>
       <p:sp>
         <p:nvSpPr>
-          <p:cNvPr id="38" name="box-114"/>
+          <p:cNvPr id="38" name="box-77"/>
           <p:cNvSpPr/>
           <p:nvPr/>
         </p:nvSpPr>
@@ -9924,7 +9538,7 @@
       </p:sp>
       <p:pic>
         <p:nvPicPr>
-          <p:cNvPr id="39" name="box-icon-115" descr="preencoded.png">    </p:cNvPr>
+          <p:cNvPr id="39" name="box-icon-78" descr="preencoded.png">    </p:cNvPr>
           <p:cNvPicPr>
             <a:picLocks noChangeAspect="1"/>
           </p:cNvPicPr>
@@ -9948,7 +9562,7 @@
       </p:pic>
       <p:sp>
         <p:nvSpPr>
-          <p:cNvPr id="40" name="box-title-116"/>
+          <p:cNvPr id="40" name="box-title-79"/>
           <p:cNvSpPr txBox="1"/>
           <p:nvPr/>
         </p:nvSpPr>
@@ -9984,7 +9598,7 @@
       </p:sp>
       <p:sp>
         <p:nvSpPr>
-          <p:cNvPr id="41" name="box-sub-117"/>
+          <p:cNvPr id="41" name="box-sub-80"/>
           <p:cNvSpPr txBox="1"/>
           <p:nvPr/>
         </p:nvSpPr>
@@ -10020,7 +9634,7 @@
       </p:sp>
       <p:sp>
         <p:nvSpPr>
-          <p:cNvPr id="42" name="box-118"/>
+          <p:cNvPr id="42" name="box-81"/>
           <p:cNvSpPr/>
           <p:nvPr/>
         </p:nvSpPr>
@@ -10042,7 +9656,7 @@
       </p:sp>
       <p:pic>
         <p:nvPicPr>
-          <p:cNvPr id="43" name="box-icon-119" descr="preencoded.png">    </p:cNvPr>
+          <p:cNvPr id="43" name="box-icon-82" descr="preencoded.png">    </p:cNvPr>
           <p:cNvPicPr>
             <a:picLocks noChangeAspect="1"/>
           </p:cNvPicPr>
@@ -10066,7 +9680,7 @@
       </p:pic>
       <p:sp>
         <p:nvSpPr>
-          <p:cNvPr id="44" name="box-title-120"/>
+          <p:cNvPr id="44" name="box-title-83"/>
           <p:cNvSpPr txBox="1"/>
           <p:nvPr/>
         </p:nvSpPr>
@@ -10102,7 +9716,7 @@
       </p:sp>
       <p:sp>
         <p:nvSpPr>
-          <p:cNvPr id="45" name="box-sub-121"/>
+          <p:cNvPr id="45" name="box-sub-84"/>
           <p:cNvSpPr txBox="1"/>
           <p:nvPr/>
         </p:nvSpPr>
@@ -10138,7 +9752,7 @@
       </p:sp>
       <p:sp>
         <p:nvSpPr>
-          <p:cNvPr id="46" name="box-122"/>
+          <p:cNvPr id="46" name="box-85"/>
           <p:cNvSpPr/>
           <p:nvPr/>
         </p:nvSpPr>
@@ -10165,7 +9779,7 @@
       </p:sp>
       <p:sp>
         <p:nvSpPr>
-          <p:cNvPr id="47" name="box-title-123"/>
+          <p:cNvPr id="47" name="box-title-86"/>
           <p:cNvSpPr txBox="1"/>
           <p:nvPr/>
         </p:nvSpPr>
@@ -10201,7 +9815,7 @@
       </p:sp>
       <p:sp>
         <p:nvSpPr>
-          <p:cNvPr id="48" name="box-sub-124"/>
+          <p:cNvPr id="48" name="box-sub-87"/>
           <p:cNvSpPr txBox="1"/>
           <p:nvPr/>
         </p:nvSpPr>
@@ -10237,7 +9851,7 @@
       </p:sp>
       <p:sp>
         <p:nvSpPr>
-          <p:cNvPr id="49" name="box-125"/>
+          <p:cNvPr id="49" name="box-88"/>
           <p:cNvSpPr/>
           <p:nvPr/>
         </p:nvSpPr>
@@ -10259,7 +9873,7 @@
       </p:sp>
       <p:pic>
         <p:nvPicPr>
-          <p:cNvPr id="50" name="box-icon-126" descr="preencoded.png">    </p:cNvPr>
+          <p:cNvPr id="50" name="box-icon-89" descr="preencoded.png">    </p:cNvPr>
           <p:cNvPicPr>
             <a:picLocks noChangeAspect="1"/>
           </p:cNvPicPr>
@@ -10283,7 +9897,7 @@
       </p:pic>
       <p:sp>
         <p:nvSpPr>
-          <p:cNvPr id="51" name="box-title-127"/>
+          <p:cNvPr id="51" name="box-title-90"/>
           <p:cNvSpPr txBox="1"/>
           <p:nvPr/>
         </p:nvSpPr>
@@ -10319,7 +9933,7 @@
       </p:sp>
       <p:sp>
         <p:nvSpPr>
-          <p:cNvPr id="52" name="box-sub-128"/>
+          <p:cNvPr id="52" name="box-sub-91"/>
           <p:cNvSpPr txBox="1"/>
           <p:nvPr/>
         </p:nvSpPr>
@@ -10355,7 +9969,7 @@
       </p:sp>
       <p:sp>
         <p:nvSpPr>
-          <p:cNvPr id="53" name="box-129"/>
+          <p:cNvPr id="53" name="box-92"/>
           <p:cNvSpPr/>
           <p:nvPr/>
         </p:nvSpPr>
@@ -10382,7 +9996,7 @@
       </p:sp>
       <p:pic>
         <p:nvPicPr>
-          <p:cNvPr id="54" name="box-icon-130" descr="preencoded.png">    </p:cNvPr>
+          <p:cNvPr id="54" name="box-icon-93" descr="preencoded.png">    </p:cNvPr>
           <p:cNvPicPr>
             <a:picLocks noChangeAspect="1"/>
           </p:cNvPicPr>
@@ -10406,7 +10020,7 @@
       </p:pic>
       <p:sp>
         <p:nvSpPr>
-          <p:cNvPr id="55" name="box-title-131"/>
+          <p:cNvPr id="55" name="box-title-94"/>
           <p:cNvSpPr txBox="1"/>
           <p:nvPr/>
         </p:nvSpPr>
@@ -10442,7 +10056,7 @@
       </p:sp>
       <p:sp>
         <p:nvSpPr>
-          <p:cNvPr id="56" name="box-sub-132"/>
+          <p:cNvPr id="56" name="box-sub-95"/>
           <p:cNvSpPr txBox="1"/>
           <p:nvPr/>
         </p:nvSpPr>
@@ -10478,7 +10092,7 @@
       </p:sp>
       <p:sp>
         <p:nvSpPr>
-          <p:cNvPr id="57" name="arrow-133"/>
+          <p:cNvPr id="57" name="arrow-96"/>
           <p:cNvSpPr/>
           <p:nvPr/>
         </p:nvSpPr>
@@ -10502,7 +10116,7 @@
       </p:sp>
       <p:sp>
         <p:nvSpPr>
-          <p:cNvPr id="58" name="wire-label-134"/>
+          <p:cNvPr id="58" name="wire-label-97"/>
           <p:cNvSpPr txBox="1"/>
           <p:nvPr/>
         </p:nvSpPr>
@@ -10538,7 +10152,7 @@
       </p:sp>
       <p:sp>
         <p:nvSpPr>
-          <p:cNvPr id="59" name="arrow-135"/>
+          <p:cNvPr id="59" name="arrow-98"/>
           <p:cNvSpPr/>
           <p:nvPr/>
         </p:nvSpPr>
@@ -10562,7 +10176,7 @@
       </p:sp>
       <p:sp>
         <p:nvSpPr>
-          <p:cNvPr id="60" name="wire-label-136"/>
+          <p:cNvPr id="60" name="wire-label-99"/>
           <p:cNvSpPr txBox="1"/>
           <p:nvPr/>
         </p:nvSpPr>
@@ -10598,7 +10212,7 @@
       </p:sp>
       <p:sp>
         <p:nvSpPr>
-          <p:cNvPr id="61" name="arrow-137"/>
+          <p:cNvPr id="61" name="arrow-100"/>
           <p:cNvSpPr/>
           <p:nvPr/>
         </p:nvSpPr>
@@ -10622,7 +10236,7 @@
       </p:sp>
       <p:sp>
         <p:nvSpPr>
-          <p:cNvPr id="62" name="arrow-138"/>
+          <p:cNvPr id="62" name="arrow-101"/>
           <p:cNvSpPr/>
           <p:nvPr/>
         </p:nvSpPr>
@@ -10646,7 +10260,7 @@
       </p:sp>
       <p:sp>
         <p:nvSpPr>
-          <p:cNvPr id="63" name="arrow-139"/>
+          <p:cNvPr id="63" name="arrow-102"/>
           <p:cNvSpPr/>
           <p:nvPr/>
         </p:nvSpPr>
@@ -10670,7 +10284,7 @@
       </p:sp>
       <p:sp>
         <p:nvSpPr>
-          <p:cNvPr id="64" name="arrow-140"/>
+          <p:cNvPr id="64" name="arrow-103"/>
           <p:cNvSpPr/>
           <p:nvPr/>
         </p:nvSpPr>
@@ -10773,7 +10387,7 @@
       </p:sp>
       <p:sp>
         <p:nvSpPr>
-          <p:cNvPr id="67" name="box-141"/>
+          <p:cNvPr id="67" name="box-104"/>
           <p:cNvSpPr/>
           <p:nvPr/>
         </p:nvSpPr>
@@ -10795,7 +10409,7 @@
       </p:sp>
       <p:pic>
         <p:nvPicPr>
-          <p:cNvPr id="68" name="box-icon-142" descr="preencoded.png">    </p:cNvPr>
+          <p:cNvPr id="68" name="box-icon-105" descr="preencoded.png">    </p:cNvPr>
           <p:cNvPicPr>
             <a:picLocks noChangeAspect="1"/>
           </p:cNvPicPr>
@@ -10819,7 +10433,7 @@
       </p:pic>
       <p:sp>
         <p:nvSpPr>
-          <p:cNvPr id="69" name="box-title-143"/>
+          <p:cNvPr id="69" name="box-title-106"/>
           <p:cNvSpPr txBox="1"/>
           <p:nvPr/>
         </p:nvSpPr>
@@ -10855,7 +10469,7 @@
       </p:sp>
       <p:sp>
         <p:nvSpPr>
-          <p:cNvPr id="70" name="box-sub-144"/>
+          <p:cNvPr id="70" name="box-sub-107"/>
           <p:cNvSpPr txBox="1"/>
           <p:nvPr/>
         </p:nvSpPr>
@@ -10891,7 +10505,7 @@
       </p:sp>
       <p:sp>
         <p:nvSpPr>
-          <p:cNvPr id="71" name="box-145"/>
+          <p:cNvPr id="71" name="box-108"/>
           <p:cNvSpPr/>
           <p:nvPr/>
         </p:nvSpPr>
@@ -10913,7 +10527,7 @@
       </p:sp>
       <p:pic>
         <p:nvPicPr>
-          <p:cNvPr id="72" name="box-icon-146" descr="preencoded.png">    </p:cNvPr>
+          <p:cNvPr id="72" name="box-icon-109" descr="preencoded.png">    </p:cNvPr>
           <p:cNvPicPr>
             <a:picLocks noChangeAspect="1"/>
           </p:cNvPicPr>
@@ -10937,7 +10551,7 @@
       </p:pic>
       <p:sp>
         <p:nvSpPr>
-          <p:cNvPr id="73" name="box-title-147"/>
+          <p:cNvPr id="73" name="box-title-110"/>
           <p:cNvSpPr txBox="1"/>
           <p:nvPr/>
         </p:nvSpPr>
@@ -10973,7 +10587,7 @@
       </p:sp>
       <p:sp>
         <p:nvSpPr>
-          <p:cNvPr id="74" name="box-sub-148"/>
+          <p:cNvPr id="74" name="box-sub-111"/>
           <p:cNvSpPr txBox="1"/>
           <p:nvPr/>
         </p:nvSpPr>
@@ -11088,7 +10702,7 @@
       </p:sp>
       <p:sp>
         <p:nvSpPr>
-          <p:cNvPr id="77" name="box-149"/>
+          <p:cNvPr id="77" name="box-112"/>
           <p:cNvSpPr/>
           <p:nvPr/>
         </p:nvSpPr>
@@ -11110,7 +10724,7 @@
       </p:sp>
       <p:pic>
         <p:nvPicPr>
-          <p:cNvPr id="78" name="box-icon-150" descr="preencoded.png">    </p:cNvPr>
+          <p:cNvPr id="78" name="box-icon-113" descr="preencoded.png">    </p:cNvPr>
           <p:cNvPicPr>
             <a:picLocks noChangeAspect="1"/>
           </p:cNvPicPr>
@@ -11134,7 +10748,7 @@
       </p:pic>
       <p:sp>
         <p:nvSpPr>
-          <p:cNvPr id="79" name="box-title-151"/>
+          <p:cNvPr id="79" name="box-title-114"/>
           <p:cNvSpPr txBox="1"/>
           <p:nvPr/>
         </p:nvSpPr>
@@ -11170,7 +10784,7 @@
       </p:sp>
       <p:sp>
         <p:nvSpPr>
-          <p:cNvPr id="80" name="box-sub-152"/>
+          <p:cNvPr id="80" name="box-sub-115"/>
           <p:cNvSpPr txBox="1"/>
           <p:nvPr/>
         </p:nvSpPr>
@@ -11206,7 +10820,7 @@
       </p:sp>
       <p:sp>
         <p:nvSpPr>
-          <p:cNvPr id="81" name="box-153"/>
+          <p:cNvPr id="81" name="box-116"/>
           <p:cNvSpPr/>
           <p:nvPr/>
         </p:nvSpPr>
@@ -11228,7 +10842,7 @@
       </p:sp>
       <p:pic>
         <p:nvPicPr>
-          <p:cNvPr id="82" name="box-icon-154" descr="preencoded.png">    </p:cNvPr>
+          <p:cNvPr id="82" name="box-icon-117" descr="preencoded.png">    </p:cNvPr>
           <p:cNvPicPr>
             <a:picLocks noChangeAspect="1"/>
           </p:cNvPicPr>
@@ -11252,7 +10866,7 @@
       </p:pic>
       <p:sp>
         <p:nvSpPr>
-          <p:cNvPr id="83" name="box-title-155"/>
+          <p:cNvPr id="83" name="box-title-118"/>
           <p:cNvSpPr txBox="1"/>
           <p:nvPr/>
         </p:nvSpPr>
@@ -11288,7 +10902,7 @@
       </p:sp>
       <p:sp>
         <p:nvSpPr>
-          <p:cNvPr id="84" name="box-156"/>
+          <p:cNvPr id="84" name="box-119"/>
           <p:cNvSpPr/>
           <p:nvPr/>
         </p:nvSpPr>
@@ -11310,7 +10924,7 @@
       </p:sp>
       <p:pic>
         <p:nvPicPr>
-          <p:cNvPr id="85" name="box-icon-157" descr="preencoded.png">    </p:cNvPr>
+          <p:cNvPr id="85" name="box-icon-120" descr="preencoded.png">    </p:cNvPr>
           <p:cNvPicPr>
             <a:picLocks noChangeAspect="1"/>
           </p:cNvPicPr>
@@ -11334,7 +10948,7 @@
       </p:pic>
       <p:sp>
         <p:nvSpPr>
-          <p:cNvPr id="86" name="box-title-158"/>
+          <p:cNvPr id="86" name="box-title-121"/>
           <p:cNvSpPr txBox="1"/>
           <p:nvPr/>
         </p:nvSpPr>
@@ -11370,7 +10984,7 @@
       </p:sp>
       <p:sp>
         <p:nvSpPr>
-          <p:cNvPr id="87" name="arrow-159"/>
+          <p:cNvPr id="87" name="arrow-122"/>
           <p:cNvSpPr/>
           <p:nvPr/>
         </p:nvSpPr>
@@ -11394,7 +11008,7 @@
       </p:sp>
       <p:sp>
         <p:nvSpPr>
-          <p:cNvPr id="88" name="wire-label-160"/>
+          <p:cNvPr id="88" name="wire-label-123"/>
           <p:cNvSpPr txBox="1"/>
           <p:nvPr/>
         </p:nvSpPr>
@@ -11430,7 +11044,7 @@
       </p:sp>
       <p:sp>
         <p:nvSpPr>
-          <p:cNvPr id="89" name="arrow-161"/>
+          <p:cNvPr id="89" name="arrow-124"/>
           <p:cNvSpPr/>
           <p:nvPr/>
         </p:nvSpPr>
@@ -11454,7 +11068,7 @@
       </p:sp>
       <p:sp>
         <p:nvSpPr>
-          <p:cNvPr id="90" name="wire-label-162"/>
+          <p:cNvPr id="90" name="wire-label-125"/>
           <p:cNvSpPr txBox="1"/>
           <p:nvPr/>
         </p:nvSpPr>
@@ -11490,7 +11104,7 @@
       </p:sp>
       <p:sp>
         <p:nvSpPr>
-          <p:cNvPr id="91" name="arrow-163"/>
+          <p:cNvPr id="91" name="arrow-126"/>
           <p:cNvSpPr/>
           <p:nvPr/>
         </p:nvSpPr>
@@ -11514,7 +11128,7 @@
       </p:sp>
       <p:sp>
         <p:nvSpPr>
-          <p:cNvPr id="92" name="wire-label-164"/>
+          <p:cNvPr id="92" name="wire-label-127"/>
           <p:cNvSpPr txBox="1"/>
           <p:nvPr/>
         </p:nvSpPr>
@@ -11650,7 +11264,7 @@
                   <a:schemeClr val="tx1"/>
                 </a:solidFill>
               </a:rPr>
-              <a:t>Agentic architecture</a:t>
+              <a:t>Agentic architecture: tools and checks</a:t>
             </a:r>
             <a:endParaRPr lang="en-US" sz="3200" dirty="0"/>
           </a:p>
@@ -11696,7 +11310,7 @@
       </p:sp>
       <p:sp>
         <p:nvSpPr>
-          <p:cNvPr id="4" name="col-head-165"/>
+          <p:cNvPr id="4" name="col-head-128"/>
           <p:cNvSpPr txBox="1"/>
           <p:nvPr/>
         </p:nvSpPr>
@@ -11732,7 +11346,7 @@
       </p:sp>
       <p:sp>
         <p:nvSpPr>
-          <p:cNvPr id="5" name="col-head-166"/>
+          <p:cNvPr id="5" name="col-head-129"/>
           <p:cNvSpPr txBox="1"/>
           <p:nvPr/>
         </p:nvSpPr>
@@ -11768,7 +11382,7 @@
       </p:sp>
       <p:sp>
         <p:nvSpPr>
-          <p:cNvPr id="6" name="col-head-167"/>
+          <p:cNvPr id="6" name="col-head-130"/>
           <p:cNvSpPr txBox="1"/>
           <p:nvPr/>
         </p:nvSpPr>
@@ -11804,7 +11418,7 @@
       </p:sp>
       <p:sp>
         <p:nvSpPr>
-          <p:cNvPr id="7" name="col-head-168"/>
+          <p:cNvPr id="7" name="col-head-131"/>
           <p:cNvSpPr txBox="1"/>
           <p:nvPr/>
         </p:nvSpPr>
@@ -11840,7 +11454,7 @@
       </p:sp>
       <p:sp>
         <p:nvSpPr>
-          <p:cNvPr id="8" name="col-head-169"/>
+          <p:cNvPr id="8" name="col-head-132"/>
           <p:cNvSpPr txBox="1"/>
           <p:nvPr/>
         </p:nvSpPr>
@@ -11977,7 +11591,7 @@
       </p:sp>
       <p:sp>
         <p:nvSpPr>
-          <p:cNvPr id="12" name="arrow-170"/>
+          <p:cNvPr id="12" name="arrow-133"/>
           <p:cNvSpPr/>
           <p:nvPr/>
         </p:nvSpPr>
@@ -12001,7 +11615,7 @@
       </p:sp>
       <p:sp>
         <p:nvSpPr>
-          <p:cNvPr id="13" name="node-171"/>
+          <p:cNvPr id="13" name="node-134"/>
           <p:cNvSpPr/>
           <p:nvPr/>
         </p:nvSpPr>
@@ -12023,7 +11637,7 @@
       </p:sp>
       <p:pic>
         <p:nvPicPr>
-          <p:cNvPr id="14" name="icon-172" descr="preencoded.png">    </p:cNvPr>
+          <p:cNvPr id="14" name="icon-135" descr="preencoded.png">    </p:cNvPr>
           <p:cNvPicPr>
             <a:picLocks noChangeAspect="1"/>
           </p:cNvPicPr>
@@ -12047,7 +11661,7 @@
       </p:pic>
       <p:sp>
         <p:nvSpPr>
-          <p:cNvPr id="15" name="node-title-173"/>
+          <p:cNvPr id="15" name="node-title-136"/>
           <p:cNvSpPr txBox="1"/>
           <p:nvPr/>
         </p:nvSpPr>
@@ -12083,7 +11697,7 @@
       </p:sp>
       <p:sp>
         <p:nvSpPr>
-          <p:cNvPr id="16" name="node-sub-174"/>
+          <p:cNvPr id="16" name="node-sub-137"/>
           <p:cNvSpPr txBox="1"/>
           <p:nvPr/>
         </p:nvSpPr>
@@ -12119,7 +11733,7 @@
       </p:sp>
       <p:sp>
         <p:nvSpPr>
-          <p:cNvPr id="17" name="no-tools-175"/>
+          <p:cNvPr id="17" name="no-tools-138"/>
           <p:cNvSpPr txBox="1"/>
           <p:nvPr/>
         </p:nvSpPr>
@@ -12155,7 +11769,7 @@
       </p:sp>
       <p:sp>
         <p:nvSpPr>
-          <p:cNvPr id="18" name="chip-176"/>
+          <p:cNvPr id="18" name="chip-139"/>
           <p:cNvSpPr/>
           <p:nvPr/>
         </p:nvSpPr>
@@ -12177,7 +11791,7 @@
       </p:sp>
       <p:sp>
         <p:nvSpPr>
-          <p:cNvPr id="19" name="chip-text-177"/>
+          <p:cNvPr id="19" name="chip-text-140"/>
           <p:cNvSpPr txBox="1"/>
           <p:nvPr/>
         </p:nvSpPr>
@@ -12216,7 +11830,7 @@
       </p:sp>
       <p:sp>
         <p:nvSpPr>
-          <p:cNvPr id="20" name="check-178"/>
+          <p:cNvPr id="20" name="check-141"/>
           <p:cNvSpPr txBox="1"/>
           <p:nvPr/>
         </p:nvSpPr>
@@ -12252,7 +11866,7 @@
       </p:sp>
       <p:sp>
         <p:nvSpPr>
-          <p:cNvPr id="21" name="arrow-179"/>
+          <p:cNvPr id="21" name="arrow-142"/>
           <p:cNvSpPr/>
           <p:nvPr/>
         </p:nvSpPr>
@@ -12276,7 +11890,7 @@
       </p:sp>
       <p:sp>
         <p:nvSpPr>
-          <p:cNvPr id="22" name="node-180"/>
+          <p:cNvPr id="22" name="node-143"/>
           <p:cNvSpPr/>
           <p:nvPr/>
         </p:nvSpPr>
@@ -12298,7 +11912,7 @@
       </p:sp>
       <p:pic>
         <p:nvPicPr>
-          <p:cNvPr id="23" name="icon-181" descr="preencoded.png">    </p:cNvPr>
+          <p:cNvPr id="23" name="icon-144" descr="preencoded.png">    </p:cNvPr>
           <p:cNvPicPr>
             <a:picLocks noChangeAspect="1"/>
           </p:cNvPicPr>
@@ -12322,7 +11936,7 @@
       </p:pic>
       <p:sp>
         <p:nvSpPr>
-          <p:cNvPr id="24" name="node-title-182"/>
+          <p:cNvPr id="24" name="node-title-145"/>
           <p:cNvSpPr txBox="1"/>
           <p:nvPr/>
         </p:nvSpPr>
@@ -12358,7 +11972,7 @@
       </p:sp>
       <p:sp>
         <p:nvSpPr>
-          <p:cNvPr id="25" name="node-sub-183"/>
+          <p:cNvPr id="25" name="node-sub-146"/>
           <p:cNvSpPr txBox="1"/>
           <p:nvPr/>
         </p:nvSpPr>
@@ -12394,7 +12008,7 @@
       </p:sp>
       <p:sp>
         <p:nvSpPr>
-          <p:cNvPr id="26" name="chip-184"/>
+          <p:cNvPr id="26" name="chip-147"/>
           <p:cNvSpPr/>
           <p:nvPr/>
         </p:nvSpPr>
@@ -12421,7 +12035,7 @@
       </p:sp>
       <p:sp>
         <p:nvSpPr>
-          <p:cNvPr id="27" name="chip-text-185"/>
+          <p:cNvPr id="27" name="chip-text-148"/>
           <p:cNvSpPr txBox="1"/>
           <p:nvPr/>
         </p:nvSpPr>
@@ -12460,7 +12074,7 @@
       </p:sp>
       <p:sp>
         <p:nvSpPr>
-          <p:cNvPr id="28" name="chip-186"/>
+          <p:cNvPr id="28" name="chip-149"/>
           <p:cNvSpPr/>
           <p:nvPr/>
         </p:nvSpPr>
@@ -12487,7 +12101,7 @@
       </p:sp>
       <p:sp>
         <p:nvSpPr>
-          <p:cNvPr id="29" name="chip-text-187"/>
+          <p:cNvPr id="29" name="chip-text-150"/>
           <p:cNvSpPr txBox="1"/>
           <p:nvPr/>
         </p:nvSpPr>
@@ -12526,7 +12140,7 @@
       </p:sp>
       <p:sp>
         <p:nvSpPr>
-          <p:cNvPr id="30" name="chip-188"/>
+          <p:cNvPr id="30" name="chip-151"/>
           <p:cNvSpPr/>
           <p:nvPr/>
         </p:nvSpPr>
@@ -12548,7 +12162,7 @@
       </p:sp>
       <p:sp>
         <p:nvSpPr>
-          <p:cNvPr id="31" name="chip-text-189"/>
+          <p:cNvPr id="31" name="chip-text-152"/>
           <p:cNvSpPr txBox="1"/>
           <p:nvPr/>
         </p:nvSpPr>
@@ -12587,7 +12201,7 @@
       </p:sp>
       <p:sp>
         <p:nvSpPr>
-          <p:cNvPr id="32" name="check-190"/>
+          <p:cNvPr id="32" name="check-153"/>
           <p:cNvSpPr txBox="1"/>
           <p:nvPr/>
         </p:nvSpPr>
@@ -12623,7 +12237,7 @@
       </p:sp>
       <p:sp>
         <p:nvSpPr>
-          <p:cNvPr id="33" name="arrow-191"/>
+          <p:cNvPr id="33" name="arrow-154"/>
           <p:cNvSpPr/>
           <p:nvPr/>
         </p:nvSpPr>
@@ -12647,7 +12261,7 @@
       </p:sp>
       <p:sp>
         <p:nvSpPr>
-          <p:cNvPr id="34" name="node-192"/>
+          <p:cNvPr id="34" name="node-155"/>
           <p:cNvSpPr/>
           <p:nvPr/>
         </p:nvSpPr>
@@ -12669,7 +12283,7 @@
       </p:sp>
       <p:sp>
         <p:nvSpPr>
-          <p:cNvPr id="35" name="node-title-193"/>
+          <p:cNvPr id="35" name="node-title-156"/>
           <p:cNvSpPr txBox="1"/>
           <p:nvPr/>
         </p:nvSpPr>
@@ -12705,7 +12319,7 @@
       </p:sp>
       <p:sp>
         <p:nvSpPr>
-          <p:cNvPr id="36" name="node-194"/>
+          <p:cNvPr id="36" name="node-157"/>
           <p:cNvSpPr/>
           <p:nvPr/>
         </p:nvSpPr>
@@ -12727,7 +12341,7 @@
       </p:sp>
       <p:sp>
         <p:nvSpPr>
-          <p:cNvPr id="37" name="node-title-195"/>
+          <p:cNvPr id="37" name="node-title-158"/>
           <p:cNvSpPr txBox="1"/>
           <p:nvPr/>
         </p:nvSpPr>
@@ -12799,7 +12413,7 @@
       </p:sp>
       <p:sp>
         <p:nvSpPr>
-          <p:cNvPr id="39" name="chip-196"/>
+          <p:cNvPr id="39" name="chip-159"/>
           <p:cNvSpPr/>
           <p:nvPr/>
         </p:nvSpPr>
@@ -12826,7 +12440,7 @@
       </p:sp>
       <p:sp>
         <p:nvSpPr>
-          <p:cNvPr id="40" name="chip-text-197"/>
+          <p:cNvPr id="40" name="chip-text-160"/>
           <p:cNvSpPr txBox="1"/>
           <p:nvPr/>
         </p:nvSpPr>
@@ -12865,7 +12479,7 @@
       </p:sp>
       <p:sp>
         <p:nvSpPr>
-          <p:cNvPr id="41" name="chip-198"/>
+          <p:cNvPr id="41" name="chip-161"/>
           <p:cNvSpPr/>
           <p:nvPr/>
         </p:nvSpPr>
@@ -12892,7 +12506,7 @@
       </p:sp>
       <p:sp>
         <p:nvSpPr>
-          <p:cNvPr id="42" name="chip-text-199"/>
+          <p:cNvPr id="42" name="chip-text-162"/>
           <p:cNvSpPr txBox="1"/>
           <p:nvPr/>
         </p:nvSpPr>
@@ -12931,7 +12545,7 @@
       </p:sp>
       <p:sp>
         <p:nvSpPr>
-          <p:cNvPr id="43" name="chip-200"/>
+          <p:cNvPr id="43" name="chip-163"/>
           <p:cNvSpPr/>
           <p:nvPr/>
         </p:nvSpPr>
@@ -12958,7 +12572,7 @@
       </p:sp>
       <p:sp>
         <p:nvSpPr>
-          <p:cNvPr id="44" name="chip-text-201"/>
+          <p:cNvPr id="44" name="chip-text-164"/>
           <p:cNvSpPr txBox="1"/>
           <p:nvPr/>
         </p:nvSpPr>
@@ -12997,7 +12611,7 @@
       </p:sp>
       <p:sp>
         <p:nvSpPr>
-          <p:cNvPr id="45" name="chip-202"/>
+          <p:cNvPr id="45" name="chip-165"/>
           <p:cNvSpPr/>
           <p:nvPr/>
         </p:nvSpPr>
@@ -13019,7 +12633,7 @@
       </p:sp>
       <p:sp>
         <p:nvSpPr>
-          <p:cNvPr id="46" name="chip-text-203"/>
+          <p:cNvPr id="46" name="chip-text-166"/>
           <p:cNvSpPr txBox="1"/>
           <p:nvPr/>
         </p:nvSpPr>
@@ -13058,7 +12672,7 @@
       </p:sp>
       <p:sp>
         <p:nvSpPr>
-          <p:cNvPr id="47" name="check-204"/>
+          <p:cNvPr id="47" name="check-167"/>
           <p:cNvSpPr txBox="1"/>
           <p:nvPr/>
         </p:nvSpPr>
@@ -13094,7 +12708,7 @@
       </p:sp>
       <p:sp>
         <p:nvSpPr>
-          <p:cNvPr id="48" name="arrow-205"/>
+          <p:cNvPr id="48" name="arrow-168"/>
           <p:cNvSpPr/>
           <p:nvPr/>
         </p:nvSpPr>
@@ -13118,7 +12732,7 @@
       </p:sp>
       <p:sp>
         <p:nvSpPr>
-          <p:cNvPr id="49" name="node-206"/>
+          <p:cNvPr id="49" name="node-169"/>
           <p:cNvSpPr/>
           <p:nvPr/>
         </p:nvSpPr>
@@ -13140,7 +12754,7 @@
       </p:sp>
       <p:pic>
         <p:nvPicPr>
-          <p:cNvPr id="50" name="icon-207" descr="preencoded.png">    </p:cNvPr>
+          <p:cNvPr id="50" name="icon-170" descr="preencoded.png">    </p:cNvPr>
           <p:cNvPicPr>
             <a:picLocks noChangeAspect="1"/>
           </p:cNvPicPr>
@@ -13164,7 +12778,7 @@
       </p:pic>
       <p:sp>
         <p:nvSpPr>
-          <p:cNvPr id="51" name="node-title-208"/>
+          <p:cNvPr id="51" name="node-title-171"/>
           <p:cNvSpPr txBox="1"/>
           <p:nvPr/>
         </p:nvSpPr>
@@ -13200,7 +12814,7 @@
       </p:sp>
       <p:sp>
         <p:nvSpPr>
-          <p:cNvPr id="52" name="node-sub-209"/>
+          <p:cNvPr id="52" name="node-sub-172"/>
           <p:cNvSpPr txBox="1"/>
           <p:nvPr/>
         </p:nvSpPr>
@@ -13236,7 +12850,7 @@
       </p:sp>
       <p:sp>
         <p:nvSpPr>
-          <p:cNvPr id="53" name="chip-210"/>
+          <p:cNvPr id="53" name="chip-173"/>
           <p:cNvSpPr/>
           <p:nvPr/>
         </p:nvSpPr>
@@ -13263,7 +12877,7 @@
       </p:sp>
       <p:sp>
         <p:nvSpPr>
-          <p:cNvPr id="54" name="chip-text-211"/>
+          <p:cNvPr id="54" name="chip-text-174"/>
           <p:cNvSpPr txBox="1"/>
           <p:nvPr/>
         </p:nvSpPr>
@@ -13302,7 +12916,7 @@
       </p:sp>
       <p:sp>
         <p:nvSpPr>
-          <p:cNvPr id="55" name="chip-212"/>
+          <p:cNvPr id="55" name="chip-175"/>
           <p:cNvSpPr/>
           <p:nvPr/>
         </p:nvSpPr>
@@ -13329,7 +12943,7 @@
       </p:sp>
       <p:sp>
         <p:nvSpPr>
-          <p:cNvPr id="56" name="chip-text-213"/>
+          <p:cNvPr id="56" name="chip-text-176"/>
           <p:cNvSpPr txBox="1"/>
           <p:nvPr/>
         </p:nvSpPr>
@@ -13368,7 +12982,7 @@
       </p:sp>
       <p:sp>
         <p:nvSpPr>
-          <p:cNvPr id="57" name="chip-214"/>
+          <p:cNvPr id="57" name="chip-177"/>
           <p:cNvSpPr/>
           <p:nvPr/>
         </p:nvSpPr>
@@ -13395,7 +13009,7 @@
       </p:sp>
       <p:sp>
         <p:nvSpPr>
-          <p:cNvPr id="58" name="chip-text-215"/>
+          <p:cNvPr id="58" name="chip-text-178"/>
           <p:cNvSpPr txBox="1"/>
           <p:nvPr/>
         </p:nvSpPr>
@@ -13434,7 +13048,7 @@
       </p:sp>
       <p:sp>
         <p:nvSpPr>
-          <p:cNvPr id="59" name="chip-216"/>
+          <p:cNvPr id="59" name="chip-179"/>
           <p:cNvSpPr/>
           <p:nvPr/>
         </p:nvSpPr>
@@ -13456,7 +13070,7 @@
       </p:sp>
       <p:sp>
         <p:nvSpPr>
-          <p:cNvPr id="60" name="chip-text-217"/>
+          <p:cNvPr id="60" name="chip-text-180"/>
           <p:cNvSpPr txBox="1"/>
           <p:nvPr/>
         </p:nvSpPr>
@@ -13495,7 +13109,7 @@
       </p:sp>
       <p:sp>
         <p:nvSpPr>
-          <p:cNvPr id="61" name="check-218"/>
+          <p:cNvPr id="61" name="check-181"/>
           <p:cNvSpPr txBox="1"/>
           <p:nvPr/>
         </p:nvSpPr>

</xml_diff>